<commit_message>
fix(presentation): Manrope+Golos fonts, card text positioning, footer
Co-authored-by: pagasbot-coder <pagasbot-coder@users.noreply.github.com>
</commit_message>
<xml_diff>
--- a/knowledge-base/presentation-travelplus-interview.pptx
+++ b/knowledge-base/presentation-travelplus-interview.pptx
@@ -3245,14 +3245,12 @@
           <a:noFill/>
         </p:spPr>
         <p:txBody>
-          <a:bodyPr wrap="square">
-            <a:spAutoFit/>
-          </a:bodyPr>
-          <a:lstStyle/>
-          <a:p>
-            <a:pPr>
-              <a:lnSpc>
-                <a:spcPct val="115000"/>
+          <a:bodyPr wrap="square" anchor="t" lIns="50800" rIns="50800" tIns="25400" bIns="25400"/>
+          <a:lstStyle/>
+          <a:p>
+            <a:pPr algn="l">
+              <a:lnSpc>
+                <a:spcPct val="118000"/>
               </a:lnSpc>
               <a:spcBef>
                 <a:spcPts val="0"/>
@@ -3266,16 +3264,16 @@
                 <a:solidFill>
                   <a:srgbClr val="FFFFFF"/>
                 </a:solidFill>
-                <a:latin typeface="Calibri"/>
-                <a:rFonts ascii="Calibri" hAnsi="Calibri" cs="Calibri"/>
+                <a:latin typeface="Manrope"/>
+                <a:rFonts ascii="Manrope" hAnsi="Manrope" cs="Manrope" eastAsia="Manrope"/>
               </a:rPr>
               <a:t>Павел Биджиев</a:t>
             </a:r>
           </a:p>
           <a:p>
-            <a:pPr>
-              <a:lnSpc>
-                <a:spcPct val="115000"/>
+            <a:pPr algn="l">
+              <a:lnSpc>
+                <a:spcPct val="118000"/>
               </a:lnSpc>
               <a:spcBef>
                 <a:spcPts val="0"/>
@@ -3289,16 +3287,16 @@
                 <a:solidFill>
                   <a:srgbClr val="FFFFFF"/>
                 </a:solidFill>
-                <a:latin typeface="Calibri"/>
-                <a:rFonts ascii="Calibri" hAnsi="Calibri" cs="Calibri"/>
+                <a:latin typeface="Golos Text"/>
+                <a:rFonts ascii="Golos Text" hAnsi="Golos Text" cs="Golos Text" eastAsia="Golos Text"/>
               </a:rPr>
               <a:t>Продакт / бренд-логика</a:t>
             </a:r>
           </a:p>
           <a:p>
-            <a:pPr>
-              <a:lnSpc>
-                <a:spcPct val="115000"/>
+            <a:pPr algn="l">
+              <a:lnSpc>
+                <a:spcPct val="118000"/>
               </a:lnSpc>
               <a:spcBef>
                 <a:spcPts val="0"/>
@@ -3312,8 +3310,8 @@
                 <a:solidFill>
                   <a:srgbClr val="C8DDD6"/>
                 </a:solidFill>
-                <a:latin typeface="Calibri"/>
-                <a:rFonts ascii="Calibri" hAnsi="Calibri" cs="Calibri"/>
+                <a:latin typeface="Golos Text"/>
+                <a:rFonts ascii="Golos Text" hAnsi="Golos Text" cs="Golos Text" eastAsia="Golos Text"/>
               </a:rPr>
               <a:t>Физические товары · HoReCa amenities</a:t>
             </a:r>
@@ -3337,14 +3335,12 @@
           <a:noFill/>
         </p:spPr>
         <p:txBody>
-          <a:bodyPr wrap="square">
-            <a:spAutoFit/>
-          </a:bodyPr>
-          <a:lstStyle/>
-          <a:p>
-            <a:pPr>
-              <a:lnSpc>
-                <a:spcPct val="115000"/>
+          <a:bodyPr wrap="square" anchor="t" lIns="50800" rIns="50800" tIns="25400" bIns="25400"/>
+          <a:lstStyle/>
+          <a:p>
+            <a:pPr algn="l">
+              <a:lnSpc>
+                <a:spcPct val="118000"/>
               </a:lnSpc>
               <a:spcBef>
                 <a:spcPts val="0"/>
@@ -3358,16 +3354,16 @@
                 <a:solidFill>
                   <a:srgbClr val="2A554A"/>
                 </a:solidFill>
-                <a:latin typeface="Calibri"/>
-                <a:rFonts ascii="Calibri" hAnsi="Calibri" cs="Calibri"/>
+                <a:latin typeface="Manrope"/>
+                <a:rFonts ascii="Manrope" hAnsi="Manrope" cs="Manrope" eastAsia="Manrope"/>
               </a:rPr>
               <a:t>Travel+ Natural</a:t>
             </a:r>
           </a:p>
           <a:p>
-            <a:pPr>
-              <a:lnSpc>
-                <a:spcPct val="115000"/>
+            <a:pPr algn="l">
+              <a:lnSpc>
+                <a:spcPct val="118000"/>
               </a:lnSpc>
               <a:spcBef>
                 <a:spcPts val="0"/>
@@ -3381,16 +3377,16 @@
                 <a:solidFill>
                   <a:srgbClr val="1A1A1A"/>
                 </a:solidFill>
-                <a:latin typeface="Calibri"/>
-                <a:rFonts ascii="Calibri" hAnsi="Calibri" cs="Calibri"/>
+                <a:latin typeface="Manrope"/>
+                <a:rFonts ascii="Manrope" hAnsi="Manrope" cs="Manrope" eastAsia="Manrope"/>
               </a:rPr>
               <a:t>Своя натуральная линейка:</a:t>
             </a:r>
           </a:p>
           <a:p>
-            <a:pPr>
-              <a:lnSpc>
-                <a:spcPct val="115000"/>
+            <a:pPr algn="l">
+              <a:lnSpc>
+                <a:spcPct val="118000"/>
               </a:lnSpc>
               <a:spcBef>
                 <a:spcPts val="0"/>
@@ -3404,16 +3400,16 @@
                 <a:solidFill>
                   <a:srgbClr val="1A1A1A"/>
                 </a:solidFill>
-                <a:latin typeface="Calibri"/>
-                <a:rFonts ascii="Calibri" hAnsi="Calibri" cs="Calibri"/>
+                <a:latin typeface="Manrope"/>
+                <a:rFonts ascii="Manrope" hAnsi="Manrope" cs="Manrope" eastAsia="Manrope"/>
               </a:rPr>
               <a:t>от рамки до пилота</a:t>
             </a:r>
           </a:p>
           <a:p>
-            <a:pPr>
-              <a:lnSpc>
-                <a:spcPct val="115000"/>
+            <a:pPr algn="l">
+              <a:lnSpc>
+                <a:spcPct val="118000"/>
               </a:lnSpc>
               <a:spcBef>
                 <a:spcPts val="0"/>
@@ -3427,16 +3423,16 @@
                 <a:solidFill>
                   <a:srgbClr val="5C5C5C"/>
                 </a:solidFill>
-                <a:latin typeface="Calibri"/>
-                <a:rFonts ascii="Calibri" hAnsi="Calibri" cs="Calibri"/>
+                <a:latin typeface="Golos Text"/>
+                <a:rFonts ascii="Golos Text" hAnsi="Golos Text" cs="Golos Text" eastAsia="Golos Text"/>
               </a:rPr>
               <a:t>Подготовка · АК-Сервис / Travel+ · Кириши</a:t>
             </a:r>
           </a:p>
           <a:p>
-            <a:pPr>
-              <a:lnSpc>
-                <a:spcPct val="115000"/>
+            <a:pPr algn="l">
+              <a:lnSpc>
+                <a:spcPct val="118000"/>
               </a:lnSpc>
               <a:spcBef>
                 <a:spcPts val="0"/>
@@ -3450,10 +3446,10 @@
                 <a:solidFill>
                   <a:srgbClr val="5C5C5C"/>
                 </a:solidFill>
-                <a:latin typeface="Calibri"/>
-                <a:rFonts ascii="Calibri" hAnsi="Calibri" cs="Calibri"/>
-              </a:rPr>
-              <a:t>Пульт бренда v1.14 · не оферта</a:t>
+                <a:latin typeface="Golos Text"/>
+                <a:rFonts ascii="Golos Text" hAnsi="Golos Text" cs="Golos Text" eastAsia="Golos Text"/>
+              </a:rPr>
+              <a:t>Образец презентации · не оферта</a:t>
             </a:r>
           </a:p>
         </p:txBody>
@@ -3589,8 +3585,8 @@
                 <a:solidFill>
                   <a:srgbClr val="2A554A"/>
                 </a:solidFill>
-                <a:latin typeface="Calibri"/>
-                <a:rFonts ascii="Calibri" hAnsi="Calibri" cs="Calibri"/>
+                <a:latin typeface="Manrope"/>
+                <a:rFonts ascii="Manrope" hAnsi="Manrope" cs="Manrope" eastAsia="Manrope"/>
               </a:rPr>
               <a:t>Поставки и экономика (Китай)</a:t>
             </a:r>
@@ -3710,10 +3706,10 @@
                 <a:solidFill>
                   <a:srgbClr val="5C5C5C"/>
                 </a:solidFill>
-                <a:latin typeface="Calibri"/>
-                <a:rFonts ascii="Calibri" hAnsi="Calibri" cs="Calibri"/>
-              </a:rPr>
-              <a:t>Travel+ Natural  ·  пульт v1.14  ·  собеседование  ·  не оферта</a:t>
+                <a:latin typeface="Golos Text"/>
+                <a:rFonts ascii="Golos Text" hAnsi="Golos Text" cs="Golos Text" eastAsia="Golos Text"/>
+              </a:rPr>
+              <a:t>Travel+ Natural  ·  образец презентации</a:t>
             </a:r>
           </a:p>
         </p:txBody>
@@ -3746,8 +3742,8 @@
                 <a:solidFill>
                   <a:srgbClr val="5C5C5C"/>
                 </a:solidFill>
-                <a:latin typeface="Calibri"/>
-                <a:rFonts ascii="Calibri" hAnsi="Calibri" cs="Calibri"/>
+                <a:latin typeface="Golos Text"/>
+                <a:rFonts ascii="Golos Text" hAnsi="Golos Text" cs="Golos Text" eastAsia="Golos Text"/>
               </a:rPr>
               <a:t>10 / 12</a:t>
             </a:r>
@@ -3810,7 +3806,7 @@
         <p:spPr>
           <a:xfrm>
             <a:off x="457200" y="960120"/>
-            <a:ext cx="5510631" cy="73152"/>
+            <a:ext cx="5510631" cy="82296"/>
           </a:xfrm>
           <a:prstGeom prst="rect">
             <a:avLst/>
@@ -3900,7 +3896,7 @@
         <p:spPr>
           <a:xfrm>
             <a:off x="6223863" y="960120"/>
-            <a:ext cx="5510631" cy="73152"/>
+            <a:ext cx="5510631" cy="82296"/>
           </a:xfrm>
           <a:prstGeom prst="rect">
             <a:avLst/>
@@ -3942,8 +3938,8 @@
         </p:nvSpPr>
         <p:spPr>
           <a:xfrm>
-            <a:off x="749808" y="1216152"/>
-            <a:ext cx="4925415" cy="4663440"/>
+            <a:off x="804672" y="1426464"/>
+            <a:ext cx="4815687" cy="4334256"/>
           </a:xfrm>
           <a:prstGeom prst="rect">
             <a:avLst/>
@@ -3951,20 +3947,18 @@
           <a:noFill/>
         </p:spPr>
         <p:txBody>
-          <a:bodyPr wrap="square">
-            <a:spAutoFit/>
-          </a:bodyPr>
-          <a:lstStyle/>
-          <a:p>
-            <a:pPr>
-              <a:lnSpc>
-                <a:spcPct val="115000"/>
-              </a:lnSpc>
-              <a:spcBef>
-                <a:spcPts val="0"/>
-              </a:spcBef>
-              <a:spcAft>
-                <a:spcPts val="1400"/>
+          <a:bodyPr wrap="square" anchor="t" lIns="50800" rIns="50800" tIns="25400" bIns="25400"/>
+          <a:lstStyle/>
+          <a:p>
+            <a:pPr algn="l">
+              <a:lnSpc>
+                <a:spcPct val="118000"/>
+              </a:lnSpc>
+              <a:spcBef>
+                <a:spcPts val="0"/>
+              </a:spcBef>
+              <a:spcAft>
+                <a:spcPts val="1200"/>
               </a:spcAft>
             </a:pPr>
             <a:r>
@@ -3972,16 +3966,16 @@
                 <a:solidFill>
                   <a:srgbClr val="2A554A"/>
                 </a:solidFill>
-                <a:latin typeface="Calibri"/>
-                <a:rFonts ascii="Calibri" hAnsi="Calibri" cs="Calibri"/>
+                <a:latin typeface="Manrope"/>
+                <a:rFonts ascii="Manrope" hAnsi="Manrope" cs="Manrope" eastAsia="Manrope"/>
               </a:rPr>
               <a:t>Экономика</a:t>
             </a:r>
           </a:p>
           <a:p>
-            <a:pPr>
-              <a:lnSpc>
-                <a:spcPct val="115000"/>
+            <a:pPr algn="l">
+              <a:lnSpc>
+                <a:spcPct val="118000"/>
               </a:lnSpc>
               <a:spcBef>
                 <a:spcPts val="0"/>
@@ -3995,16 +3989,16 @@
                 <a:solidFill>
                   <a:srgbClr val="1A1A1A"/>
                 </a:solidFill>
-                <a:latin typeface="Calibri"/>
-                <a:rFonts ascii="Calibri" hAnsi="Calibri" cs="Calibri"/>
+                <a:latin typeface="Golos Text"/>
+                <a:rFonts ascii="Golos Text" hAnsi="Golos Text" cs="Golos Text" eastAsia="Golos Text"/>
               </a:rPr>
               <a:t>Прайс — после себестоимости на складе.</a:t>
             </a:r>
           </a:p>
           <a:p>
-            <a:pPr>
-              <a:lnSpc>
-                <a:spcPct val="115000"/>
+            <a:pPr algn="l">
+              <a:lnSpc>
+                <a:spcPct val="118000"/>
               </a:lnSpc>
               <a:spcBef>
                 <a:spcPts val="0"/>
@@ -4018,16 +4012,16 @@
                 <a:solidFill>
                   <a:srgbClr val="1A1A1A"/>
                 </a:solidFill>
-                <a:latin typeface="Calibri"/>
-                <a:rFonts ascii="Calibri" hAnsi="Calibri" cs="Calibri"/>
+                <a:latin typeface="Golos Text"/>
+                <a:rFonts ascii="Golos Text" hAnsi="Golos Text" cs="Golos Text" eastAsia="Golos Text"/>
               </a:rPr>
               <a:t>Ориентир: выше Hotel Line · рядом с ЕТС · ниже NS.</a:t>
             </a:r>
           </a:p>
           <a:p>
-            <a:pPr>
-              <a:lnSpc>
-                <a:spcPct val="115000"/>
+            <a:pPr algn="l">
+              <a:lnSpc>
+                <a:spcPct val="118000"/>
               </a:lnSpc>
               <a:spcBef>
                 <a:spcPts val="0"/>
@@ -4041,16 +4035,16 @@
                 <a:solidFill>
                   <a:srgbClr val="1A1A1A"/>
                 </a:solidFill>
-                <a:latin typeface="Calibri"/>
-                <a:rFonts ascii="Calibri" hAnsi="Calibri" cs="Calibri"/>
+                <a:latin typeface="Manrope"/>
+                <a:rFonts ascii="Manrope" hAnsi="Manrope" cs="Manrope" eastAsia="Manrope"/>
               </a:rPr>
               <a:t>Не воюем копейкой.</a:t>
             </a:r>
           </a:p>
           <a:p>
-            <a:pPr>
-              <a:lnSpc>
-                <a:spcPct val="115000"/>
+            <a:pPr algn="l">
+              <a:lnSpc>
+                <a:spcPct val="118000"/>
               </a:lnSpc>
               <a:spcBef>
                 <a:spcPts val="0"/>
@@ -4064,8 +4058,8 @@
                 <a:solidFill>
                   <a:srgbClr val="1A1A1A"/>
                 </a:solidFill>
-                <a:latin typeface="Calibri"/>
-                <a:rFonts ascii="Calibri" hAnsi="Calibri" cs="Calibri"/>
+                <a:latin typeface="Golos Text"/>
+                <a:rFonts ascii="Golos Text" hAnsi="Golos Text" cs="Golos Text" eastAsia="Golos Text"/>
               </a:rPr>
               <a:t>Выигрываем пакетом и ощущением.</a:t>
             </a:r>
@@ -4080,8 +4074,8 @@
         </p:nvSpPr>
         <p:spPr>
           <a:xfrm>
-            <a:off x="6516471" y="1216152"/>
-            <a:ext cx="4925415" cy="4663440"/>
+            <a:off x="6571335" y="1426464"/>
+            <a:ext cx="4815687" cy="4334256"/>
           </a:xfrm>
           <a:prstGeom prst="rect">
             <a:avLst/>
@@ -4089,20 +4083,18 @@
           <a:noFill/>
         </p:spPr>
         <p:txBody>
-          <a:bodyPr wrap="square">
-            <a:spAutoFit/>
-          </a:bodyPr>
-          <a:lstStyle/>
-          <a:p>
-            <a:pPr>
-              <a:lnSpc>
-                <a:spcPct val="115000"/>
-              </a:lnSpc>
-              <a:spcBef>
-                <a:spcPts val="0"/>
-              </a:spcBef>
-              <a:spcAft>
-                <a:spcPts val="1400"/>
+          <a:bodyPr wrap="square" anchor="t" lIns="50800" rIns="50800" tIns="25400" bIns="25400"/>
+          <a:lstStyle/>
+          <a:p>
+            <a:pPr algn="l">
+              <a:lnSpc>
+                <a:spcPct val="118000"/>
+              </a:lnSpc>
+              <a:spcBef>
+                <a:spcPts val="0"/>
+              </a:spcBef>
+              <a:spcAft>
+                <a:spcPts val="1200"/>
               </a:spcAft>
             </a:pPr>
             <a:r>
@@ -4110,16 +4102,16 @@
                 <a:solidFill>
                   <a:srgbClr val="2A554A"/>
                 </a:solidFill>
-                <a:latin typeface="Calibri"/>
-                <a:rFonts ascii="Calibri" hAnsi="Calibri" cs="Calibri"/>
+                <a:latin typeface="Manrope"/>
+                <a:rFonts ascii="Manrope" hAnsi="Manrope" cs="Manrope" eastAsia="Manrope"/>
               </a:rPr>
               <a:t>Если Китай или гибрид</a:t>
             </a:r>
           </a:p>
           <a:p>
-            <a:pPr>
-              <a:lnSpc>
-                <a:spcPct val="115000"/>
+            <a:pPr algn="l">
+              <a:lnSpc>
+                <a:spcPct val="118000"/>
               </a:lnSpc>
               <a:spcBef>
                 <a:spcPts val="0"/>
@@ -4133,16 +4125,16 @@
                 <a:solidFill>
                   <a:srgbClr val="1A1A1A"/>
                 </a:solidFill>
-                <a:latin typeface="Calibri"/>
-                <a:rFonts ascii="Calibri" hAnsi="Calibri" cs="Calibri"/>
+                <a:latin typeface="Golos Text"/>
+                <a:rFonts ascii="Golos Text" hAnsi="Golos Text" cs="Golos Text" eastAsia="Golos Text"/>
               </a:rPr>
               <a:t>Сравниваем заводы в FOB</a:t>
             </a:r>
           </a:p>
           <a:p>
-            <a:pPr>
-              <a:lnSpc>
-                <a:spcPct val="115000"/>
+            <a:pPr algn="l">
+              <a:lnSpc>
+                <a:spcPct val="118000"/>
               </a:lnSpc>
               <a:spcBef>
                 <a:spcPts val="0"/>
@@ -4156,16 +4148,16 @@
                 <a:solidFill>
                   <a:srgbClr val="1A1A1A"/>
                 </a:solidFill>
-                <a:latin typeface="Calibri"/>
-                <a:rFonts ascii="Calibri" hAnsi="Calibri" cs="Calibri"/>
+                <a:latin typeface="Golos Text"/>
+                <a:rFonts ascii="Golos Text" hAnsi="Golos Text" cs="Golos Text" eastAsia="Golos Text"/>
               </a:rPr>
               <a:t>Логистику до Кириши считаем отдельно</a:t>
             </a:r>
           </a:p>
           <a:p>
-            <a:pPr>
-              <a:lnSpc>
-                <a:spcPct val="115000"/>
+            <a:pPr algn="l">
+              <a:lnSpc>
+                <a:spcPct val="118000"/>
               </a:lnSpc>
               <a:spcBef>
                 <a:spcPts val="0"/>
@@ -4179,16 +4171,16 @@
                 <a:solidFill>
                   <a:srgbClr val="1A1A1A"/>
                 </a:solidFill>
-                <a:latin typeface="Calibri"/>
-                <a:rFonts ascii="Calibri" hAnsi="Calibri" cs="Calibri"/>
+                <a:latin typeface="Golos Text"/>
+                <a:rFonts ascii="Golos Text" hAnsi="Golos Text" cs="Golos Text" eastAsia="Golos Text"/>
               </a:rPr>
               <a:t>Полная цена = FOB + фрахт + таможня + довоз</a:t>
             </a:r>
           </a:p>
           <a:p>
-            <a:pPr>
-              <a:lnSpc>
-                <a:spcPct val="115000"/>
+            <a:pPr algn="l">
+              <a:lnSpc>
+                <a:spcPct val="118000"/>
               </a:lnSpc>
               <a:spcBef>
                 <a:spcPts val="0"/>
@@ -4202,16 +4194,16 @@
                 <a:solidFill>
                   <a:srgbClr val="1A1A1A"/>
                 </a:solidFill>
-                <a:latin typeface="Calibri"/>
-                <a:rFonts ascii="Calibri" hAnsi="Calibri" cs="Calibri"/>
+                <a:latin typeface="Manrope"/>
+                <a:rFonts ascii="Manrope" hAnsi="Manrope" cs="Manrope" eastAsia="Manrope"/>
               </a:rPr>
               <a:t>Срок пилота — «на складе»</a:t>
             </a:r>
           </a:p>
           <a:p>
-            <a:pPr>
-              <a:lnSpc>
-                <a:spcPct val="115000"/>
+            <a:pPr algn="l">
+              <a:lnSpc>
+                <a:spcPct val="118000"/>
               </a:lnSpc>
               <a:spcBef>
                 <a:spcPts val="0"/>
@@ -4225,8 +4217,8 @@
                 <a:solidFill>
                   <a:srgbClr val="1A1A1A"/>
                 </a:solidFill>
-                <a:latin typeface="Calibri"/>
-                <a:rFonts ascii="Calibri" hAnsi="Calibri" cs="Calibri"/>
+                <a:latin typeface="Golos Text"/>
+                <a:rFonts ascii="Golos Text" hAnsi="Golos Text" cs="Golos Text" eastAsia="Golos Text"/>
               </a:rPr>
               <a:t>Origin не ясен → не говорим «российское»</a:t>
             </a:r>
@@ -4364,8 +4356,8 @@
                 <a:solidFill>
                   <a:srgbClr val="2A554A"/>
                 </a:solidFill>
-                <a:latin typeface="Calibri"/>
-                <a:rFonts ascii="Calibri" hAnsi="Calibri" cs="Calibri"/>
+                <a:latin typeface="Manrope"/>
+                <a:rFonts ascii="Manrope" hAnsi="Manrope" cs="Manrope" eastAsia="Manrope"/>
               </a:rPr>
               <a:t>Что уже есть в пульте</a:t>
             </a:r>
@@ -4485,10 +4477,10 @@
                 <a:solidFill>
                   <a:srgbClr val="5C5C5C"/>
                 </a:solidFill>
-                <a:latin typeface="Calibri"/>
-                <a:rFonts ascii="Calibri" hAnsi="Calibri" cs="Calibri"/>
-              </a:rPr>
-              <a:t>Travel+ Natural  ·  пульт v1.14  ·  собеседование  ·  не оферта</a:t>
+                <a:latin typeface="Golos Text"/>
+                <a:rFonts ascii="Golos Text" hAnsi="Golos Text" cs="Golos Text" eastAsia="Golos Text"/>
+              </a:rPr>
+              <a:t>Travel+ Natural  ·  образец презентации</a:t>
             </a:r>
           </a:p>
         </p:txBody>
@@ -4521,8 +4513,8 @@
                 <a:solidFill>
                   <a:srgbClr val="5C5C5C"/>
                 </a:solidFill>
-                <a:latin typeface="Calibri"/>
-                <a:rFonts ascii="Calibri" hAnsi="Calibri" cs="Calibri"/>
+                <a:latin typeface="Golos Text"/>
+                <a:rFonts ascii="Golos Text" hAnsi="Golos Text" cs="Golos Text" eastAsia="Golos Text"/>
               </a:rPr>
               <a:t>11 / 12</a:t>
             </a:r>
@@ -4585,7 +4577,7 @@
         <p:spPr>
           <a:xfrm>
             <a:off x="457200" y="960120"/>
-            <a:ext cx="5510631" cy="73152"/>
+            <a:ext cx="5510631" cy="82296"/>
           </a:xfrm>
           <a:prstGeom prst="rect">
             <a:avLst/>
@@ -4675,7 +4667,7 @@
         <p:spPr>
           <a:xfrm>
             <a:off x="6223863" y="960120"/>
-            <a:ext cx="5510631" cy="73152"/>
+            <a:ext cx="5510631" cy="82296"/>
           </a:xfrm>
           <a:prstGeom prst="rect">
             <a:avLst/>
@@ -4717,8 +4709,8 @@
         </p:nvSpPr>
         <p:spPr>
           <a:xfrm>
-            <a:off x="749808" y="1216152"/>
-            <a:ext cx="4925415" cy="4663440"/>
+            <a:off x="804672" y="1426464"/>
+            <a:ext cx="4815687" cy="4334256"/>
           </a:xfrm>
           <a:prstGeom prst="rect">
             <a:avLst/>
@@ -4726,20 +4718,18 @@
           <a:noFill/>
         </p:spPr>
         <p:txBody>
-          <a:bodyPr wrap="square">
-            <a:spAutoFit/>
-          </a:bodyPr>
-          <a:lstStyle/>
-          <a:p>
-            <a:pPr>
-              <a:lnSpc>
-                <a:spcPct val="115000"/>
-              </a:lnSpc>
-              <a:spcBef>
-                <a:spcPts val="0"/>
-              </a:spcBef>
-              <a:spcAft>
-                <a:spcPts val="1400"/>
+          <a:bodyPr wrap="square" anchor="t" lIns="50800" rIns="50800" tIns="25400" bIns="25400"/>
+          <a:lstStyle/>
+          <a:p>
+            <a:pPr algn="l">
+              <a:lnSpc>
+                <a:spcPct val="118000"/>
+              </a:lnSpc>
+              <a:spcBef>
+                <a:spcPts val="0"/>
+              </a:spcBef>
+              <a:spcAft>
+                <a:spcPts val="1200"/>
               </a:spcAft>
             </a:pPr>
             <a:r>
@@ -4747,16 +4737,16 @@
                 <a:solidFill>
                   <a:srgbClr val="2A554A"/>
                 </a:solidFill>
-                <a:latin typeface="Calibri"/>
-                <a:rFonts ascii="Calibri" hAnsi="Calibri" cs="Calibri"/>
+                <a:latin typeface="Manrope"/>
+                <a:rFonts ascii="Manrope" hAnsi="Manrope" cs="Manrope" eastAsia="Manrope"/>
               </a:rPr>
               <a:t>Содержание</a:t>
             </a:r>
           </a:p>
           <a:p>
-            <a:pPr>
-              <a:lnSpc>
-                <a:spcPct val="115000"/>
+            <a:pPr algn="l">
+              <a:lnSpc>
+                <a:spcPct val="118000"/>
               </a:lnSpc>
               <a:spcBef>
                 <a:spcPts val="0"/>
@@ -4770,16 +4760,16 @@
                 <a:solidFill>
                   <a:srgbClr val="1A1A1A"/>
                 </a:solidFill>
-                <a:latin typeface="Calibri"/>
-                <a:rFonts ascii="Calibri" hAnsi="Calibri" cs="Calibri"/>
+                <a:latin typeface="Golos Text"/>
+                <a:rFonts ascii="Golos Text" hAnsi="Golos Text" cs="Golos Text" eastAsia="Golos Text"/>
               </a:rPr>
               <a:t>Этапы 0–2 — разведка и правила</a:t>
             </a:r>
           </a:p>
           <a:p>
-            <a:pPr>
-              <a:lnSpc>
-                <a:spcPct val="115000"/>
+            <a:pPr algn="l">
+              <a:lnSpc>
+                <a:spcPct val="118000"/>
               </a:lnSpc>
               <a:spcBef>
                 <a:spcPts val="0"/>
@@ -4793,16 +4783,16 @@
                 <a:solidFill>
                   <a:srgbClr val="1A1A1A"/>
                 </a:solidFill>
-                <a:latin typeface="Calibri"/>
-                <a:rFonts ascii="Calibri" hAnsi="Calibri" cs="Calibri"/>
+                <a:latin typeface="Golos Text"/>
+                <a:rFonts ascii="Golos Text" hAnsi="Golos Text" cs="Golos Text" eastAsia="Golos Text"/>
               </a:rPr>
               <a:t>Этапы 3–6 — сценарий «как вести дело»</a:t>
             </a:r>
           </a:p>
           <a:p>
-            <a:pPr>
-              <a:lnSpc>
-                <a:spcPct val="115000"/>
+            <a:pPr algn="l">
+              <a:lnSpc>
+                <a:spcPct val="118000"/>
               </a:lnSpc>
               <a:spcBef>
                 <a:spcPts val="0"/>
@@ -4816,16 +4806,16 @@
                 <a:solidFill>
                   <a:srgbClr val="1A1A1A"/>
                 </a:solidFill>
-                <a:latin typeface="Calibri"/>
-                <a:rFonts ascii="Calibri" hAnsi="Calibri" cs="Calibri"/>
+                <a:latin typeface="Golos Text"/>
+                <a:rFonts ascii="Golos Text" hAnsi="Golos Text" cs="Golos Text" eastAsia="Golos Text"/>
               </a:rPr>
               <a:t>StoryBrand · DoD · риски · возврат</a:t>
             </a:r>
           </a:p>
           <a:p>
-            <a:pPr>
-              <a:lnSpc>
-                <a:spcPct val="115000"/>
+            <a:pPr algn="l">
+              <a:lnSpc>
+                <a:spcPct val="118000"/>
               </a:lnSpc>
               <a:spcBef>
                 <a:spcPts val="0"/>
@@ -4839,8 +4829,8 @@
                 <a:solidFill>
                   <a:srgbClr val="1A1A1A"/>
                 </a:solidFill>
-                <a:latin typeface="Calibri"/>
-                <a:rFonts ascii="Calibri" hAnsi="Calibri" cs="Calibri"/>
+                <a:latin typeface="Golos Text"/>
+                <a:rFonts ascii="Golos Text" hAnsi="Golos Text" cs="Golos Text" eastAsia="Golos Text"/>
               </a:rPr>
               <a:t>Мостик портфеля Travel+</a:t>
             </a:r>
@@ -4855,8 +4845,8 @@
         </p:nvSpPr>
         <p:spPr>
           <a:xfrm>
-            <a:off x="6516471" y="1216152"/>
-            <a:ext cx="4925415" cy="4663440"/>
+            <a:off x="6571335" y="1426464"/>
+            <a:ext cx="4815687" cy="4334256"/>
           </a:xfrm>
           <a:prstGeom prst="rect">
             <a:avLst/>
@@ -4864,14 +4854,58 @@
           <a:noFill/>
         </p:spPr>
         <p:txBody>
-          <a:bodyPr wrap="square">
-            <a:spAutoFit/>
-          </a:bodyPr>
-          <a:lstStyle/>
-          <a:p>
-            <a:pPr>
-              <a:lnSpc>
-                <a:spcPct val="115000"/>
+          <a:bodyPr wrap="square" anchor="t" lIns="50800" rIns="50800" tIns="25400" bIns="25400"/>
+          <a:lstStyle/>
+          <a:p>
+            <a:pPr algn="l">
+              <a:lnSpc>
+                <a:spcPct val="118000"/>
+              </a:lnSpc>
+              <a:spcBef>
+                <a:spcPts val="0"/>
+              </a:spcBef>
+              <a:spcAft>
+                <a:spcPts val="1200"/>
+              </a:spcAft>
+            </a:pPr>
+            <a:r>
+              <a:rPr sz="1500" b="1">
+                <a:solidFill>
+                  <a:srgbClr val="2A554A"/>
+                </a:solidFill>
+                <a:latin typeface="Manrope"/>
+                <a:rFonts ascii="Manrope" hAnsi="Manrope" cs="Manrope" eastAsia="Manrope"/>
+              </a:rPr>
+              <a:t>Справочники</a:t>
+            </a:r>
+          </a:p>
+          <a:p>
+            <a:pPr algn="l">
+              <a:lnSpc>
+                <a:spcPct val="118000"/>
+              </a:lnSpc>
+              <a:spcBef>
+                <a:spcPts val="0"/>
+              </a:spcBef>
+              <a:spcAft>
+                <a:spcPts val="800"/>
+              </a:spcAft>
+            </a:pPr>
+            <a:r>
+              <a:rPr sz="1600" b="0">
+                <a:solidFill>
+                  <a:srgbClr val="1A1A1A"/>
+                </a:solidFill>
+                <a:latin typeface="Golos Text"/>
+                <a:rFonts ascii="Golos Text" hAnsi="Golos Text" cs="Golos Text" eastAsia="Golos Text"/>
+              </a:rPr>
+              <a:t>Глоссарий бренда + глоссарий ВЭД</a:t>
+            </a:r>
+          </a:p>
+          <a:p>
+            <a:pPr algn="l">
+              <a:lnSpc>
+                <a:spcPct val="118000"/>
               </a:lnSpc>
               <a:spcBef>
                 <a:spcPts val="0"/>
@@ -4881,20 +4915,20 @@
               </a:spcAft>
             </a:pPr>
             <a:r>
-              <a:rPr sz="1500" b="1">
-                <a:solidFill>
-                  <a:srgbClr val="2A554A"/>
-                </a:solidFill>
-                <a:latin typeface="Calibri"/>
-                <a:rFonts ascii="Calibri" hAnsi="Calibri" cs="Calibri"/>
-              </a:rPr>
-              <a:t>Справочники</a:t>
-            </a:r>
-          </a:p>
-          <a:p>
-            <a:pPr>
-              <a:lnSpc>
-                <a:spcPct val="115000"/>
+              <a:rPr sz="1600" b="0">
+                <a:solidFill>
+                  <a:srgbClr val="1A1A1A"/>
+                </a:solidFill>
+                <a:latin typeface="Golos Text"/>
+                <a:rFonts ascii="Golos Text" hAnsi="Golos Text" cs="Golos Text" eastAsia="Golos Text"/>
+              </a:rPr>
+              <a:t>Раздел L: путь · Incoterms · RFQ</a:t>
+            </a:r>
+          </a:p>
+          <a:p>
+            <a:pPr algn="l">
+              <a:lnSpc>
+                <a:spcPct val="118000"/>
               </a:lnSpc>
               <a:spcBef>
                 <a:spcPts val="0"/>
@@ -4908,77 +4942,31 @@
                 <a:solidFill>
                   <a:srgbClr val="1A1A1A"/>
                 </a:solidFill>
-                <a:latin typeface="Calibri"/>
-                <a:rFonts ascii="Calibri" hAnsi="Calibri" cs="Calibri"/>
-              </a:rPr>
-              <a:t>Глоссарий бренда + глоссарий ВЭД</a:t>
-            </a:r>
-          </a:p>
-          <a:p>
-            <a:pPr>
-              <a:lnSpc>
-                <a:spcPct val="115000"/>
-              </a:lnSpc>
-              <a:spcBef>
-                <a:spcPts val="0"/>
-              </a:spcBef>
-              <a:spcAft>
-                <a:spcPts val="1400"/>
-              </a:spcAft>
-            </a:pPr>
-            <a:r>
-              <a:rPr sz="1600" b="0">
+                <a:latin typeface="Golos Text"/>
+                <a:rFonts ascii="Golos Text" hAnsi="Golos Text" cs="Golos Text" eastAsia="Golos Text"/>
+              </a:rPr>
+              <a:t>Статус: рамка для поля и собеседования.</a:t>
+            </a:r>
+          </a:p>
+          <a:p>
+            <a:pPr algn="l">
+              <a:lnSpc>
+                <a:spcPct val="118000"/>
+              </a:lnSpc>
+              <a:spcBef>
+                <a:spcPts val="0"/>
+              </a:spcBef>
+              <a:spcAft>
+                <a:spcPts val="800"/>
+              </a:spcAft>
+            </a:pPr>
+            <a:r>
+              <a:rPr sz="1600" b="1">
                 <a:solidFill>
                   <a:srgbClr val="1A1A1A"/>
                 </a:solidFill>
-                <a:latin typeface="Calibri"/>
-                <a:rFonts ascii="Calibri" hAnsi="Calibri" cs="Calibri"/>
-              </a:rPr>
-              <a:t>Раздел L: путь · Incoterms · RFQ</a:t>
-            </a:r>
-          </a:p>
-          <a:p>
-            <a:pPr>
-              <a:lnSpc>
-                <a:spcPct val="115000"/>
-              </a:lnSpc>
-              <a:spcBef>
-                <a:spcPts val="0"/>
-              </a:spcBef>
-              <a:spcAft>
-                <a:spcPts val="800"/>
-              </a:spcAft>
-            </a:pPr>
-            <a:r>
-              <a:rPr sz="1600" b="0">
-                <a:solidFill>
-                  <a:srgbClr val="1A1A1A"/>
-                </a:solidFill>
-                <a:latin typeface="Calibri"/>
-                <a:rFonts ascii="Calibri" hAnsi="Calibri" cs="Calibri"/>
-              </a:rPr>
-              <a:t>Статус: рамка для поля и собеседования.</a:t>
-            </a:r>
-          </a:p>
-          <a:p>
-            <a:pPr>
-              <a:lnSpc>
-                <a:spcPct val="115000"/>
-              </a:lnSpc>
-              <a:spcBef>
-                <a:spcPts val="0"/>
-              </a:spcBef>
-              <a:spcAft>
-                <a:spcPts val="800"/>
-              </a:spcAft>
-            </a:pPr>
-            <a:r>
-              <a:rPr sz="1600" b="1">
-                <a:solidFill>
-                  <a:srgbClr val="1A1A1A"/>
-                </a:solidFill>
-                <a:latin typeface="Calibri"/>
-                <a:rFonts ascii="Calibri" hAnsi="Calibri" cs="Calibri"/>
+                <a:latin typeface="Manrope"/>
+                <a:rFonts ascii="Manrope" hAnsi="Manrope" cs="Manrope" eastAsia="Manrope"/>
               </a:rPr>
               <a:t>v2.0 — когда технолог даст цифры.</a:t>
             </a:r>
@@ -5116,8 +5104,8 @@
                 <a:solidFill>
                   <a:srgbClr val="2A554A"/>
                 </a:solidFill>
-                <a:latin typeface="Calibri"/>
-                <a:rFonts ascii="Calibri" hAnsi="Calibri" cs="Calibri"/>
+                <a:latin typeface="Manrope"/>
+                <a:rFonts ascii="Manrope" hAnsi="Manrope" cs="Manrope" eastAsia="Manrope"/>
               </a:rPr>
               <a:t>Итог и следующий шаг</a:t>
             </a:r>
@@ -5237,10 +5225,10 @@
                 <a:solidFill>
                   <a:srgbClr val="5C5C5C"/>
                 </a:solidFill>
-                <a:latin typeface="Calibri"/>
-                <a:rFonts ascii="Calibri" hAnsi="Calibri" cs="Calibri"/>
-              </a:rPr>
-              <a:t>Travel+ Natural  ·  пульт v1.14  ·  собеседование  ·  не оферта</a:t>
+                <a:latin typeface="Golos Text"/>
+                <a:rFonts ascii="Golos Text" hAnsi="Golos Text" cs="Golos Text" eastAsia="Golos Text"/>
+              </a:rPr>
+              <a:t>Travel+ Natural  ·  образец презентации</a:t>
             </a:r>
           </a:p>
         </p:txBody>
@@ -5273,8 +5261,8 @@
                 <a:solidFill>
                   <a:srgbClr val="5C5C5C"/>
                 </a:solidFill>
-                <a:latin typeface="Calibri"/>
-                <a:rFonts ascii="Calibri" hAnsi="Calibri" cs="Calibri"/>
+                <a:latin typeface="Golos Text"/>
+                <a:rFonts ascii="Golos Text" hAnsi="Golos Text" cs="Golos Text" eastAsia="Golos Text"/>
               </a:rPr>
               <a:t>12 / 12</a:t>
             </a:r>
@@ -5337,7 +5325,7 @@
         <p:spPr>
           <a:xfrm>
             <a:off x="457200" y="960120"/>
-            <a:ext cx="5510631" cy="73152"/>
+            <a:ext cx="5510631" cy="82296"/>
           </a:xfrm>
           <a:prstGeom prst="rect">
             <a:avLst/>
@@ -5427,7 +5415,7 @@
         <p:spPr>
           <a:xfrm>
             <a:off x="6223863" y="960120"/>
-            <a:ext cx="5510631" cy="73152"/>
+            <a:ext cx="5510631" cy="82296"/>
           </a:xfrm>
           <a:prstGeom prst="rect">
             <a:avLst/>
@@ -5469,8 +5457,8 @@
         </p:nvSpPr>
         <p:spPr>
           <a:xfrm>
-            <a:off x="749808" y="1216152"/>
-            <a:ext cx="4925415" cy="4663440"/>
+            <a:off x="804672" y="1426464"/>
+            <a:ext cx="4815687" cy="4334256"/>
           </a:xfrm>
           <a:prstGeom prst="rect">
             <a:avLst/>
@@ -5478,14 +5466,81 @@
           <a:noFill/>
         </p:spPr>
         <p:txBody>
-          <a:bodyPr wrap="square">
-            <a:spAutoFit/>
-          </a:bodyPr>
-          <a:lstStyle/>
-          <a:p>
-            <a:pPr>
-              <a:lnSpc>
-                <a:spcPct val="115000"/>
+          <a:bodyPr wrap="square" anchor="t" lIns="50800" rIns="50800" tIns="25400" bIns="25400"/>
+          <a:lstStyle/>
+          <a:p>
+            <a:pPr algn="l">
+              <a:lnSpc>
+                <a:spcPct val="118000"/>
+              </a:lnSpc>
+              <a:spcBef>
+                <a:spcPts val="0"/>
+              </a:spcBef>
+              <a:spcAft>
+                <a:spcPts val="1200"/>
+              </a:spcAft>
+            </a:pPr>
+            <a:r>
+              <a:rPr sz="1500" b="1">
+                <a:solidFill>
+                  <a:srgbClr val="2A554A"/>
+                </a:solidFill>
+                <a:latin typeface="Manrope"/>
+                <a:rFonts ascii="Manrope" hAnsi="Manrope" cs="Manrope" eastAsia="Manrope"/>
+              </a:rPr>
+              <a:t>Собрал</a:t>
+            </a:r>
+          </a:p>
+          <a:p>
+            <a:pPr algn="l">
+              <a:lnSpc>
+                <a:spcPct val="118000"/>
+              </a:lnSpc>
+              <a:spcBef>
+                <a:spcPts val="0"/>
+              </a:spcBef>
+              <a:spcAft>
+                <a:spcPts val="800"/>
+              </a:spcAft>
+            </a:pPr>
+            <a:r>
+              <a:rPr sz="1600" b="0">
+                <a:solidFill>
+                  <a:srgbClr val="1A1A1A"/>
+                </a:solidFill>
+                <a:latin typeface="Golos Text"/>
+                <a:rFonts ascii="Golos Text" hAnsi="Golos Text" cs="Golos Text" eastAsia="Golos Text"/>
+              </a:rPr>
+              <a:t>ДНК + StoryBrand + DoD</a:t>
+            </a:r>
+          </a:p>
+          <a:p>
+            <a:pPr algn="l">
+              <a:lnSpc>
+                <a:spcPct val="118000"/>
+              </a:lnSpc>
+              <a:spcBef>
+                <a:spcPts val="0"/>
+              </a:spcBef>
+              <a:spcAft>
+                <a:spcPts val="800"/>
+              </a:spcAft>
+            </a:pPr>
+            <a:r>
+              <a:rPr sz="1600" b="0">
+                <a:solidFill>
+                  <a:srgbClr val="1A1A1A"/>
+                </a:solidFill>
+                <a:latin typeface="Golos Text"/>
+                <a:rFonts ascii="Golos Text" hAnsi="Golos Text" cs="Golos Text" eastAsia="Golos Text"/>
+              </a:rPr>
+              <a:t>Полевая защита</a:t>
+            </a:r>
+          </a:p>
+          <a:p>
+            <a:pPr algn="l">
+              <a:lnSpc>
+                <a:spcPct val="118000"/>
               </a:lnSpc>
               <a:spcBef>
                 <a:spcPts val="0"/>
@@ -5495,89 +5550,20 @@
               </a:spcAft>
             </a:pPr>
             <a:r>
-              <a:rPr sz="1500" b="1">
-                <a:solidFill>
-                  <a:srgbClr val="2A554A"/>
-                </a:solidFill>
-                <a:latin typeface="Calibri"/>
-                <a:rFonts ascii="Calibri" hAnsi="Calibri" cs="Calibri"/>
-              </a:rPr>
-              <a:t>Собрал</a:t>
-            </a:r>
-          </a:p>
-          <a:p>
-            <a:pPr>
-              <a:lnSpc>
-                <a:spcPct val="115000"/>
-              </a:lnSpc>
-              <a:spcBef>
-                <a:spcPts val="0"/>
-              </a:spcBef>
-              <a:spcAft>
-                <a:spcPts val="800"/>
-              </a:spcAft>
-            </a:pPr>
-            <a:r>
               <a:rPr sz="1600" b="0">
                 <a:solidFill>
                   <a:srgbClr val="1A1A1A"/>
                 </a:solidFill>
-                <a:latin typeface="Calibri"/>
-                <a:rFonts ascii="Calibri" hAnsi="Calibri" cs="Calibri"/>
-              </a:rPr>
-              <a:t>ДНК + StoryBrand + DoD</a:t>
-            </a:r>
-          </a:p>
-          <a:p>
-            <a:pPr>
-              <a:lnSpc>
-                <a:spcPct val="115000"/>
-              </a:lnSpc>
-              <a:spcBef>
-                <a:spcPts val="0"/>
-              </a:spcBef>
-              <a:spcAft>
-                <a:spcPts val="800"/>
-              </a:spcAft>
-            </a:pPr>
-            <a:r>
-              <a:rPr sz="1600" b="0">
-                <a:solidFill>
-                  <a:srgbClr val="1A1A1A"/>
-                </a:solidFill>
-                <a:latin typeface="Calibri"/>
-                <a:rFonts ascii="Calibri" hAnsi="Calibri" cs="Calibri"/>
-              </a:rPr>
-              <a:t>Полевая защита</a:t>
-            </a:r>
-          </a:p>
-          <a:p>
-            <a:pPr>
-              <a:lnSpc>
-                <a:spcPct val="115000"/>
-              </a:lnSpc>
-              <a:spcBef>
-                <a:spcPts val="0"/>
-              </a:spcBef>
-              <a:spcAft>
-                <a:spcPts val="1400"/>
-              </a:spcAft>
-            </a:pPr>
-            <a:r>
-              <a:rPr sz="1600" b="0">
-                <a:solidFill>
-                  <a:srgbClr val="1A1A1A"/>
-                </a:solidFill>
-                <a:latin typeface="Calibri"/>
-                <a:rFonts ascii="Calibri" hAnsi="Calibri" cs="Calibri"/>
+                <a:latin typeface="Golos Text"/>
+                <a:rFonts ascii="Golos Text" hAnsi="Golos Text" cs="Golos Text" eastAsia="Golos Text"/>
               </a:rPr>
               <a:t>Чеклист поставок при Китае (раздел L)</a:t>
             </a:r>
           </a:p>
           <a:p>
-            <a:pPr>
-              <a:lnSpc>
-                <a:spcPct val="115000"/>
+            <a:pPr algn="l">
+              <a:lnSpc>
+                <a:spcPct val="118000"/>
               </a:lnSpc>
               <a:spcBef>
                 <a:spcPts val="0"/>
@@ -5591,8 +5577,8 @@
                 <a:solidFill>
                   <a:srgbClr val="5C5C5C"/>
                 </a:solidFill>
-                <a:latin typeface="Calibri"/>
-                <a:rFonts ascii="Calibri" hAnsi="Calibri" cs="Calibri"/>
+                <a:latin typeface="Golos Text"/>
+                <a:rFonts ascii="Golos Text" hAnsi="Golos Text" cs="Golos Text" eastAsia="Golos Text"/>
               </a:rPr>
               <a:t>Не прайс завода. Не КП.</a:t>
             </a:r>
@@ -5607,8 +5593,8 @@
         </p:nvSpPr>
         <p:spPr>
           <a:xfrm>
-            <a:off x="6516471" y="1216152"/>
-            <a:ext cx="4925415" cy="4663440"/>
+            <a:off x="6571335" y="1426464"/>
+            <a:ext cx="4815687" cy="4334256"/>
           </a:xfrm>
           <a:prstGeom prst="rect">
             <a:avLst/>
@@ -5616,14 +5602,81 @@
           <a:noFill/>
         </p:spPr>
         <p:txBody>
-          <a:bodyPr wrap="square">
-            <a:spAutoFit/>
-          </a:bodyPr>
-          <a:lstStyle/>
-          <a:p>
-            <a:pPr>
-              <a:lnSpc>
-                <a:spcPct val="115000"/>
+          <a:bodyPr wrap="square" anchor="t" lIns="50800" rIns="50800" tIns="25400" bIns="25400"/>
+          <a:lstStyle/>
+          <a:p>
+            <a:pPr algn="l">
+              <a:lnSpc>
+                <a:spcPct val="118000"/>
+              </a:lnSpc>
+              <a:spcBef>
+                <a:spcPts val="0"/>
+              </a:spcBef>
+              <a:spcAft>
+                <a:spcPts val="1200"/>
+              </a:spcAft>
+            </a:pPr>
+            <a:r>
+              <a:rPr sz="1500" b="1">
+                <a:solidFill>
+                  <a:srgbClr val="2A554A"/>
+                </a:solidFill>
+                <a:latin typeface="Manrope"/>
+                <a:rFonts ascii="Manrope" hAnsi="Manrope" cs="Manrope" eastAsia="Manrope"/>
+              </a:rPr>
+              <a:t>Готов обсудить</a:t>
+            </a:r>
+          </a:p>
+          <a:p>
+            <a:pPr algn="l">
+              <a:lnSpc>
+                <a:spcPct val="118000"/>
+              </a:lnSpc>
+              <a:spcBef>
+                <a:spcPts val="0"/>
+              </a:spcBef>
+              <a:spcAft>
+                <a:spcPts val="800"/>
+              </a:spcAft>
+            </a:pPr>
+            <a:r>
+              <a:rPr sz="1600" b="0">
+                <a:solidFill>
+                  <a:srgbClr val="1A1A1A"/>
+                </a:solidFill>
+                <a:latin typeface="Golos Text"/>
+                <a:rFonts ascii="Golos Text" hAnsi="Golos Text" cs="Golos Text" eastAsia="Golos Text"/>
+              </a:rPr>
+              <a:t>1) Приоритет блокеров этапа 2 с технологом</a:t>
+            </a:r>
+          </a:p>
+          <a:p>
+            <a:pPr algn="l">
+              <a:lnSpc>
+                <a:spcPct val="118000"/>
+              </a:lnSpc>
+              <a:spcBef>
+                <a:spcPts val="0"/>
+              </a:spcBef>
+              <a:spcAft>
+                <a:spcPts val="800"/>
+              </a:spcAft>
+            </a:pPr>
+            <a:r>
+              <a:rPr sz="1600" b="0">
+                <a:solidFill>
+                  <a:srgbClr val="1A1A1A"/>
+                </a:solidFill>
+                <a:latin typeface="Golos Text"/>
+                <a:rFonts ascii="Golos Text" hAnsi="Golos Text" cs="Golos Text" eastAsia="Golos Text"/>
+              </a:rPr>
+              <a:t>2) Пилотный сегмент eco / wellness</a:t>
+            </a:r>
+          </a:p>
+          <a:p>
+            <a:pPr algn="l">
+              <a:lnSpc>
+                <a:spcPct val="118000"/>
               </a:lnSpc>
               <a:spcBef>
                 <a:spcPts val="0"/>
@@ -5633,20 +5686,20 @@
               </a:spcAft>
             </a:pPr>
             <a:r>
-              <a:rPr sz="1500" b="1">
-                <a:solidFill>
-                  <a:srgbClr val="2A554A"/>
-                </a:solidFill>
-                <a:latin typeface="Calibri"/>
-                <a:rFonts ascii="Calibri" hAnsi="Calibri" cs="Calibri"/>
-              </a:rPr>
-              <a:t>Готов обсудить</a:t>
-            </a:r>
-          </a:p>
-          <a:p>
-            <a:pPr>
-              <a:lnSpc>
-                <a:spcPct val="115000"/>
+              <a:rPr sz="1600" b="0">
+                <a:solidFill>
+                  <a:srgbClr val="1A1A1A"/>
+                </a:solidFill>
+                <a:latin typeface="Golos Text"/>
+                <a:rFonts ascii="Golos Text" hAnsi="Golos Text" cs="Golos Text" eastAsia="Golos Text"/>
+              </a:rPr>
+              <a:t>3) Как вести продажи, чтобы Natural не ушёл в эконом Hotel Line</a:t>
+            </a:r>
+          </a:p>
+          <a:p>
+            <a:pPr algn="l">
+              <a:lnSpc>
+                <a:spcPct val="118000"/>
               </a:lnSpc>
               <a:spcBef>
                 <a:spcPts val="0"/>
@@ -5656,81 +5709,12 @@
               </a:spcAft>
             </a:pPr>
             <a:r>
-              <a:rPr sz="1600" b="0">
+              <a:rPr sz="1600" b="1">
                 <a:solidFill>
                   <a:srgbClr val="1A1A1A"/>
                 </a:solidFill>
-                <a:latin typeface="Calibri"/>
-                <a:rFonts ascii="Calibri" hAnsi="Calibri" cs="Calibri"/>
-              </a:rPr>
-              <a:t>1) Приоритет блокеров этапа 2 с технологом</a:t>
-            </a:r>
-          </a:p>
-          <a:p>
-            <a:pPr>
-              <a:lnSpc>
-                <a:spcPct val="115000"/>
-              </a:lnSpc>
-              <a:spcBef>
-                <a:spcPts val="0"/>
-              </a:spcBef>
-              <a:spcAft>
-                <a:spcPts val="800"/>
-              </a:spcAft>
-            </a:pPr>
-            <a:r>
-              <a:rPr sz="1600" b="0">
-                <a:solidFill>
-                  <a:srgbClr val="1A1A1A"/>
-                </a:solidFill>
-                <a:latin typeface="Calibri"/>
-                <a:rFonts ascii="Calibri" hAnsi="Calibri" cs="Calibri"/>
-              </a:rPr>
-              <a:t>2) Пилотный сегмент eco / wellness</a:t>
-            </a:r>
-          </a:p>
-          <a:p>
-            <a:pPr>
-              <a:lnSpc>
-                <a:spcPct val="115000"/>
-              </a:lnSpc>
-              <a:spcBef>
-                <a:spcPts val="0"/>
-              </a:spcBef>
-              <a:spcAft>
-                <a:spcPts val="1400"/>
-              </a:spcAft>
-            </a:pPr>
-            <a:r>
-              <a:rPr sz="1600" b="0">
-                <a:solidFill>
-                  <a:srgbClr val="1A1A1A"/>
-                </a:solidFill>
-                <a:latin typeface="Calibri"/>
-                <a:rFonts ascii="Calibri" hAnsi="Calibri" cs="Calibri"/>
-              </a:rPr>
-              <a:t>3) Как вести продажи, чтобы Natural не ушёл в эконом Hotel Line</a:t>
-            </a:r>
-          </a:p>
-          <a:p>
-            <a:pPr>
-              <a:lnSpc>
-                <a:spcPct val="115000"/>
-              </a:lnSpc>
-              <a:spcBef>
-                <a:spcPts val="0"/>
-              </a:spcBef>
-              <a:spcAft>
-                <a:spcPts val="800"/>
-              </a:spcAft>
-            </a:pPr>
-            <a:r>
-              <a:rPr sz="1600" b="1">
-                <a:solidFill>
-                  <a:srgbClr val="1A1A1A"/>
-                </a:solidFill>
-                <a:latin typeface="Calibri"/>
-                <a:rFonts ascii="Calibri" hAnsi="Calibri" cs="Calibri"/>
+                <a:latin typeface="Manrope"/>
+                <a:rFonts ascii="Manrope" hAnsi="Manrope" cs="Manrope" eastAsia="Manrope"/>
               </a:rPr>
               <a:t>Спасибо. Вопросы.</a:t>
             </a:r>
@@ -5868,8 +5852,8 @@
                 <a:solidFill>
                   <a:srgbClr val="2A554A"/>
                 </a:solidFill>
-                <a:latin typeface="Calibri"/>
-                <a:rFonts ascii="Calibri" hAnsi="Calibri" cs="Calibri"/>
+                <a:latin typeface="Manrope"/>
+                <a:rFonts ascii="Manrope" hAnsi="Manrope" cs="Manrope" eastAsia="Manrope"/>
               </a:rPr>
               <a:t>Как понял роль</a:t>
             </a:r>
@@ -5989,10 +5973,10 @@
                 <a:solidFill>
                   <a:srgbClr val="5C5C5C"/>
                 </a:solidFill>
-                <a:latin typeface="Calibri"/>
-                <a:rFonts ascii="Calibri" hAnsi="Calibri" cs="Calibri"/>
-              </a:rPr>
-              <a:t>Travel+ Natural  ·  пульт v1.14  ·  собеседование  ·  не оферта</a:t>
+                <a:latin typeface="Golos Text"/>
+                <a:rFonts ascii="Golos Text" hAnsi="Golos Text" cs="Golos Text" eastAsia="Golos Text"/>
+              </a:rPr>
+              <a:t>Travel+ Natural  ·  образец презентации</a:t>
             </a:r>
           </a:p>
         </p:txBody>
@@ -6025,8 +6009,8 @@
                 <a:solidFill>
                   <a:srgbClr val="5C5C5C"/>
                 </a:solidFill>
-                <a:latin typeface="Calibri"/>
-                <a:rFonts ascii="Calibri" hAnsi="Calibri" cs="Calibri"/>
+                <a:latin typeface="Golos Text"/>
+                <a:rFonts ascii="Golos Text" hAnsi="Golos Text" cs="Golos Text" eastAsia="Golos Text"/>
               </a:rPr>
               <a:t>2 / 12</a:t>
             </a:r>
@@ -6089,7 +6073,7 @@
         <p:spPr>
           <a:xfrm>
             <a:off x="457200" y="960120"/>
-            <a:ext cx="5510631" cy="73152"/>
+            <a:ext cx="5510631" cy="82296"/>
           </a:xfrm>
           <a:prstGeom prst="rect">
             <a:avLst/>
@@ -6179,7 +6163,7 @@
         <p:spPr>
           <a:xfrm>
             <a:off x="6223863" y="960120"/>
-            <a:ext cx="5510631" cy="73152"/>
+            <a:ext cx="5510631" cy="82296"/>
           </a:xfrm>
           <a:prstGeom prst="rect">
             <a:avLst/>
@@ -6221,8 +6205,8 @@
         </p:nvSpPr>
         <p:spPr>
           <a:xfrm>
-            <a:off x="749808" y="1216152"/>
-            <a:ext cx="4925415" cy="4663440"/>
+            <a:off x="804672" y="1426464"/>
+            <a:ext cx="4815687" cy="4334256"/>
           </a:xfrm>
           <a:prstGeom prst="rect">
             <a:avLst/>
@@ -6230,14 +6214,104 @@
           <a:noFill/>
         </p:spPr>
         <p:txBody>
-          <a:bodyPr wrap="square">
-            <a:spAutoFit/>
-          </a:bodyPr>
-          <a:lstStyle/>
-          <a:p>
-            <a:pPr>
-              <a:lnSpc>
-                <a:spcPct val="115000"/>
+          <a:bodyPr wrap="square" anchor="t" lIns="50800" rIns="50800" tIns="25400" bIns="25400"/>
+          <a:lstStyle/>
+          <a:p>
+            <a:pPr algn="l">
+              <a:lnSpc>
+                <a:spcPct val="118000"/>
+              </a:lnSpc>
+              <a:spcBef>
+                <a:spcPts val="0"/>
+              </a:spcBef>
+              <a:spcAft>
+                <a:spcPts val="1200"/>
+              </a:spcAft>
+            </a:pPr>
+            <a:r>
+              <a:rPr sz="1500" b="1">
+                <a:solidFill>
+                  <a:srgbClr val="2A554A"/>
+                </a:solidFill>
+                <a:latin typeface="Manrope"/>
+                <a:rFonts ascii="Manrope" hAnsi="Manrope" cs="Manrope" eastAsia="Manrope"/>
+              </a:rPr>
+              <a:t>Travel+</a:t>
+            </a:r>
+          </a:p>
+          <a:p>
+            <a:pPr algn="l">
+              <a:lnSpc>
+                <a:spcPct val="118000"/>
+              </a:lnSpc>
+              <a:spcBef>
+                <a:spcPts val="0"/>
+              </a:spcBef>
+              <a:spcAft>
+                <a:spcPts val="800"/>
+              </a:spcAft>
+            </a:pPr>
+            <a:r>
+              <a:rPr sz="1600" b="0">
+                <a:solidFill>
+                  <a:srgbClr val="1A1A1A"/>
+                </a:solidFill>
+                <a:latin typeface="Golos Text"/>
+                <a:rFonts ascii="Golos Text" hAnsi="Golos Text" cs="Golos Text" eastAsia="Golos Text"/>
+              </a:rPr>
+              <a:t>Производство и one-stop на номер:</a:t>
+            </a:r>
+          </a:p>
+          <a:p>
+            <a:pPr algn="l">
+              <a:lnSpc>
+                <a:spcPct val="118000"/>
+              </a:lnSpc>
+              <a:spcBef>
+                <a:spcPts val="0"/>
+              </a:spcBef>
+              <a:spcAft>
+                <a:spcPts val="800"/>
+              </a:spcAft>
+            </a:pPr>
+            <a:r>
+              <a:rPr sz="1600" b="0">
+                <a:solidFill>
+                  <a:srgbClr val="1A1A1A"/>
+                </a:solidFill>
+                <a:latin typeface="Golos Text"/>
+                <a:rFonts ascii="Golos Text" hAnsi="Golos Text" cs="Golos Text" eastAsia="Golos Text"/>
+              </a:rPr>
+              <a:t>• Косметика</a:t>
+            </a:r>
+          </a:p>
+          <a:p>
+            <a:pPr algn="l">
+              <a:lnSpc>
+                <a:spcPct val="118000"/>
+              </a:lnSpc>
+              <a:spcBef>
+                <a:spcPts val="0"/>
+              </a:spcBef>
+              <a:spcAft>
+                <a:spcPts val="800"/>
+              </a:spcAft>
+            </a:pPr>
+            <a:r>
+              <a:rPr sz="1600" b="0">
+                <a:solidFill>
+                  <a:srgbClr val="1A1A1A"/>
+                </a:solidFill>
+                <a:latin typeface="Golos Text"/>
+                <a:rFonts ascii="Golos Text" hAnsi="Golos Text" cs="Golos Text" eastAsia="Golos Text"/>
+              </a:rPr>
+              <a:t>• Тапочки</a:t>
+            </a:r>
+          </a:p>
+          <a:p>
+            <a:pPr algn="l">
+              <a:lnSpc>
+                <a:spcPct val="118000"/>
               </a:lnSpc>
               <a:spcBef>
                 <a:spcPts val="0"/>
@@ -6247,20 +6321,20 @@
               </a:spcAft>
             </a:pPr>
             <a:r>
-              <a:rPr sz="1500" b="1">
-                <a:solidFill>
-                  <a:srgbClr val="2A554A"/>
-                </a:solidFill>
-                <a:latin typeface="Calibri"/>
-                <a:rFonts ascii="Calibri" hAnsi="Calibri" cs="Calibri"/>
-              </a:rPr>
-              <a:t>Travel+</a:t>
-            </a:r>
-          </a:p>
-          <a:p>
-            <a:pPr>
-              <a:lnSpc>
-                <a:spcPct val="115000"/>
+              <a:rPr sz="1600" b="0">
+                <a:solidFill>
+                  <a:srgbClr val="1A1A1A"/>
+                </a:solidFill>
+                <a:latin typeface="Golos Text"/>
+                <a:rFonts ascii="Golos Text" hAnsi="Golos Text" cs="Golos Text" eastAsia="Golos Text"/>
+              </a:rPr>
+              <a:t>• Наборы</a:t>
+            </a:r>
+          </a:p>
+          <a:p>
+            <a:pPr algn="l">
+              <a:lnSpc>
+                <a:spcPct val="118000"/>
               </a:lnSpc>
               <a:spcBef>
                 <a:spcPts val="0"/>
@@ -6270,127 +6344,35 @@
               </a:spcAft>
             </a:pPr>
             <a:r>
+              <a:rPr sz="1600" b="1">
+                <a:solidFill>
+                  <a:srgbClr val="1A1A1A"/>
+                </a:solidFill>
+                <a:latin typeface="Manrope"/>
+                <a:rFonts ascii="Manrope" hAnsi="Manrope" cs="Manrope" eastAsia="Manrope"/>
+              </a:rPr>
+              <a:t>Не IT-roadmap.</a:t>
+            </a:r>
+          </a:p>
+          <a:p>
+            <a:pPr algn="l">
+              <a:lnSpc>
+                <a:spcPct val="118000"/>
+              </a:lnSpc>
+              <a:spcBef>
+                <a:spcPts val="0"/>
+              </a:spcBef>
+              <a:spcAft>
+                <a:spcPts val="800"/>
+              </a:spcAft>
+            </a:pPr>
+            <a:r>
               <a:rPr sz="1600" b="0">
                 <a:solidFill>
                   <a:srgbClr val="1A1A1A"/>
                 </a:solidFill>
-                <a:latin typeface="Calibri"/>
-                <a:rFonts ascii="Calibri" hAnsi="Calibri" cs="Calibri"/>
-              </a:rPr>
-              <a:t>Производство и one-stop на номер:</a:t>
-            </a:r>
-          </a:p>
-          <a:p>
-            <a:pPr>
-              <a:lnSpc>
-                <a:spcPct val="115000"/>
-              </a:lnSpc>
-              <a:spcBef>
-                <a:spcPts val="0"/>
-              </a:spcBef>
-              <a:spcAft>
-                <a:spcPts val="800"/>
-              </a:spcAft>
-            </a:pPr>
-            <a:r>
-              <a:rPr sz="1600" b="0">
-                <a:solidFill>
-                  <a:srgbClr val="1A1A1A"/>
-                </a:solidFill>
-                <a:latin typeface="Calibri"/>
-                <a:rFonts ascii="Calibri" hAnsi="Calibri" cs="Calibri"/>
-              </a:rPr>
-              <a:t>• Косметика</a:t>
-            </a:r>
-          </a:p>
-          <a:p>
-            <a:pPr>
-              <a:lnSpc>
-                <a:spcPct val="115000"/>
-              </a:lnSpc>
-              <a:spcBef>
-                <a:spcPts val="0"/>
-              </a:spcBef>
-              <a:spcAft>
-                <a:spcPts val="800"/>
-              </a:spcAft>
-            </a:pPr>
-            <a:r>
-              <a:rPr sz="1600" b="0">
-                <a:solidFill>
-                  <a:srgbClr val="1A1A1A"/>
-                </a:solidFill>
-                <a:latin typeface="Calibri"/>
-                <a:rFonts ascii="Calibri" hAnsi="Calibri" cs="Calibri"/>
-              </a:rPr>
-              <a:t>• Тапочки</a:t>
-            </a:r>
-          </a:p>
-          <a:p>
-            <a:pPr>
-              <a:lnSpc>
-                <a:spcPct val="115000"/>
-              </a:lnSpc>
-              <a:spcBef>
-                <a:spcPts val="0"/>
-              </a:spcBef>
-              <a:spcAft>
-                <a:spcPts val="1400"/>
-              </a:spcAft>
-            </a:pPr>
-            <a:r>
-              <a:rPr sz="1600" b="0">
-                <a:solidFill>
-                  <a:srgbClr val="1A1A1A"/>
-                </a:solidFill>
-                <a:latin typeface="Calibri"/>
-                <a:rFonts ascii="Calibri" hAnsi="Calibri" cs="Calibri"/>
-              </a:rPr>
-              <a:t>• Наборы</a:t>
-            </a:r>
-          </a:p>
-          <a:p>
-            <a:pPr>
-              <a:lnSpc>
-                <a:spcPct val="115000"/>
-              </a:lnSpc>
-              <a:spcBef>
-                <a:spcPts val="0"/>
-              </a:spcBef>
-              <a:spcAft>
-                <a:spcPts val="800"/>
-              </a:spcAft>
-            </a:pPr>
-            <a:r>
-              <a:rPr sz="1600" b="1">
-                <a:solidFill>
-                  <a:srgbClr val="1A1A1A"/>
-                </a:solidFill>
-                <a:latin typeface="Calibri"/>
-                <a:rFonts ascii="Calibri" hAnsi="Calibri" cs="Calibri"/>
-              </a:rPr>
-              <a:t>Не IT-roadmap.</a:t>
-            </a:r>
-          </a:p>
-          <a:p>
-            <a:pPr>
-              <a:lnSpc>
-                <a:spcPct val="115000"/>
-              </a:lnSpc>
-              <a:spcBef>
-                <a:spcPts val="0"/>
-              </a:spcBef>
-              <a:spcAft>
-                <a:spcPts val="800"/>
-              </a:spcAft>
-            </a:pPr>
-            <a:r>
-              <a:rPr sz="1600" b="0">
-                <a:solidFill>
-                  <a:srgbClr val="1A1A1A"/>
-                </a:solidFill>
-                <a:latin typeface="Calibri"/>
-                <a:rFonts ascii="Calibri" hAnsi="Calibri" cs="Calibri"/>
+                <a:latin typeface="Golos Text"/>
+                <a:rFonts ascii="Golos Text" hAnsi="Golos Text" cs="Golos Text" eastAsia="Golos Text"/>
               </a:rPr>
               <a:t>Товар от идеи до полки и маржи.</a:t>
             </a:r>
@@ -6405,8 +6387,8 @@
         </p:nvSpPr>
         <p:spPr>
           <a:xfrm>
-            <a:off x="6516471" y="1216152"/>
-            <a:ext cx="4925415" cy="4663440"/>
+            <a:off x="6571335" y="1426464"/>
+            <a:ext cx="4815687" cy="4334256"/>
           </a:xfrm>
           <a:prstGeom prst="rect">
             <a:avLst/>
@@ -6414,20 +6396,18 @@
           <a:noFill/>
         </p:spPr>
         <p:txBody>
-          <a:bodyPr wrap="square">
-            <a:spAutoFit/>
-          </a:bodyPr>
-          <a:lstStyle/>
-          <a:p>
-            <a:pPr>
-              <a:lnSpc>
-                <a:spcPct val="115000"/>
-              </a:lnSpc>
-              <a:spcBef>
-                <a:spcPts val="0"/>
-              </a:spcBef>
-              <a:spcAft>
-                <a:spcPts val="1400"/>
+          <a:bodyPr wrap="square" anchor="t" lIns="50800" rIns="50800" tIns="25400" bIns="25400"/>
+          <a:lstStyle/>
+          <a:p>
+            <a:pPr algn="l">
+              <a:lnSpc>
+                <a:spcPct val="118000"/>
+              </a:lnSpc>
+              <a:spcBef>
+                <a:spcPts val="0"/>
+              </a:spcBef>
+              <a:spcAft>
+                <a:spcPts val="1200"/>
               </a:spcAft>
             </a:pPr>
             <a:r>
@@ -6435,16 +6415,16 @@
                 <a:solidFill>
                   <a:srgbClr val="2A554A"/>
                 </a:solidFill>
-                <a:latin typeface="Calibri"/>
-                <a:rFonts ascii="Calibri" hAnsi="Calibri" cs="Calibri"/>
+                <a:latin typeface="Manrope"/>
+                <a:rFonts ascii="Manrope" hAnsi="Manrope" cs="Manrope" eastAsia="Manrope"/>
               </a:rPr>
               <a:t>Роль здесь</a:t>
             </a:r>
           </a:p>
           <a:p>
-            <a:pPr>
-              <a:lnSpc>
-                <a:spcPct val="115000"/>
+            <a:pPr algn="l">
+              <a:lnSpc>
+                <a:spcPct val="118000"/>
               </a:lnSpc>
               <a:spcBef>
                 <a:spcPts val="0"/>
@@ -6458,16 +6438,16 @@
                 <a:solidFill>
                   <a:srgbClr val="1A1A1A"/>
                 </a:solidFill>
-                <a:latin typeface="Calibri"/>
-                <a:rFonts ascii="Calibri" hAnsi="Calibri" cs="Calibri"/>
+                <a:latin typeface="Golos Text"/>
+                <a:rFonts ascii="Golos Text" hAnsi="Golos Text" cs="Golos Text" eastAsia="Golos Text"/>
               </a:rPr>
               <a:t>• Ассортимент и новинки</a:t>
             </a:r>
           </a:p>
           <a:p>
-            <a:pPr>
-              <a:lnSpc>
-                <a:spcPct val="115000"/>
+            <a:pPr algn="l">
+              <a:lnSpc>
+                <a:spcPct val="118000"/>
               </a:lnSpc>
               <a:spcBef>
                 <a:spcPts val="0"/>
@@ -6481,16 +6461,16 @@
                 <a:solidFill>
                   <a:srgbClr val="1A1A1A"/>
                 </a:solidFill>
-                <a:latin typeface="Calibri"/>
-                <a:rFonts ascii="Calibri" hAnsi="Calibri" cs="Calibri"/>
+                <a:latin typeface="Golos Text"/>
+                <a:rFonts ascii="Golos Text" hAnsi="Golos Text" cs="Golos Text" eastAsia="Golos Text"/>
               </a:rPr>
               <a:t>• Позиция линейки в доме брендов</a:t>
             </a:r>
           </a:p>
           <a:p>
-            <a:pPr>
-              <a:lnSpc>
-                <a:spcPct val="115000"/>
+            <a:pPr algn="l">
+              <a:lnSpc>
+                <a:spcPct val="118000"/>
               </a:lnSpc>
               <a:spcBef>
                 <a:spcPts val="0"/>
@@ -6504,16 +6484,16 @@
                 <a:solidFill>
                   <a:srgbClr val="1A1A1A"/>
                 </a:solidFill>
-                <a:latin typeface="Calibri"/>
-                <a:rFonts ascii="Calibri" hAnsi="Calibri" cs="Calibri"/>
+                <a:latin typeface="Golos Text"/>
+                <a:rFonts ascii="Golos Text" hAnsi="Golos Text" cs="Golos Text" eastAsia="Golos Text"/>
               </a:rPr>
               <a:t>• Продукт и доказательства до витрины</a:t>
             </a:r>
           </a:p>
           <a:p>
-            <a:pPr>
-              <a:lnSpc>
-                <a:spcPct val="115000"/>
+            <a:pPr algn="l">
+              <a:lnSpc>
+                <a:spcPct val="118000"/>
               </a:lnSpc>
               <a:spcBef>
                 <a:spcPts val="0"/>
@@ -6527,8 +6507,8 @@
                 <a:solidFill>
                   <a:srgbClr val="1A1A1A"/>
                 </a:solidFill>
-                <a:latin typeface="Calibri"/>
-                <a:rFonts ascii="Calibri" hAnsi="Calibri" cs="Calibri"/>
+                <a:latin typeface="Golos Text"/>
+                <a:rFonts ascii="Golos Text" hAnsi="Golos Text" cs="Golos Text" eastAsia="Golos Text"/>
               </a:rPr>
               <a:t>• Связка: технолог → продажи → экономика → поставка</a:t>
             </a:r>
@@ -6666,8 +6646,8 @@
                 <a:solidFill>
                   <a:srgbClr val="2A554A"/>
                 </a:solidFill>
-                <a:latin typeface="Calibri"/>
-                <a:rFonts ascii="Calibri" hAnsi="Calibri" cs="Calibri"/>
+                <a:latin typeface="Manrope"/>
+                <a:rFonts ascii="Manrope" hAnsi="Manrope" cs="Manrope" eastAsia="Manrope"/>
               </a:rPr>
               <a:t>Дыра на витрине</a:t>
             </a:r>
@@ -6787,10 +6767,10 @@
                 <a:solidFill>
                   <a:srgbClr val="5C5C5C"/>
                 </a:solidFill>
-                <a:latin typeface="Calibri"/>
-                <a:rFonts ascii="Calibri" hAnsi="Calibri" cs="Calibri"/>
-              </a:rPr>
-              <a:t>Travel+ Natural  ·  пульт v1.14  ·  собеседование  ·  не оферта</a:t>
+                <a:latin typeface="Golos Text"/>
+                <a:rFonts ascii="Golos Text" hAnsi="Golos Text" cs="Golos Text" eastAsia="Golos Text"/>
+              </a:rPr>
+              <a:t>Travel+ Natural  ·  образец презентации</a:t>
             </a:r>
           </a:p>
         </p:txBody>
@@ -6823,8 +6803,8 @@
                 <a:solidFill>
                   <a:srgbClr val="5C5C5C"/>
                 </a:solidFill>
-                <a:latin typeface="Calibri"/>
-                <a:rFonts ascii="Calibri" hAnsi="Calibri" cs="Calibri"/>
+                <a:latin typeface="Golos Text"/>
+                <a:rFonts ascii="Golos Text" hAnsi="Golos Text" cs="Golos Text" eastAsia="Golos Text"/>
               </a:rPr>
               <a:t>3 / 12</a:t>
             </a:r>
@@ -6887,7 +6867,7 @@
         <p:spPr>
           <a:xfrm>
             <a:off x="457200" y="960120"/>
-            <a:ext cx="5510631" cy="73152"/>
+            <a:ext cx="5510631" cy="82296"/>
           </a:xfrm>
           <a:prstGeom prst="rect">
             <a:avLst/>
@@ -6977,7 +6957,7 @@
         <p:spPr>
           <a:xfrm>
             <a:off x="6223863" y="960120"/>
-            <a:ext cx="5510631" cy="73152"/>
+            <a:ext cx="5510631" cy="82296"/>
           </a:xfrm>
           <a:prstGeom prst="rect">
             <a:avLst/>
@@ -7019,8 +6999,8 @@
         </p:nvSpPr>
         <p:spPr>
           <a:xfrm>
-            <a:off x="749808" y="1216152"/>
-            <a:ext cx="4925415" cy="4663440"/>
+            <a:off x="804672" y="1426464"/>
+            <a:ext cx="4815687" cy="4334256"/>
           </a:xfrm>
           <a:prstGeom prst="rect">
             <a:avLst/>
@@ -7028,20 +7008,18 @@
           <a:noFill/>
         </p:spPr>
         <p:txBody>
-          <a:bodyPr wrap="square">
-            <a:spAutoFit/>
-          </a:bodyPr>
-          <a:lstStyle/>
-          <a:p>
-            <a:pPr>
-              <a:lnSpc>
-                <a:spcPct val="115000"/>
-              </a:lnSpc>
-              <a:spcBef>
-                <a:spcPts val="0"/>
-              </a:spcBef>
-              <a:spcAft>
-                <a:spcPts val="1400"/>
+          <a:bodyPr wrap="square" anchor="t" lIns="50800" rIns="50800" tIns="25400" bIns="25400"/>
+          <a:lstStyle/>
+          <a:p>
+            <a:pPr algn="l">
+              <a:lnSpc>
+                <a:spcPct val="118000"/>
+              </a:lnSpc>
+              <a:spcBef>
+                <a:spcPts val="0"/>
+              </a:spcBef>
+              <a:spcAft>
+                <a:spcPts val="1200"/>
               </a:spcAft>
             </a:pPr>
             <a:r>
@@ -7049,16 +7027,16 @@
                 <a:solidFill>
                   <a:srgbClr val="2A554A"/>
                 </a:solidFill>
-                <a:latin typeface="Calibri"/>
-                <a:rFonts ascii="Calibri" hAnsi="Calibri" cs="Calibri"/>
+                <a:latin typeface="Manrope"/>
+                <a:rFonts ascii="Manrope" hAnsi="Manrope" cs="Manrope" eastAsia="Manrope"/>
               </a:rPr>
               <a:t>Рынок</a:t>
             </a:r>
           </a:p>
           <a:p>
-            <a:pPr>
-              <a:lnSpc>
-                <a:spcPct val="115000"/>
+            <a:pPr algn="l">
+              <a:lnSpc>
+                <a:spcPct val="118000"/>
               </a:lnSpc>
               <a:spcBef>
                 <a:spcPts val="0"/>
@@ -7072,16 +7050,16 @@
                 <a:solidFill>
                   <a:srgbClr val="1A1A1A"/>
                 </a:solidFill>
-                <a:latin typeface="Calibri"/>
-                <a:rFonts ascii="Calibri" hAnsi="Calibri" cs="Calibri"/>
+                <a:latin typeface="Golos Text"/>
+                <a:rFonts ascii="Golos Text" hAnsi="Golos Text" cs="Golos Text" eastAsia="Golos Text"/>
               </a:rPr>
               <a:t>Конкуренты: ЕТС Natural · MEZO · NS</a:t>
             </a:r>
           </a:p>
           <a:p>
-            <a:pPr>
-              <a:lnSpc>
-                <a:spcPct val="115000"/>
+            <a:pPr algn="l">
+              <a:lnSpc>
+                <a:spcPct val="118000"/>
               </a:lnSpc>
               <a:spcBef>
                 <a:spcPts val="0"/>
@@ -7095,16 +7073,16 @@
                 <a:solidFill>
                   <a:srgbClr val="5C5C5C"/>
                 </a:solidFill>
-                <a:latin typeface="Calibri"/>
-                <a:rFonts ascii="Calibri" hAnsi="Calibri" cs="Calibri"/>
+                <a:latin typeface="Golos Text"/>
+                <a:rFonts ascii="Golos Text" hAnsi="Golos Text" cs="Golos Text" eastAsia="Golos Text"/>
               </a:rPr>
               <a:t>(NS — чужой premium в каталоге)</a:t>
             </a:r>
           </a:p>
           <a:p>
-            <a:pPr>
-              <a:lnSpc>
-                <a:spcPct val="115000"/>
+            <a:pPr algn="l">
+              <a:lnSpc>
+                <a:spcPct val="118000"/>
               </a:lnSpc>
               <a:spcBef>
                 <a:spcPts val="0"/>
@@ -7118,16 +7096,16 @@
                 <a:solidFill>
                   <a:srgbClr val="1A1A1A"/>
                 </a:solidFill>
-                <a:latin typeface="Calibri"/>
-                <a:rFonts ascii="Calibri" hAnsi="Calibri" cs="Calibri"/>
+                <a:latin typeface="Golos Text"/>
+                <a:rFonts ascii="Golos Text" hAnsi="Golos Text" cs="Golos Text" eastAsia="Golos Text"/>
               </a:rPr>
               <a:t>Travel+ силён в масс и среднем.</a:t>
             </a:r>
           </a:p>
           <a:p>
-            <a:pPr>
-              <a:lnSpc>
-                <a:spcPct val="115000"/>
+            <a:pPr algn="l">
+              <a:lnSpc>
+                <a:spcPct val="118000"/>
               </a:lnSpc>
               <a:spcBef>
                 <a:spcPts val="0"/>
@@ -7141,8 +7119,8 @@
                 <a:solidFill>
                   <a:srgbClr val="1A1A1A"/>
                 </a:solidFill>
-                <a:latin typeface="Calibri"/>
-                <a:rFonts ascii="Calibri" hAnsi="Calibri" cs="Calibri"/>
+                <a:latin typeface="Manrope"/>
+                <a:rFonts ascii="Manrope" hAnsi="Manrope" cs="Manrope" eastAsia="Manrope"/>
               </a:rPr>
               <a:t>Слабое место: своя Natural с документами.</a:t>
             </a:r>
@@ -7157,8 +7135,8 @@
         </p:nvSpPr>
         <p:spPr>
           <a:xfrm>
-            <a:off x="6516471" y="1216152"/>
-            <a:ext cx="4925415" cy="4663440"/>
+            <a:off x="6571335" y="1426464"/>
+            <a:ext cx="4815687" cy="4334256"/>
           </a:xfrm>
           <a:prstGeom prst="rect">
             <a:avLst/>
@@ -7166,14 +7144,81 @@
           <a:noFill/>
         </p:spPr>
         <p:txBody>
-          <a:bodyPr wrap="square">
-            <a:spAutoFit/>
-          </a:bodyPr>
-          <a:lstStyle/>
-          <a:p>
-            <a:pPr>
-              <a:lnSpc>
-                <a:spcPct val="115000"/>
+          <a:bodyPr wrap="square" anchor="t" lIns="50800" rIns="50800" tIns="25400" bIns="25400"/>
+          <a:lstStyle/>
+          <a:p>
+            <a:pPr algn="l">
+              <a:lnSpc>
+                <a:spcPct val="118000"/>
+              </a:lnSpc>
+              <a:spcBef>
+                <a:spcPts val="0"/>
+              </a:spcBef>
+              <a:spcAft>
+                <a:spcPts val="1200"/>
+              </a:spcAft>
+            </a:pPr>
+            <a:r>
+              <a:rPr sz="1500" b="1">
+                <a:solidFill>
+                  <a:srgbClr val="2A554A"/>
+                </a:solidFill>
+                <a:latin typeface="Manrope"/>
+                <a:rFonts ascii="Manrope" hAnsi="Manrope" cs="Manrope" eastAsia="Manrope"/>
+              </a:rPr>
+              <a:t>Ориентир цен (не оферта)</a:t>
+            </a:r>
+          </a:p>
+          <a:p>
+            <a:pPr algn="l">
+              <a:lnSpc>
+                <a:spcPct val="118000"/>
+              </a:lnSpc>
+              <a:spcBef>
+                <a:spcPts val="0"/>
+              </a:spcBef>
+              <a:spcAft>
+                <a:spcPts val="800"/>
+              </a:spcAft>
+            </a:pPr>
+            <a:r>
+              <a:rPr sz="1600" b="0">
+                <a:solidFill>
+                  <a:srgbClr val="1A1A1A"/>
+                </a:solidFill>
+                <a:latin typeface="Golos Text"/>
+                <a:rFonts ascii="Golos Text" hAnsi="Golos Text" cs="Golos Text" eastAsia="Golos Text"/>
+              </a:rPr>
+              <a:t>Hotel Line ≈ 12–15 ₽ / 30 мл</a:t>
+            </a:r>
+          </a:p>
+          <a:p>
+            <a:pPr algn="l">
+              <a:lnSpc>
+                <a:spcPct val="118000"/>
+              </a:lnSpc>
+              <a:spcBef>
+                <a:spcPts val="0"/>
+              </a:spcBef>
+              <a:spcAft>
+                <a:spcPts val="800"/>
+              </a:spcAft>
+            </a:pPr>
+            <a:r>
+              <a:rPr sz="1600" b="0">
+                <a:solidFill>
+                  <a:srgbClr val="1A1A1A"/>
+                </a:solidFill>
+                <a:latin typeface="Golos Text"/>
+                <a:rFonts ascii="Golos Text" hAnsi="Golos Text" cs="Golos Text" eastAsia="Golos Text"/>
+              </a:rPr>
+              <a:t>ЕТС Natural ≈ 18 ₽ / 25 мл</a:t>
+            </a:r>
+          </a:p>
+          <a:p>
+            <a:pPr algn="l">
+              <a:lnSpc>
+                <a:spcPct val="118000"/>
               </a:lnSpc>
               <a:spcBef>
                 <a:spcPts val="0"/>
@@ -7183,20 +7228,20 @@
               </a:spcAft>
             </a:pPr>
             <a:r>
-              <a:rPr sz="1500" b="1">
-                <a:solidFill>
-                  <a:srgbClr val="2A554A"/>
-                </a:solidFill>
-                <a:latin typeface="Calibri"/>
-                <a:rFonts ascii="Calibri" hAnsi="Calibri" cs="Calibri"/>
-              </a:rPr>
-              <a:t>Ориентир цен (не оферта)</a:t>
-            </a:r>
-          </a:p>
-          <a:p>
-            <a:pPr>
-              <a:lnSpc>
-                <a:spcPct val="115000"/>
+              <a:rPr sz="1600" b="0">
+                <a:solidFill>
+                  <a:srgbClr val="1A1A1A"/>
+                </a:solidFill>
+                <a:latin typeface="Golos Text"/>
+                <a:rFonts ascii="Golos Text" hAnsi="Golos Text" cs="Golos Text" eastAsia="Golos Text"/>
+              </a:rPr>
+              <a:t>Natura Siberica — выше</a:t>
+            </a:r>
+          </a:p>
+          <a:p>
+            <a:pPr algn="l">
+              <a:lnSpc>
+                <a:spcPct val="118000"/>
               </a:lnSpc>
               <a:spcBef>
                 <a:spcPts val="0"/>
@@ -7206,104 +7251,35 @@
               </a:spcAft>
             </a:pPr>
             <a:r>
+              <a:rPr sz="1600" b="1">
+                <a:solidFill>
+                  <a:srgbClr val="1A1A1A"/>
+                </a:solidFill>
+                <a:latin typeface="Manrope"/>
+                <a:rFonts ascii="Manrope" hAnsi="Manrope" cs="Manrope" eastAsia="Manrope"/>
+              </a:rPr>
+              <a:t>Ставка: между HL и NS</a:t>
+            </a:r>
+          </a:p>
+          <a:p>
+            <a:pPr algn="l">
+              <a:lnSpc>
+                <a:spcPct val="118000"/>
+              </a:lnSpc>
+              <a:spcBef>
+                <a:spcPts val="0"/>
+              </a:spcBef>
+              <a:spcAft>
+                <a:spcPts val="800"/>
+              </a:spcAft>
+            </a:pPr>
+            <a:r>
               <a:rPr sz="1600" b="0">
                 <a:solidFill>
                   <a:srgbClr val="1A1A1A"/>
                 </a:solidFill>
-                <a:latin typeface="Calibri"/>
-                <a:rFonts ascii="Calibri" hAnsi="Calibri" cs="Calibri"/>
-              </a:rPr>
-              <a:t>Hotel Line ≈ 12–15 ₽ / 30 мл</a:t>
-            </a:r>
-          </a:p>
-          <a:p>
-            <a:pPr>
-              <a:lnSpc>
-                <a:spcPct val="115000"/>
-              </a:lnSpc>
-              <a:spcBef>
-                <a:spcPts val="0"/>
-              </a:spcBef>
-              <a:spcAft>
-                <a:spcPts val="800"/>
-              </a:spcAft>
-            </a:pPr>
-            <a:r>
-              <a:rPr sz="1600" b="0">
-                <a:solidFill>
-                  <a:srgbClr val="1A1A1A"/>
-                </a:solidFill>
-                <a:latin typeface="Calibri"/>
-                <a:rFonts ascii="Calibri" hAnsi="Calibri" cs="Calibri"/>
-              </a:rPr>
-              <a:t>ЕТС Natural ≈ 18 ₽ / 25 мл</a:t>
-            </a:r>
-          </a:p>
-          <a:p>
-            <a:pPr>
-              <a:lnSpc>
-                <a:spcPct val="115000"/>
-              </a:lnSpc>
-              <a:spcBef>
-                <a:spcPts val="0"/>
-              </a:spcBef>
-              <a:spcAft>
-                <a:spcPts val="1400"/>
-              </a:spcAft>
-            </a:pPr>
-            <a:r>
-              <a:rPr sz="1600" b="0">
-                <a:solidFill>
-                  <a:srgbClr val="1A1A1A"/>
-                </a:solidFill>
-                <a:latin typeface="Calibri"/>
-                <a:rFonts ascii="Calibri" hAnsi="Calibri" cs="Calibri"/>
-              </a:rPr>
-              <a:t>Natura Siberica — выше</a:t>
-            </a:r>
-          </a:p>
-          <a:p>
-            <a:pPr>
-              <a:lnSpc>
-                <a:spcPct val="115000"/>
-              </a:lnSpc>
-              <a:spcBef>
-                <a:spcPts val="0"/>
-              </a:spcBef>
-              <a:spcAft>
-                <a:spcPts val="800"/>
-              </a:spcAft>
-            </a:pPr>
-            <a:r>
-              <a:rPr sz="1600" b="1">
-                <a:solidFill>
-                  <a:srgbClr val="1A1A1A"/>
-                </a:solidFill>
-                <a:latin typeface="Calibri"/>
-                <a:rFonts ascii="Calibri" hAnsi="Calibri" cs="Calibri"/>
-              </a:rPr>
-              <a:t>Ставка: между HL и NS</a:t>
-            </a:r>
-          </a:p>
-          <a:p>
-            <a:pPr>
-              <a:lnSpc>
-                <a:spcPct val="115000"/>
-              </a:lnSpc>
-              <a:spcBef>
-                <a:spcPts val="0"/>
-              </a:spcBef>
-              <a:spcAft>
-                <a:spcPts val="800"/>
-              </a:spcAft>
-            </a:pPr>
-            <a:r>
-              <a:rPr sz="1600" b="0">
-                <a:solidFill>
-                  <a:srgbClr val="1A1A1A"/>
-                </a:solidFill>
-                <a:latin typeface="Calibri"/>
-                <a:rFonts ascii="Calibri" hAnsi="Calibri" cs="Calibri"/>
+                <a:latin typeface="Golos Text"/>
+                <a:rFonts ascii="Golos Text" hAnsi="Golos Text" cs="Golos Text" eastAsia="Golos Text"/>
               </a:rPr>
               <a:t>Натуральность · документы · один поставщик</a:t>
             </a:r>
@@ -7441,8 +7417,8 @@
                 <a:solidFill>
                   <a:srgbClr val="2A554A"/>
                 </a:solidFill>
-                <a:latin typeface="Calibri"/>
-                <a:rFonts ascii="Calibri" hAnsi="Calibri" cs="Calibri"/>
+                <a:latin typeface="Manrope"/>
+                <a:rFonts ascii="Manrope" hAnsi="Manrope" cs="Manrope" eastAsia="Manrope"/>
               </a:rPr>
               <a:t>Дом линеек</a:t>
             </a:r>
@@ -7562,10 +7538,10 @@
                 <a:solidFill>
                   <a:srgbClr val="5C5C5C"/>
                 </a:solidFill>
-                <a:latin typeface="Calibri"/>
-                <a:rFonts ascii="Calibri" hAnsi="Calibri" cs="Calibri"/>
-              </a:rPr>
-              <a:t>Travel+ Natural  ·  пульт v1.14  ·  собеседование  ·  не оферта</a:t>
+                <a:latin typeface="Golos Text"/>
+                <a:rFonts ascii="Golos Text" hAnsi="Golos Text" cs="Golos Text" eastAsia="Golos Text"/>
+              </a:rPr>
+              <a:t>Travel+ Natural  ·  образец презентации</a:t>
             </a:r>
           </a:p>
         </p:txBody>
@@ -7598,8 +7574,8 @@
                 <a:solidFill>
                   <a:srgbClr val="5C5C5C"/>
                 </a:solidFill>
-                <a:latin typeface="Calibri"/>
-                <a:rFonts ascii="Calibri" hAnsi="Calibri" cs="Calibri"/>
+                <a:latin typeface="Golos Text"/>
+                <a:rFonts ascii="Golos Text" hAnsi="Golos Text" cs="Golos Text" eastAsia="Golos Text"/>
               </a:rPr>
               <a:t>4 / 12</a:t>
             </a:r>
@@ -7662,7 +7638,7 @@
         <p:spPr>
           <a:xfrm>
             <a:off x="457200" y="960120"/>
-            <a:ext cx="5510631" cy="73152"/>
+            <a:ext cx="5510631" cy="82296"/>
           </a:xfrm>
           <a:prstGeom prst="rect">
             <a:avLst/>
@@ -7752,7 +7728,7 @@
         <p:spPr>
           <a:xfrm>
             <a:off x="6223863" y="960120"/>
-            <a:ext cx="5510631" cy="73152"/>
+            <a:ext cx="5510631" cy="82296"/>
           </a:xfrm>
           <a:prstGeom prst="rect">
             <a:avLst/>
@@ -7794,8 +7770,8 @@
         </p:nvSpPr>
         <p:spPr>
           <a:xfrm>
-            <a:off x="749808" y="1216152"/>
-            <a:ext cx="4925415" cy="4663440"/>
+            <a:off x="804672" y="1426464"/>
+            <a:ext cx="4815687" cy="4334256"/>
           </a:xfrm>
           <a:prstGeom prst="rect">
             <a:avLst/>
@@ -7803,20 +7779,18 @@
           <a:noFill/>
         </p:spPr>
         <p:txBody>
-          <a:bodyPr wrap="square">
-            <a:spAutoFit/>
-          </a:bodyPr>
-          <a:lstStyle/>
-          <a:p>
-            <a:pPr>
-              <a:lnSpc>
-                <a:spcPct val="115000"/>
-              </a:lnSpc>
-              <a:spcBef>
-                <a:spcPts val="0"/>
-              </a:spcBef>
-              <a:spcAft>
-                <a:spcPts val="1400"/>
+          <a:bodyPr wrap="square" anchor="t" lIns="50800" rIns="50800" tIns="25400" bIns="25400"/>
+          <a:lstStyle/>
+          <a:p>
+            <a:pPr algn="l">
+              <a:lnSpc>
+                <a:spcPct val="118000"/>
+              </a:lnSpc>
+              <a:spcBef>
+                <a:spcPts val="0"/>
+              </a:spcBef>
+              <a:spcAft>
+                <a:spcPts val="1200"/>
               </a:spcAft>
             </a:pPr>
             <a:r>
@@ -7824,16 +7798,16 @@
                 <a:solidFill>
                   <a:srgbClr val="2A554A"/>
                 </a:solidFill>
-                <a:latin typeface="Calibri"/>
-                <a:rFonts ascii="Calibri" hAnsi="Calibri" cs="Calibri"/>
+                <a:latin typeface="Manrope"/>
+                <a:rFonts ascii="Manrope" hAnsi="Manrope" cs="Manrope" eastAsia="Manrope"/>
               </a:rPr>
               <a:t>Карта</a:t>
             </a:r>
           </a:p>
           <a:p>
-            <a:pPr>
-              <a:lnSpc>
-                <a:spcPct val="115000"/>
+            <a:pPr algn="l">
+              <a:lnSpc>
+                <a:spcPct val="118000"/>
               </a:lnSpc>
               <a:spcBef>
                 <a:spcPts val="0"/>
@@ -7847,16 +7821,16 @@
                 <a:solidFill>
                   <a:srgbClr val="1A1A1A"/>
                 </a:solidFill>
-                <a:latin typeface="Calibri"/>
-                <a:rFonts ascii="Calibri" hAnsi="Calibri" cs="Calibri"/>
+                <a:latin typeface="Golos Text"/>
+                <a:rFonts ascii="Golos Text" hAnsi="Golos Text" cs="Golos Text" eastAsia="Golos Text"/>
               </a:rPr>
               <a:t>Hotel Line → цена</a:t>
             </a:r>
           </a:p>
           <a:p>
-            <a:pPr>
-              <a:lnSpc>
-                <a:spcPct val="115000"/>
+            <a:pPr algn="l">
+              <a:lnSpc>
+                <a:spcPct val="118000"/>
               </a:lnSpc>
               <a:spcBef>
                 <a:spcPts val="0"/>
@@ -7870,16 +7844,16 @@
                 <a:solidFill>
                   <a:srgbClr val="1A1A1A"/>
                 </a:solidFill>
-                <a:latin typeface="Calibri"/>
-                <a:rFonts ascii="Calibri" hAnsi="Calibri" cs="Calibri"/>
+                <a:latin typeface="Golos Text"/>
+                <a:rFonts ascii="Golos Text" hAnsi="Golos Text" cs="Golos Text" eastAsia="Golos Text"/>
               </a:rPr>
               <a:t>Fleur / Aquatique / La Nuit → дизайн и аромат</a:t>
             </a:r>
           </a:p>
           <a:p>
-            <a:pPr>
-              <a:lnSpc>
-                <a:spcPct val="115000"/>
+            <a:pPr algn="l">
+              <a:lnSpc>
+                <a:spcPct val="118000"/>
               </a:lnSpc>
               <a:spcBef>
                 <a:spcPts val="0"/>
@@ -7893,16 +7867,16 @@
                 <a:solidFill>
                   <a:srgbClr val="1A1A1A"/>
                 </a:solidFill>
-                <a:latin typeface="Calibri"/>
-                <a:rFonts ascii="Calibri" hAnsi="Calibri" cs="Calibri"/>
+                <a:latin typeface="Manrope"/>
+                <a:rFonts ascii="Manrope" hAnsi="Manrope" cs="Manrope" eastAsia="Manrope"/>
               </a:rPr>
               <a:t>Natural → натуральность + документы</a:t>
             </a:r>
           </a:p>
           <a:p>
-            <a:pPr>
-              <a:lnSpc>
-                <a:spcPct val="115000"/>
+            <a:pPr algn="l">
+              <a:lnSpc>
+                <a:spcPct val="118000"/>
               </a:lnSpc>
               <a:spcBef>
                 <a:spcPts val="0"/>
@@ -7916,16 +7890,16 @@
                 <a:solidFill>
                   <a:srgbClr val="1A1A1A"/>
                 </a:solidFill>
-                <a:latin typeface="Calibri"/>
-                <a:rFonts ascii="Calibri" hAnsi="Calibri" cs="Calibri"/>
+                <a:latin typeface="Golos Text"/>
+                <a:rFonts ascii="Golos Text" hAnsi="Golos Text" cs="Golos Text" eastAsia="Golos Text"/>
               </a:rPr>
               <a:t>Natura Siberica → чужой premium</a:t>
             </a:r>
           </a:p>
           <a:p>
-            <a:pPr>
-              <a:lnSpc>
-                <a:spcPct val="115000"/>
+            <a:pPr algn="l">
+              <a:lnSpc>
+                <a:spcPct val="118000"/>
               </a:lnSpc>
               <a:spcBef>
                 <a:spcPts val="0"/>
@@ -7939,8 +7913,8 @@
                 <a:solidFill>
                   <a:srgbClr val="1A1A1A"/>
                 </a:solidFill>
-                <a:latin typeface="Calibri"/>
-                <a:rFonts ascii="Calibri" hAnsi="Calibri" cs="Calibri"/>
+                <a:latin typeface="Golos Text"/>
+                <a:rFonts ascii="Golos Text" hAnsi="Golos Text" cs="Golos Text" eastAsia="Golos Text"/>
               </a:rPr>
               <a:t>СТМ (лого отеля) → отдельный проект</a:t>
             </a:r>
@@ -7955,8 +7929,8 @@
         </p:nvSpPr>
         <p:spPr>
           <a:xfrm>
-            <a:off x="6516471" y="1216152"/>
-            <a:ext cx="4925415" cy="4663440"/>
+            <a:off x="6571335" y="1426464"/>
+            <a:ext cx="4815687" cy="4334256"/>
           </a:xfrm>
           <a:prstGeom prst="rect">
             <a:avLst/>
@@ -7964,20 +7938,18 @@
           <a:noFill/>
         </p:spPr>
         <p:txBody>
-          <a:bodyPr wrap="square">
-            <a:spAutoFit/>
-          </a:bodyPr>
-          <a:lstStyle/>
-          <a:p>
-            <a:pPr>
-              <a:lnSpc>
-                <a:spcPct val="115000"/>
-              </a:lnSpc>
-              <a:spcBef>
-                <a:spcPts val="0"/>
-              </a:spcBef>
-              <a:spcAft>
-                <a:spcPts val="1400"/>
+          <a:bodyPr wrap="square" anchor="t" lIns="50800" rIns="50800" tIns="25400" bIns="25400"/>
+          <a:lstStyle/>
+          <a:p>
+            <a:pPr algn="l">
+              <a:lnSpc>
+                <a:spcPct val="118000"/>
+              </a:lnSpc>
+              <a:spcBef>
+                <a:spcPts val="0"/>
+              </a:spcBef>
+              <a:spcAft>
+                <a:spcPts val="1200"/>
               </a:spcAft>
             </a:pPr>
             <a:r>
@@ -7985,16 +7957,16 @@
                 <a:solidFill>
                   <a:srgbClr val="2A554A"/>
                 </a:solidFill>
-                <a:latin typeface="Calibri"/>
-                <a:rFonts ascii="Calibri" hAnsi="Calibri" cs="Calibri"/>
+                <a:latin typeface="Manrope"/>
+                <a:rFonts ascii="Manrope" hAnsi="Manrope" cs="Manrope" eastAsia="Manrope"/>
               </a:rPr>
               <a:t>Мостик для продаж</a:t>
             </a:r>
           </a:p>
           <a:p>
-            <a:pPr>
-              <a:lnSpc>
-                <a:spcPct val="115000"/>
+            <a:pPr algn="l">
+              <a:lnSpc>
+                <a:spcPct val="118000"/>
               </a:lnSpc>
               <a:spcBef>
                 <a:spcPts val="0"/>
@@ -8008,16 +7980,16 @@
                 <a:solidFill>
                   <a:srgbClr val="1A1A1A"/>
                 </a:solidFill>
-                <a:latin typeface="Calibri"/>
-                <a:rFonts ascii="Calibri" hAnsi="Calibri" cs="Calibri"/>
+                <a:latin typeface="Golos Text"/>
+                <a:rFonts ascii="Golos Text" hAnsi="Golos Text" cs="Golos Text" eastAsia="Golos Text"/>
               </a:rPr>
               <a:t>Дизайн и аромат — Fleur.</a:t>
             </a:r>
           </a:p>
           <a:p>
-            <a:pPr>
-              <a:lnSpc>
-                <a:spcPct val="115000"/>
+            <a:pPr algn="l">
+              <a:lnSpc>
+                <a:spcPct val="118000"/>
               </a:lnSpc>
               <a:spcBef>
                 <a:spcPts val="0"/>
@@ -8031,16 +8003,16 @@
                 <a:solidFill>
                   <a:srgbClr val="1A1A1A"/>
                 </a:solidFill>
-                <a:latin typeface="Calibri"/>
-                <a:rFonts ascii="Calibri" hAnsi="Calibri" cs="Calibri"/>
+                <a:latin typeface="Golos Text"/>
+                <a:rFonts ascii="Golos Text" hAnsi="Golos Text" cs="Golos Text" eastAsia="Golos Text"/>
               </a:rPr>
               <a:t>Натуральность и документы — Natural.</a:t>
             </a:r>
           </a:p>
           <a:p>
-            <a:pPr>
-              <a:lnSpc>
-                <a:spcPct val="115000"/>
+            <a:pPr algn="l">
+              <a:lnSpc>
+                <a:spcPct val="118000"/>
               </a:lnSpc>
               <a:spcBef>
                 <a:spcPts val="0"/>
@@ -8054,16 +8026,16 @@
                 <a:solidFill>
                   <a:srgbClr val="1A1A1A"/>
                 </a:solidFill>
-                <a:latin typeface="Calibri"/>
-                <a:rFonts ascii="Calibri" hAnsi="Calibri" cs="Calibri"/>
+                <a:latin typeface="Manrope"/>
+                <a:rFonts ascii="Manrope" hAnsi="Manrope" cs="Manrope" eastAsia="Manrope"/>
               </a:rPr>
               <a:t>Не конкурируют.</a:t>
             </a:r>
           </a:p>
           <a:p>
-            <a:pPr>
-              <a:lnSpc>
-                <a:spcPct val="115000"/>
+            <a:pPr algn="l">
+              <a:lnSpc>
+                <a:spcPct val="118000"/>
               </a:lnSpc>
               <a:spcBef>
                 <a:spcPts val="0"/>
@@ -8077,8 +8049,8 @@
                 <a:solidFill>
                   <a:srgbClr val="1A1A1A"/>
                 </a:solidFill>
-                <a:latin typeface="Calibri"/>
-                <a:rFonts ascii="Calibri" hAnsi="Calibri" cs="Calibri"/>
+                <a:latin typeface="Golos Text"/>
+                <a:rFonts ascii="Golos Text" hAnsi="Golos Text" cs="Golos Text" eastAsia="Golos Text"/>
               </a:rPr>
               <a:t>Могут жить на разных этажах одного объекта.</a:t>
             </a:r>
@@ -8216,8 +8188,8 @@
                 <a:solidFill>
                   <a:srgbClr val="2A554A"/>
                 </a:solidFill>
-                <a:latin typeface="Calibri"/>
-                <a:rFonts ascii="Calibri" hAnsi="Calibri" cs="Calibri"/>
+                <a:latin typeface="Manrope"/>
+                <a:rFonts ascii="Manrope" hAnsi="Manrope" cs="Manrope" eastAsia="Manrope"/>
               </a:rPr>
               <a:t>Обещание + StoryBrand</a:t>
             </a:r>
@@ -8337,10 +8309,10 @@
                 <a:solidFill>
                   <a:srgbClr val="5C5C5C"/>
                 </a:solidFill>
-                <a:latin typeface="Calibri"/>
-                <a:rFonts ascii="Calibri" hAnsi="Calibri" cs="Calibri"/>
-              </a:rPr>
-              <a:t>Travel+ Natural  ·  пульт v1.14  ·  собеседование  ·  не оферта</a:t>
+                <a:latin typeface="Golos Text"/>
+                <a:rFonts ascii="Golos Text" hAnsi="Golos Text" cs="Golos Text" eastAsia="Golos Text"/>
+              </a:rPr>
+              <a:t>Travel+ Natural  ·  образец презентации</a:t>
             </a:r>
           </a:p>
         </p:txBody>
@@ -8373,8 +8345,8 @@
                 <a:solidFill>
                   <a:srgbClr val="5C5C5C"/>
                 </a:solidFill>
-                <a:latin typeface="Calibri"/>
-                <a:rFonts ascii="Calibri" hAnsi="Calibri" cs="Calibri"/>
+                <a:latin typeface="Golos Text"/>
+                <a:rFonts ascii="Golos Text" hAnsi="Golos Text" cs="Golos Text" eastAsia="Golos Text"/>
               </a:rPr>
               <a:t>5 / 12</a:t>
             </a:r>
@@ -8437,7 +8409,7 @@
         <p:spPr>
           <a:xfrm>
             <a:off x="457200" y="960120"/>
-            <a:ext cx="5510631" cy="73152"/>
+            <a:ext cx="5510631" cy="82296"/>
           </a:xfrm>
           <a:prstGeom prst="rect">
             <a:avLst/>
@@ -8527,7 +8499,7 @@
         <p:spPr>
           <a:xfrm>
             <a:off x="6223863" y="960120"/>
-            <a:ext cx="5510631" cy="73152"/>
+            <a:ext cx="5510631" cy="82296"/>
           </a:xfrm>
           <a:prstGeom prst="rect">
             <a:avLst/>
@@ -8569,8 +8541,8 @@
         </p:nvSpPr>
         <p:spPr>
           <a:xfrm>
-            <a:off x="749808" y="1216152"/>
-            <a:ext cx="4925415" cy="4663440"/>
+            <a:off x="804672" y="1426464"/>
+            <a:ext cx="4815687" cy="4334256"/>
           </a:xfrm>
           <a:prstGeom prst="rect">
             <a:avLst/>
@@ -8578,20 +8550,18 @@
           <a:noFill/>
         </p:spPr>
         <p:txBody>
-          <a:bodyPr wrap="square">
-            <a:spAutoFit/>
-          </a:bodyPr>
-          <a:lstStyle/>
-          <a:p>
-            <a:pPr>
-              <a:lnSpc>
-                <a:spcPct val="115000"/>
-              </a:lnSpc>
-              <a:spcBef>
-                <a:spcPts val="0"/>
-              </a:spcBef>
-              <a:spcAft>
-                <a:spcPts val="1400"/>
+          <a:bodyPr wrap="square" anchor="t" lIns="50800" rIns="50800" tIns="25400" bIns="25400"/>
+          <a:lstStyle/>
+          <a:p>
+            <a:pPr algn="l">
+              <a:lnSpc>
+                <a:spcPct val="118000"/>
+              </a:lnSpc>
+              <a:spcBef>
+                <a:spcPts val="0"/>
+              </a:spcBef>
+              <a:spcAft>
+                <a:spcPts val="1200"/>
               </a:spcAft>
             </a:pPr>
             <a:r>
@@ -8599,16 +8569,16 @@
                 <a:solidFill>
                   <a:srgbClr val="2A554A"/>
                 </a:solidFill>
-                <a:latin typeface="Calibri"/>
-                <a:rFonts ascii="Calibri" hAnsi="Calibri" cs="Calibri"/>
+                <a:latin typeface="Manrope"/>
+                <a:rFonts ascii="Manrope" hAnsi="Manrope" cs="Manrope" eastAsia="Manrope"/>
               </a:rPr>
               <a:t>Обещание</a:t>
             </a:r>
           </a:p>
           <a:p>
-            <a:pPr>
-              <a:lnSpc>
-                <a:spcPct val="115000"/>
+            <a:pPr algn="l">
+              <a:lnSpc>
+                <a:spcPct val="118000"/>
               </a:lnSpc>
               <a:spcBef>
                 <a:spcPts val="0"/>
@@ -8622,16 +8592,16 @@
                 <a:solidFill>
                   <a:srgbClr val="1A1A1A"/>
                 </a:solidFill>
-                <a:latin typeface="Calibri"/>
-                <a:rFonts ascii="Calibri" hAnsi="Calibri" cs="Calibri"/>
+                <a:latin typeface="Manrope"/>
+                <a:rFonts ascii="Manrope" hAnsi="Manrope" cs="Manrope" eastAsia="Manrope"/>
               </a:rPr>
               <a:t>Мягкий уход с понятной натуральностью</a:t>
             </a:r>
           </a:p>
           <a:p>
-            <a:pPr>
-              <a:lnSpc>
-                <a:spcPct val="115000"/>
+            <a:pPr algn="l">
+              <a:lnSpc>
+                <a:spcPct val="118000"/>
               </a:lnSpc>
               <a:spcBef>
                 <a:spcPts val="0"/>
@@ -8645,16 +8615,16 @@
                 <a:solidFill>
                   <a:srgbClr val="1A1A1A"/>
                 </a:solidFill>
-                <a:latin typeface="Calibri"/>
-                <a:rFonts ascii="Calibri" hAnsi="Calibri" cs="Calibri"/>
+                <a:latin typeface="Golos Text"/>
+                <a:rFonts ascii="Golos Text" hAnsi="Golos Text" cs="Golos Text" eastAsia="Golos Text"/>
               </a:rPr>
               <a:t>для отеля, которому важны и гость, и документы.</a:t>
             </a:r>
           </a:p>
           <a:p>
-            <a:pPr>
-              <a:lnSpc>
-                <a:spcPct val="115000"/>
+            <a:pPr algn="l">
+              <a:lnSpc>
+                <a:spcPct val="118000"/>
               </a:lnSpc>
               <a:spcBef>
                 <a:spcPts val="0"/>
@@ -8668,16 +8638,16 @@
                 <a:solidFill>
                   <a:srgbClr val="5C5C5C"/>
                 </a:solidFill>
-                <a:latin typeface="Calibri"/>
-                <a:rFonts ascii="Calibri" hAnsi="Calibri" cs="Calibri"/>
+                <a:latin typeface="Golos Text"/>
+                <a:rFonts ascii="Golos Text" hAnsi="Golos Text" cs="Golos Text" eastAsia="Golos Text"/>
               </a:rPr>
               <a:t>Доказательства:</a:t>
             </a:r>
           </a:p>
           <a:p>
-            <a:pPr>
-              <a:lnSpc>
-                <a:spcPct val="115000"/>
+            <a:pPr algn="l">
+              <a:lnSpc>
+                <a:spcPct val="118000"/>
               </a:lnSpc>
               <a:spcBef>
                 <a:spcPts val="0"/>
@@ -8691,16 +8661,16 @@
                 <a:solidFill>
                   <a:srgbClr val="1A1A1A"/>
                 </a:solidFill>
-                <a:latin typeface="Calibri"/>
-                <a:rFonts ascii="Calibri" hAnsi="Calibri" cs="Calibri"/>
+                <a:latin typeface="Golos Text"/>
+                <a:rFonts ascii="Golos Text" hAnsi="Golos Text" cs="Golos Text" eastAsia="Golos Text"/>
               </a:rPr>
               <a:t>• Состав в границах</a:t>
             </a:r>
           </a:p>
           <a:p>
-            <a:pPr>
-              <a:lnSpc>
-                <a:spcPct val="115000"/>
+            <a:pPr algn="l">
+              <a:lnSpc>
+                <a:spcPct val="118000"/>
               </a:lnSpc>
               <a:spcBef>
                 <a:spcPts val="0"/>
@@ -8714,16 +8684,16 @@
                 <a:solidFill>
                   <a:srgbClr val="1A1A1A"/>
                 </a:solidFill>
-                <a:latin typeface="Calibri"/>
-                <a:rFonts ascii="Calibri" hAnsi="Calibri" cs="Calibri"/>
+                <a:latin typeface="Golos Text"/>
+                <a:rFonts ascii="Golos Text" hAnsi="Golos Text" cs="Golos Text" eastAsia="Golos Text"/>
               </a:rPr>
               <a:t>• Пакет документов Travel+</a:t>
             </a:r>
           </a:p>
           <a:p>
-            <a:pPr>
-              <a:lnSpc>
-                <a:spcPct val="115000"/>
+            <a:pPr algn="l">
+              <a:lnSpc>
+                <a:spcPct val="118000"/>
               </a:lnSpc>
               <a:spcBef>
                 <a:spcPts val="0"/>
@@ -8737,16 +8707,16 @@
                 <a:solidFill>
                   <a:srgbClr val="1A1A1A"/>
                 </a:solidFill>
-                <a:latin typeface="Calibri"/>
-                <a:rFonts ascii="Calibri" hAnsi="Calibri" cs="Calibri"/>
+                <a:latin typeface="Golos Text"/>
+                <a:rFonts ascii="Golos Text" hAnsi="Golos Text" cs="Golos Text" eastAsia="Golos Text"/>
               </a:rPr>
               <a:t>• Ощущение в номере</a:t>
             </a:r>
           </a:p>
           <a:p>
-            <a:pPr>
-              <a:lnSpc>
-                <a:spcPct val="115000"/>
+            <a:pPr algn="l">
+              <a:lnSpc>
+                <a:spcPct val="118000"/>
               </a:lnSpc>
               <a:spcBef>
                 <a:spcPts val="0"/>
@@ -8760,16 +8730,16 @@
                 <a:solidFill>
                   <a:srgbClr val="1A1A1A"/>
                 </a:solidFill>
-                <a:latin typeface="Calibri"/>
-                <a:rFonts ascii="Calibri" hAnsi="Calibri" cs="Calibri"/>
+                <a:latin typeface="Golos Text"/>
+                <a:rFonts ascii="Golos Text" hAnsi="Golos Text" cs="Golos Text" eastAsia="Golos Text"/>
               </a:rPr>
               <a:t>• Один поставщик на номер</a:t>
             </a:r>
           </a:p>
           <a:p>
-            <a:pPr>
-              <a:lnSpc>
-                <a:spcPct val="115000"/>
+            <a:pPr algn="l">
+              <a:lnSpc>
+                <a:spcPct val="118000"/>
               </a:lnSpc>
               <a:spcBef>
                 <a:spcPts val="0"/>
@@ -8783,8 +8753,8 @@
                 <a:solidFill>
                   <a:srgbClr val="1A1A1A"/>
                 </a:solidFill>
-                <a:latin typeface="Calibri"/>
-                <a:rFonts ascii="Calibri" hAnsi="Calibri" cs="Calibri"/>
+                <a:latin typeface="Golos Text"/>
+                <a:rFonts ascii="Golos Text" hAnsi="Golos Text" cs="Golos Text" eastAsia="Golos Text"/>
               </a:rPr>
               <a:t>• Блок «простыми словами» на этикетке</a:t>
             </a:r>
@@ -8799,8 +8769,8 @@
         </p:nvSpPr>
         <p:spPr>
           <a:xfrm>
-            <a:off x="6516471" y="1216152"/>
-            <a:ext cx="4925415" cy="4663440"/>
+            <a:off x="6571335" y="1426464"/>
+            <a:ext cx="4815687" cy="4334256"/>
           </a:xfrm>
           <a:prstGeom prst="rect">
             <a:avLst/>
@@ -8808,14 +8778,81 @@
           <a:noFill/>
         </p:spPr>
         <p:txBody>
-          <a:bodyPr wrap="square">
-            <a:spAutoFit/>
-          </a:bodyPr>
-          <a:lstStyle/>
-          <a:p>
-            <a:pPr>
-              <a:lnSpc>
-                <a:spcPct val="115000"/>
+          <a:bodyPr wrap="square" anchor="t" lIns="50800" rIns="50800" tIns="25400" bIns="25400"/>
+          <a:lstStyle/>
+          <a:p>
+            <a:pPr algn="l">
+              <a:lnSpc>
+                <a:spcPct val="118000"/>
+              </a:lnSpc>
+              <a:spcBef>
+                <a:spcPts val="0"/>
+              </a:spcBef>
+              <a:spcAft>
+                <a:spcPts val="1200"/>
+              </a:spcAft>
+            </a:pPr>
+            <a:r>
+              <a:rPr sz="1500" b="1">
+                <a:solidFill>
+                  <a:srgbClr val="2A554A"/>
+                </a:solidFill>
+                <a:latin typeface="Manrope"/>
+                <a:rFonts ascii="Manrope" hAnsi="Manrope" cs="Manrope" eastAsia="Manrope"/>
+              </a:rPr>
+              <a:t>BrandScript</a:t>
+            </a:r>
+          </a:p>
+          <a:p>
+            <a:pPr algn="l">
+              <a:lnSpc>
+                <a:spcPct val="118000"/>
+              </a:lnSpc>
+              <a:spcBef>
+                <a:spcPts val="0"/>
+              </a:spcBef>
+              <a:spcAft>
+                <a:spcPts val="800"/>
+              </a:spcAft>
+            </a:pPr>
+            <a:r>
+              <a:rPr sz="1600" b="0">
+                <a:solidFill>
+                  <a:srgbClr val="1A1A1A"/>
+                </a:solidFill>
+                <a:latin typeface="Golos Text"/>
+                <a:rFonts ascii="Golos Text" hAnsi="Golos Text" cs="Golos Text" eastAsia="Golos Text"/>
+              </a:rPr>
+              <a:t>Герой: закупщик eco / wellness</a:t>
+            </a:r>
+          </a:p>
+          <a:p>
+            <a:pPr algn="l">
+              <a:lnSpc>
+                <a:spcPct val="118000"/>
+              </a:lnSpc>
+              <a:spcBef>
+                <a:spcPts val="0"/>
+              </a:spcBef>
+              <a:spcAft>
+                <a:spcPts val="800"/>
+              </a:spcAft>
+            </a:pPr>
+            <a:r>
+              <a:rPr sz="1600" b="0">
+                <a:solidFill>
+                  <a:srgbClr val="1A1A1A"/>
+                </a:solidFill>
+                <a:latin typeface="Golos Text"/>
+                <a:rFonts ascii="Golos Text" hAnsi="Golos Text" cs="Golos Text" eastAsia="Golos Text"/>
+              </a:rPr>
+              <a:t>Проводник: Travel+ Natural</a:t>
+            </a:r>
+          </a:p>
+          <a:p>
+            <a:pPr algn="l">
+              <a:lnSpc>
+                <a:spcPct val="118000"/>
               </a:lnSpc>
               <a:spcBef>
                 <a:spcPts val="0"/>
@@ -8825,20 +8862,43 @@
               </a:spcAft>
             </a:pPr>
             <a:r>
-              <a:rPr sz="1500" b="1">
-                <a:solidFill>
-                  <a:srgbClr val="2A554A"/>
-                </a:solidFill>
-                <a:latin typeface="Calibri"/>
-                <a:rFonts ascii="Calibri" hAnsi="Calibri" cs="Calibri"/>
-              </a:rPr>
-              <a:t>BrandScript</a:t>
-            </a:r>
-          </a:p>
-          <a:p>
-            <a:pPr>
-              <a:lnSpc>
-                <a:spcPct val="115000"/>
+              <a:rPr sz="1600" b="0">
+                <a:solidFill>
+                  <a:srgbClr val="1A1A1A"/>
+                </a:solidFill>
+                <a:latin typeface="Golos Text"/>
+                <a:rFonts ascii="Golos Text" hAnsi="Golos Text" cs="Golos Text" eastAsia="Golos Text"/>
+              </a:rPr>
+              <a:t>План: сегмент → образец + документы → пилот</a:t>
+            </a:r>
+          </a:p>
+          <a:p>
+            <a:pPr algn="l">
+              <a:lnSpc>
+                <a:spcPct val="118000"/>
+              </a:lnSpc>
+              <a:spcBef>
+                <a:spcPts val="0"/>
+              </a:spcBef>
+              <a:spcAft>
+                <a:spcPts val="600"/>
+              </a:spcAft>
+            </a:pPr>
+            <a:r>
+              <a:rPr sz="1400" b="0">
+                <a:solidFill>
+                  <a:srgbClr val="5C5C5C"/>
+                </a:solidFill>
+                <a:latin typeface="Golos Text"/>
+                <a:rFonts ascii="Golos Text" hAnsi="Golos Text" cs="Golos Text" eastAsia="Golos Text"/>
+              </a:rPr>
+              <a:t>Гость после дороги:</a:t>
+            </a:r>
+          </a:p>
+          <a:p>
+            <a:pPr algn="l">
+              <a:lnSpc>
+                <a:spcPct val="118000"/>
               </a:lnSpc>
               <a:spcBef>
                 <a:spcPts val="0"/>
@@ -8848,127 +8908,35 @@
               </a:spcAft>
             </a:pPr>
             <a:r>
+              <a:rPr sz="1600" b="1">
+                <a:solidFill>
+                  <a:srgbClr val="1A1A1A"/>
+                </a:solidFill>
+                <a:latin typeface="Manrope"/>
+                <a:rFonts ascii="Manrope" hAnsi="Manrope" cs="Manrope" eastAsia="Manrope"/>
+              </a:rPr>
+              <a:t>Мягче, чем ждал.</a:t>
+            </a:r>
+          </a:p>
+          <a:p>
+            <a:pPr algn="l">
+              <a:lnSpc>
+                <a:spcPct val="118000"/>
+              </a:lnSpc>
+              <a:spcBef>
+                <a:spcPts val="0"/>
+              </a:spcBef>
+              <a:spcAft>
+                <a:spcPts val="800"/>
+              </a:spcAft>
+            </a:pPr>
+            <a:r>
               <a:rPr sz="1600" b="0">
                 <a:solidFill>
                   <a:srgbClr val="1A1A1A"/>
                 </a:solidFill>
-                <a:latin typeface="Calibri"/>
-                <a:rFonts ascii="Calibri" hAnsi="Calibri" cs="Calibri"/>
-              </a:rPr>
-              <a:t>Герой: закупщик eco / wellness</a:t>
-            </a:r>
-          </a:p>
-          <a:p>
-            <a:pPr>
-              <a:lnSpc>
-                <a:spcPct val="115000"/>
-              </a:lnSpc>
-              <a:spcBef>
-                <a:spcPts val="0"/>
-              </a:spcBef>
-              <a:spcAft>
-                <a:spcPts val="800"/>
-              </a:spcAft>
-            </a:pPr>
-            <a:r>
-              <a:rPr sz="1600" b="0">
-                <a:solidFill>
-                  <a:srgbClr val="1A1A1A"/>
-                </a:solidFill>
-                <a:latin typeface="Calibri"/>
-                <a:rFonts ascii="Calibri" hAnsi="Calibri" cs="Calibri"/>
-              </a:rPr>
-              <a:t>Проводник: Travel+ Natural</a:t>
-            </a:r>
-          </a:p>
-          <a:p>
-            <a:pPr>
-              <a:lnSpc>
-                <a:spcPct val="115000"/>
-              </a:lnSpc>
-              <a:spcBef>
-                <a:spcPts val="0"/>
-              </a:spcBef>
-              <a:spcAft>
-                <a:spcPts val="1400"/>
-              </a:spcAft>
-            </a:pPr>
-            <a:r>
-              <a:rPr sz="1600" b="0">
-                <a:solidFill>
-                  <a:srgbClr val="1A1A1A"/>
-                </a:solidFill>
-                <a:latin typeface="Calibri"/>
-                <a:rFonts ascii="Calibri" hAnsi="Calibri" cs="Calibri"/>
-              </a:rPr>
-              <a:t>План: сегмент → образец + документы → пилот</a:t>
-            </a:r>
-          </a:p>
-          <a:p>
-            <a:pPr>
-              <a:lnSpc>
-                <a:spcPct val="115000"/>
-              </a:lnSpc>
-              <a:spcBef>
-                <a:spcPts val="0"/>
-              </a:spcBef>
-              <a:spcAft>
-                <a:spcPts val="600"/>
-              </a:spcAft>
-            </a:pPr>
-            <a:r>
-              <a:rPr sz="1400" b="0">
-                <a:solidFill>
-                  <a:srgbClr val="5C5C5C"/>
-                </a:solidFill>
-                <a:latin typeface="Calibri"/>
-                <a:rFonts ascii="Calibri" hAnsi="Calibri" cs="Calibri"/>
-              </a:rPr>
-              <a:t>Гость после дороги:</a:t>
-            </a:r>
-          </a:p>
-          <a:p>
-            <a:pPr>
-              <a:lnSpc>
-                <a:spcPct val="115000"/>
-              </a:lnSpc>
-              <a:spcBef>
-                <a:spcPts val="0"/>
-              </a:spcBef>
-              <a:spcAft>
-                <a:spcPts val="800"/>
-              </a:spcAft>
-            </a:pPr>
-            <a:r>
-              <a:rPr sz="1600" b="1">
-                <a:solidFill>
-                  <a:srgbClr val="1A1A1A"/>
-                </a:solidFill>
-                <a:latin typeface="Calibri"/>
-                <a:rFonts ascii="Calibri" hAnsi="Calibri" cs="Calibri"/>
-              </a:rPr>
-              <a:t>Мягче, чем ждал.</a:t>
-            </a:r>
-          </a:p>
-          <a:p>
-            <a:pPr>
-              <a:lnSpc>
-                <a:spcPct val="115000"/>
-              </a:lnSpc>
-              <a:spcBef>
-                <a:spcPts val="0"/>
-              </a:spcBef>
-              <a:spcAft>
-                <a:spcPts val="800"/>
-              </a:spcAft>
-            </a:pPr>
-            <a:r>
-              <a:rPr sz="1600" b="0">
-                <a:solidFill>
-                  <a:srgbClr val="1A1A1A"/>
-                </a:solidFill>
-                <a:latin typeface="Calibri"/>
-                <a:rFonts ascii="Calibri" hAnsi="Calibri" cs="Calibri"/>
+                <a:latin typeface="Golos Text"/>
+                <a:rFonts ascii="Golos Text" hAnsi="Golos Text" cs="Golos Text" eastAsia="Golos Text"/>
               </a:rPr>
               <a:t>Понятная натуральность без громких обещаний.</a:t>
             </a:r>
@@ -9106,8 +9074,8 @@
                 <a:solidFill>
                   <a:srgbClr val="2A554A"/>
                 </a:solidFill>
-                <a:latin typeface="Calibri"/>
-                <a:rFonts ascii="Calibri" hAnsi="Calibri" cs="Calibri"/>
+                <a:latin typeface="Manrope"/>
+                <a:rFonts ascii="Manrope" hAnsi="Manrope" cs="Manrope" eastAsia="Manrope"/>
               </a:rPr>
               <a:t>Границы до рынка — DoD этапа 2</a:t>
             </a:r>
@@ -9227,10 +9195,10 @@
                 <a:solidFill>
                   <a:srgbClr val="5C5C5C"/>
                 </a:solidFill>
-                <a:latin typeface="Calibri"/>
-                <a:rFonts ascii="Calibri" hAnsi="Calibri" cs="Calibri"/>
-              </a:rPr>
-              <a:t>Travel+ Natural  ·  пульт v1.14  ·  собеседование  ·  не оферта</a:t>
+                <a:latin typeface="Golos Text"/>
+                <a:rFonts ascii="Golos Text" hAnsi="Golos Text" cs="Golos Text" eastAsia="Golos Text"/>
+              </a:rPr>
+              <a:t>Travel+ Natural  ·  образец презентации</a:t>
             </a:r>
           </a:p>
         </p:txBody>
@@ -9263,8 +9231,8 @@
                 <a:solidFill>
                   <a:srgbClr val="5C5C5C"/>
                 </a:solidFill>
-                <a:latin typeface="Calibri"/>
-                <a:rFonts ascii="Calibri" hAnsi="Calibri" cs="Calibri"/>
+                <a:latin typeface="Golos Text"/>
+                <a:rFonts ascii="Golos Text" hAnsi="Golos Text" cs="Golos Text" eastAsia="Golos Text"/>
               </a:rPr>
               <a:t>6 / 12</a:t>
             </a:r>
@@ -9327,7 +9295,7 @@
         <p:spPr>
           <a:xfrm>
             <a:off x="457200" y="960120"/>
-            <a:ext cx="5510631" cy="73152"/>
+            <a:ext cx="5510631" cy="82296"/>
           </a:xfrm>
           <a:prstGeom prst="rect">
             <a:avLst/>
@@ -9417,7 +9385,7 @@
         <p:spPr>
           <a:xfrm>
             <a:off x="6223863" y="960120"/>
-            <a:ext cx="5510631" cy="73152"/>
+            <a:ext cx="5510631" cy="82296"/>
           </a:xfrm>
           <a:prstGeom prst="rect">
             <a:avLst/>
@@ -9459,8 +9427,8 @@
         </p:nvSpPr>
         <p:spPr>
           <a:xfrm>
-            <a:off x="749808" y="1216152"/>
-            <a:ext cx="4925415" cy="4663440"/>
+            <a:off x="804672" y="1426464"/>
+            <a:ext cx="4815687" cy="4334256"/>
           </a:xfrm>
           <a:prstGeom prst="rect">
             <a:avLst/>
@@ -9468,20 +9436,18 @@
           <a:noFill/>
         </p:spPr>
         <p:txBody>
-          <a:bodyPr wrap="square">
-            <a:spAutoFit/>
-          </a:bodyPr>
-          <a:lstStyle/>
-          <a:p>
-            <a:pPr>
-              <a:lnSpc>
-                <a:spcPct val="115000"/>
-              </a:lnSpc>
-              <a:spcBef>
-                <a:spcPts val="0"/>
-              </a:spcBef>
-              <a:spcAft>
-                <a:spcPts val="1400"/>
+          <a:bodyPr wrap="square" anchor="t" lIns="50800" rIns="50800" tIns="25400" bIns="25400"/>
+          <a:lstStyle/>
+          <a:p>
+            <a:pPr algn="l">
+              <a:lnSpc>
+                <a:spcPct val="118000"/>
+              </a:lnSpc>
+              <a:spcBef>
+                <a:spcPts val="0"/>
+              </a:spcBef>
+              <a:spcAft>
+                <a:spcPts val="1200"/>
               </a:spcAft>
             </a:pPr>
             <a:r>
@@ -9489,16 +9455,16 @@
                 <a:solidFill>
                   <a:srgbClr val="2A554A"/>
                 </a:solidFill>
-                <a:latin typeface="Calibri"/>
-                <a:rFonts ascii="Calibri" hAnsi="Calibri" cs="Calibri"/>
+                <a:latin typeface="Manrope"/>
+                <a:rFonts ascii="Manrope" hAnsi="Manrope" cs="Manrope" eastAsia="Manrope"/>
               </a:rPr>
               <a:t>Пока красное — витрину не открываем</a:t>
             </a:r>
           </a:p>
           <a:p>
-            <a:pPr>
-              <a:lnSpc>
-                <a:spcPct val="115000"/>
+            <a:pPr algn="l">
+              <a:lnSpc>
+                <a:spcPct val="118000"/>
               </a:lnSpc>
               <a:spcBef>
                 <a:spcPts val="0"/>
@@ -9512,16 +9478,16 @@
                 <a:solidFill>
                   <a:srgbClr val="1A1A1A"/>
                 </a:solidFill>
-                <a:latin typeface="Calibri"/>
-                <a:rFonts ascii="Calibri" hAnsi="Calibri" cs="Calibri"/>
+                <a:latin typeface="Golos Text"/>
+                <a:rFonts ascii="Golos Text" hAnsi="Golos Text" cs="Golos Text" eastAsia="Golos Text"/>
               </a:rPr>
               <a:t>□ Метод и % натуральности</a:t>
             </a:r>
           </a:p>
           <a:p>
-            <a:pPr>
-              <a:lnSpc>
-                <a:spcPct val="115000"/>
+            <a:pPr algn="l">
+              <a:lnSpc>
+                <a:spcPct val="118000"/>
               </a:lnSpc>
               <a:spcBef>
                 <a:spcPts val="0"/>
@@ -9535,16 +9501,16 @@
                 <a:solidFill>
                   <a:srgbClr val="1A1A1A"/>
                 </a:solidFill>
-                <a:latin typeface="Calibri"/>
-                <a:rFonts ascii="Calibri" hAnsi="Calibri" cs="Calibri"/>
+                <a:latin typeface="Golos Text"/>
+                <a:rFonts ascii="Golos Text" hAnsi="Golos Text" cs="Golos Text" eastAsia="Golos Text"/>
               </a:rPr>
               <a:t>□ Пакет как у HL / Fleur + лист Natural</a:t>
             </a:r>
           </a:p>
           <a:p>
-            <a:pPr>
-              <a:lnSpc>
-                <a:spcPct val="115000"/>
+            <a:pPr algn="l">
+              <a:lnSpc>
+                <a:spcPct val="118000"/>
               </a:lnSpc>
               <a:spcBef>
                 <a:spcPts val="0"/>
@@ -9558,16 +9524,16 @@
                 <a:solidFill>
                   <a:srgbClr val="1A1A1A"/>
                 </a:solidFill>
-                <a:latin typeface="Calibri"/>
-                <a:rFonts ascii="Calibri" hAnsi="Calibri" cs="Calibri"/>
+                <a:latin typeface="Golos Text"/>
+                <a:rFonts ascii="Golos Text" hAnsi="Golos Text" cs="Golos Text" eastAsia="Golos Text"/>
               </a:rPr>
               <a:t>□ Origin зафиксирован</a:t>
             </a:r>
           </a:p>
           <a:p>
-            <a:pPr>
-              <a:lnSpc>
-                <a:spcPct val="115000"/>
+            <a:pPr algn="l">
+              <a:lnSpc>
+                <a:spcPct val="118000"/>
               </a:lnSpc>
               <a:spcBef>
                 <a:spcPts val="0"/>
@@ -9581,16 +9547,16 @@
                 <a:solidFill>
                   <a:srgbClr val="1A1A1A"/>
                 </a:solidFill>
-                <a:latin typeface="Calibri"/>
-                <a:rFonts ascii="Calibri" hAnsi="Calibri" cs="Calibri"/>
+                <a:latin typeface="Golos Text"/>
+                <a:rFonts ascii="Golos Text" hAnsi="Golos Text" cs="Golos Text" eastAsia="Golos Text"/>
               </a:rPr>
               <a:t>□ Слепой тест запаха с гостями</a:t>
             </a:r>
           </a:p>
           <a:p>
-            <a:pPr>
-              <a:lnSpc>
-                <a:spcPct val="115000"/>
+            <a:pPr algn="l">
+              <a:lnSpc>
+                <a:spcPct val="118000"/>
               </a:lnSpc>
               <a:spcBef>
                 <a:spcPts val="0"/>
@@ -9604,16 +9570,16 @@
                 <a:solidFill>
                   <a:srgbClr val="1A1A1A"/>
                 </a:solidFill>
-                <a:latin typeface="Calibri"/>
-                <a:rFonts ascii="Calibri" hAnsi="Calibri" cs="Calibri"/>
+                <a:latin typeface="Golos Text"/>
+                <a:rFonts ascii="Golos Text" hAnsi="Golos Text" cs="Golos Text" eastAsia="Golos Text"/>
               </a:rPr>
               <a:t>□ Этикетка «простыми словами»</a:t>
             </a:r>
           </a:p>
           <a:p>
-            <a:pPr>
-              <a:lnSpc>
-                <a:spcPct val="115000"/>
+            <a:pPr algn="l">
+              <a:lnSpc>
+                <a:spcPct val="118000"/>
               </a:lnSpc>
               <a:spcBef>
                 <a:spcPts val="0"/>
@@ -9627,16 +9593,16 @@
                 <a:solidFill>
                   <a:srgbClr val="1A1A1A"/>
                 </a:solidFill>
-                <a:latin typeface="Calibri"/>
-                <a:rFonts ascii="Calibri" hAnsi="Calibri" cs="Calibri"/>
+                <a:latin typeface="Golos Text"/>
+                <a:rFonts ascii="Golos Text" hAnsi="Golos Text" cs="Golos Text" eastAsia="Golos Text"/>
               </a:rPr>
               <a:t>□ Себестоимость и коридор цены</a:t>
             </a:r>
           </a:p>
           <a:p>
-            <a:pPr>
-              <a:lnSpc>
-                <a:spcPct val="115000"/>
+            <a:pPr algn="l">
+              <a:lnSpc>
+                <a:spcPct val="118000"/>
               </a:lnSpc>
               <a:spcBef>
                 <a:spcPts val="0"/>
@@ -9650,8 +9616,8 @@
                 <a:solidFill>
                   <a:srgbClr val="1A1A1A"/>
                 </a:solidFill>
-                <a:latin typeface="Calibri"/>
-                <a:rFonts ascii="Calibri" hAnsi="Calibri" cs="Calibri"/>
+                <a:latin typeface="Golos Text"/>
+                <a:rFonts ascii="Golos Text" hAnsi="Golos Text" cs="Golos Text" eastAsia="Golos Text"/>
               </a:rPr>
               <a:t>□ Срок поставки / мин. заказ / брак</a:t>
             </a:r>
@@ -9666,8 +9632,8 @@
         </p:nvSpPr>
         <p:spPr>
           <a:xfrm>
-            <a:off x="6516471" y="1216152"/>
-            <a:ext cx="4925415" cy="4663440"/>
+            <a:off x="6571335" y="1426464"/>
+            <a:ext cx="4815687" cy="4334256"/>
           </a:xfrm>
           <a:prstGeom prst="rect">
             <a:avLst/>
@@ -9675,20 +9641,18 @@
           <a:noFill/>
         </p:spPr>
         <p:txBody>
-          <a:bodyPr wrap="square">
-            <a:spAutoFit/>
-          </a:bodyPr>
-          <a:lstStyle/>
-          <a:p>
-            <a:pPr>
-              <a:lnSpc>
-                <a:spcPct val="115000"/>
-              </a:lnSpc>
-              <a:spcBef>
-                <a:spcPts val="0"/>
-              </a:spcBef>
-              <a:spcAft>
-                <a:spcPts val="1400"/>
+          <a:bodyPr wrap="square" anchor="t" lIns="50800" rIns="50800" tIns="25400" bIns="25400"/>
+          <a:lstStyle/>
+          <a:p>
+            <a:pPr algn="l">
+              <a:lnSpc>
+                <a:spcPct val="118000"/>
+              </a:lnSpc>
+              <a:spcBef>
+                <a:spcPts val="0"/>
+              </a:spcBef>
+              <a:spcAft>
+                <a:spcPts val="1200"/>
               </a:spcAft>
             </a:pPr>
             <a:r>
@@ -9696,16 +9660,16 @@
                 <a:solidFill>
                   <a:srgbClr val="2A554A"/>
                 </a:solidFill>
-                <a:latin typeface="Calibri"/>
-                <a:rFonts ascii="Calibri" hAnsi="Calibri" cs="Calibri"/>
+                <a:latin typeface="Manrope"/>
+                <a:rFonts ascii="Manrope" hAnsi="Manrope" cs="Manrope" eastAsia="Manrope"/>
               </a:rPr>
               <a:t>Правила</a:t>
             </a:r>
           </a:p>
           <a:p>
-            <a:pPr>
-              <a:lnSpc>
-                <a:spcPct val="115000"/>
+            <a:pPr algn="l">
+              <a:lnSpc>
+                <a:spcPct val="118000"/>
               </a:lnSpc>
               <a:spcBef>
                 <a:spcPts val="0"/>
@@ -9719,16 +9683,16 @@
                 <a:solidFill>
                   <a:srgbClr val="1A1A1A"/>
                 </a:solidFill>
-                <a:latin typeface="Calibri"/>
-                <a:rFonts ascii="Calibri" hAnsi="Calibri" cs="Calibri"/>
+                <a:latin typeface="Golos Text"/>
+                <a:rFonts ascii="Golos Text" hAnsi="Golos Text" cs="Golos Text" eastAsia="Golos Text"/>
               </a:rPr>
               <a:t>На старте без COSMOS, если знака нет — честно.</a:t>
             </a:r>
           </a:p>
           <a:p>
-            <a:pPr>
-              <a:lnSpc>
-                <a:spcPct val="115000"/>
+            <a:pPr algn="l">
+              <a:lnSpc>
+                <a:spcPct val="118000"/>
               </a:lnSpc>
               <a:spcBef>
                 <a:spcPts val="0"/>
@@ -9742,16 +9706,16 @@
                 <a:solidFill>
                   <a:srgbClr val="1A1A1A"/>
                 </a:solidFill>
-                <a:latin typeface="Calibri"/>
-                <a:rFonts ascii="Calibri" hAnsi="Calibri" cs="Calibri"/>
+                <a:latin typeface="Manrope"/>
+                <a:rFonts ascii="Manrope" hAnsi="Manrope" cs="Manrope" eastAsia="Manrope"/>
               </a:rPr>
               <a:t>Без DoD — не КП и не live GTM.</a:t>
             </a:r>
           </a:p>
           <a:p>
-            <a:pPr>
-              <a:lnSpc>
-                <a:spcPct val="115000"/>
+            <a:pPr algn="l">
+              <a:lnSpc>
+                <a:spcPct val="118000"/>
               </a:lnSpc>
               <a:spcBef>
                 <a:spcPts val="0"/>
@@ -9765,16 +9729,16 @@
                 <a:solidFill>
                   <a:srgbClr val="1A1A1A"/>
                 </a:solidFill>
-                <a:latin typeface="Calibri"/>
-                <a:rFonts ascii="Calibri" hAnsi="Calibri" cs="Calibri"/>
+                <a:latin typeface="Golos Text"/>
+                <a:rFonts ascii="Golos Text" hAnsi="Golos Text" cs="Golos Text" eastAsia="Golos Text"/>
               </a:rPr>
               <a:t>Этапы 3–6 — учебный сценарий,</a:t>
             </a:r>
           </a:p>
           <a:p>
-            <a:pPr>
-              <a:lnSpc>
-                <a:spcPct val="115000"/>
+            <a:pPr algn="l">
+              <a:lnSpc>
+                <a:spcPct val="118000"/>
               </a:lnSpc>
               <a:spcBef>
                 <a:spcPts val="0"/>
@@ -9788,8 +9752,8 @@
                 <a:solidFill>
                   <a:srgbClr val="1A1A1A"/>
                 </a:solidFill>
-                <a:latin typeface="Calibri"/>
-                <a:rFonts ascii="Calibri" hAnsi="Calibri" cs="Calibri"/>
+                <a:latin typeface="Golos Text"/>
+                <a:rFonts ascii="Golos Text" hAnsi="Golos Text" cs="Golos Text" eastAsia="Golos Text"/>
               </a:rPr>
               <a:t>не факт завода.</a:t>
             </a:r>
@@ -9927,8 +9891,8 @@
                 <a:solidFill>
                   <a:srgbClr val="2A554A"/>
                 </a:solidFill>
-                <a:latin typeface="Calibri"/>
-                <a:rFonts ascii="Calibri" hAnsi="Calibri" cs="Calibri"/>
+                <a:latin typeface="Manrope"/>
+                <a:rFonts ascii="Manrope" hAnsi="Manrope" cs="Manrope" eastAsia="Manrope"/>
               </a:rPr>
               <a:t>Питч закупщику (30 секунд)</a:t>
             </a:r>
@@ -10048,10 +10012,10 @@
                 <a:solidFill>
                   <a:srgbClr val="5C5C5C"/>
                 </a:solidFill>
-                <a:latin typeface="Calibri"/>
-                <a:rFonts ascii="Calibri" hAnsi="Calibri" cs="Calibri"/>
-              </a:rPr>
-              <a:t>Travel+ Natural  ·  пульт v1.14  ·  собеседование  ·  не оферта</a:t>
+                <a:latin typeface="Golos Text"/>
+                <a:rFonts ascii="Golos Text" hAnsi="Golos Text" cs="Golos Text" eastAsia="Golos Text"/>
+              </a:rPr>
+              <a:t>Travel+ Natural  ·  образец презентации</a:t>
             </a:r>
           </a:p>
         </p:txBody>
@@ -10084,8 +10048,8 @@
                 <a:solidFill>
                   <a:srgbClr val="5C5C5C"/>
                 </a:solidFill>
-                <a:latin typeface="Calibri"/>
-                <a:rFonts ascii="Calibri" hAnsi="Calibri" cs="Calibri"/>
+                <a:latin typeface="Golos Text"/>
+                <a:rFonts ascii="Golos Text" hAnsi="Golos Text" cs="Golos Text" eastAsia="Golos Text"/>
               </a:rPr>
               <a:t>7 / 12</a:t>
             </a:r>
@@ -10148,7 +10112,7 @@
         <p:spPr>
           <a:xfrm>
             <a:off x="457200" y="960120"/>
-            <a:ext cx="11277295" cy="73152"/>
+            <a:ext cx="11277295" cy="82296"/>
           </a:xfrm>
           <a:prstGeom prst="rect">
             <a:avLst/>
@@ -10190,8 +10154,8 @@
         </p:nvSpPr>
         <p:spPr>
           <a:xfrm>
-            <a:off x="749808" y="1280160"/>
-            <a:ext cx="10692079" cy="3657600"/>
+            <a:off x="804672" y="1426464"/>
+            <a:ext cx="10582351" cy="3465576"/>
           </a:xfrm>
           <a:prstGeom prst="rect">
             <a:avLst/>
@@ -10199,14 +10163,12 @@
           <a:noFill/>
         </p:spPr>
         <p:txBody>
-          <a:bodyPr wrap="square">
-            <a:spAutoFit/>
-          </a:bodyPr>
-          <a:lstStyle/>
-          <a:p>
-            <a:pPr>
-              <a:lnSpc>
-                <a:spcPct val="115000"/>
+          <a:bodyPr wrap="square" anchor="t" lIns="50800" rIns="50800" tIns="25400" bIns="25400"/>
+          <a:lstStyle/>
+          <a:p>
+            <a:pPr algn="l">
+              <a:lnSpc>
+                <a:spcPct val="118000"/>
               </a:lnSpc>
               <a:spcBef>
                 <a:spcPts val="0"/>
@@ -10220,16 +10182,16 @@
                 <a:solidFill>
                   <a:srgbClr val="1A1A1A"/>
                 </a:solidFill>
-                <a:latin typeface="Calibri"/>
-                <a:rFonts ascii="Calibri" hAnsi="Calibri" cs="Calibri"/>
+                <a:latin typeface="Golos Text"/>
+                <a:rFonts ascii="Golos Text" hAnsi="Golos Text" cs="Golos Text" eastAsia="Golos Text"/>
               </a:rPr>
               <a:t>«Вам нужно выглядеть зеленее — и спокойно пройти и гостя, и документы.</a:t>
             </a:r>
           </a:p>
           <a:p>
-            <a:pPr>
-              <a:lnSpc>
-                <a:spcPct val="115000"/>
+            <a:pPr algn="l">
+              <a:lnSpc>
+                <a:spcPct val="118000"/>
               </a:lnSpc>
               <a:spcBef>
                 <a:spcPts val="0"/>
@@ -10243,16 +10205,16 @@
                 <a:solidFill>
                   <a:srgbClr val="1A1A1A"/>
                 </a:solidFill>
-                <a:latin typeface="Calibri"/>
-                <a:rFonts ascii="Calibri" hAnsi="Calibri" cs="Calibri"/>
+                <a:latin typeface="Golos Text"/>
+                <a:rFonts ascii="Golos Text" hAnsi="Golos Text" cs="Golos Text" eastAsia="Golos Text"/>
               </a:rPr>
               <a:t>Travel+ Natural: пакет документов как у Hotel Line и Fleur</a:t>
             </a:r>
           </a:p>
           <a:p>
-            <a:pPr>
-              <a:lnSpc>
-                <a:spcPct val="115000"/>
+            <a:pPr algn="l">
+              <a:lnSpc>
+                <a:spcPct val="118000"/>
               </a:lnSpc>
               <a:spcBef>
                 <a:spcPts val="0"/>
@@ -10266,16 +10228,16 @@
                 <a:solidFill>
                   <a:srgbClr val="5C5C5C"/>
                 </a:solidFill>
-                <a:latin typeface="Calibri"/>
-                <a:rFonts ascii="Calibri" hAnsi="Calibri" cs="Calibri"/>
+                <a:latin typeface="Golos Text"/>
+                <a:rFonts ascii="Golos Text" hAnsi="Golos Text" cs="Golos Text" eastAsia="Golos Text"/>
               </a:rPr>
               <a:t>(декларация / СГР, INCI, протоколы по запросу),</a:t>
             </a:r>
           </a:p>
           <a:p>
-            <a:pPr>
-              <a:lnSpc>
-                <a:spcPct val="115000"/>
+            <a:pPr algn="l">
+              <a:lnSpc>
+                <a:spcPct val="118000"/>
               </a:lnSpc>
               <a:spcBef>
                 <a:spcPts val="0"/>
@@ -10289,16 +10251,16 @@
                 <a:solidFill>
                   <a:srgbClr val="1A1A1A"/>
                 </a:solidFill>
-                <a:latin typeface="Calibri"/>
-                <a:rFonts ascii="Calibri" hAnsi="Calibri" cs="Calibri"/>
+                <a:latin typeface="Golos Text"/>
+                <a:rFonts ascii="Golos Text" hAnsi="Golos Text" cs="Golos Text" eastAsia="Golos Text"/>
               </a:rPr>
               <a:t>прозрачный состав с блоком «простыми словами», один договор на номер.</a:t>
             </a:r>
           </a:p>
           <a:p>
-            <a:pPr>
-              <a:lnSpc>
-                <a:spcPct val="115000"/>
+            <a:pPr algn="l">
+              <a:lnSpc>
+                <a:spcPct val="118000"/>
               </a:lnSpc>
               <a:spcBef>
                 <a:spcPts val="0"/>
@@ -10312,8 +10274,8 @@
                 <a:solidFill>
                   <a:srgbClr val="1A1A1A"/>
                 </a:solidFill>
-                <a:latin typeface="Calibri"/>
-                <a:rFonts ascii="Calibri" hAnsi="Calibri" cs="Calibri"/>
+                <a:latin typeface="Manrope"/>
+                <a:rFonts ascii="Manrope" hAnsi="Manrope" cs="Manrope" eastAsia="Manrope"/>
               </a:rPr>
               <a:t>Три шага: eco / wellness → образец → пилот.»</a:t>
             </a:r>
@@ -10328,8 +10290,8 @@
         </p:nvSpPr>
         <p:spPr>
           <a:xfrm>
-            <a:off x="457200" y="5394960"/>
-            <a:ext cx="11277295" cy="548640"/>
+            <a:off x="804672" y="5367528"/>
+            <a:ext cx="10582351" cy="502920"/>
           </a:xfrm>
           <a:prstGeom prst="rect">
             <a:avLst/>
@@ -10337,20 +10299,18 @@
           <a:noFill/>
         </p:spPr>
         <p:txBody>
-          <a:bodyPr wrap="square">
-            <a:spAutoFit/>
-          </a:bodyPr>
-          <a:lstStyle/>
-          <a:p>
-            <a:pPr>
-              <a:lnSpc>
-                <a:spcPct val="115000"/>
-              </a:lnSpc>
-              <a:spcBef>
-                <a:spcPts val="0"/>
-              </a:spcBef>
-              <a:spcAft>
-                <a:spcPts val="600"/>
+          <a:bodyPr wrap="square" anchor="t" lIns="50800" rIns="50800" tIns="25400" bIns="25400"/>
+          <a:lstStyle/>
+          <a:p>
+            <a:pPr algn="l">
+              <a:lnSpc>
+                <a:spcPct val="118000"/>
+              </a:lnSpc>
+              <a:spcBef>
+                <a:spcPts val="0"/>
+              </a:spcBef>
+              <a:spcAft>
+                <a:spcPts val="0"/>
               </a:spcAft>
             </a:pPr>
             <a:r>
@@ -10358,8 +10318,8 @@
                 <a:solidFill>
                   <a:srgbClr val="5C5C5C"/>
                 </a:solidFill>
-                <a:latin typeface="Calibri"/>
-                <a:rFonts ascii="Calibri" hAnsi="Calibri" cs="Calibri"/>
+                <a:latin typeface="Golos Text"/>
+                <a:rFonts ascii="Golos Text" hAnsi="Golos Text" cs="Golos Text" eastAsia="Golos Text"/>
               </a:rPr>
               <a:t>Отрицания (COSMOS, origin, цена Hotel Line) — только в возражениях.</a:t>
             </a:r>
@@ -10497,8 +10457,8 @@
                 <a:solidFill>
                   <a:srgbClr val="2A554A"/>
                 </a:solidFill>
-                <a:latin typeface="Calibri"/>
-                <a:rFonts ascii="Calibri" hAnsi="Calibri" cs="Calibri"/>
+                <a:latin typeface="Manrope"/>
+                <a:rFonts ascii="Manrope" hAnsi="Manrope" cs="Manrope" eastAsia="Manrope"/>
               </a:rPr>
               <a:t>Поле: возражения и риски</a:t>
             </a:r>
@@ -10618,10 +10578,10 @@
                 <a:solidFill>
                   <a:srgbClr val="5C5C5C"/>
                 </a:solidFill>
-                <a:latin typeface="Calibri"/>
-                <a:rFonts ascii="Calibri" hAnsi="Calibri" cs="Calibri"/>
-              </a:rPr>
-              <a:t>Travel+ Natural  ·  пульт v1.14  ·  собеседование  ·  не оферта</a:t>
+                <a:latin typeface="Golos Text"/>
+                <a:rFonts ascii="Golos Text" hAnsi="Golos Text" cs="Golos Text" eastAsia="Golos Text"/>
+              </a:rPr>
+              <a:t>Travel+ Natural  ·  образец презентации</a:t>
             </a:r>
           </a:p>
         </p:txBody>
@@ -10654,8 +10614,8 @@
                 <a:solidFill>
                   <a:srgbClr val="5C5C5C"/>
                 </a:solidFill>
-                <a:latin typeface="Calibri"/>
-                <a:rFonts ascii="Calibri" hAnsi="Calibri" cs="Calibri"/>
+                <a:latin typeface="Golos Text"/>
+                <a:rFonts ascii="Golos Text" hAnsi="Golos Text" cs="Golos Text" eastAsia="Golos Text"/>
               </a:rPr>
               <a:t>8 / 12</a:t>
             </a:r>
@@ -10718,7 +10678,7 @@
         <p:spPr>
           <a:xfrm>
             <a:off x="457200" y="960120"/>
-            <a:ext cx="5510631" cy="73152"/>
+            <a:ext cx="5510631" cy="82296"/>
           </a:xfrm>
           <a:prstGeom prst="rect">
             <a:avLst/>
@@ -10808,7 +10768,7 @@
         <p:spPr>
           <a:xfrm>
             <a:off x="6223863" y="960120"/>
-            <a:ext cx="5510631" cy="73152"/>
+            <a:ext cx="5510631" cy="82296"/>
           </a:xfrm>
           <a:prstGeom prst="rect">
             <a:avLst/>
@@ -10850,8 +10810,8 @@
         </p:nvSpPr>
         <p:spPr>
           <a:xfrm>
-            <a:off x="749808" y="1216152"/>
-            <a:ext cx="4925415" cy="4663440"/>
+            <a:off x="804672" y="1426464"/>
+            <a:ext cx="4815687" cy="4334256"/>
           </a:xfrm>
           <a:prstGeom prst="rect">
             <a:avLst/>
@@ -10859,20 +10819,18 @@
           <a:noFill/>
         </p:spPr>
         <p:txBody>
-          <a:bodyPr wrap="square">
-            <a:spAutoFit/>
-          </a:bodyPr>
-          <a:lstStyle/>
-          <a:p>
-            <a:pPr>
-              <a:lnSpc>
-                <a:spcPct val="115000"/>
-              </a:lnSpc>
-              <a:spcBef>
-                <a:spcPts val="0"/>
-              </a:spcBef>
-              <a:spcAft>
-                <a:spcPts val="1400"/>
+          <a:bodyPr wrap="square" anchor="t" lIns="50800" rIns="50800" tIns="25400" bIns="25400"/>
+          <a:lstStyle/>
+          <a:p>
+            <a:pPr algn="l">
+              <a:lnSpc>
+                <a:spcPct val="118000"/>
+              </a:lnSpc>
+              <a:spcBef>
+                <a:spcPts val="0"/>
+              </a:spcBef>
+              <a:spcAft>
+                <a:spcPts val="1200"/>
               </a:spcAft>
             </a:pPr>
             <a:r>
@@ -10880,16 +10838,16 @@
                 <a:solidFill>
                   <a:srgbClr val="2A554A"/>
                 </a:solidFill>
-                <a:latin typeface="Calibri"/>
-                <a:rFonts ascii="Calibri" hAnsi="Calibri" cs="Calibri"/>
+                <a:latin typeface="Manrope"/>
+                <a:rFonts ascii="Manrope" hAnsi="Manrope" cs="Manrope" eastAsia="Manrope"/>
               </a:rPr>
               <a:t>Возражения</a:t>
             </a:r>
           </a:p>
           <a:p>
-            <a:pPr>
-              <a:lnSpc>
-                <a:spcPct val="115000"/>
+            <a:pPr algn="l">
+              <a:lnSpc>
+                <a:spcPct val="118000"/>
               </a:lnSpc>
               <a:spcBef>
                 <a:spcPts val="0"/>
@@ -10903,16 +10861,16 @@
                 <a:solidFill>
                   <a:srgbClr val="1A1A1A"/>
                 </a:solidFill>
-                <a:latin typeface="Calibri"/>
-                <a:rFonts ascii="Calibri" hAnsi="Calibri" cs="Calibri"/>
+                <a:latin typeface="Golos Text"/>
+                <a:rFonts ascii="Golos Text" hAnsi="Golos Text" cs="Golos Text" eastAsia="Golos Text"/>
               </a:rPr>
               <a:t>COSMOS обязателен → Natural в это КП не ставим</a:t>
             </a:r>
           </a:p>
           <a:p>
-            <a:pPr>
-              <a:lnSpc>
-                <a:spcPct val="115000"/>
+            <a:pPr algn="l">
+              <a:lnSpc>
+                <a:spcPct val="118000"/>
               </a:lnSpc>
               <a:spcBef>
                 <a:spcPts val="0"/>
@@ -10926,16 +10884,16 @@
                 <a:solidFill>
                   <a:srgbClr val="1A1A1A"/>
                 </a:solidFill>
-                <a:latin typeface="Calibri"/>
-                <a:rFonts ascii="Calibri" hAnsi="Calibri" cs="Calibri"/>
+                <a:latin typeface="Golos Text"/>
+                <a:rFonts ascii="Golos Text" hAnsi="Golos Text" cs="Golos Text" eastAsia="Golos Text"/>
               </a:rPr>
               <a:t>«Natural по цене Hotel Line» → нет</a:t>
             </a:r>
           </a:p>
           <a:p>
-            <a:pPr>
-              <a:lnSpc>
-                <a:spcPct val="115000"/>
+            <a:pPr algn="l">
+              <a:lnSpc>
+                <a:spcPct val="118000"/>
               </a:lnSpc>
               <a:spcBef>
                 <a:spcPts val="0"/>
@@ -10949,16 +10907,16 @@
                 <a:solidFill>
                   <a:srgbClr val="1A1A1A"/>
                 </a:solidFill>
-                <a:latin typeface="Calibri"/>
-                <a:rFonts ascii="Calibri" hAnsi="Calibri" cs="Calibri"/>
+                <a:latin typeface="Golos Text"/>
+                <a:rFonts ascii="Golos Text" hAnsi="Golos Text" cs="Golos Text" eastAsia="Golos Text"/>
               </a:rPr>
               <a:t>СТМ / лого отеля → отдельный проект</a:t>
             </a:r>
           </a:p>
           <a:p>
-            <a:pPr>
-              <a:lnSpc>
-                <a:spcPct val="115000"/>
+            <a:pPr algn="l">
+              <a:lnSpc>
+                <a:spcPct val="118000"/>
               </a:lnSpc>
               <a:spcBef>
                 <a:spcPts val="0"/>
@@ -10972,8 +10930,8 @@
                 <a:solidFill>
                   <a:srgbClr val="1A1A1A"/>
                 </a:solidFill>
-                <a:latin typeface="Calibri"/>
-                <a:rFonts ascii="Calibri" hAnsi="Calibri" cs="Calibri"/>
+                <a:latin typeface="Golos Text"/>
+                <a:rFonts ascii="Golos Text" hAnsi="Golos Text" cs="Golos Text" eastAsia="Golos Text"/>
               </a:rPr>
               <a:t>«Где произведено?» → только зафиксированный origin</a:t>
             </a:r>
@@ -10988,8 +10946,8 @@
         </p:nvSpPr>
         <p:spPr>
           <a:xfrm>
-            <a:off x="6516471" y="1216152"/>
-            <a:ext cx="4925415" cy="4663440"/>
+            <a:off x="6571335" y="1426464"/>
+            <a:ext cx="4815687" cy="4334256"/>
           </a:xfrm>
           <a:prstGeom prst="rect">
             <a:avLst/>
@@ -10997,20 +10955,18 @@
           <a:noFill/>
         </p:spPr>
         <p:txBody>
-          <a:bodyPr wrap="square">
-            <a:spAutoFit/>
-          </a:bodyPr>
-          <a:lstStyle/>
-          <a:p>
-            <a:pPr>
-              <a:lnSpc>
-                <a:spcPct val="115000"/>
-              </a:lnSpc>
-              <a:spcBef>
-                <a:spcPts val="0"/>
-              </a:spcBef>
-              <a:spcAft>
-                <a:spcPts val="1400"/>
+          <a:bodyPr wrap="square" anchor="t" lIns="50800" rIns="50800" tIns="25400" bIns="25400"/>
+          <a:lstStyle/>
+          <a:p>
+            <a:pPr algn="l">
+              <a:lnSpc>
+                <a:spcPct val="118000"/>
+              </a:lnSpc>
+              <a:spcBef>
+                <a:spcPts val="0"/>
+              </a:spcBef>
+              <a:spcAft>
+                <a:spcPts val="1200"/>
               </a:spcAft>
             </a:pPr>
             <a:r>
@@ -11018,16 +10974,16 @@
                 <a:solidFill>
                   <a:srgbClr val="2A554A"/>
                 </a:solidFill>
-                <a:latin typeface="Calibri"/>
-                <a:rFonts ascii="Calibri" hAnsi="Calibri" cs="Calibri"/>
+                <a:latin typeface="Manrope"/>
+                <a:rFonts ascii="Manrope" hAnsi="Manrope" cs="Manrope" eastAsia="Manrope"/>
               </a:rPr>
               <a:t>Полевая дисциплина</a:t>
             </a:r>
           </a:p>
           <a:p>
-            <a:pPr>
-              <a:lnSpc>
-                <a:spcPct val="115000"/>
+            <a:pPr algn="l">
+              <a:lnSpc>
+                <a:spcPct val="118000"/>
               </a:lnSpc>
               <a:spcBef>
                 <a:spcPts val="0"/>
@@ -11041,16 +10997,16 @@
                 <a:solidFill>
                   <a:srgbClr val="1A1A1A"/>
                 </a:solidFill>
-                <a:latin typeface="Calibri"/>
-                <a:rFonts ascii="Calibri" hAnsi="Calibri" cs="Calibri"/>
+                <a:latin typeface="Golos Text"/>
+                <a:rFonts ascii="Golos Text" hAnsi="Golos Text" cs="Golos Text" eastAsia="Golos Text"/>
               </a:rPr>
               <a:t>Реестр рисков — один лист</a:t>
             </a:r>
           </a:p>
           <a:p>
-            <a:pPr>
-              <a:lnSpc>
-                <a:spcPct val="115000"/>
+            <a:pPr algn="l">
+              <a:lnSpc>
+                <a:spcPct val="118000"/>
               </a:lnSpc>
               <a:spcBef>
                 <a:spcPts val="0"/>
@@ -11064,16 +11020,16 @@
                 <a:solidFill>
                   <a:srgbClr val="5C5C5C"/>
                 </a:solidFill>
-                <a:latin typeface="Calibri"/>
-                <a:rFonts ascii="Calibri" hAnsi="Calibri" cs="Calibri"/>
+                <a:latin typeface="Golos Text"/>
+                <a:rFonts ascii="Golos Text" hAnsi="Golos Text" cs="Golos Text" eastAsia="Golos Text"/>
               </a:rPr>
               <a:t>(14 пунктов в пульте)</a:t>
             </a:r>
           </a:p>
           <a:p>
-            <a:pPr>
-              <a:lnSpc>
-                <a:spcPct val="115000"/>
+            <a:pPr algn="l">
+              <a:lnSpc>
+                <a:spcPct val="118000"/>
               </a:lnSpc>
               <a:spcBef>
                 <a:spcPts val="0"/>
@@ -11087,16 +11043,16 @@
                 <a:solidFill>
                   <a:srgbClr val="1A1A1A"/>
                 </a:solidFill>
-                <a:latin typeface="Calibri"/>
-                <a:rFonts ascii="Calibri" hAnsi="Calibri" cs="Calibri"/>
+                <a:latin typeface="Golos Text"/>
+                <a:rFonts ascii="Golos Text" hAnsi="Golos Text" cs="Golos Text" eastAsia="Golos Text"/>
               </a:rPr>
               <a:t>Сегмент не размываем.</a:t>
             </a:r>
           </a:p>
           <a:p>
-            <a:pPr>
-              <a:lnSpc>
-                <a:spcPct val="115000"/>
+            <a:pPr algn="l">
+              <a:lnSpc>
+                <a:spcPct val="118000"/>
               </a:lnSpc>
               <a:spcBef>
                 <a:spcPts val="0"/>
@@ -11110,8 +11066,8 @@
                 <a:solidFill>
                   <a:srgbClr val="1A1A1A"/>
                 </a:solidFill>
-                <a:latin typeface="Calibri"/>
-                <a:rFonts ascii="Calibri" hAnsi="Calibri" cs="Calibri"/>
+                <a:latin typeface="Manrope"/>
+                <a:rFonts ascii="Manrope" hAnsi="Manrope" cs="Manrope" eastAsia="Manrope"/>
               </a:rPr>
               <a:t>Не продаём Natural в эконом Hotel Line.</a:t>
             </a:r>
@@ -11249,8 +11205,8 @@
                 <a:solidFill>
                   <a:srgbClr val="2A554A"/>
                 </a:solidFill>
-                <a:latin typeface="Calibri"/>
-                <a:rFonts ascii="Calibri" hAnsi="Calibri" cs="Calibri"/>
+                <a:latin typeface="Manrope"/>
+                <a:rFonts ascii="Manrope" hAnsi="Manrope" cs="Manrope" eastAsia="Manrope"/>
               </a:rPr>
               <a:t>Пилот: успех, провал, выход</a:t>
             </a:r>
@@ -11370,10 +11326,10 @@
                 <a:solidFill>
                   <a:srgbClr val="5C5C5C"/>
                 </a:solidFill>
-                <a:latin typeface="Calibri"/>
-                <a:rFonts ascii="Calibri" hAnsi="Calibri" cs="Calibri"/>
-              </a:rPr>
-              <a:t>Travel+ Natural  ·  пульт v1.14  ·  собеседование  ·  не оферта</a:t>
+                <a:latin typeface="Golos Text"/>
+                <a:rFonts ascii="Golos Text" hAnsi="Golos Text" cs="Golos Text" eastAsia="Golos Text"/>
+              </a:rPr>
+              <a:t>Travel+ Natural  ·  образец презентации</a:t>
             </a:r>
           </a:p>
         </p:txBody>
@@ -11406,8 +11362,8 @@
                 <a:solidFill>
                   <a:srgbClr val="5C5C5C"/>
                 </a:solidFill>
-                <a:latin typeface="Calibri"/>
-                <a:rFonts ascii="Calibri" hAnsi="Calibri" cs="Calibri"/>
+                <a:latin typeface="Golos Text"/>
+                <a:rFonts ascii="Golos Text" hAnsi="Golos Text" cs="Golos Text" eastAsia="Golos Text"/>
               </a:rPr>
               <a:t>9 / 12</a:t>
             </a:r>
@@ -11470,7 +11426,7 @@
         <p:spPr>
           <a:xfrm>
             <a:off x="457200" y="960120"/>
-            <a:ext cx="5510631" cy="73152"/>
+            <a:ext cx="5510631" cy="82296"/>
           </a:xfrm>
           <a:prstGeom prst="rect">
             <a:avLst/>
@@ -11560,7 +11516,7 @@
         <p:spPr>
           <a:xfrm>
             <a:off x="6223863" y="960120"/>
-            <a:ext cx="5510631" cy="73152"/>
+            <a:ext cx="5510631" cy="82296"/>
           </a:xfrm>
           <a:prstGeom prst="rect">
             <a:avLst/>
@@ -11602,8 +11558,8 @@
         </p:nvSpPr>
         <p:spPr>
           <a:xfrm>
-            <a:off x="749808" y="1216152"/>
-            <a:ext cx="4925415" cy="4663440"/>
+            <a:off x="804672" y="1426464"/>
+            <a:ext cx="4815687" cy="4334256"/>
           </a:xfrm>
           <a:prstGeom prst="rect">
             <a:avLst/>
@@ -11611,14 +11567,104 @@
           <a:noFill/>
         </p:spPr>
         <p:txBody>
-          <a:bodyPr wrap="square">
-            <a:spAutoFit/>
-          </a:bodyPr>
-          <a:lstStyle/>
-          <a:p>
-            <a:pPr>
-              <a:lnSpc>
-                <a:spcPct val="115000"/>
+          <a:bodyPr wrap="square" anchor="t" lIns="50800" rIns="50800" tIns="25400" bIns="25400"/>
+          <a:lstStyle/>
+          <a:p>
+            <a:pPr algn="l">
+              <a:lnSpc>
+                <a:spcPct val="118000"/>
+              </a:lnSpc>
+              <a:spcBef>
+                <a:spcPts val="0"/>
+              </a:spcBef>
+              <a:spcAft>
+                <a:spcPts val="1200"/>
+              </a:spcAft>
+            </a:pPr>
+            <a:r>
+              <a:rPr sz="1500" b="1">
+                <a:solidFill>
+                  <a:srgbClr val="2A554A"/>
+                </a:solidFill>
+                <a:latin typeface="Manrope"/>
+                <a:rFonts ascii="Manrope" hAnsi="Manrope" cs="Manrope" eastAsia="Manrope"/>
+              </a:rPr>
+              <a:t>Успех (учебный порог)</a:t>
+            </a:r>
+          </a:p>
+          <a:p>
+            <a:pPr algn="l">
+              <a:lnSpc>
+                <a:spcPct val="118000"/>
+              </a:lnSpc>
+              <a:spcBef>
+                <a:spcPts val="0"/>
+              </a:spcBef>
+              <a:spcAft>
+                <a:spcPts val="800"/>
+              </a:spcAft>
+            </a:pPr>
+            <a:r>
+              <a:rPr sz="1600" b="0">
+                <a:solidFill>
+                  <a:srgbClr val="1A1A1A"/>
+                </a:solidFill>
+                <a:latin typeface="Golos Text"/>
+                <a:rFonts ascii="Golos Text" hAnsi="Golos Text" cs="Golos Text" eastAsia="Golos Text"/>
+              </a:rPr>
+              <a:t>• 3 пилотных клиента</a:t>
+            </a:r>
+          </a:p>
+          <a:p>
+            <a:pPr algn="l">
+              <a:lnSpc>
+                <a:spcPct val="118000"/>
+              </a:lnSpc>
+              <a:spcBef>
+                <a:spcPts val="0"/>
+              </a:spcBef>
+              <a:spcAft>
+                <a:spcPts val="800"/>
+              </a:spcAft>
+            </a:pPr>
+            <a:r>
+              <a:rPr sz="1600" b="0">
+                <a:solidFill>
+                  <a:srgbClr val="1A1A1A"/>
+                </a:solidFill>
+                <a:latin typeface="Golos Text"/>
+                <a:rFonts ascii="Golos Text" hAnsi="Golos Text" cs="Golos Text" eastAsia="Golos Text"/>
+              </a:rPr>
+              <a:t>• Повторный заказ у ≥ 2 из 3</a:t>
+            </a:r>
+          </a:p>
+          <a:p>
+            <a:pPr algn="l">
+              <a:lnSpc>
+                <a:spcPct val="118000"/>
+              </a:lnSpc>
+              <a:spcBef>
+                <a:spcPts val="0"/>
+              </a:spcBef>
+              <a:spcAft>
+                <a:spcPts val="1000"/>
+              </a:spcAft>
+            </a:pPr>
+            <a:r>
+              <a:rPr sz="1600" b="0">
+                <a:solidFill>
+                  <a:srgbClr val="1A1A1A"/>
+                </a:solidFill>
+                <a:latin typeface="Golos Text"/>
+                <a:rFonts ascii="Golos Text" hAnsi="Golos Text" cs="Golos Text" eastAsia="Golos Text"/>
+              </a:rPr>
+              <a:t>• Мягкость и ощущение натуральности ≥ 70%</a:t>
+            </a:r>
+          </a:p>
+          <a:p>
+            <a:pPr algn="l">
+              <a:lnSpc>
+                <a:spcPct val="118000"/>
               </a:lnSpc>
               <a:spcBef>
                 <a:spcPts val="0"/>
@@ -11628,112 +11674,20 @@
               </a:spcAft>
             </a:pPr>
             <a:r>
-              <a:rPr sz="1500" b="1">
-                <a:solidFill>
-                  <a:srgbClr val="2A554A"/>
-                </a:solidFill>
-                <a:latin typeface="Calibri"/>
-                <a:rFonts ascii="Calibri" hAnsi="Calibri" cs="Calibri"/>
-              </a:rPr>
-              <a:t>Успех (учебный порог)</a:t>
-            </a:r>
-          </a:p>
-          <a:p>
-            <a:pPr>
-              <a:lnSpc>
-                <a:spcPct val="115000"/>
-              </a:lnSpc>
-              <a:spcBef>
-                <a:spcPts val="0"/>
-              </a:spcBef>
-              <a:spcAft>
-                <a:spcPts val="800"/>
-              </a:spcAft>
-            </a:pPr>
-            <a:r>
-              <a:rPr sz="1600" b="0">
+              <a:rPr sz="1600" b="1">
                 <a:solidFill>
                   <a:srgbClr val="1A1A1A"/>
                 </a:solidFill>
-                <a:latin typeface="Calibri"/>
-                <a:rFonts ascii="Calibri" hAnsi="Calibri" cs="Calibri"/>
-              </a:rPr>
-              <a:t>• 3 пилотных клиента</a:t>
-            </a:r>
-          </a:p>
-          <a:p>
-            <a:pPr>
-              <a:lnSpc>
-                <a:spcPct val="115000"/>
-              </a:lnSpc>
-              <a:spcBef>
-                <a:spcPts val="0"/>
-              </a:spcBef>
-              <a:spcAft>
-                <a:spcPts val="800"/>
-              </a:spcAft>
-            </a:pPr>
-            <a:r>
-              <a:rPr sz="1600" b="0">
-                <a:solidFill>
-                  <a:srgbClr val="1A1A1A"/>
-                </a:solidFill>
-                <a:latin typeface="Calibri"/>
-                <a:rFonts ascii="Calibri" hAnsi="Calibri" cs="Calibri"/>
-              </a:rPr>
-              <a:t>• Повторный заказ у ≥ 2 из 3</a:t>
-            </a:r>
-          </a:p>
-          <a:p>
-            <a:pPr>
-              <a:lnSpc>
-                <a:spcPct val="115000"/>
-              </a:lnSpc>
-              <a:spcBef>
-                <a:spcPts val="0"/>
-              </a:spcBef>
-              <a:spcAft>
-                <a:spcPts val="1000"/>
-              </a:spcAft>
-            </a:pPr>
-            <a:r>
-              <a:rPr sz="1600" b="0">
-                <a:solidFill>
-                  <a:srgbClr val="1A1A1A"/>
-                </a:solidFill>
-                <a:latin typeface="Calibri"/>
-                <a:rFonts ascii="Calibri" hAnsi="Calibri" cs="Calibri"/>
-              </a:rPr>
-              <a:t>• Мягкость и ощущение натуральности ≥ 70%</a:t>
-            </a:r>
-          </a:p>
-          <a:p>
-            <a:pPr>
-              <a:lnSpc>
-                <a:spcPct val="115000"/>
-              </a:lnSpc>
-              <a:spcBef>
-                <a:spcPts val="0"/>
-              </a:spcBef>
-              <a:spcAft>
-                <a:spcPts val="1400"/>
-              </a:spcAft>
-            </a:pPr>
-            <a:r>
-              <a:rPr sz="1600" b="1">
-                <a:solidFill>
-                  <a:srgbClr val="1A1A1A"/>
-                </a:solidFill>
-                <a:latin typeface="Calibri"/>
-                <a:rFonts ascii="Calibri" hAnsi="Calibri" cs="Calibri"/>
+                <a:latin typeface="Manrope"/>
+                <a:rFonts ascii="Manrope" hAnsi="Manrope" cs="Manrope" eastAsia="Manrope"/>
               </a:rPr>
               <a:t>• Natural не ушёл в эконом Hotel Line</a:t>
             </a:r>
           </a:p>
           <a:p>
-            <a:pPr>
-              <a:lnSpc>
-                <a:spcPct val="115000"/>
+            <a:pPr algn="l">
+              <a:lnSpc>
+                <a:spcPct val="118000"/>
               </a:lnSpc>
               <a:spcBef>
                 <a:spcPts val="0"/>
@@ -11747,16 +11701,16 @@
                 <a:solidFill>
                   <a:srgbClr val="5C5C5C"/>
                 </a:solidFill>
-                <a:latin typeface="Calibri"/>
-                <a:rFonts ascii="Calibri" hAnsi="Calibri" cs="Calibri"/>
+                <a:latin typeface="Golos Text"/>
+                <a:rFonts ascii="Golos Text" hAnsi="Golos Text" cs="Golos Text" eastAsia="Golos Text"/>
               </a:rPr>
               <a:t>Цифры сценария — учебный пример,</a:t>
             </a:r>
           </a:p>
           <a:p>
-            <a:pPr>
-              <a:lnSpc>
-                <a:spcPct val="115000"/>
+            <a:pPr algn="l">
+              <a:lnSpc>
+                <a:spcPct val="118000"/>
               </a:lnSpc>
               <a:spcBef>
                 <a:spcPts val="0"/>
@@ -11770,8 +11724,8 @@
                 <a:solidFill>
                   <a:srgbClr val="5C5C5C"/>
                 </a:solidFill>
-                <a:latin typeface="Calibri"/>
-                <a:rFonts ascii="Calibri" hAnsi="Calibri" cs="Calibri"/>
+                <a:latin typeface="Golos Text"/>
+                <a:rFonts ascii="Golos Text" hAnsi="Golos Text" cs="Golos Text" eastAsia="Golos Text"/>
               </a:rPr>
               <a:t>не отчёт завода.</a:t>
             </a:r>
@@ -11786,8 +11740,8 @@
         </p:nvSpPr>
         <p:spPr>
           <a:xfrm>
-            <a:off x="6516471" y="1216152"/>
-            <a:ext cx="4925415" cy="4663440"/>
+            <a:off x="6571335" y="1426464"/>
+            <a:ext cx="4815687" cy="4334256"/>
           </a:xfrm>
           <a:prstGeom prst="rect">
             <a:avLst/>
@@ -11795,20 +11749,18 @@
           <a:noFill/>
         </p:spPr>
         <p:txBody>
-          <a:bodyPr wrap="square">
-            <a:spAutoFit/>
-          </a:bodyPr>
-          <a:lstStyle/>
-          <a:p>
-            <a:pPr>
-              <a:lnSpc>
-                <a:spcPct val="115000"/>
-              </a:lnSpc>
-              <a:spcBef>
-                <a:spcPts val="0"/>
-              </a:spcBef>
-              <a:spcAft>
-                <a:spcPts val="1400"/>
+          <a:bodyPr wrap="square" anchor="t" lIns="50800" rIns="50800" tIns="25400" bIns="25400"/>
+          <a:lstStyle/>
+          <a:p>
+            <a:pPr algn="l">
+              <a:lnSpc>
+                <a:spcPct val="118000"/>
+              </a:lnSpc>
+              <a:spcBef>
+                <a:spcPts val="0"/>
+              </a:spcBef>
+              <a:spcAft>
+                <a:spcPts val="1200"/>
               </a:spcAft>
             </a:pPr>
             <a:r>
@@ -11816,16 +11768,16 @@
                 <a:solidFill>
                   <a:srgbClr val="2A554A"/>
                 </a:solidFill>
-                <a:latin typeface="Calibri"/>
-                <a:rFonts ascii="Calibri" hAnsi="Calibri" cs="Calibri"/>
+                <a:latin typeface="Manrope"/>
+                <a:rFonts ascii="Manrope" hAnsi="Manrope" cs="Manrope" eastAsia="Manrope"/>
               </a:rPr>
               <a:t>Провал и выход</a:t>
             </a:r>
           </a:p>
           <a:p>
-            <a:pPr>
-              <a:lnSpc>
-                <a:spcPct val="115000"/>
+            <a:pPr algn="l">
+              <a:lnSpc>
+                <a:spcPct val="118000"/>
               </a:lnSpc>
               <a:spcBef>
                 <a:spcPts val="0"/>
@@ -11839,16 +11791,16 @@
                 <a:solidFill>
                   <a:srgbClr val="1A1A1A"/>
                 </a:solidFill>
-                <a:latin typeface="Calibri"/>
-                <a:rFonts ascii="Calibri" hAnsi="Calibri" cs="Calibri"/>
+                <a:latin typeface="Golos Text"/>
+                <a:rFonts ascii="Golos Text" hAnsi="Golos Text" cs="Golos Text" eastAsia="Golos Text"/>
               </a:rPr>
               <a:t>Повтор &lt; 2 из 3 или метрики &lt; 60%</a:t>
             </a:r>
           </a:p>
           <a:p>
-            <a:pPr>
-              <a:lnSpc>
-                <a:spcPct val="115000"/>
+            <a:pPr algn="l">
+              <a:lnSpc>
+                <a:spcPct val="118000"/>
               </a:lnSpc>
               <a:spcBef>
                 <a:spcPts val="0"/>
@@ -11862,16 +11814,16 @@
                 <a:solidFill>
                   <a:srgbClr val="1A1A1A"/>
                 </a:solidFill>
-                <a:latin typeface="Calibri"/>
-                <a:rFonts ascii="Calibri" hAnsi="Calibri" cs="Calibri"/>
+                <a:latin typeface="Manrope"/>
+                <a:rFonts ascii="Manrope" hAnsi="Manrope" cs="Manrope" eastAsia="Manrope"/>
               </a:rPr>
               <a:t>→ Останавливаем масштаб</a:t>
             </a:r>
           </a:p>
           <a:p>
-            <a:pPr>
-              <a:lnSpc>
-                <a:spcPct val="115000"/>
+            <a:pPr algn="l">
+              <a:lnSpc>
+                <a:spcPct val="118000"/>
               </a:lnSpc>
               <a:spcBef>
                 <a:spcPts val="0"/>
@@ -11885,16 +11837,16 @@
                 <a:solidFill>
                   <a:srgbClr val="1A1A1A"/>
                 </a:solidFill>
-                <a:latin typeface="Calibri"/>
-                <a:rFonts ascii="Calibri" hAnsi="Calibri" cs="Calibri"/>
+                <a:latin typeface="Golos Text"/>
+                <a:rFonts ascii="Golos Text" hAnsi="Golos Text" cs="Golos Text" eastAsia="Golos Text"/>
               </a:rPr>
               <a:t>Диагноз бренд-менеджера за 2 недели</a:t>
             </a:r>
           </a:p>
           <a:p>
-            <a:pPr>
-              <a:lnSpc>
-                <a:spcPct val="115000"/>
+            <a:pPr algn="l">
+              <a:lnSpc>
+                <a:spcPct val="118000"/>
               </a:lnSpc>
               <a:spcBef>
                 <a:spcPts val="0"/>
@@ -11908,16 +11860,16 @@
                 <a:solidFill>
                   <a:srgbClr val="1A1A1A"/>
                 </a:solidFill>
-                <a:latin typeface="Calibri"/>
-                <a:rFonts ascii="Calibri" hAnsi="Calibri" cs="Calibri"/>
+                <a:latin typeface="Golos Text"/>
+                <a:rFonts ascii="Golos Text" hAnsi="Golos Text" cs="Golos Text" eastAsia="Golos Text"/>
               </a:rPr>
               <a:t>Второй круг снова провален</a:t>
             </a:r>
           </a:p>
           <a:p>
-            <a:pPr>
-              <a:lnSpc>
-                <a:spcPct val="115000"/>
+            <a:pPr algn="l">
+              <a:lnSpc>
+                <a:spcPct val="118000"/>
               </a:lnSpc>
               <a:spcBef>
                 <a:spcPts val="0"/>
@@ -11931,8 +11883,8 @@
                 <a:solidFill>
                   <a:srgbClr val="1A1A1A"/>
                 </a:solidFill>
-                <a:latin typeface="Calibri"/>
-                <a:rFonts ascii="Calibri" hAnsi="Calibri" cs="Calibri"/>
+                <a:latin typeface="Manrope"/>
+                <a:rFonts ascii="Manrope" hAnsi="Manrope" cs="Manrope" eastAsia="Manrope"/>
               </a:rPr>
               <a:t>→ Закрываем линейку</a:t>
             </a:r>

</xml_diff>

<commit_message>
content(presentation): expand copy slides 3-11, footnotes, clearer DoD
Co-authored-by: pagasbot-coder <pagasbot-coder@users.noreply.github.com>
</commit_message>
<xml_diff>
--- a/knowledge-base/presentation-travelplus-interview.pptx
+++ b/knowledge-base/presentation-travelplus-interview.pptx
@@ -3969,99 +3969,168 @@
                 <a:latin typeface="Manrope"/>
                 <a:rFonts ascii="Manrope" hAnsi="Manrope" cs="Manrope" eastAsia="Manrope"/>
               </a:rPr>
-              <a:t>Экономика</a:t>
-            </a:r>
-          </a:p>
-          <a:p>
-            <a:pPr algn="l">
-              <a:lnSpc>
-                <a:spcPct val="118000"/>
-              </a:lnSpc>
-              <a:spcBef>
-                <a:spcPts val="0"/>
-              </a:spcBef>
-              <a:spcAft>
-                <a:spcPts val="800"/>
-              </a:spcAft>
-            </a:pPr>
-            <a:r>
-              <a:rPr sz="1600" b="0">
+              <a:t>Экономика и цена</a:t>
+            </a:r>
+          </a:p>
+          <a:p>
+            <a:pPr algn="l">
+              <a:lnSpc>
+                <a:spcPct val="118000"/>
+              </a:lnSpc>
+              <a:spcBef>
+                <a:spcPts val="0"/>
+              </a:spcBef>
+              <a:spcAft>
+                <a:spcPts val="600"/>
+              </a:spcAft>
+            </a:pPr>
+            <a:r>
+              <a:rPr sz="1500" b="0">
                 <a:solidFill>
                   <a:srgbClr val="1A1A1A"/>
                 </a:solidFill>
                 <a:latin typeface="Golos Text"/>
                 <a:rFonts ascii="Golos Text" hAnsi="Golos Text" cs="Golos Text" eastAsia="Golos Text"/>
               </a:rPr>
-              <a:t>Прайс — после себестоимости на складе.</a:t>
-            </a:r>
-          </a:p>
-          <a:p>
-            <a:pPr algn="l">
-              <a:lnSpc>
-                <a:spcPct val="118000"/>
-              </a:lnSpc>
-              <a:spcBef>
-                <a:spcPts val="0"/>
-              </a:spcBef>
-              <a:spcAft>
-                <a:spcPts val="1200"/>
-              </a:spcAft>
-            </a:pPr>
-            <a:r>
-              <a:rPr sz="1600" b="0">
+              <a:t>Прайс утверждаем только после себестоимости на складе в Киришах.</a:t>
+            </a:r>
+          </a:p>
+          <a:p>
+            <a:pPr algn="l">
+              <a:lnSpc>
+                <a:spcPct val="118000"/>
+              </a:lnSpc>
+              <a:spcBef>
+                <a:spcPts val="0"/>
+              </a:spcBef>
+              <a:spcAft>
+                <a:spcPts val="400"/>
+              </a:spcAft>
+            </a:pPr>
+            <a:r>
+              <a:rPr sz="1500" b="0">
                 <a:solidFill>
                   <a:srgbClr val="1A1A1A"/>
                 </a:solidFill>
                 <a:latin typeface="Golos Text"/>
                 <a:rFonts ascii="Golos Text" hAnsi="Golos Text" cs="Golos Text" eastAsia="Golos Text"/>
               </a:rPr>
-              <a:t>Ориентир: выше Hotel Line · рядом с ЕТС · ниже NS.</a:t>
-            </a:r>
-          </a:p>
-          <a:p>
-            <a:pPr algn="l">
-              <a:lnSpc>
-                <a:spcPct val="118000"/>
-              </a:lnSpc>
-              <a:spcBef>
-                <a:spcPts val="0"/>
-              </a:spcBef>
-              <a:spcAft>
-                <a:spcPts val="800"/>
-              </a:spcAft>
-            </a:pPr>
-            <a:r>
-              <a:rPr sz="1600" b="1">
+              <a:t>Ориентир по полке:</a:t>
+            </a:r>
+          </a:p>
+          <a:p>
+            <a:pPr algn="l">
+              <a:lnSpc>
+                <a:spcPct val="118000"/>
+              </a:lnSpc>
+              <a:spcBef>
+                <a:spcPts val="0"/>
+              </a:spcBef>
+              <a:spcAft>
+                <a:spcPts val="600"/>
+              </a:spcAft>
+            </a:pPr>
+            <a:r>
+              <a:rPr sz="1500" b="0">
+                <a:solidFill>
+                  <a:srgbClr val="1A1A1A"/>
+                </a:solidFill>
+                <a:latin typeface="Golos Text"/>
+                <a:rFonts ascii="Golos Text" hAnsi="Golos Text" cs="Golos Text" eastAsia="Golos Text"/>
+              </a:rPr>
+              <a:t>• выше Hotel Line</a:t>
+            </a:r>
+          </a:p>
+          <a:p>
+            <a:pPr algn="l">
+              <a:lnSpc>
+                <a:spcPct val="118000"/>
+              </a:lnSpc>
+              <a:spcBef>
+                <a:spcPts val="0"/>
+              </a:spcBef>
+              <a:spcAft>
+                <a:spcPts val="600"/>
+              </a:spcAft>
+            </a:pPr>
+            <a:r>
+              <a:rPr sz="1500" b="0">
+                <a:solidFill>
+                  <a:srgbClr val="1A1A1A"/>
+                </a:solidFill>
+                <a:latin typeface="Golos Text"/>
+                <a:rFonts ascii="Golos Text" hAnsi="Golos Text" cs="Golos Text" eastAsia="Golos Text"/>
+              </a:rPr>
+              <a:t>• рядом с ЕТС Natural</a:t>
+            </a:r>
+          </a:p>
+          <a:p>
+            <a:pPr algn="l">
+              <a:lnSpc>
+                <a:spcPct val="118000"/>
+              </a:lnSpc>
+              <a:spcBef>
+                <a:spcPts val="0"/>
+              </a:spcBef>
+              <a:spcAft>
+                <a:spcPts val="1000"/>
+              </a:spcAft>
+            </a:pPr>
+            <a:r>
+              <a:rPr sz="1500" b="0">
+                <a:solidFill>
+                  <a:srgbClr val="1A1A1A"/>
+                </a:solidFill>
+                <a:latin typeface="Golos Text"/>
+                <a:rFonts ascii="Golos Text" hAnsi="Golos Text" cs="Golos Text" eastAsia="Golos Text"/>
+              </a:rPr>
+              <a:t>• ниже Natura Siberica</a:t>
+            </a:r>
+          </a:p>
+          <a:p>
+            <a:pPr algn="l">
+              <a:lnSpc>
+                <a:spcPct val="118000"/>
+              </a:lnSpc>
+              <a:spcBef>
+                <a:spcPts val="0"/>
+              </a:spcBef>
+              <a:spcAft>
+                <a:spcPts val="400"/>
+              </a:spcAft>
+            </a:pPr>
+            <a:r>
+              <a:rPr sz="1500" b="1">
                 <a:solidFill>
                   <a:srgbClr val="1A1A1A"/>
                 </a:solidFill>
                 <a:latin typeface="Manrope"/>
                 <a:rFonts ascii="Manrope" hAnsi="Manrope" cs="Manrope" eastAsia="Manrope"/>
               </a:rPr>
-              <a:t>Не воюем копейкой.</a:t>
-            </a:r>
-          </a:p>
-          <a:p>
-            <a:pPr algn="l">
-              <a:lnSpc>
-                <a:spcPct val="118000"/>
-              </a:lnSpc>
-              <a:spcBef>
-                <a:spcPts val="0"/>
-              </a:spcBef>
-              <a:spcAft>
-                <a:spcPts val="800"/>
-              </a:spcAft>
-            </a:pPr>
-            <a:r>
-              <a:rPr sz="1600" b="0">
+              <a:t>Не воюем копейкой с ЕТС.</a:t>
+            </a:r>
+          </a:p>
+          <a:p>
+            <a:pPr algn="l">
+              <a:lnSpc>
+                <a:spcPct val="118000"/>
+              </a:lnSpc>
+              <a:spcBef>
+                <a:spcPts val="0"/>
+              </a:spcBef>
+              <a:spcAft>
+                <a:spcPts val="600"/>
+              </a:spcAft>
+            </a:pPr>
+            <a:r>
+              <a:rPr sz="1500" b="0">
                 <a:solidFill>
                   <a:srgbClr val="1A1A1A"/>
                 </a:solidFill>
                 <a:latin typeface="Golos Text"/>
                 <a:rFonts ascii="Golos Text" hAnsi="Golos Text" cs="Golos Text" eastAsia="Golos Text"/>
               </a:rPr>
-              <a:t>Выигрываем пакетом и ощущением.</a:t>
+              <a:t>Выигрываем пакетом документов и ощущением в номере.</a:t>
             </a:r>
           </a:p>
         </p:txBody>
@@ -4105,53 +4174,53 @@
                 <a:latin typeface="Manrope"/>
                 <a:rFonts ascii="Manrope" hAnsi="Manrope" cs="Manrope" eastAsia="Manrope"/>
               </a:rPr>
-              <a:t>Если Китай или гибрид</a:t>
-            </a:r>
-          </a:p>
-          <a:p>
-            <a:pPr algn="l">
-              <a:lnSpc>
-                <a:spcPct val="118000"/>
-              </a:lnSpc>
-              <a:spcBef>
-                <a:spcPts val="0"/>
-              </a:spcBef>
-              <a:spcAft>
-                <a:spcPts val="800"/>
-              </a:spcAft>
-            </a:pPr>
-            <a:r>
-              <a:rPr sz="1600" b="0">
+              <a:t>Если поставка из Китая</a:t>
+            </a:r>
+          </a:p>
+          <a:p>
+            <a:pPr algn="l">
+              <a:lnSpc>
+                <a:spcPct val="118000"/>
+              </a:lnSpc>
+              <a:spcBef>
+                <a:spcPts val="0"/>
+              </a:spcBef>
+              <a:spcAft>
+                <a:spcPts val="600"/>
+              </a:spcAft>
+            </a:pPr>
+            <a:r>
+              <a:rPr sz="1500" b="0">
                 <a:solidFill>
                   <a:srgbClr val="1A1A1A"/>
                 </a:solidFill>
                 <a:latin typeface="Golos Text"/>
                 <a:rFonts ascii="Golos Text" hAnsi="Golos Text" cs="Golos Text" eastAsia="Golos Text"/>
               </a:rPr>
-              <a:t>Сравниваем заводы в FOB</a:t>
-            </a:r>
-          </a:p>
-          <a:p>
-            <a:pPr algn="l">
-              <a:lnSpc>
-                <a:spcPct val="118000"/>
-              </a:lnSpc>
-              <a:spcBef>
-                <a:spcPts val="0"/>
-              </a:spcBef>
-              <a:spcAft>
-                <a:spcPts val="800"/>
-              </a:spcAft>
-            </a:pPr>
-            <a:r>
-              <a:rPr sz="1600" b="0">
+              <a:t>1. Сравниваем заводы в цене FOB</a:t>
+            </a:r>
+          </a:p>
+          <a:p>
+            <a:pPr algn="l">
+              <a:lnSpc>
+                <a:spcPct val="118000"/>
+              </a:lnSpc>
+              <a:spcBef>
+                <a:spcPts val="0"/>
+              </a:spcBef>
+              <a:spcAft>
+                <a:spcPts val="600"/>
+              </a:spcAft>
+            </a:pPr>
+            <a:r>
+              <a:rPr sz="1500" b="0">
                 <a:solidFill>
                   <a:srgbClr val="1A1A1A"/>
                 </a:solidFill>
                 <a:latin typeface="Golos Text"/>
                 <a:rFonts ascii="Golos Text" hAnsi="Golos Text" cs="Golos Text" eastAsia="Golos Text"/>
               </a:rPr>
-              <a:t>Логистику до Кириши считаем отдельно</a:t>
+              <a:t>2. Логистику до Кириши считаем отдельной строкой</a:t>
             </a:r>
           </a:p>
           <a:p>
@@ -4167,60 +4236,83 @@
               </a:spcAft>
             </a:pPr>
             <a:r>
-              <a:rPr sz="1600" b="0">
+              <a:rPr sz="1500" b="0">
                 <a:solidFill>
                   <a:srgbClr val="1A1A1A"/>
                 </a:solidFill>
                 <a:latin typeface="Golos Text"/>
                 <a:rFonts ascii="Golos Text" hAnsi="Golos Text" cs="Golos Text" eastAsia="Golos Text"/>
               </a:rPr>
-              <a:t>Полная цена = FOB + фрахт + таможня + довоз</a:t>
-            </a:r>
-          </a:p>
-          <a:p>
-            <a:pPr algn="l">
-              <a:lnSpc>
-                <a:spcPct val="118000"/>
-              </a:lnSpc>
-              <a:spcBef>
-                <a:spcPts val="0"/>
-              </a:spcBef>
-              <a:spcAft>
-                <a:spcPts val="800"/>
-              </a:spcAft>
-            </a:pPr>
-            <a:r>
-              <a:rPr sz="1600" b="1">
+              <a:t>3. Полная цена = FOB + фрахт + таможня + довоз + запас</a:t>
+            </a:r>
+          </a:p>
+          <a:p>
+            <a:pPr algn="l">
+              <a:lnSpc>
+                <a:spcPct val="118000"/>
+              </a:lnSpc>
+              <a:spcBef>
+                <a:spcPts val="0"/>
+              </a:spcBef>
+              <a:spcAft>
+                <a:spcPts val="200"/>
+              </a:spcAft>
+            </a:pPr>
+            <a:r>
+              <a:rPr sz="1500" b="1">
                 <a:solidFill>
                   <a:srgbClr val="1A1A1A"/>
                 </a:solidFill>
                 <a:latin typeface="Manrope"/>
                 <a:rFonts ascii="Manrope" hAnsi="Manrope" cs="Manrope" eastAsia="Manrope"/>
               </a:rPr>
-              <a:t>Срок пилота — «на складе»</a:t>
-            </a:r>
-          </a:p>
-          <a:p>
-            <a:pPr algn="l">
-              <a:lnSpc>
-                <a:spcPct val="118000"/>
-              </a:lnSpc>
-              <a:spcBef>
-                <a:spcPts val="0"/>
-              </a:spcBef>
-              <a:spcAft>
-                <a:spcPts val="800"/>
-              </a:spcAft>
-            </a:pPr>
-            <a:r>
-              <a:rPr sz="1600" b="0">
+              <a:t>Срок пилота — дата «на складе»,</a:t>
+            </a:r>
+          </a:p>
+          <a:p>
+            <a:pPr algn="l">
+              <a:lnSpc>
+                <a:spcPct val="118000"/>
+              </a:lnSpc>
+              <a:spcBef>
+                <a:spcPts val="0"/>
+              </a:spcBef>
+              <a:spcAft>
+                <a:spcPts val="600"/>
+              </a:spcAft>
+            </a:pPr>
+            <a:r>
+              <a:rPr sz="1500" b="0">
                 <a:solidFill>
                   <a:srgbClr val="1A1A1A"/>
                 </a:solidFill>
                 <a:latin typeface="Golos Text"/>
                 <a:rFonts ascii="Golos Text" hAnsi="Golos Text" cs="Golos Text" eastAsia="Golos Text"/>
               </a:rPr>
-              <a:t>Origin не ясен → не говорим «российское»</a:t>
+              <a:t>а не формулировка «завод отгрузил».</a:t>
+            </a:r>
+          </a:p>
+          <a:p>
+            <a:pPr algn="l">
+              <a:lnSpc>
+                <a:spcPct val="118000"/>
+              </a:lnSpc>
+              <a:spcBef>
+                <a:spcPts val="0"/>
+              </a:spcBef>
+              <a:spcAft>
+                <a:spcPts val="600"/>
+              </a:spcAft>
+            </a:pPr>
+            <a:r>
+              <a:rPr sz="1500" b="0">
+                <a:solidFill>
+                  <a:srgbClr val="1A1A1A"/>
+                </a:solidFill>
+                <a:latin typeface="Golos Text"/>
+                <a:rFonts ascii="Golos Text" hAnsi="Golos Text" cs="Golos Text" eastAsia="Golos Text"/>
+              </a:rPr>
+              <a:t>Происхождение не зафиксировано — не называем «российское».</a:t>
             </a:r>
           </a:p>
         </p:txBody>
@@ -4740,99 +4832,145 @@
                 <a:latin typeface="Manrope"/>
                 <a:rFonts ascii="Manrope" hAnsi="Manrope" cs="Manrope" eastAsia="Manrope"/>
               </a:rPr>
-              <a:t>Содержание</a:t>
-            </a:r>
-          </a:p>
-          <a:p>
-            <a:pPr algn="l">
-              <a:lnSpc>
-                <a:spcPct val="118000"/>
-              </a:lnSpc>
-              <a:spcBef>
-                <a:spcPts val="0"/>
-              </a:spcBef>
-              <a:spcAft>
-                <a:spcPts val="800"/>
-              </a:spcAft>
-            </a:pPr>
-            <a:r>
-              <a:rPr sz="1600" b="0">
+              <a:t>Содержание пульта v1.14</a:t>
+            </a:r>
+          </a:p>
+          <a:p>
+            <a:pPr algn="l">
+              <a:lnSpc>
+                <a:spcPct val="118000"/>
+              </a:lnSpc>
+              <a:spcBef>
+                <a:spcPts val="0"/>
+              </a:spcBef>
+              <a:spcAft>
+                <a:spcPts val="600"/>
+              </a:spcAft>
+            </a:pPr>
+            <a:r>
+              <a:rPr sz="1500" b="0">
                 <a:solidFill>
                   <a:srgbClr val="1A1A1A"/>
                 </a:solidFill>
                 <a:latin typeface="Golos Text"/>
                 <a:rFonts ascii="Golos Text" hAnsi="Golos Text" cs="Golos Text" eastAsia="Golos Text"/>
               </a:rPr>
-              <a:t>Этапы 0–2 — разведка и правила</a:t>
-            </a:r>
-          </a:p>
-          <a:p>
-            <a:pPr algn="l">
-              <a:lnSpc>
-                <a:spcPct val="118000"/>
-              </a:lnSpc>
-              <a:spcBef>
-                <a:spcPts val="0"/>
-              </a:spcBef>
-              <a:spcAft>
-                <a:spcPts val="800"/>
-              </a:spcAft>
-            </a:pPr>
-            <a:r>
-              <a:rPr sz="1600" b="0">
+              <a:t>Этапы 0–2: разведка, правила, границы продукта</a:t>
+            </a:r>
+          </a:p>
+          <a:p>
+            <a:pPr algn="l">
+              <a:lnSpc>
+                <a:spcPct val="118000"/>
+              </a:lnSpc>
+              <a:spcBef>
+                <a:spcPts val="0"/>
+              </a:spcBef>
+              <a:spcAft>
+                <a:spcPts val="600"/>
+              </a:spcAft>
+            </a:pPr>
+            <a:r>
+              <a:rPr sz="1500" b="0">
                 <a:solidFill>
                   <a:srgbClr val="1A1A1A"/>
                 </a:solidFill>
                 <a:latin typeface="Golos Text"/>
                 <a:rFonts ascii="Golos Text" hAnsi="Golos Text" cs="Golos Text" eastAsia="Golos Text"/>
               </a:rPr>
-              <a:t>Этапы 3–6 — сценарий «как вести дело»</a:t>
-            </a:r>
-          </a:p>
-          <a:p>
-            <a:pPr algn="l">
-              <a:lnSpc>
-                <a:spcPct val="118000"/>
-              </a:lnSpc>
-              <a:spcBef>
-                <a:spcPts val="0"/>
-              </a:spcBef>
-              <a:spcAft>
-                <a:spcPts val="800"/>
-              </a:spcAft>
-            </a:pPr>
-            <a:r>
-              <a:rPr sz="1600" b="0">
+              <a:t>Этапы 3–6: учебный сценарий «как вести дело»</a:t>
+            </a:r>
+          </a:p>
+          <a:p>
+            <a:pPr algn="l">
+              <a:lnSpc>
+                <a:spcPct val="118000"/>
+              </a:lnSpc>
+              <a:spcBef>
+                <a:spcPts val="0"/>
+              </a:spcBef>
+              <a:spcAft>
+                <a:spcPts val="600"/>
+              </a:spcAft>
+            </a:pPr>
+            <a:r>
+              <a:rPr sz="1500" b="0">
                 <a:solidFill>
                   <a:srgbClr val="1A1A1A"/>
                 </a:solidFill>
                 <a:latin typeface="Golos Text"/>
                 <a:rFonts ascii="Golos Text" hAnsi="Golos Text" cs="Golos Text" eastAsia="Golos Text"/>
               </a:rPr>
-              <a:t>StoryBrand · DoD · риски · возврат</a:t>
-            </a:r>
-          </a:p>
-          <a:p>
-            <a:pPr algn="l">
-              <a:lnSpc>
-                <a:spcPct val="118000"/>
-              </a:lnSpc>
-              <a:spcBef>
-                <a:spcPts val="0"/>
-              </a:spcBef>
-              <a:spcAft>
-                <a:spcPts val="800"/>
-              </a:spcAft>
-            </a:pPr>
-            <a:r>
-              <a:rPr sz="1600" b="0">
+              <a:t>StoryBrand, чеклист готовности, реестр рисков</a:t>
+            </a:r>
+          </a:p>
+          <a:p>
+            <a:pPr algn="l">
+              <a:lnSpc>
+                <a:spcPct val="118000"/>
+              </a:lnSpc>
+              <a:spcBef>
+                <a:spcPts val="0"/>
+              </a:spcBef>
+              <a:spcAft>
+                <a:spcPts val="600"/>
+              </a:spcAft>
+            </a:pPr>
+            <a:r>
+              <a:rPr sz="1500" b="0">
                 <a:solidFill>
                   <a:srgbClr val="1A1A1A"/>
                 </a:solidFill>
                 <a:latin typeface="Golos Text"/>
                 <a:rFonts ascii="Golos Text" hAnsi="Golos Text" cs="Golos Text" eastAsia="Golos Text"/>
               </a:rPr>
-              <a:t>Мостик портфеля Travel+</a:t>
+              <a:t>Правила пилота: успех, провал, выход</a:t>
+            </a:r>
+          </a:p>
+          <a:p>
+            <a:pPr algn="l">
+              <a:lnSpc>
+                <a:spcPct val="118000"/>
+              </a:lnSpc>
+              <a:spcBef>
+                <a:spcPts val="0"/>
+              </a:spcBef>
+              <a:spcAft>
+                <a:spcPts val="600"/>
+              </a:spcAft>
+            </a:pPr>
+            <a:r>
+              <a:rPr sz="1500" b="0">
+                <a:solidFill>
+                  <a:srgbClr val="1A1A1A"/>
+                </a:solidFill>
+                <a:latin typeface="Golos Text"/>
+                <a:rFonts ascii="Golos Text" hAnsi="Golos Text" cs="Golos Text" eastAsia="Golos Text"/>
+              </a:rPr>
+              <a:t>Мостик портфеля Travel+ (Hotel Line, Fleur, Natural, СТМ)</a:t>
+            </a:r>
+          </a:p>
+          <a:p>
+            <a:pPr algn="l">
+              <a:lnSpc>
+                <a:spcPct val="118000"/>
+              </a:lnSpc>
+              <a:spcBef>
+                <a:spcPts val="1800"/>
+              </a:spcBef>
+              <a:spcAft>
+                <a:spcPts val="0"/>
+              </a:spcAft>
+            </a:pPr>
+            <a:r>
+              <a:rPr sz="1200" b="0">
+                <a:solidFill>
+                  <a:srgbClr val="5C5C5C"/>
+                </a:solidFill>
+                <a:latin typeface="Golos Text"/>
+                <a:rFonts ascii="Golos Text" hAnsi="Golos Text" cs="Golos Text" eastAsia="Golos Text"/>
+              </a:rPr>
+              <a:t>Статус: образец для поля и собеседования. Не коммерческое предложение.</a:t>
             </a:r>
           </a:p>
         </p:txBody>
@@ -4876,76 +5014,99 @@
                 <a:latin typeface="Manrope"/>
                 <a:rFonts ascii="Manrope" hAnsi="Manrope" cs="Manrope" eastAsia="Manrope"/>
               </a:rPr>
-              <a:t>Справочники</a:t>
-            </a:r>
-          </a:p>
-          <a:p>
-            <a:pPr algn="l">
-              <a:lnSpc>
-                <a:spcPct val="118000"/>
-              </a:lnSpc>
-              <a:spcBef>
-                <a:spcPts val="0"/>
-              </a:spcBef>
-              <a:spcAft>
-                <a:spcPts val="800"/>
-              </a:spcAft>
-            </a:pPr>
-            <a:r>
-              <a:rPr sz="1600" b="0">
+              <a:t>Справочники и логистика</a:t>
+            </a:r>
+          </a:p>
+          <a:p>
+            <a:pPr algn="l">
+              <a:lnSpc>
+                <a:spcPct val="118000"/>
+              </a:lnSpc>
+              <a:spcBef>
+                <a:spcPts val="0"/>
+              </a:spcBef>
+              <a:spcAft>
+                <a:spcPts val="600"/>
+              </a:spcAft>
+            </a:pPr>
+            <a:r>
+              <a:rPr sz="1500" b="0">
                 <a:solidFill>
                   <a:srgbClr val="1A1A1A"/>
                 </a:solidFill>
                 <a:latin typeface="Golos Text"/>
                 <a:rFonts ascii="Golos Text" hAnsi="Golos Text" cs="Golos Text" eastAsia="Golos Text"/>
               </a:rPr>
-              <a:t>Глоссарий бренда + глоссарий ВЭД</a:t>
-            </a:r>
-          </a:p>
-          <a:p>
-            <a:pPr algn="l">
-              <a:lnSpc>
-                <a:spcPct val="118000"/>
-              </a:lnSpc>
-              <a:spcBef>
-                <a:spcPts val="0"/>
-              </a:spcBef>
-              <a:spcAft>
-                <a:spcPts val="1400"/>
-              </a:spcAft>
-            </a:pPr>
-            <a:r>
-              <a:rPr sz="1600" b="0">
+              <a:t>Глоссарий бренда и глоссарий ВЭД</a:t>
+            </a:r>
+          </a:p>
+          <a:p>
+            <a:pPr algn="l">
+              <a:lnSpc>
+                <a:spcPct val="118000"/>
+              </a:lnSpc>
+              <a:spcBef>
+                <a:spcPts val="0"/>
+              </a:spcBef>
+              <a:spcAft>
+                <a:spcPts val="600"/>
+              </a:spcAft>
+            </a:pPr>
+            <a:r>
+              <a:rPr sz="1500" b="0">
                 <a:solidFill>
                   <a:srgbClr val="1A1A1A"/>
                 </a:solidFill>
                 <a:latin typeface="Golos Text"/>
                 <a:rFonts ascii="Golos Text" hAnsi="Golos Text" cs="Golos Text" eastAsia="Golos Text"/>
               </a:rPr>
-              <a:t>Раздел L: путь · Incoterms · RFQ</a:t>
-            </a:r>
-          </a:p>
-          <a:p>
-            <a:pPr algn="l">
-              <a:lnSpc>
-                <a:spcPct val="118000"/>
-              </a:lnSpc>
-              <a:spcBef>
-                <a:spcPts val="0"/>
-              </a:spcBef>
-              <a:spcAft>
-                <a:spcPts val="800"/>
-              </a:spcAft>
-            </a:pPr>
-            <a:r>
-              <a:rPr sz="1600" b="0">
+              <a:t>Раздел L: путь товара, Incoterms, RFQ, приёмка на складе</a:t>
+            </a:r>
+          </a:p>
+          <a:p>
+            <a:pPr algn="l">
+              <a:lnSpc>
+                <a:spcPct val="118000"/>
+              </a:lnSpc>
+              <a:spcBef>
+                <a:spcPts val="0"/>
+              </a:spcBef>
+              <a:spcAft>
+                <a:spcPts val="600"/>
+              </a:spcAft>
+            </a:pPr>
+            <a:r>
+              <a:rPr sz="1500" b="0">
                 <a:solidFill>
                   <a:srgbClr val="1A1A1A"/>
                 </a:solidFill>
                 <a:latin typeface="Golos Text"/>
                 <a:rFonts ascii="Golos Text" hAnsi="Golos Text" cs="Golos Text" eastAsia="Golos Text"/>
               </a:rPr>
-              <a:t>Статус: рамка для поля и собеседования.</a:t>
+              <a:t>Волна A: markdown-реестры в папке brand-pult/</a:t>
+            </a:r>
+          </a:p>
+          <a:p>
+            <a:pPr algn="l">
+              <a:lnSpc>
+                <a:spcPct val="118000"/>
+              </a:lnSpc>
+              <a:spcBef>
+                <a:spcPts val="0"/>
+              </a:spcBef>
+              <a:spcAft>
+                <a:spcPts val="1000"/>
+              </a:spcAft>
+            </a:pPr>
+            <a:r>
+              <a:rPr sz="1500" b="0">
+                <a:solidFill>
+                  <a:srgbClr val="1A1A1A"/>
+                </a:solidFill>
+                <a:latin typeface="Golos Text"/>
+                <a:rFonts ascii="Golos Text" hAnsi="Golos Text" cs="Golos Text" eastAsia="Golos Text"/>
+              </a:rPr>
+              <a:t>Презентация и скрипт — синхрон с пультом</a:t>
             </a:r>
           </a:p>
           <a:p>
@@ -4961,14 +5122,14 @@
               </a:spcAft>
             </a:pPr>
             <a:r>
-              <a:rPr sz="1600" b="1">
+              <a:rPr sz="1500" b="1">
                 <a:solidFill>
                   <a:srgbClr val="1A1A1A"/>
                 </a:solidFill>
                 <a:latin typeface="Manrope"/>
                 <a:rFonts ascii="Manrope" hAnsi="Manrope" cs="Manrope" eastAsia="Manrope"/>
               </a:rPr>
-              <a:t>v2.0 — когда технолог даст цифры.</a:t>
+              <a:t>Версия 2.0 — когда технолог закроет цифры завода.</a:t>
             </a:r>
           </a:p>
         </p:txBody>
@@ -7042,30 +7203,30 @@
                 <a:spcPts val="0"/>
               </a:spcBef>
               <a:spcAft>
-                <a:spcPts val="800"/>
-              </a:spcAft>
-            </a:pPr>
-            <a:r>
-              <a:rPr sz="1600" b="0">
+                <a:spcPts val="600"/>
+              </a:spcAft>
+            </a:pPr>
+            <a:r>
+              <a:rPr sz="1500" b="0">
                 <a:solidFill>
                   <a:srgbClr val="1A1A1A"/>
                 </a:solidFill>
                 <a:latin typeface="Golos Text"/>
                 <a:rFonts ascii="Golos Text" hAnsi="Golos Text" cs="Golos Text" eastAsia="Golos Text"/>
               </a:rPr>
-              <a:t>Конкуренты: ЕТС Natural · MEZO · NS</a:t>
-            </a:r>
-          </a:p>
-          <a:p>
-            <a:pPr algn="l">
-              <a:lnSpc>
-                <a:spcPct val="118000"/>
-              </a:lnSpc>
-              <a:spcBef>
-                <a:spcPts val="0"/>
-              </a:spcBef>
-              <a:spcAft>
-                <a:spcPts val="1200"/>
+              <a:t>Конкуренты на полке: ЕТС Natural, MEZO, Natura Siberica.</a:t>
+            </a:r>
+          </a:p>
+          <a:p>
+            <a:pPr algn="l">
+              <a:lnSpc>
+                <a:spcPct val="118000"/>
+              </a:lnSpc>
+              <a:spcBef>
+                <a:spcPts val="0"/>
+              </a:spcBef>
+              <a:spcAft>
+                <a:spcPts val="1000"/>
               </a:spcAft>
             </a:pPr>
             <a:r>
@@ -7076,30 +7237,30 @@
                 <a:latin typeface="Golos Text"/>
                 <a:rFonts ascii="Golos Text" hAnsi="Golos Text" cs="Golos Text" eastAsia="Golos Text"/>
               </a:rPr>
-              <a:t>(NS — чужой premium в каталоге)</a:t>
-            </a:r>
-          </a:p>
-          <a:p>
-            <a:pPr algn="l">
-              <a:lnSpc>
-                <a:spcPct val="118000"/>
-              </a:lnSpc>
-              <a:spcBef>
-                <a:spcPts val="0"/>
-              </a:spcBef>
-              <a:spcAft>
-                <a:spcPts val="800"/>
-              </a:spcAft>
-            </a:pPr>
-            <a:r>
-              <a:rPr sz="1600" b="0">
+              <a:t>(Natura Siberica — чужой премиум в каталоге Travel+)</a:t>
+            </a:r>
+          </a:p>
+          <a:p>
+            <a:pPr algn="l">
+              <a:lnSpc>
+                <a:spcPct val="118000"/>
+              </a:lnSpc>
+              <a:spcBef>
+                <a:spcPts val="0"/>
+              </a:spcBef>
+              <a:spcAft>
+                <a:spcPts val="600"/>
+              </a:spcAft>
+            </a:pPr>
+            <a:r>
+              <a:rPr sz="1500" b="0">
                 <a:solidFill>
                   <a:srgbClr val="1A1A1A"/>
                 </a:solidFill>
                 <a:latin typeface="Golos Text"/>
                 <a:rFonts ascii="Golos Text" hAnsi="Golos Text" cs="Golos Text" eastAsia="Golos Text"/>
               </a:rPr>
-              <a:t>Travel+ силён в масс и среднем.</a:t>
+              <a:t>Travel+ силён в массовом и среднем сегменте.</a:t>
             </a:r>
           </a:p>
           <a:p>
@@ -7115,14 +7276,14 @@
               </a:spcAft>
             </a:pPr>
             <a:r>
-              <a:rPr sz="1600" b="1">
+              <a:rPr sz="1500" b="1">
                 <a:solidFill>
                   <a:srgbClr val="1A1A1A"/>
                 </a:solidFill>
                 <a:latin typeface="Manrope"/>
                 <a:rFonts ascii="Manrope" hAnsi="Manrope" cs="Manrope" eastAsia="Manrope"/>
               </a:rPr>
-              <a:t>Слабое место: своя Natural с документами.</a:t>
+              <a:t>Слабое место: своей линейки Natural с документами нет.</a:t>
             </a:r>
           </a:p>
         </p:txBody>
@@ -7178,64 +7339,64 @@
                 <a:spcPts val="0"/>
               </a:spcBef>
               <a:spcAft>
-                <a:spcPts val="800"/>
-              </a:spcAft>
-            </a:pPr>
-            <a:r>
-              <a:rPr sz="1600" b="0">
+                <a:spcPts val="600"/>
+              </a:spcAft>
+            </a:pPr>
+            <a:r>
+              <a:rPr sz="1500" b="0">
                 <a:solidFill>
                   <a:srgbClr val="1A1A1A"/>
                 </a:solidFill>
                 <a:latin typeface="Golos Text"/>
                 <a:rFonts ascii="Golos Text" hAnsi="Golos Text" cs="Golos Text" eastAsia="Golos Text"/>
               </a:rPr>
-              <a:t>Hotel Line ≈ 12–15 ₽ / 30 мл</a:t>
-            </a:r>
-          </a:p>
-          <a:p>
-            <a:pPr algn="l">
-              <a:lnSpc>
-                <a:spcPct val="118000"/>
-              </a:lnSpc>
-              <a:spcBef>
-                <a:spcPts val="0"/>
-              </a:spcBef>
-              <a:spcAft>
-                <a:spcPts val="800"/>
-              </a:spcAft>
-            </a:pPr>
-            <a:r>
-              <a:rPr sz="1600" b="0">
+              <a:t>Hotel Line — ориентир 12–15 ₽ / 30 мл</a:t>
+            </a:r>
+          </a:p>
+          <a:p>
+            <a:pPr algn="l">
+              <a:lnSpc>
+                <a:spcPct val="118000"/>
+              </a:lnSpc>
+              <a:spcBef>
+                <a:spcPts val="0"/>
+              </a:spcBef>
+              <a:spcAft>
+                <a:spcPts val="600"/>
+              </a:spcAft>
+            </a:pPr>
+            <a:r>
+              <a:rPr sz="1500" b="0">
                 <a:solidFill>
                   <a:srgbClr val="1A1A1A"/>
                 </a:solidFill>
                 <a:latin typeface="Golos Text"/>
                 <a:rFonts ascii="Golos Text" hAnsi="Golos Text" cs="Golos Text" eastAsia="Golos Text"/>
               </a:rPr>
-              <a:t>ЕТС Natural ≈ 18 ₽ / 25 мл</a:t>
-            </a:r>
-          </a:p>
-          <a:p>
-            <a:pPr algn="l">
-              <a:lnSpc>
-                <a:spcPct val="118000"/>
-              </a:lnSpc>
-              <a:spcBef>
-                <a:spcPts val="0"/>
-              </a:spcBef>
-              <a:spcAft>
-                <a:spcPts val="1400"/>
-              </a:spcAft>
-            </a:pPr>
-            <a:r>
-              <a:rPr sz="1600" b="0">
+              <a:t>ЕТС Natural — ориентир 18 ₽ / 25 мл</a:t>
+            </a:r>
+          </a:p>
+          <a:p>
+            <a:pPr algn="l">
+              <a:lnSpc>
+                <a:spcPct val="118000"/>
+              </a:lnSpc>
+              <a:spcBef>
+                <a:spcPts val="0"/>
+              </a:spcBef>
+              <a:spcAft>
+                <a:spcPts val="1200"/>
+              </a:spcAft>
+            </a:pPr>
+            <a:r>
+              <a:rPr sz="1500" b="0">
                 <a:solidFill>
                   <a:srgbClr val="1A1A1A"/>
                 </a:solidFill>
                 <a:latin typeface="Golos Text"/>
                 <a:rFonts ascii="Golos Text" hAnsi="Golos Text" cs="Golos Text" eastAsia="Golos Text"/>
               </a:rPr>
-              <a:t>Natura Siberica — выше</a:t>
+              <a:t>Natura Siberica — ориентир 30–40 ₽ и выше</a:t>
             </a:r>
           </a:p>
           <a:p>
@@ -7251,37 +7412,37 @@
               </a:spcAft>
             </a:pPr>
             <a:r>
-              <a:rPr sz="1600" b="1">
+              <a:rPr sz="1500" b="1">
                 <a:solidFill>
                   <a:srgbClr val="1A1A1A"/>
                 </a:solidFill>
                 <a:latin typeface="Manrope"/>
                 <a:rFonts ascii="Manrope" hAnsi="Manrope" cs="Manrope" eastAsia="Manrope"/>
               </a:rPr>
-              <a:t>Ставка: между HL и NS</a:t>
-            </a:r>
-          </a:p>
-          <a:p>
-            <a:pPr algn="l">
-              <a:lnSpc>
-                <a:spcPct val="118000"/>
-              </a:lnSpc>
-              <a:spcBef>
-                <a:spcPts val="0"/>
-              </a:spcBef>
-              <a:spcAft>
-                <a:spcPts val="800"/>
-              </a:spcAft>
-            </a:pPr>
-            <a:r>
-              <a:rPr sz="1600" b="0">
+              <a:t>Ставка Natural: между Hotel Line и Natura Siberica</a:t>
+            </a:r>
+          </a:p>
+          <a:p>
+            <a:pPr algn="l">
+              <a:lnSpc>
+                <a:spcPct val="118000"/>
+              </a:lnSpc>
+              <a:spcBef>
+                <a:spcPts val="0"/>
+              </a:spcBef>
+              <a:spcAft>
+                <a:spcPts val="600"/>
+              </a:spcAft>
+            </a:pPr>
+            <a:r>
+              <a:rPr sz="1500" b="0">
                 <a:solidFill>
                   <a:srgbClr val="1A1A1A"/>
                 </a:solidFill>
                 <a:latin typeface="Golos Text"/>
                 <a:rFonts ascii="Golos Text" hAnsi="Golos Text" cs="Golos Text" eastAsia="Golos Text"/>
               </a:rPr>
-              <a:t>Натуральность · документы · один поставщик</a:t>
+              <a:t>Натуральность, пакет документов, один поставщик на номер.</a:t>
             </a:r>
           </a:p>
         </p:txBody>
@@ -7801,53 +7962,53 @@
                 <a:latin typeface="Manrope"/>
                 <a:rFonts ascii="Manrope" hAnsi="Manrope" cs="Manrope" eastAsia="Manrope"/>
               </a:rPr>
-              <a:t>Карта</a:t>
-            </a:r>
-          </a:p>
-          <a:p>
-            <a:pPr algn="l">
-              <a:lnSpc>
-                <a:spcPct val="118000"/>
-              </a:lnSpc>
-              <a:spcBef>
-                <a:spcPts val="0"/>
-              </a:spcBef>
-              <a:spcAft>
-                <a:spcPts val="800"/>
-              </a:spcAft>
-            </a:pPr>
-            <a:r>
-              <a:rPr sz="1600" b="0">
+              <a:t>Карта портфеля</a:t>
+            </a:r>
+          </a:p>
+          <a:p>
+            <a:pPr algn="l">
+              <a:lnSpc>
+                <a:spcPct val="118000"/>
+              </a:lnSpc>
+              <a:spcBef>
+                <a:spcPts val="0"/>
+              </a:spcBef>
+              <a:spcAft>
+                <a:spcPts val="600"/>
+              </a:spcAft>
+            </a:pPr>
+            <a:r>
+              <a:rPr sz="1500" b="0">
                 <a:solidFill>
                   <a:srgbClr val="1A1A1A"/>
                 </a:solidFill>
                 <a:latin typeface="Golos Text"/>
                 <a:rFonts ascii="Golos Text" hAnsi="Golos Text" cs="Golos Text" eastAsia="Golos Text"/>
               </a:rPr>
-              <a:t>Hotel Line → цена</a:t>
-            </a:r>
-          </a:p>
-          <a:p>
-            <a:pPr algn="l">
-              <a:lnSpc>
-                <a:spcPct val="118000"/>
-              </a:lnSpc>
-              <a:spcBef>
-                <a:spcPts val="0"/>
-              </a:spcBef>
-              <a:spcAft>
-                <a:spcPts val="800"/>
-              </a:spcAft>
-            </a:pPr>
-            <a:r>
-              <a:rPr sz="1600" b="0">
+              <a:t>Hotel Line — цена и базовый сегмент</a:t>
+            </a:r>
+          </a:p>
+          <a:p>
+            <a:pPr algn="l">
+              <a:lnSpc>
+                <a:spcPct val="118000"/>
+              </a:lnSpc>
+              <a:spcBef>
+                <a:spcPts val="0"/>
+              </a:spcBef>
+              <a:spcAft>
+                <a:spcPts val="600"/>
+              </a:spcAft>
+            </a:pPr>
+            <a:r>
+              <a:rPr sz="1500" b="0">
                 <a:solidFill>
                   <a:srgbClr val="1A1A1A"/>
                 </a:solidFill>
                 <a:latin typeface="Golos Text"/>
                 <a:rFonts ascii="Golos Text" hAnsi="Golos Text" cs="Golos Text" eastAsia="Golos Text"/>
               </a:rPr>
-              <a:t>Fleur / Aquatique / La Nuit → дизайн и аромат</a:t>
+              <a:t>Fleur / Aquatique / La Nuit — дизайн и аромат</a:t>
             </a:r>
           </a:p>
           <a:p>
@@ -7863,60 +8024,60 @@
               </a:spcAft>
             </a:pPr>
             <a:r>
-              <a:rPr sz="1600" b="1">
+              <a:rPr sz="1500" b="1">
                 <a:solidFill>
                   <a:srgbClr val="1A1A1A"/>
                 </a:solidFill>
                 <a:latin typeface="Manrope"/>
                 <a:rFonts ascii="Manrope" hAnsi="Manrope" cs="Manrope" eastAsia="Manrope"/>
               </a:rPr>
-              <a:t>Natural → натуральность + документы</a:t>
-            </a:r>
-          </a:p>
-          <a:p>
-            <a:pPr algn="l">
-              <a:lnSpc>
-                <a:spcPct val="118000"/>
-              </a:lnSpc>
-              <a:spcBef>
-                <a:spcPts val="0"/>
-              </a:spcBef>
-              <a:spcAft>
-                <a:spcPts val="800"/>
-              </a:spcAft>
-            </a:pPr>
-            <a:r>
-              <a:rPr sz="1600" b="0">
+              <a:t>Natural — натуральность и документы</a:t>
+            </a:r>
+          </a:p>
+          <a:p>
+            <a:pPr algn="l">
+              <a:lnSpc>
+                <a:spcPct val="118000"/>
+              </a:lnSpc>
+              <a:spcBef>
+                <a:spcPts val="0"/>
+              </a:spcBef>
+              <a:spcAft>
+                <a:spcPts val="600"/>
+              </a:spcAft>
+            </a:pPr>
+            <a:r>
+              <a:rPr sz="1500" b="0">
                 <a:solidFill>
                   <a:srgbClr val="1A1A1A"/>
                 </a:solidFill>
                 <a:latin typeface="Golos Text"/>
                 <a:rFonts ascii="Golos Text" hAnsi="Golos Text" cs="Golos Text" eastAsia="Golos Text"/>
               </a:rPr>
-              <a:t>Natura Siberica → чужой premium</a:t>
-            </a:r>
-          </a:p>
-          <a:p>
-            <a:pPr algn="l">
-              <a:lnSpc>
-                <a:spcPct val="118000"/>
-              </a:lnSpc>
-              <a:spcBef>
-                <a:spcPts val="0"/>
-              </a:spcBef>
-              <a:spcAft>
-                <a:spcPts val="800"/>
-              </a:spcAft>
-            </a:pPr>
-            <a:r>
-              <a:rPr sz="1600" b="0">
+              <a:t>Natura Siberica — чужой премиум в каталоге</a:t>
+            </a:r>
+          </a:p>
+          <a:p>
+            <a:pPr algn="l">
+              <a:lnSpc>
+                <a:spcPct val="118000"/>
+              </a:lnSpc>
+              <a:spcBef>
+                <a:spcPts val="0"/>
+              </a:spcBef>
+              <a:spcAft>
+                <a:spcPts val="600"/>
+              </a:spcAft>
+            </a:pPr>
+            <a:r>
+              <a:rPr sz="1500" b="0">
                 <a:solidFill>
                   <a:srgbClr val="1A1A1A"/>
                 </a:solidFill>
                 <a:latin typeface="Golos Text"/>
                 <a:rFonts ascii="Golos Text" hAnsi="Golos Text" cs="Golos Text" eastAsia="Golos Text"/>
               </a:rPr>
-              <a:t>СТМ (лого отеля) → отдельный проект</a:t>
+              <a:t>СТМ с логотипом отеля — отдельный проект</a:t>
             </a:r>
           </a:p>
         </p:txBody>
@@ -7972,87 +8133,87 @@
                 <a:spcPts val="0"/>
               </a:spcBef>
               <a:spcAft>
-                <a:spcPts val="800"/>
-              </a:spcAft>
-            </a:pPr>
-            <a:r>
-              <a:rPr sz="1600" b="0">
+                <a:spcPts val="600"/>
+              </a:spcAft>
+            </a:pPr>
+            <a:r>
+              <a:rPr sz="1500" b="0">
                 <a:solidFill>
                   <a:srgbClr val="1A1A1A"/>
                 </a:solidFill>
                 <a:latin typeface="Golos Text"/>
                 <a:rFonts ascii="Golos Text" hAnsi="Golos Text" cs="Golos Text" eastAsia="Golos Text"/>
               </a:rPr>
-              <a:t>Дизайн и аромат — Fleur.</a:t>
-            </a:r>
-          </a:p>
-          <a:p>
-            <a:pPr algn="l">
-              <a:lnSpc>
-                <a:spcPct val="118000"/>
-              </a:lnSpc>
-              <a:spcBef>
-                <a:spcPts val="0"/>
-              </a:spcBef>
-              <a:spcAft>
-                <a:spcPts val="800"/>
-              </a:spcAft>
-            </a:pPr>
-            <a:r>
-              <a:rPr sz="1600" b="0">
+              <a:t>Fleur закрывает дизайн и аромат в номере.</a:t>
+            </a:r>
+          </a:p>
+          <a:p>
+            <a:pPr algn="l">
+              <a:lnSpc>
+                <a:spcPct val="118000"/>
+              </a:lnSpc>
+              <a:spcBef>
+                <a:spcPts val="0"/>
+              </a:spcBef>
+              <a:spcAft>
+                <a:spcPts val="600"/>
+              </a:spcAft>
+            </a:pPr>
+            <a:r>
+              <a:rPr sz="1500" b="0">
                 <a:solidFill>
                   <a:srgbClr val="1A1A1A"/>
                 </a:solidFill>
                 <a:latin typeface="Golos Text"/>
                 <a:rFonts ascii="Golos Text" hAnsi="Golos Text" cs="Golos Text" eastAsia="Golos Text"/>
               </a:rPr>
-              <a:t>Натуральность и документы — Natural.</a:t>
-            </a:r>
-          </a:p>
-          <a:p>
-            <a:pPr algn="l">
-              <a:lnSpc>
-                <a:spcPct val="118000"/>
-              </a:lnSpc>
-              <a:spcBef>
-                <a:spcPts val="0"/>
-              </a:spcBef>
-              <a:spcAft>
-                <a:spcPts val="800"/>
-              </a:spcAft>
-            </a:pPr>
-            <a:r>
-              <a:rPr sz="1600" b="1">
+              <a:t>Natural — запрос на натуральность и полный пакет документов.</a:t>
+            </a:r>
+          </a:p>
+          <a:p>
+            <a:pPr algn="l">
+              <a:lnSpc>
+                <a:spcPct val="118000"/>
+              </a:lnSpc>
+              <a:spcBef>
+                <a:spcPts val="0"/>
+              </a:spcBef>
+              <a:spcAft>
+                <a:spcPts val="1000"/>
+              </a:spcAft>
+            </a:pPr>
+            <a:r>
+              <a:rPr sz="1500" b="1">
                 <a:solidFill>
                   <a:srgbClr val="1A1A1A"/>
                 </a:solidFill>
                 <a:latin typeface="Manrope"/>
                 <a:rFonts ascii="Manrope" hAnsi="Manrope" cs="Manrope" eastAsia="Manrope"/>
               </a:rPr>
-              <a:t>Не конкурируют.</a:t>
-            </a:r>
-          </a:p>
-          <a:p>
-            <a:pPr algn="l">
-              <a:lnSpc>
-                <a:spcPct val="118000"/>
-              </a:lnSpc>
-              <a:spcBef>
-                <a:spcPts val="0"/>
-              </a:spcBef>
-              <a:spcAft>
-                <a:spcPts val="800"/>
-              </a:spcAft>
-            </a:pPr>
-            <a:r>
-              <a:rPr sz="1600" b="0">
+              <a:t>Fleur и Natural не конкурируют — разные задачи.</a:t>
+            </a:r>
+          </a:p>
+          <a:p>
+            <a:pPr algn="l">
+              <a:lnSpc>
+                <a:spcPct val="118000"/>
+              </a:lnSpc>
+              <a:spcBef>
+                <a:spcPts val="0"/>
+              </a:spcBef>
+              <a:spcAft>
+                <a:spcPts val="600"/>
+              </a:spcAft>
+            </a:pPr>
+            <a:r>
+              <a:rPr sz="1500" b="0">
                 <a:solidFill>
                   <a:srgbClr val="1A1A1A"/>
                 </a:solidFill>
                 <a:latin typeface="Golos Text"/>
                 <a:rFonts ascii="Golos Text" hAnsi="Golos Text" cs="Golos Text" eastAsia="Golos Text"/>
               </a:rPr>
-              <a:t>Могут жить на разных этажах одного объекта.</a:t>
+              <a:t>На одном объекте: стандартные номера — Hotel Line или Fleur; wellness-корпус или этаж с eco-запросом — Natural.</a:t>
             </a:r>
           </a:p>
         </p:txBody>
@@ -8588,7 +8749,7 @@
               </a:spcAft>
             </a:pPr>
             <a:r>
-              <a:rPr sz="1600" b="1">
+              <a:rPr sz="1500" b="1">
                 <a:solidFill>
                   <a:srgbClr val="1A1A1A"/>
                 </a:solidFill>
@@ -8607,30 +8768,30 @@
                 <a:spcPts val="0"/>
               </a:spcBef>
               <a:spcAft>
-                <a:spcPts val="1200"/>
-              </a:spcAft>
-            </a:pPr>
-            <a:r>
-              <a:rPr sz="1600" b="0">
+                <a:spcPts val="1000"/>
+              </a:spcAft>
+            </a:pPr>
+            <a:r>
+              <a:rPr sz="1500" b="0">
                 <a:solidFill>
                   <a:srgbClr val="1A1A1A"/>
                 </a:solidFill>
                 <a:latin typeface="Golos Text"/>
                 <a:rFonts ascii="Golos Text" hAnsi="Golos Text" cs="Golos Text" eastAsia="Golos Text"/>
               </a:rPr>
-              <a:t>для отеля, которому важны и гость, и документы.</a:t>
-            </a:r>
-          </a:p>
-          <a:p>
-            <a:pPr algn="l">
-              <a:lnSpc>
-                <a:spcPct val="118000"/>
-              </a:lnSpc>
-              <a:spcBef>
-                <a:spcPts val="0"/>
-              </a:spcBef>
-              <a:spcAft>
-                <a:spcPts val="600"/>
+              <a:t>Для отеля, которому важен комфорт гостя и спокойная проверка документов.</a:t>
+            </a:r>
+          </a:p>
+          <a:p>
+            <a:pPr algn="l">
+              <a:lnSpc>
+                <a:spcPct val="118000"/>
+              </a:lnSpc>
+              <a:spcBef>
+                <a:spcPts val="0"/>
+              </a:spcBef>
+              <a:spcAft>
+                <a:spcPts val="400"/>
               </a:spcAft>
             </a:pPr>
             <a:r>
@@ -8653,34 +8814,34 @@
                 <a:spcPts val="0"/>
               </a:spcBef>
               <a:spcAft>
-                <a:spcPts val="800"/>
-              </a:spcAft>
-            </a:pPr>
-            <a:r>
-              <a:rPr sz="1600" b="0">
+                <a:spcPts val="600"/>
+              </a:spcAft>
+            </a:pPr>
+            <a:r>
+              <a:rPr sz="1500" b="0">
                 <a:solidFill>
                   <a:srgbClr val="1A1A1A"/>
                 </a:solidFill>
                 <a:latin typeface="Golos Text"/>
                 <a:rFonts ascii="Golos Text" hAnsi="Golos Text" cs="Golos Text" eastAsia="Golos Text"/>
               </a:rPr>
-              <a:t>• Состав в границах</a:t>
-            </a:r>
-          </a:p>
-          <a:p>
-            <a:pPr algn="l">
-              <a:lnSpc>
-                <a:spcPct val="118000"/>
-              </a:lnSpc>
-              <a:spcBef>
-                <a:spcPts val="0"/>
-              </a:spcBef>
-              <a:spcAft>
-                <a:spcPts val="800"/>
-              </a:spcAft>
-            </a:pPr>
-            <a:r>
-              <a:rPr sz="1600" b="0">
+              <a:t>• Состав в согласованных границах</a:t>
+            </a:r>
+          </a:p>
+          <a:p>
+            <a:pPr algn="l">
+              <a:lnSpc>
+                <a:spcPct val="118000"/>
+              </a:lnSpc>
+              <a:spcBef>
+                <a:spcPts val="0"/>
+              </a:spcBef>
+              <a:spcAft>
+                <a:spcPts val="600"/>
+              </a:spcAft>
+            </a:pPr>
+            <a:r>
+              <a:rPr sz="1500" b="0">
                 <a:solidFill>
                   <a:srgbClr val="1A1A1A"/>
                 </a:solidFill>
@@ -8699,57 +8860,57 @@
                 <a:spcPts val="0"/>
               </a:spcBef>
               <a:spcAft>
-                <a:spcPts val="800"/>
-              </a:spcAft>
-            </a:pPr>
-            <a:r>
-              <a:rPr sz="1600" b="0">
+                <a:spcPts val="600"/>
+              </a:spcAft>
+            </a:pPr>
+            <a:r>
+              <a:rPr sz="1500" b="0">
                 <a:solidFill>
                   <a:srgbClr val="1A1A1A"/>
                 </a:solidFill>
                 <a:latin typeface="Golos Text"/>
                 <a:rFonts ascii="Golos Text" hAnsi="Golos Text" cs="Golos Text" eastAsia="Golos Text"/>
               </a:rPr>
-              <a:t>• Ощущение в номере</a:t>
-            </a:r>
-          </a:p>
-          <a:p>
-            <a:pPr algn="l">
-              <a:lnSpc>
-                <a:spcPct val="118000"/>
-              </a:lnSpc>
-              <a:spcBef>
-                <a:spcPts val="0"/>
-              </a:spcBef>
-              <a:spcAft>
-                <a:spcPts val="800"/>
-              </a:spcAft>
-            </a:pPr>
-            <a:r>
-              <a:rPr sz="1600" b="0">
+              <a:t>• Ощущение в номере после использования</a:t>
+            </a:r>
+          </a:p>
+          <a:p>
+            <a:pPr algn="l">
+              <a:lnSpc>
+                <a:spcPct val="118000"/>
+              </a:lnSpc>
+              <a:spcBef>
+                <a:spcPts val="0"/>
+              </a:spcBef>
+              <a:spcAft>
+                <a:spcPts val="600"/>
+              </a:spcAft>
+            </a:pPr>
+            <a:r>
+              <a:rPr sz="1500" b="0">
                 <a:solidFill>
                   <a:srgbClr val="1A1A1A"/>
                 </a:solidFill>
                 <a:latin typeface="Golos Text"/>
                 <a:rFonts ascii="Golos Text" hAnsi="Golos Text" cs="Golos Text" eastAsia="Golos Text"/>
               </a:rPr>
-              <a:t>• Один поставщик на номер</a:t>
-            </a:r>
-          </a:p>
-          <a:p>
-            <a:pPr algn="l">
-              <a:lnSpc>
-                <a:spcPct val="118000"/>
-              </a:lnSpc>
-              <a:spcBef>
-                <a:spcPts val="0"/>
-              </a:spcBef>
-              <a:spcAft>
-                <a:spcPts val="800"/>
-              </a:spcAft>
-            </a:pPr>
-            <a:r>
-              <a:rPr sz="1600" b="0">
+              <a:t>• Один поставщик на весь номер</a:t>
+            </a:r>
+          </a:p>
+          <a:p>
+            <a:pPr algn="l">
+              <a:lnSpc>
+                <a:spcPct val="118000"/>
+              </a:lnSpc>
+              <a:spcBef>
+                <a:spcPts val="0"/>
+              </a:spcBef>
+              <a:spcAft>
+                <a:spcPts val="600"/>
+              </a:spcAft>
+            </a:pPr>
+            <a:r>
+              <a:rPr sz="1500" b="0">
                 <a:solidFill>
                   <a:srgbClr val="1A1A1A"/>
                 </a:solidFill>
@@ -8812,18 +8973,64 @@
                 <a:spcPts val="0"/>
               </a:spcBef>
               <a:spcAft>
+                <a:spcPts val="200"/>
+              </a:spcAft>
+            </a:pPr>
+            <a:r>
+              <a:rPr sz="1500" b="1">
+                <a:solidFill>
+                  <a:srgbClr val="1A1A1A"/>
+                </a:solidFill>
+                <a:latin typeface="Manrope"/>
+                <a:rFonts ascii="Manrope" hAnsi="Manrope" cs="Manrope" eastAsia="Manrope"/>
+              </a:rPr>
+              <a:t>Герой</a:t>
+            </a:r>
+          </a:p>
+          <a:p>
+            <a:pPr algn="l">
+              <a:lnSpc>
+                <a:spcPct val="118000"/>
+              </a:lnSpc>
+              <a:spcBef>
+                <a:spcPts val="0"/>
+              </a:spcBef>
+              <a:spcAft>
                 <a:spcPts val="800"/>
               </a:spcAft>
             </a:pPr>
             <a:r>
-              <a:rPr sz="1600" b="0">
+              <a:rPr sz="1500" b="0">
                 <a:solidFill>
                   <a:srgbClr val="1A1A1A"/>
                 </a:solidFill>
                 <a:latin typeface="Golos Text"/>
                 <a:rFonts ascii="Golos Text" hAnsi="Golos Text" cs="Golos Text" eastAsia="Golos Text"/>
               </a:rPr>
-              <a:t>Герой: закупщик eco / wellness</a:t>
+              <a:t>Закупщик отеля с запросом eco / wellness: выглядеть «зеленее» без дыры в бюджете и в бумагах.</a:t>
+            </a:r>
+          </a:p>
+          <a:p>
+            <a:pPr algn="l">
+              <a:lnSpc>
+                <a:spcPct val="118000"/>
+              </a:lnSpc>
+              <a:spcBef>
+                <a:spcPts val="0"/>
+              </a:spcBef>
+              <a:spcAft>
+                <a:spcPts val="200"/>
+              </a:spcAft>
+            </a:pPr>
+            <a:r>
+              <a:rPr sz="1500" b="1">
+                <a:solidFill>
+                  <a:srgbClr val="1A1A1A"/>
+                </a:solidFill>
+                <a:latin typeface="Manrope"/>
+                <a:rFonts ascii="Manrope" hAnsi="Manrope" cs="Manrope" eastAsia="Manrope"/>
+              </a:rPr>
+              <a:t>Проводник</a:t>
             </a:r>
           </a:p>
           <a:p>
@@ -8839,37 +9046,60 @@
               </a:spcAft>
             </a:pPr>
             <a:r>
-              <a:rPr sz="1600" b="0">
+              <a:rPr sz="1500" b="0">
                 <a:solidFill>
                   <a:srgbClr val="1A1A1A"/>
                 </a:solidFill>
                 <a:latin typeface="Golos Text"/>
                 <a:rFonts ascii="Golos Text" hAnsi="Golos Text" cs="Golos Text" eastAsia="Golos Text"/>
               </a:rPr>
-              <a:t>Проводник: Travel+ Natural</a:t>
-            </a:r>
-          </a:p>
-          <a:p>
-            <a:pPr algn="l">
-              <a:lnSpc>
-                <a:spcPct val="118000"/>
-              </a:lnSpc>
-              <a:spcBef>
-                <a:spcPts val="0"/>
-              </a:spcBef>
-              <a:spcAft>
-                <a:spcPts val="1400"/>
-              </a:spcAft>
-            </a:pPr>
-            <a:r>
-              <a:rPr sz="1600" b="0">
+              <a:t>Travel+ Natural — своя линейка, документы и one-stop на номер.</a:t>
+            </a:r>
+          </a:p>
+          <a:p>
+            <a:pPr algn="l">
+              <a:lnSpc>
+                <a:spcPct val="118000"/>
+              </a:lnSpc>
+              <a:spcBef>
+                <a:spcPts val="0"/>
+              </a:spcBef>
+              <a:spcAft>
+                <a:spcPts val="200"/>
+              </a:spcAft>
+            </a:pPr>
+            <a:r>
+              <a:rPr sz="1500" b="1">
+                <a:solidFill>
+                  <a:srgbClr val="1A1A1A"/>
+                </a:solidFill>
+                <a:latin typeface="Manrope"/>
+                <a:rFonts ascii="Manrope" hAnsi="Manrope" cs="Manrope" eastAsia="Manrope"/>
+              </a:rPr>
+              <a:t>План</a:t>
+            </a:r>
+          </a:p>
+          <a:p>
+            <a:pPr algn="l">
+              <a:lnSpc>
+                <a:spcPct val="118000"/>
+              </a:lnSpc>
+              <a:spcBef>
+                <a:spcPts val="0"/>
+              </a:spcBef>
+              <a:spcAft>
+                <a:spcPts val="600"/>
+              </a:spcAft>
+            </a:pPr>
+            <a:r>
+              <a:rPr sz="1500" b="0">
                 <a:solidFill>
                   <a:srgbClr val="1A1A1A"/>
                 </a:solidFill>
                 <a:latin typeface="Golos Text"/>
                 <a:rFonts ascii="Golos Text" hAnsi="Golos Text" cs="Golos Text" eastAsia="Golos Text"/>
               </a:rPr>
-              <a:t>План: сегмент → образец + документы → пилот</a:t>
+              <a:t>1. Согласовать сегмент и объект</a:t>
             </a:r>
           </a:p>
           <a:p>
@@ -8885,13 +9115,59 @@
               </a:spcAft>
             </a:pPr>
             <a:r>
-              <a:rPr sz="1400" b="0">
-                <a:solidFill>
-                  <a:srgbClr val="5C5C5C"/>
+              <a:rPr sz="1500" b="0">
+                <a:solidFill>
+                  <a:srgbClr val="1A1A1A"/>
                 </a:solidFill>
                 <a:latin typeface="Golos Text"/>
                 <a:rFonts ascii="Golos Text" hAnsi="Golos Text" cs="Golos Text" eastAsia="Golos Text"/>
               </a:rPr>
+              <a:t>2. Образец с этикеткой и пакетом документов</a:t>
+            </a:r>
+          </a:p>
+          <a:p>
+            <a:pPr algn="l">
+              <a:lnSpc>
+                <a:spcPct val="118000"/>
+              </a:lnSpc>
+              <a:spcBef>
+                <a:spcPts val="0"/>
+              </a:spcBef>
+              <a:spcAft>
+                <a:spcPts val="1000"/>
+              </a:spcAft>
+            </a:pPr>
+            <a:r>
+              <a:rPr sz="1500" b="0">
+                <a:solidFill>
+                  <a:srgbClr val="1A1A1A"/>
+                </a:solidFill>
+                <a:latin typeface="Golos Text"/>
+                <a:rFonts ascii="Golos Text" hAnsi="Golos Text" cs="Golos Text" eastAsia="Golos Text"/>
+              </a:rPr>
+              <a:t>3. Пилот на этаже или в корпусе</a:t>
+            </a:r>
+          </a:p>
+          <a:p>
+            <a:pPr algn="l">
+              <a:lnSpc>
+                <a:spcPct val="118000"/>
+              </a:lnSpc>
+              <a:spcBef>
+                <a:spcPts val="0"/>
+              </a:spcBef>
+              <a:spcAft>
+                <a:spcPts val="400"/>
+              </a:spcAft>
+            </a:pPr>
+            <a:r>
+              <a:rPr sz="1400" b="0">
+                <a:solidFill>
+                  <a:srgbClr val="5C5C5C"/>
+                </a:solidFill>
+                <a:latin typeface="Golos Text"/>
+                <a:rFonts ascii="Golos Text" hAnsi="Golos Text" cs="Golos Text" eastAsia="Golos Text"/>
+              </a:rPr>
               <a:t>Гость после дороги:</a:t>
             </a:r>
           </a:p>
@@ -8904,41 +9180,41 @@
                 <a:spcPts val="0"/>
               </a:spcBef>
               <a:spcAft>
-                <a:spcPts val="800"/>
-              </a:spcAft>
-            </a:pPr>
-            <a:r>
-              <a:rPr sz="1600" b="1">
+                <a:spcPts val="200"/>
+              </a:spcAft>
+            </a:pPr>
+            <a:r>
+              <a:rPr sz="1500" b="1">
                 <a:solidFill>
                   <a:srgbClr val="1A1A1A"/>
                 </a:solidFill>
                 <a:latin typeface="Manrope"/>
                 <a:rFonts ascii="Manrope" hAnsi="Manrope" cs="Manrope" eastAsia="Manrope"/>
               </a:rPr>
-              <a:t>Мягче, чем ждал.</a:t>
-            </a:r>
-          </a:p>
-          <a:p>
-            <a:pPr algn="l">
-              <a:lnSpc>
-                <a:spcPct val="118000"/>
-              </a:lnSpc>
-              <a:spcBef>
-                <a:spcPts val="0"/>
-              </a:spcBef>
-              <a:spcAft>
-                <a:spcPts val="800"/>
-              </a:spcAft>
-            </a:pPr>
-            <a:r>
-              <a:rPr sz="1600" b="0">
+              <a:t>Ощущение мягче, чем ожидал.</a:t>
+            </a:r>
+          </a:p>
+          <a:p>
+            <a:pPr algn="l">
+              <a:lnSpc>
+                <a:spcPct val="118000"/>
+              </a:lnSpc>
+              <a:spcBef>
+                <a:spcPts val="0"/>
+              </a:spcBef>
+              <a:spcAft>
+                <a:spcPts val="600"/>
+              </a:spcAft>
+            </a:pPr>
+            <a:r>
+              <a:rPr sz="1500" b="0">
                 <a:solidFill>
                   <a:srgbClr val="1A1A1A"/>
                 </a:solidFill>
                 <a:latin typeface="Golos Text"/>
                 <a:rFonts ascii="Golos Text" hAnsi="Golos Text" cs="Golos Text" eastAsia="Golos Text"/>
               </a:rPr>
-              <a:t>Понятная натуральность без громких обещаний.</a:t>
+              <a:t>Понятная натуральность — без громких обещаний на этикетке.</a:t>
             </a:r>
           </a:p>
         </p:txBody>
@@ -9077,7 +9353,7 @@
                 <a:latin typeface="Manrope"/>
                 <a:rFonts ascii="Manrope" hAnsi="Manrope" cs="Manrope" eastAsia="Manrope"/>
               </a:rPr>
-              <a:t>Границы до рынка — DoD этапа 2</a:t>
+              <a:t>Готовность продукта перед рынком</a:t>
             </a:r>
           </a:p>
         </p:txBody>
@@ -9458,168 +9734,168 @@
                 <a:latin typeface="Manrope"/>
                 <a:rFonts ascii="Manrope" hAnsi="Manrope" cs="Manrope" eastAsia="Manrope"/>
               </a:rPr>
-              <a:t>Пока красное — витрину не открываем</a:t>
-            </a:r>
-          </a:p>
-          <a:p>
-            <a:pPr algn="l">
-              <a:lnSpc>
-                <a:spcPct val="118000"/>
-              </a:lnSpc>
-              <a:spcBef>
-                <a:spcPts val="0"/>
-              </a:spcBef>
-              <a:spcAft>
-                <a:spcPts val="800"/>
-              </a:spcAft>
-            </a:pPr>
-            <a:r>
-              <a:rPr sz="1600" b="0">
+              <a:t>Чеклист: без этого — не в продажи</a:t>
+            </a:r>
+          </a:p>
+          <a:p>
+            <a:pPr algn="l">
+              <a:lnSpc>
+                <a:spcPct val="118000"/>
+              </a:lnSpc>
+              <a:spcBef>
+                <a:spcPts val="0"/>
+              </a:spcBef>
+              <a:spcAft>
+                <a:spcPts val="600"/>
+              </a:spcAft>
+            </a:pPr>
+            <a:r>
+              <a:rPr sz="1500" b="0">
                 <a:solidFill>
                   <a:srgbClr val="1A1A1A"/>
                 </a:solidFill>
                 <a:latin typeface="Golos Text"/>
                 <a:rFonts ascii="Golos Text" hAnsi="Golos Text" cs="Golos Text" eastAsia="Golos Text"/>
               </a:rPr>
-              <a:t>□ Метод и % натуральности</a:t>
-            </a:r>
-          </a:p>
-          <a:p>
-            <a:pPr algn="l">
-              <a:lnSpc>
-                <a:spcPct val="118000"/>
-              </a:lnSpc>
-              <a:spcBef>
-                <a:spcPts val="0"/>
-              </a:spcBef>
-              <a:spcAft>
-                <a:spcPts val="800"/>
-              </a:spcAft>
-            </a:pPr>
-            <a:r>
-              <a:rPr sz="1600" b="0">
+              <a:t>□ Метод расчёта и доля натуральных ингредиентов</a:t>
+            </a:r>
+          </a:p>
+          <a:p>
+            <a:pPr algn="l">
+              <a:lnSpc>
+                <a:spcPct val="118000"/>
+              </a:lnSpc>
+              <a:spcBef>
+                <a:spcPts val="0"/>
+              </a:spcBef>
+              <a:spcAft>
+                <a:spcPts val="600"/>
+              </a:spcAft>
+            </a:pPr>
+            <a:r>
+              <a:rPr sz="1500" b="0">
                 <a:solidFill>
                   <a:srgbClr val="1A1A1A"/>
                 </a:solidFill>
                 <a:latin typeface="Golos Text"/>
                 <a:rFonts ascii="Golos Text" hAnsi="Golos Text" cs="Golos Text" eastAsia="Golos Text"/>
               </a:rPr>
-              <a:t>□ Пакет как у HL / Fleur + лист Natural</a:t>
-            </a:r>
-          </a:p>
-          <a:p>
-            <a:pPr algn="l">
-              <a:lnSpc>
-                <a:spcPct val="118000"/>
-              </a:lnSpc>
-              <a:spcBef>
-                <a:spcPts val="0"/>
-              </a:spcBef>
-              <a:spcAft>
-                <a:spcPts val="800"/>
-              </a:spcAft>
-            </a:pPr>
-            <a:r>
-              <a:rPr sz="1600" b="0">
+              <a:t>□ Пакет документов как у Hotel Line и Fleur + лист состава Natural</a:t>
+            </a:r>
+          </a:p>
+          <a:p>
+            <a:pPr algn="l">
+              <a:lnSpc>
+                <a:spcPct val="118000"/>
+              </a:lnSpc>
+              <a:spcBef>
+                <a:spcPts val="0"/>
+              </a:spcBef>
+              <a:spcAft>
+                <a:spcPts val="600"/>
+              </a:spcAft>
+            </a:pPr>
+            <a:r>
+              <a:rPr sz="1500" b="0">
                 <a:solidFill>
                   <a:srgbClr val="1A1A1A"/>
                 </a:solidFill>
                 <a:latin typeface="Golos Text"/>
                 <a:rFonts ascii="Golos Text" hAnsi="Golos Text" cs="Golos Text" eastAsia="Golos Text"/>
               </a:rPr>
-              <a:t>□ Origin зафиксирован</a:t>
-            </a:r>
-          </a:p>
-          <a:p>
-            <a:pPr algn="l">
-              <a:lnSpc>
-                <a:spcPct val="118000"/>
-              </a:lnSpc>
-              <a:spcBef>
-                <a:spcPts val="0"/>
-              </a:spcBef>
-              <a:spcAft>
-                <a:spcPts val="800"/>
-              </a:spcAft>
-            </a:pPr>
-            <a:r>
-              <a:rPr sz="1600" b="0">
+              <a:t>□ Происхождение (origin) зафиксировано письменно</a:t>
+            </a:r>
+          </a:p>
+          <a:p>
+            <a:pPr algn="l">
+              <a:lnSpc>
+                <a:spcPct val="118000"/>
+              </a:lnSpc>
+              <a:spcBef>
+                <a:spcPts val="0"/>
+              </a:spcBef>
+              <a:spcAft>
+                <a:spcPts val="600"/>
+              </a:spcAft>
+            </a:pPr>
+            <a:r>
+              <a:rPr sz="1500" b="0">
                 <a:solidFill>
                   <a:srgbClr val="1A1A1A"/>
                 </a:solidFill>
                 <a:latin typeface="Golos Text"/>
                 <a:rFonts ascii="Golos Text" hAnsi="Golos Text" cs="Golos Text" eastAsia="Golos Text"/>
               </a:rPr>
-              <a:t>□ Слепой тест запаха с гостями</a:t>
-            </a:r>
-          </a:p>
-          <a:p>
-            <a:pPr algn="l">
-              <a:lnSpc>
-                <a:spcPct val="118000"/>
-              </a:lnSpc>
-              <a:spcBef>
-                <a:spcPts val="0"/>
-              </a:spcBef>
-              <a:spcAft>
-                <a:spcPts val="800"/>
-              </a:spcAft>
-            </a:pPr>
-            <a:r>
-              <a:rPr sz="1600" b="0">
+              <a:t>□ Слепой тест запаха и ощущения с гостями</a:t>
+            </a:r>
+          </a:p>
+          <a:p>
+            <a:pPr algn="l">
+              <a:lnSpc>
+                <a:spcPct val="118000"/>
+              </a:lnSpc>
+              <a:spcBef>
+                <a:spcPts val="0"/>
+              </a:spcBef>
+              <a:spcAft>
+                <a:spcPts val="600"/>
+              </a:spcAft>
+            </a:pPr>
+            <a:r>
+              <a:rPr sz="1500" b="0">
                 <a:solidFill>
                   <a:srgbClr val="1A1A1A"/>
                 </a:solidFill>
                 <a:latin typeface="Golos Text"/>
                 <a:rFonts ascii="Golos Text" hAnsi="Golos Text" cs="Golos Text" eastAsia="Golos Text"/>
               </a:rPr>
-              <a:t>□ Этикетка «простыми словами»</a:t>
-            </a:r>
-          </a:p>
-          <a:p>
-            <a:pPr algn="l">
-              <a:lnSpc>
-                <a:spcPct val="118000"/>
-              </a:lnSpc>
-              <a:spcBef>
-                <a:spcPts val="0"/>
-              </a:spcBef>
-              <a:spcAft>
-                <a:spcPts val="800"/>
-              </a:spcAft>
-            </a:pPr>
-            <a:r>
-              <a:rPr sz="1600" b="0">
+              <a:t>□ Этикетка с блоком «простыми словами»</a:t>
+            </a:r>
+          </a:p>
+          <a:p>
+            <a:pPr algn="l">
+              <a:lnSpc>
+                <a:spcPct val="118000"/>
+              </a:lnSpc>
+              <a:spcBef>
+                <a:spcPts val="0"/>
+              </a:spcBef>
+              <a:spcAft>
+                <a:spcPts val="600"/>
+              </a:spcAft>
+            </a:pPr>
+            <a:r>
+              <a:rPr sz="1500" b="0">
                 <a:solidFill>
                   <a:srgbClr val="1A1A1A"/>
                 </a:solidFill>
                 <a:latin typeface="Golos Text"/>
                 <a:rFonts ascii="Golos Text" hAnsi="Golos Text" cs="Golos Text" eastAsia="Golos Text"/>
               </a:rPr>
-              <a:t>□ Себестоимость и коридор цены</a:t>
-            </a:r>
-          </a:p>
-          <a:p>
-            <a:pPr algn="l">
-              <a:lnSpc>
-                <a:spcPct val="118000"/>
-              </a:lnSpc>
-              <a:spcBef>
-                <a:spcPts val="0"/>
-              </a:spcBef>
-              <a:spcAft>
-                <a:spcPts val="800"/>
-              </a:spcAft>
-            </a:pPr>
-            <a:r>
-              <a:rPr sz="1600" b="0">
+              <a:t>□ Себестоимость и коридор цены на полке</a:t>
+            </a:r>
+          </a:p>
+          <a:p>
+            <a:pPr algn="l">
+              <a:lnSpc>
+                <a:spcPct val="118000"/>
+              </a:lnSpc>
+              <a:spcBef>
+                <a:spcPts val="0"/>
+              </a:spcBef>
+              <a:spcAft>
+                <a:spcPts val="600"/>
+              </a:spcAft>
+            </a:pPr>
+            <a:r>
+              <a:rPr sz="1500" b="0">
                 <a:solidFill>
                   <a:srgbClr val="1A1A1A"/>
                 </a:solidFill>
                 <a:latin typeface="Golos Text"/>
                 <a:rFonts ascii="Golos Text" hAnsi="Golos Text" cs="Golos Text" eastAsia="Golos Text"/>
               </a:rPr>
-              <a:t>□ Срок поставки / мин. заказ / брак</a:t>
+              <a:t>□ Срок поставки, минимальный заказ, правила брака</a:t>
             </a:r>
           </a:p>
         </p:txBody>
@@ -9663,99 +9939,122 @@
                 <a:latin typeface="Manrope"/>
                 <a:rFonts ascii="Manrope" hAnsi="Manrope" cs="Manrope" eastAsia="Manrope"/>
               </a:rPr>
-              <a:t>Правила</a:t>
-            </a:r>
-          </a:p>
-          <a:p>
-            <a:pPr algn="l">
-              <a:lnSpc>
-                <a:spcPct val="118000"/>
-              </a:lnSpc>
-              <a:spcBef>
-                <a:spcPts val="0"/>
-              </a:spcBef>
-              <a:spcAft>
-                <a:spcPts val="800"/>
-              </a:spcAft>
-            </a:pPr>
-            <a:r>
-              <a:rPr sz="1600" b="0">
+              <a:t>Как читать список</a:t>
+            </a:r>
+          </a:p>
+          <a:p>
+            <a:pPr algn="l">
+              <a:lnSpc>
+                <a:spcPct val="118000"/>
+              </a:lnSpc>
+              <a:spcBef>
+                <a:spcPts val="0"/>
+              </a:spcBef>
+              <a:spcAft>
+                <a:spcPts val="600"/>
+              </a:spcAft>
+            </a:pPr>
+            <a:r>
+              <a:rPr sz="1500" b="0">
                 <a:solidFill>
                   <a:srgbClr val="1A1A1A"/>
                 </a:solidFill>
                 <a:latin typeface="Golos Text"/>
                 <a:rFonts ascii="Golos Text" hAnsi="Golos Text" cs="Golos Text" eastAsia="Golos Text"/>
               </a:rPr>
-              <a:t>На старте без COSMOS, если знака нет — честно.</a:t>
-            </a:r>
-          </a:p>
-          <a:p>
-            <a:pPr algn="l">
-              <a:lnSpc>
-                <a:spcPct val="118000"/>
-              </a:lnSpc>
-              <a:spcBef>
-                <a:spcPts val="0"/>
-              </a:spcBef>
-              <a:spcAft>
-                <a:spcPts val="1200"/>
-              </a:spcAft>
-            </a:pPr>
-            <a:r>
-              <a:rPr sz="1600" b="1">
+              <a:t>Каждый пункт — обязательное условие.</a:t>
+            </a:r>
+          </a:p>
+          <a:p>
+            <a:pPr algn="l">
+              <a:lnSpc>
+                <a:spcPct val="118000"/>
+              </a:lnSpc>
+              <a:spcBef>
+                <a:spcPts val="0"/>
+              </a:spcBef>
+              <a:spcAft>
+                <a:spcPts val="600"/>
+              </a:spcAft>
+            </a:pPr>
+            <a:r>
+              <a:rPr sz="1500" b="0">
+                <a:solidFill>
+                  <a:srgbClr val="1A1A1A"/>
+                </a:solidFill>
+                <a:latin typeface="Golos Text"/>
+                <a:rFonts ascii="Golos Text" hAnsi="Golos Text" cs="Golos Text" eastAsia="Golos Text"/>
+              </a:rPr>
+              <a:t>Пока хотя бы один не закрыт — коммерческое предложение и выход на витрину стоп.</a:t>
+            </a:r>
+          </a:p>
+          <a:p>
+            <a:pPr algn="l">
+              <a:lnSpc>
+                <a:spcPct val="118000"/>
+              </a:lnSpc>
+              <a:spcBef>
+                <a:spcPts val="0"/>
+              </a:spcBef>
+              <a:spcAft>
+                <a:spcPts val="1000"/>
+              </a:spcAft>
+            </a:pPr>
+            <a:r>
+              <a:rPr sz="1500" b="0">
+                <a:solidFill>
+                  <a:srgbClr val="1A1A1A"/>
+                </a:solidFill>
+                <a:latin typeface="Golos Text"/>
+                <a:rFonts ascii="Golos Text" hAnsi="Golos Text" cs="Golos Text" eastAsia="Golos Text"/>
+              </a:rPr>
+              <a:t>На старте без знака COSMOS, если его нет — говорим честно.</a:t>
+            </a:r>
+          </a:p>
+          <a:p>
+            <a:pPr algn="l">
+              <a:lnSpc>
+                <a:spcPct val="118000"/>
+              </a:lnSpc>
+              <a:spcBef>
+                <a:spcPts val="0"/>
+              </a:spcBef>
+              <a:spcAft>
+                <a:spcPts val="200"/>
+              </a:spcAft>
+            </a:pPr>
+            <a:r>
+              <a:rPr sz="1500" b="1">
                 <a:solidFill>
                   <a:srgbClr val="1A1A1A"/>
                 </a:solidFill>
                 <a:latin typeface="Manrope"/>
                 <a:rFonts ascii="Manrope" hAnsi="Manrope" cs="Manrope" eastAsia="Manrope"/>
               </a:rPr>
-              <a:t>Без DoD — не КП и не live GTM.</a:t>
-            </a:r>
-          </a:p>
-          <a:p>
-            <a:pPr algn="l">
-              <a:lnSpc>
-                <a:spcPct val="118000"/>
-              </a:lnSpc>
-              <a:spcBef>
-                <a:spcPts val="0"/>
-              </a:spcBef>
-              <a:spcAft>
-                <a:spcPts val="800"/>
-              </a:spcAft>
-            </a:pPr>
-            <a:r>
-              <a:rPr sz="1600" b="0">
+              <a:t>Этапы 3–6 в пульте — учебный сценарий,</a:t>
+            </a:r>
+          </a:p>
+          <a:p>
+            <a:pPr algn="l">
+              <a:lnSpc>
+                <a:spcPct val="118000"/>
+              </a:lnSpc>
+              <a:spcBef>
+                <a:spcPts val="0"/>
+              </a:spcBef>
+              <a:spcAft>
+                <a:spcPts val="600"/>
+              </a:spcAft>
+            </a:pPr>
+            <a:r>
+              <a:rPr sz="1500" b="0">
                 <a:solidFill>
                   <a:srgbClr val="1A1A1A"/>
                 </a:solidFill>
                 <a:latin typeface="Golos Text"/>
                 <a:rFonts ascii="Golos Text" hAnsi="Golos Text" cs="Golos Text" eastAsia="Golos Text"/>
               </a:rPr>
-              <a:t>Этапы 3–6 — учебный сценарий,</a:t>
-            </a:r>
-          </a:p>
-          <a:p>
-            <a:pPr algn="l">
-              <a:lnSpc>
-                <a:spcPct val="118000"/>
-              </a:lnSpc>
-              <a:spcBef>
-                <a:spcPts val="0"/>
-              </a:spcBef>
-              <a:spcAft>
-                <a:spcPts val="800"/>
-              </a:spcAft>
-            </a:pPr>
-            <a:r>
-              <a:rPr sz="1600" b="0">
-                <a:solidFill>
-                  <a:srgbClr val="1A1A1A"/>
-                </a:solidFill>
-                <a:latin typeface="Golos Text"/>
-                <a:rFonts ascii="Golos Text" hAnsi="Golos Text" cs="Golos Text" eastAsia="Golos Text"/>
-              </a:rPr>
-              <a:t>не факт завода.</a:t>
+              <a:t>а не отчёт завода и не основание для КП.</a:t>
             </a:r>
           </a:p>
         </p:txBody>
@@ -10065,7 +10364,7 @@
         <p:spPr>
           <a:xfrm>
             <a:off x="457200" y="960120"/>
-            <a:ext cx="11277295" cy="4206240"/>
+            <a:ext cx="11277295" cy="4343400"/>
           </a:xfrm>
           <a:prstGeom prst="roundRect">
             <a:avLst>
@@ -10155,7 +10454,7 @@
         <p:spPr>
           <a:xfrm>
             <a:off x="804672" y="1426464"/>
-            <a:ext cx="10582351" cy="3465576"/>
+            <a:ext cx="10582351" cy="3602736"/>
           </a:xfrm>
           <a:prstGeom prst="rect">
             <a:avLst/>
@@ -10174,18 +10473,41 @@
                 <a:spcPts val="0"/>
               </a:spcBef>
               <a:spcAft>
+                <a:spcPts val="400"/>
+              </a:spcAft>
+            </a:pPr>
+            <a:r>
+              <a:rPr sz="1600" b="1">
+                <a:solidFill>
+                  <a:srgbClr val="1A1A1A"/>
+                </a:solidFill>
+                <a:latin typeface="Manrope"/>
+                <a:rFonts ascii="Manrope" hAnsi="Manrope" cs="Manrope" eastAsia="Manrope"/>
+              </a:rPr>
+              <a:t>Задача закупщика</a:t>
+            </a:r>
+          </a:p>
+          <a:p>
+            <a:pPr algn="l">
+              <a:lnSpc>
+                <a:spcPct val="118000"/>
+              </a:lnSpc>
+              <a:spcBef>
+                <a:spcPts val="0"/>
+              </a:spcBef>
+              <a:spcAft>
                 <a:spcPts val="1000"/>
               </a:spcAft>
             </a:pPr>
             <a:r>
-              <a:rPr sz="1700" b="0">
+              <a:rPr sz="1500" b="0">
                 <a:solidFill>
                   <a:srgbClr val="1A1A1A"/>
                 </a:solidFill>
                 <a:latin typeface="Golos Text"/>
                 <a:rFonts ascii="Golos Text" hAnsi="Golos Text" cs="Golos Text" eastAsia="Golos Text"/>
               </a:rPr>
-              <a:t>«Вам нужно выглядеть зеленее — и спокойно пройти и гостя, и документы.</a:t>
+              <a:t>Отель хочет выглядеть экологичнее — без риска для гостя и без пробелов в документах при проверке.</a:t>
             </a:r>
           </a:p>
           <a:p>
@@ -10201,37 +10523,60 @@
               </a:spcAft>
             </a:pPr>
             <a:r>
-              <a:rPr sz="1700" b="0">
+              <a:rPr sz="1600" b="1">
+                <a:solidFill>
+                  <a:srgbClr val="1A1A1A"/>
+                </a:solidFill>
+                <a:latin typeface="Manrope"/>
+                <a:rFonts ascii="Manrope" hAnsi="Manrope" cs="Manrope" eastAsia="Manrope"/>
+              </a:rPr>
+              <a:t>Что предлагаем</a:t>
+            </a:r>
+          </a:p>
+          <a:p>
+            <a:pPr algn="l">
+              <a:lnSpc>
+                <a:spcPct val="118000"/>
+              </a:lnSpc>
+              <a:spcBef>
+                <a:spcPts val="0"/>
+              </a:spcBef>
+              <a:spcAft>
+                <a:spcPts val="600"/>
+              </a:spcAft>
+            </a:pPr>
+            <a:r>
+              <a:rPr sz="1500" b="0">
                 <a:solidFill>
                   <a:srgbClr val="1A1A1A"/>
                 </a:solidFill>
                 <a:latin typeface="Golos Text"/>
                 <a:rFonts ascii="Golos Text" hAnsi="Golos Text" cs="Golos Text" eastAsia="Golos Text"/>
               </a:rPr>
-              <a:t>Travel+ Natural: пакет документов как у Hotel Line и Fleur</a:t>
-            </a:r>
-          </a:p>
-          <a:p>
-            <a:pPr algn="l">
-              <a:lnSpc>
-                <a:spcPct val="118000"/>
-              </a:lnSpc>
-              <a:spcBef>
-                <a:spcPts val="0"/>
-              </a:spcBef>
-              <a:spcAft>
-                <a:spcPts val="800"/>
-              </a:spcAft>
-            </a:pPr>
-            <a:r>
-              <a:rPr sz="1400" b="0">
-                <a:solidFill>
-                  <a:srgbClr val="5C5C5C"/>
+              <a:t>Travel+ Natural — пакет документов как у Hotel Line и Fleur:</a:t>
+            </a:r>
+          </a:p>
+          <a:p>
+            <a:pPr algn="l">
+              <a:lnSpc>
+                <a:spcPct val="118000"/>
+              </a:lnSpc>
+              <a:spcBef>
+                <a:spcPts val="0"/>
+              </a:spcBef>
+              <a:spcAft>
+                <a:spcPts val="600"/>
+              </a:spcAft>
+            </a:pPr>
+            <a:r>
+              <a:rPr sz="1500" b="0">
+                <a:solidFill>
+                  <a:srgbClr val="1A1A1A"/>
                 </a:solidFill>
                 <a:latin typeface="Golos Text"/>
                 <a:rFonts ascii="Golos Text" hAnsi="Golos Text" cs="Golos Text" eastAsia="Golos Text"/>
               </a:rPr>
-              <a:t>(декларация / СГР, INCI, протоколы по запросу),</a:t>
+              <a:t>декларация или СГР, INCI, протоколы по запросу.</a:t>
             </a:r>
           </a:p>
           <a:p>
@@ -10247,37 +10592,106 @@
               </a:spcAft>
             </a:pPr>
             <a:r>
-              <a:rPr sz="1700" b="0">
+              <a:rPr sz="1500" b="0">
                 <a:solidFill>
                   <a:srgbClr val="1A1A1A"/>
                 </a:solidFill>
                 <a:latin typeface="Golos Text"/>
                 <a:rFonts ascii="Golos Text" hAnsi="Golos Text" cs="Golos Text" eastAsia="Golos Text"/>
               </a:rPr>
-              <a:t>прозрачный состав с блоком «простыми словами», один договор на номер.</a:t>
-            </a:r>
-          </a:p>
-          <a:p>
-            <a:pPr algn="l">
-              <a:lnSpc>
-                <a:spcPct val="118000"/>
-              </a:lnSpc>
-              <a:spcBef>
-                <a:spcPts val="0"/>
-              </a:spcBef>
-              <a:spcAft>
-                <a:spcPts val="800"/>
-              </a:spcAft>
-            </a:pPr>
-            <a:r>
-              <a:rPr sz="1700" b="1">
+              <a:t>Состав с блоком «простыми словами». Один договор на весь номер.</a:t>
+            </a:r>
+          </a:p>
+          <a:p>
+            <a:pPr algn="l">
+              <a:lnSpc>
+                <a:spcPct val="118000"/>
+              </a:lnSpc>
+              <a:spcBef>
+                <a:spcPts val="0"/>
+              </a:spcBef>
+              <a:spcAft>
+                <a:spcPts val="400"/>
+              </a:spcAft>
+            </a:pPr>
+            <a:r>
+              <a:rPr sz="1600" b="1">
                 <a:solidFill>
                   <a:srgbClr val="1A1A1A"/>
                 </a:solidFill>
                 <a:latin typeface="Manrope"/>
                 <a:rFonts ascii="Manrope" hAnsi="Manrope" cs="Manrope" eastAsia="Manrope"/>
               </a:rPr>
-              <a:t>Три шага: eco / wellness → образец → пилот.»</a:t>
+              <a:t>Три шага</a:t>
+            </a:r>
+          </a:p>
+          <a:p>
+            <a:pPr algn="l">
+              <a:lnSpc>
+                <a:spcPct val="118000"/>
+              </a:lnSpc>
+              <a:spcBef>
+                <a:spcPts val="0"/>
+              </a:spcBef>
+              <a:spcAft>
+                <a:spcPts val="600"/>
+              </a:spcAft>
+            </a:pPr>
+            <a:r>
+              <a:rPr sz="1500" b="0">
+                <a:solidFill>
+                  <a:srgbClr val="1A1A1A"/>
+                </a:solidFill>
+                <a:latin typeface="Golos Text"/>
+                <a:rFonts ascii="Golos Text" hAnsi="Golos Text" cs="Golos Text" eastAsia="Golos Text"/>
+              </a:rPr>
+              <a:t>1. Сегмент eco / wellness и объект</a:t>
+            </a:r>
+          </a:p>
+          <a:p>
+            <a:pPr algn="l">
+              <a:lnSpc>
+                <a:spcPct val="118000"/>
+              </a:lnSpc>
+              <a:spcBef>
+                <a:spcPts val="0"/>
+              </a:spcBef>
+              <a:spcAft>
+                <a:spcPts val="600"/>
+              </a:spcAft>
+            </a:pPr>
+            <a:r>
+              <a:rPr sz="1500" b="0">
+                <a:solidFill>
+                  <a:srgbClr val="1A1A1A"/>
+                </a:solidFill>
+                <a:latin typeface="Golos Text"/>
+                <a:rFonts ascii="Golos Text" hAnsi="Golos Text" cs="Golos Text" eastAsia="Golos Text"/>
+              </a:rPr>
+              <a:t>2. Образец с этикеткой и документами</a:t>
+            </a:r>
+          </a:p>
+          <a:p>
+            <a:pPr algn="l">
+              <a:lnSpc>
+                <a:spcPct val="118000"/>
+              </a:lnSpc>
+              <a:spcBef>
+                <a:spcPts val="0"/>
+              </a:spcBef>
+              <a:spcAft>
+                <a:spcPts val="600"/>
+              </a:spcAft>
+            </a:pPr>
+            <a:r>
+              <a:rPr sz="1500" b="0">
+                <a:solidFill>
+                  <a:srgbClr val="1A1A1A"/>
+                </a:solidFill>
+                <a:latin typeface="Golos Text"/>
+                <a:rFonts ascii="Golos Text" hAnsi="Golos Text" cs="Golos Text" eastAsia="Golos Text"/>
+              </a:rPr>
+              <a:t>3. Пилот на этаже или в корпусе</a:t>
             </a:r>
           </a:p>
         </p:txBody>
@@ -10290,7 +10704,7 @@
         </p:nvSpPr>
         <p:spPr>
           <a:xfrm>
-            <a:off x="804672" y="5367528"/>
+            <a:off x="804672" y="5468112"/>
             <a:ext cx="10582351" cy="502920"/>
           </a:xfrm>
           <a:prstGeom prst="rect">
@@ -10321,7 +10735,7 @@
                 <a:latin typeface="Golos Text"/>
                 <a:rFonts ascii="Golos Text" hAnsi="Golos Text" cs="Golos Text" eastAsia="Golos Text"/>
               </a:rPr>
-              <a:t>Отрицания (COSMOS, origin, цена Hotel Line) — только в возражениях.</a:t>
+              <a:t>Отрицания (COSMOS, происхождение, цена Hotel Line) — только в блоке возражений.</a:t>
             </a:r>
           </a:p>
         </p:txBody>
@@ -10841,53 +11255,122 @@
                 <a:latin typeface="Manrope"/>
                 <a:rFonts ascii="Manrope" hAnsi="Manrope" cs="Manrope" eastAsia="Manrope"/>
               </a:rPr>
-              <a:t>Возражения</a:t>
-            </a:r>
-          </a:p>
-          <a:p>
-            <a:pPr algn="l">
-              <a:lnSpc>
-                <a:spcPct val="118000"/>
-              </a:lnSpc>
-              <a:spcBef>
-                <a:spcPts val="0"/>
-              </a:spcBef>
-              <a:spcAft>
-                <a:spcPts val="800"/>
-              </a:spcAft>
-            </a:pPr>
-            <a:r>
-              <a:rPr sz="1600" b="0">
+              <a:t>Возражения и ответы</a:t>
+            </a:r>
+          </a:p>
+          <a:p>
+            <a:pPr algn="l">
+              <a:lnSpc>
+                <a:spcPct val="118000"/>
+              </a:lnSpc>
+              <a:spcBef>
+                <a:spcPts val="0"/>
+              </a:spcBef>
+              <a:spcAft>
+                <a:spcPts val="200"/>
+              </a:spcAft>
+            </a:pPr>
+            <a:r>
+              <a:rPr sz="1500" b="1">
+                <a:solidFill>
+                  <a:srgbClr val="1A1A1A"/>
+                </a:solidFill>
+                <a:latin typeface="Manrope"/>
+                <a:rFonts ascii="Manrope" hAnsi="Manrope" cs="Manrope" eastAsia="Manrope"/>
+              </a:rPr>
+              <a:t>COSMOS в тендере обязателен</a:t>
+            </a:r>
+          </a:p>
+          <a:p>
+            <a:pPr algn="l">
+              <a:lnSpc>
+                <a:spcPct val="118000"/>
+              </a:lnSpc>
+              <a:spcBef>
+                <a:spcPts val="0"/>
+              </a:spcBef>
+              <a:spcAft>
+                <a:spcPts val="1000"/>
+              </a:spcAft>
+            </a:pPr>
+            <a:r>
+              <a:rPr sz="1500" b="0">
                 <a:solidFill>
                   <a:srgbClr val="1A1A1A"/>
                 </a:solidFill>
                 <a:latin typeface="Golos Text"/>
                 <a:rFonts ascii="Golos Text" hAnsi="Golos Text" cs="Golos Text" eastAsia="Golos Text"/>
               </a:rPr>
-              <a:t>COSMOS обязателен → Natural в это КП не ставим</a:t>
-            </a:r>
-          </a:p>
-          <a:p>
-            <a:pPr algn="l">
-              <a:lnSpc>
-                <a:spcPct val="118000"/>
-              </a:lnSpc>
-              <a:spcBef>
-                <a:spcPts val="0"/>
-              </a:spcBef>
-              <a:spcAft>
-                <a:spcPts val="800"/>
-              </a:spcAft>
-            </a:pPr>
-            <a:r>
-              <a:rPr sz="1600" b="0">
+              <a:t>Знака нет — Natural в это коммерческое предложение не ставим. Предлагаем Hotel Line или отказ.</a:t>
+            </a:r>
+          </a:p>
+          <a:p>
+            <a:pPr algn="l">
+              <a:lnSpc>
+                <a:spcPct val="118000"/>
+              </a:lnSpc>
+              <a:spcBef>
+                <a:spcPts val="0"/>
+              </a:spcBef>
+              <a:spcAft>
+                <a:spcPts val="200"/>
+              </a:spcAft>
+            </a:pPr>
+            <a:r>
+              <a:rPr sz="1500" b="1">
+                <a:solidFill>
+                  <a:srgbClr val="1A1A1A"/>
+                </a:solidFill>
+                <a:latin typeface="Manrope"/>
+                <a:rFonts ascii="Manrope" hAnsi="Manrope" cs="Manrope" eastAsia="Manrope"/>
+              </a:rPr>
+              <a:t>«Natural по цене Hotel Line»</a:t>
+            </a:r>
+          </a:p>
+          <a:p>
+            <a:pPr algn="l">
+              <a:lnSpc>
+                <a:spcPct val="118000"/>
+              </a:lnSpc>
+              <a:spcBef>
+                <a:spcPts val="0"/>
+              </a:spcBef>
+              <a:spcAft>
+                <a:spcPts val="1000"/>
+              </a:spcAft>
+            </a:pPr>
+            <a:r>
+              <a:rPr sz="1500" b="0">
                 <a:solidFill>
                   <a:srgbClr val="1A1A1A"/>
                 </a:solidFill>
                 <a:latin typeface="Golos Text"/>
                 <a:rFonts ascii="Golos Text" hAnsi="Golos Text" cs="Golos Text" eastAsia="Golos Text"/>
               </a:rPr>
-              <a:t>«Natural по цене Hotel Line» → нет</a:t>
+              <a:t>Нет. Другая себестоимость и другая позиция на полке.</a:t>
+            </a:r>
+          </a:p>
+          <a:p>
+            <a:pPr algn="l">
+              <a:lnSpc>
+                <a:spcPct val="118000"/>
+              </a:lnSpc>
+              <a:spcBef>
+                <a:spcPts val="0"/>
+              </a:spcBef>
+              <a:spcAft>
+                <a:spcPts val="200"/>
+              </a:spcAft>
+            </a:pPr>
+            <a:r>
+              <a:rPr sz="1500" b="1">
+                <a:solidFill>
+                  <a:srgbClr val="1A1A1A"/>
+                </a:solidFill>
+                <a:latin typeface="Manrope"/>
+                <a:rFonts ascii="Manrope" hAnsi="Manrope" cs="Manrope" eastAsia="Manrope"/>
+              </a:rPr>
+              <a:t>СТМ / логотип отеля</a:t>
             </a:r>
           </a:p>
           <a:p>
@@ -10903,37 +11386,60 @@
               </a:spcAft>
             </a:pPr>
             <a:r>
-              <a:rPr sz="1600" b="0">
+              <a:rPr sz="1500" b="0">
                 <a:solidFill>
                   <a:srgbClr val="1A1A1A"/>
                 </a:solidFill>
                 <a:latin typeface="Golos Text"/>
                 <a:rFonts ascii="Golos Text" hAnsi="Golos Text" cs="Golos Text" eastAsia="Golos Text"/>
               </a:rPr>
-              <a:t>СТМ / лого отеля → отдельный проект</a:t>
-            </a:r>
-          </a:p>
-          <a:p>
-            <a:pPr algn="l">
-              <a:lnSpc>
-                <a:spcPct val="118000"/>
-              </a:lnSpc>
-              <a:spcBef>
-                <a:spcPts val="0"/>
-              </a:spcBef>
-              <a:spcAft>
-                <a:spcPts val="800"/>
-              </a:spcAft>
-            </a:pPr>
-            <a:r>
-              <a:rPr sz="1600" b="0">
+              <a:t>Отдельный проект. Не маскируем под Natural.</a:t>
+            </a:r>
+          </a:p>
+          <a:p>
+            <a:pPr algn="l">
+              <a:lnSpc>
+                <a:spcPct val="118000"/>
+              </a:lnSpc>
+              <a:spcBef>
+                <a:spcPts val="0"/>
+              </a:spcBef>
+              <a:spcAft>
+                <a:spcPts val="200"/>
+              </a:spcAft>
+            </a:pPr>
+            <a:r>
+              <a:rPr sz="1500" b="1">
+                <a:solidFill>
+                  <a:srgbClr val="1A1A1A"/>
+                </a:solidFill>
+                <a:latin typeface="Manrope"/>
+                <a:rFonts ascii="Manrope" hAnsi="Manrope" cs="Manrope" eastAsia="Manrope"/>
+              </a:rPr>
+              <a:t>«Где произведено?»</a:t>
+            </a:r>
+          </a:p>
+          <a:p>
+            <a:pPr algn="l">
+              <a:lnSpc>
+                <a:spcPct val="118000"/>
+              </a:lnSpc>
+              <a:spcBef>
+                <a:spcPts val="0"/>
+              </a:spcBef>
+              <a:spcAft>
+                <a:spcPts val="600"/>
+              </a:spcAft>
+            </a:pPr>
+            <a:r>
+              <a:rPr sz="1500" b="0">
                 <a:solidFill>
                   <a:srgbClr val="1A1A1A"/>
                 </a:solidFill>
                 <a:latin typeface="Golos Text"/>
                 <a:rFonts ascii="Golos Text" hAnsi="Golos Text" cs="Golos Text" eastAsia="Golos Text"/>
               </a:rPr>
-              <a:t>«Где произведено?» → только зафиксированный origin</a:t>
+              <a:t>Только зафиксированное происхождение. Без догадок и «скорее всего».</a:t>
             </a:r>
           </a:p>
         </p:txBody>
@@ -10989,41 +11495,41 @@
                 <a:spcPts val="0"/>
               </a:spcBef>
               <a:spcAft>
-                <a:spcPts val="800"/>
-              </a:spcAft>
-            </a:pPr>
-            <a:r>
-              <a:rPr sz="1600" b="0">
+                <a:spcPts val="600"/>
+              </a:spcAft>
+            </a:pPr>
+            <a:r>
+              <a:rPr sz="1500" b="0">
                 <a:solidFill>
                   <a:srgbClr val="1A1A1A"/>
                 </a:solidFill>
                 <a:latin typeface="Golos Text"/>
                 <a:rFonts ascii="Golos Text" hAnsi="Golos Text" cs="Golos Text" eastAsia="Golos Text"/>
               </a:rPr>
-              <a:t>Реестр рисков — один лист</a:t>
-            </a:r>
-          </a:p>
-          <a:p>
-            <a:pPr algn="l">
-              <a:lnSpc>
-                <a:spcPct val="118000"/>
-              </a:lnSpc>
-              <a:spcBef>
-                <a:spcPts val="0"/>
-              </a:spcBef>
-              <a:spcAft>
-                <a:spcPts val="1200"/>
-              </a:spcAft>
-            </a:pPr>
-            <a:r>
-              <a:rPr sz="1400" b="0">
-                <a:solidFill>
-                  <a:srgbClr val="5C5C5C"/>
+              <a:t>Реестр рисков — один лист в пульте (14 пунктов).</a:t>
+            </a:r>
+          </a:p>
+          <a:p>
+            <a:pPr algn="l">
+              <a:lnSpc>
+                <a:spcPct val="118000"/>
+              </a:lnSpc>
+              <a:spcBef>
+                <a:spcPts val="0"/>
+              </a:spcBef>
+              <a:spcAft>
+                <a:spcPts val="1000"/>
+              </a:spcAft>
+            </a:pPr>
+            <a:r>
+              <a:rPr sz="1500" b="0">
+                <a:solidFill>
+                  <a:srgbClr val="1A1A1A"/>
                 </a:solidFill>
                 <a:latin typeface="Golos Text"/>
                 <a:rFonts ascii="Golos Text" hAnsi="Golos Text" cs="Golos Text" eastAsia="Golos Text"/>
               </a:rPr>
-              <a:t>(14 пунктов в пульте)</a:t>
+              <a:t>Сегмент не размываем: Natural не уходит в эконом-запрос.</a:t>
             </a:r>
           </a:p>
           <a:p>
@@ -11039,37 +11545,37 @@
               </a:spcAft>
             </a:pPr>
             <a:r>
-              <a:rPr sz="1600" b="0">
+              <a:rPr sz="1500" b="1">
                 <a:solidFill>
                   <a:srgbClr val="1A1A1A"/>
+                </a:solidFill>
+                <a:latin typeface="Manrope"/>
+                <a:rFonts ascii="Manrope" hAnsi="Manrope" cs="Manrope" eastAsia="Manrope"/>
+              </a:rPr>
+              <a:t>Не продаём Natural вместо Hotel Line по цене базовой линейки.</a:t>
+            </a:r>
+          </a:p>
+          <a:p>
+            <a:pPr algn="l">
+              <a:lnSpc>
+                <a:spcPct val="118000"/>
+              </a:lnSpc>
+              <a:spcBef>
+                <a:spcPts val="1800"/>
+              </a:spcBef>
+              <a:spcAft>
+                <a:spcPts val="0"/>
+              </a:spcAft>
+            </a:pPr>
+            <a:r>
+              <a:rPr sz="1200" b="0">
+                <a:solidFill>
+                  <a:srgbClr val="5C5C5C"/>
                 </a:solidFill>
                 <a:latin typeface="Golos Text"/>
                 <a:rFonts ascii="Golos Text" hAnsi="Golos Text" cs="Golos Text" eastAsia="Golos Text"/>
               </a:rPr>
-              <a:t>Сегмент не размываем.</a:t>
-            </a:r>
-          </a:p>
-          <a:p>
-            <a:pPr algn="l">
-              <a:lnSpc>
-                <a:spcPct val="118000"/>
-              </a:lnSpc>
-              <a:spcBef>
-                <a:spcPts val="0"/>
-              </a:spcBef>
-              <a:spcAft>
-                <a:spcPts val="800"/>
-              </a:spcAft>
-            </a:pPr>
-            <a:r>
-              <a:rPr sz="1600" b="1">
-                <a:solidFill>
-                  <a:srgbClr val="1A1A1A"/>
-                </a:solidFill>
-                <a:latin typeface="Manrope"/>
-                <a:rFonts ascii="Manrope" hAnsi="Manrope" cs="Manrope" eastAsia="Manrope"/>
-              </a:rPr>
-              <a:t>Не продаём Natural в эконом Hotel Line.</a:t>
+              <a:t>Цифры сценария — учебный пример, не отчёт завода.</a:t>
             </a:r>
           </a:p>
         </p:txBody>
@@ -11601,80 +12107,80 @@
                 <a:spcPts val="0"/>
               </a:spcBef>
               <a:spcAft>
-                <a:spcPts val="800"/>
-              </a:spcAft>
-            </a:pPr>
-            <a:r>
-              <a:rPr sz="1600" b="0">
+                <a:spcPts val="600"/>
+              </a:spcAft>
+            </a:pPr>
+            <a:r>
+              <a:rPr sz="1500" b="0">
                 <a:solidFill>
                   <a:srgbClr val="1A1A1A"/>
                 </a:solidFill>
                 <a:latin typeface="Golos Text"/>
                 <a:rFonts ascii="Golos Text" hAnsi="Golos Text" cs="Golos Text" eastAsia="Golos Text"/>
               </a:rPr>
-              <a:t>• 3 пилотных клиента</a:t>
-            </a:r>
-          </a:p>
-          <a:p>
-            <a:pPr algn="l">
-              <a:lnSpc>
-                <a:spcPct val="118000"/>
-              </a:lnSpc>
-              <a:spcBef>
-                <a:spcPts val="0"/>
-              </a:spcBef>
-              <a:spcAft>
-                <a:spcPts val="800"/>
-              </a:spcAft>
-            </a:pPr>
-            <a:r>
-              <a:rPr sz="1600" b="0">
+              <a:t>• Три пилотных клиента</a:t>
+            </a:r>
+          </a:p>
+          <a:p>
+            <a:pPr algn="l">
+              <a:lnSpc>
+                <a:spcPct val="118000"/>
+              </a:lnSpc>
+              <a:spcBef>
+                <a:spcPts val="0"/>
+              </a:spcBef>
+              <a:spcAft>
+                <a:spcPts val="600"/>
+              </a:spcAft>
+            </a:pPr>
+            <a:r>
+              <a:rPr sz="1500" b="0">
                 <a:solidFill>
                   <a:srgbClr val="1A1A1A"/>
                 </a:solidFill>
                 <a:latin typeface="Golos Text"/>
                 <a:rFonts ascii="Golos Text" hAnsi="Golos Text" cs="Golos Text" eastAsia="Golos Text"/>
               </a:rPr>
-              <a:t>• Повторный заказ у ≥ 2 из 3</a:t>
-            </a:r>
-          </a:p>
-          <a:p>
-            <a:pPr algn="l">
-              <a:lnSpc>
-                <a:spcPct val="118000"/>
-              </a:lnSpc>
-              <a:spcBef>
-                <a:spcPts val="0"/>
-              </a:spcBef>
-              <a:spcAft>
-                <a:spcPts val="1000"/>
-              </a:spcAft>
-            </a:pPr>
-            <a:r>
-              <a:rPr sz="1600" b="0">
+              <a:t>• Повторный заказ минимум у двух из трёх</a:t>
+            </a:r>
+          </a:p>
+          <a:p>
+            <a:pPr algn="l">
+              <a:lnSpc>
+                <a:spcPct val="118000"/>
+              </a:lnSpc>
+              <a:spcBef>
+                <a:spcPts val="0"/>
+              </a:spcBef>
+              <a:spcAft>
+                <a:spcPts val="600"/>
+              </a:spcAft>
+            </a:pPr>
+            <a:r>
+              <a:rPr sz="1500" b="0">
                 <a:solidFill>
                   <a:srgbClr val="1A1A1A"/>
                 </a:solidFill>
                 <a:latin typeface="Golos Text"/>
                 <a:rFonts ascii="Golos Text" hAnsi="Golos Text" cs="Golos Text" eastAsia="Golos Text"/>
               </a:rPr>
-              <a:t>• Мягкость и ощущение натуральности ≥ 70%</a:t>
-            </a:r>
-          </a:p>
-          <a:p>
-            <a:pPr algn="l">
-              <a:lnSpc>
-                <a:spcPct val="118000"/>
-              </a:lnSpc>
-              <a:spcBef>
-                <a:spcPts val="0"/>
-              </a:spcBef>
-              <a:spcAft>
-                <a:spcPts val="1400"/>
-              </a:spcAft>
-            </a:pPr>
-            <a:r>
-              <a:rPr sz="1600" b="1">
+              <a:t>• Мягкость и ощущение натуральности — не ниже 70% в опросе</a:t>
+            </a:r>
+          </a:p>
+          <a:p>
+            <a:pPr algn="l">
+              <a:lnSpc>
+                <a:spcPct val="118000"/>
+              </a:lnSpc>
+              <a:spcBef>
+                <a:spcPts val="0"/>
+              </a:spcBef>
+              <a:spcAft>
+                <a:spcPts val="800"/>
+              </a:spcAft>
+            </a:pPr>
+            <a:r>
+              <a:rPr sz="1500" b="1">
                 <a:solidFill>
                   <a:srgbClr val="1A1A1A"/>
                 </a:solidFill>
@@ -11690,21 +12196,65 @@
                 <a:spcPct val="118000"/>
               </a:lnSpc>
               <a:spcBef>
-                <a:spcPts val="0"/>
-              </a:spcBef>
-              <a:spcAft>
-                <a:spcPts val="600"/>
-              </a:spcAft>
-            </a:pPr>
-            <a:r>
-              <a:rPr sz="1400" b="0">
+                <a:spcPts val="1800"/>
+              </a:spcBef>
+              <a:spcAft>
+                <a:spcPts val="0"/>
+              </a:spcAft>
+            </a:pPr>
+            <a:r>
+              <a:rPr sz="1200" b="0">
                 <a:solidFill>
                   <a:srgbClr val="5C5C5C"/>
                 </a:solidFill>
                 <a:latin typeface="Golos Text"/>
                 <a:rFonts ascii="Golos Text" hAnsi="Golos Text" cs="Golos Text" eastAsia="Golos Text"/>
               </a:rPr>
-              <a:t>Цифры сценария — учебный пример,</a:t>
+              <a:t>Цифры сценария — учебный пример, не отчёт завода.</a:t>
+            </a:r>
+          </a:p>
+        </p:txBody>
+      </p:sp>
+      <p:sp>
+        <p:nvSpPr>
+          <p:cNvPr id="14" name="TextBox 13"/>
+          <p:cNvSpPr txBox="1"/>
+          <p:nvPr/>
+        </p:nvSpPr>
+        <p:spPr>
+          <a:xfrm>
+            <a:off x="6571335" y="1426464"/>
+            <a:ext cx="4815687" cy="4334256"/>
+          </a:xfrm>
+          <a:prstGeom prst="rect">
+            <a:avLst/>
+          </a:prstGeom>
+          <a:noFill/>
+        </p:spPr>
+        <p:txBody>
+          <a:bodyPr wrap="square" anchor="t" lIns="50800" rIns="50800" tIns="25400" bIns="25400"/>
+          <a:lstStyle/>
+          <a:p>
+            <a:pPr algn="l">
+              <a:lnSpc>
+                <a:spcPct val="118000"/>
+              </a:lnSpc>
+              <a:spcBef>
+                <a:spcPts val="0"/>
+              </a:spcBef>
+              <a:spcAft>
+                <a:spcPts val="1200"/>
+              </a:spcAft>
+            </a:pPr>
+            <a:r>
+              <a:rPr sz="1500" b="1">
+                <a:solidFill>
+                  <a:srgbClr val="2A554A"/>
+                </a:solidFill>
+                <a:latin typeface="Manrope"/>
+                <a:rFonts ascii="Manrope" hAnsi="Manrope" cs="Manrope" eastAsia="Manrope"/>
+              </a:rPr>
+              <a:t>Провал и выход</a:t>
             </a:r>
           </a:p>
           <a:p>
@@ -11720,173 +12270,129 @@
               </a:spcAft>
             </a:pPr>
             <a:r>
-              <a:rPr sz="1400" b="0">
-                <a:solidFill>
-                  <a:srgbClr val="5C5C5C"/>
+              <a:rPr sz="1500" b="0">
+                <a:solidFill>
+                  <a:srgbClr val="1A1A1A"/>
                 </a:solidFill>
                 <a:latin typeface="Golos Text"/>
                 <a:rFonts ascii="Golos Text" hAnsi="Golos Text" cs="Golos Text" eastAsia="Golos Text"/>
               </a:rPr>
-              <a:t>не отчёт завода.</a:t>
-            </a:r>
-          </a:p>
-        </p:txBody>
-      </p:sp>
-      <p:sp>
-        <p:nvSpPr>
-          <p:cNvPr id="14" name="TextBox 13"/>
-          <p:cNvSpPr txBox="1"/>
-          <p:nvPr/>
-        </p:nvSpPr>
-        <p:spPr>
-          <a:xfrm>
-            <a:off x="6571335" y="1426464"/>
-            <a:ext cx="4815687" cy="4334256"/>
-          </a:xfrm>
-          <a:prstGeom prst="rect">
-            <a:avLst/>
-          </a:prstGeom>
-          <a:noFill/>
-        </p:spPr>
-        <p:txBody>
-          <a:bodyPr wrap="square" anchor="t" lIns="50800" rIns="50800" tIns="25400" bIns="25400"/>
-          <a:lstStyle/>
-          <a:p>
-            <a:pPr algn="l">
-              <a:lnSpc>
-                <a:spcPct val="118000"/>
-              </a:lnSpc>
-              <a:spcBef>
-                <a:spcPts val="0"/>
-              </a:spcBef>
-              <a:spcAft>
-                <a:spcPts val="1200"/>
+              <a:t>Повторный заказ меньше чем у двух из трёх — или метрики ниже 60%.</a:t>
+            </a:r>
+          </a:p>
+          <a:p>
+            <a:pPr algn="l">
+              <a:lnSpc>
+                <a:spcPct val="118000"/>
+              </a:lnSpc>
+              <a:spcBef>
+                <a:spcPts val="0"/>
+              </a:spcBef>
+              <a:spcAft>
+                <a:spcPts val="800"/>
               </a:spcAft>
             </a:pPr>
             <a:r>
               <a:rPr sz="1500" b="1">
                 <a:solidFill>
-                  <a:srgbClr val="2A554A"/>
+                  <a:srgbClr val="1A1A1A"/>
                 </a:solidFill>
                 <a:latin typeface="Manrope"/>
                 <a:rFonts ascii="Manrope" hAnsi="Manrope" cs="Manrope" eastAsia="Manrope"/>
               </a:rPr>
-              <a:t>Провал и выход</a:t>
-            </a:r>
-          </a:p>
-          <a:p>
-            <a:pPr algn="l">
-              <a:lnSpc>
-                <a:spcPct val="118000"/>
-              </a:lnSpc>
-              <a:spcBef>
-                <a:spcPts val="0"/>
-              </a:spcBef>
-              <a:spcAft>
-                <a:spcPts val="800"/>
-              </a:spcAft>
-            </a:pPr>
-            <a:r>
-              <a:rPr sz="1600" b="0">
+              <a:t>→ Останавливаем масштабирование</a:t>
+            </a:r>
+          </a:p>
+          <a:p>
+            <a:pPr algn="l">
+              <a:lnSpc>
+                <a:spcPct val="118000"/>
+              </a:lnSpc>
+              <a:spcBef>
+                <a:spcPts val="0"/>
+              </a:spcBef>
+              <a:spcAft>
+                <a:spcPts val="600"/>
+              </a:spcAft>
+            </a:pPr>
+            <a:r>
+              <a:rPr sz="1500" b="0">
                 <a:solidFill>
                   <a:srgbClr val="1A1A1A"/>
                 </a:solidFill>
                 <a:latin typeface="Golos Text"/>
                 <a:rFonts ascii="Golos Text" hAnsi="Golos Text" cs="Golos Text" eastAsia="Golos Text"/>
               </a:rPr>
-              <a:t>Повтор &lt; 2 из 3 или метрики &lt; 60%</a:t>
-            </a:r>
-          </a:p>
-          <a:p>
-            <a:pPr algn="l">
-              <a:lnSpc>
-                <a:spcPct val="118000"/>
-              </a:lnSpc>
-              <a:spcBef>
-                <a:spcPts val="0"/>
-              </a:spcBef>
-              <a:spcAft>
-                <a:spcPts val="1200"/>
-              </a:spcAft>
-            </a:pPr>
-            <a:r>
-              <a:rPr sz="1600" b="1">
+              <a:t>Диагноз бренд-менеджера — в течение двух недель.</a:t>
+            </a:r>
+          </a:p>
+          <a:p>
+            <a:pPr algn="l">
+              <a:lnSpc>
+                <a:spcPct val="118000"/>
+              </a:lnSpc>
+              <a:spcBef>
+                <a:spcPts val="0"/>
+              </a:spcBef>
+              <a:spcAft>
+                <a:spcPts val="600"/>
+              </a:spcAft>
+            </a:pPr>
+            <a:r>
+              <a:rPr sz="1500" b="0">
+                <a:solidFill>
+                  <a:srgbClr val="1A1A1A"/>
+                </a:solidFill>
+                <a:latin typeface="Golos Text"/>
+                <a:rFonts ascii="Golos Text" hAnsi="Golos Text" cs="Golos Text" eastAsia="Golos Text"/>
+              </a:rPr>
+              <a:t>Второй пилотный круг снова провален.</a:t>
+            </a:r>
+          </a:p>
+          <a:p>
+            <a:pPr algn="l">
+              <a:lnSpc>
+                <a:spcPct val="118000"/>
+              </a:lnSpc>
+              <a:spcBef>
+                <a:spcPts val="0"/>
+              </a:spcBef>
+              <a:spcAft>
+                <a:spcPts val="800"/>
+              </a:spcAft>
+            </a:pPr>
+            <a:r>
+              <a:rPr sz="1500" b="1">
                 <a:solidFill>
                   <a:srgbClr val="1A1A1A"/>
                 </a:solidFill>
                 <a:latin typeface="Manrope"/>
                 <a:rFonts ascii="Manrope" hAnsi="Manrope" cs="Manrope" eastAsia="Manrope"/>
               </a:rPr>
-              <a:t>→ Останавливаем масштаб</a:t>
-            </a:r>
-          </a:p>
-          <a:p>
-            <a:pPr algn="l">
-              <a:lnSpc>
-                <a:spcPct val="118000"/>
-              </a:lnSpc>
-              <a:spcBef>
-                <a:spcPts val="0"/>
-              </a:spcBef>
-              <a:spcAft>
-                <a:spcPts val="800"/>
-              </a:spcAft>
-            </a:pPr>
-            <a:r>
-              <a:rPr sz="1600" b="0">
-                <a:solidFill>
-                  <a:srgbClr val="1A1A1A"/>
+              <a:t>→ Закрываем линейку</a:t>
+            </a:r>
+          </a:p>
+          <a:p>
+            <a:pPr algn="l">
+              <a:lnSpc>
+                <a:spcPct val="118000"/>
+              </a:lnSpc>
+              <a:spcBef>
+                <a:spcPts val="1800"/>
+              </a:spcBef>
+              <a:spcAft>
+                <a:spcPts val="0"/>
+              </a:spcAft>
+            </a:pPr>
+            <a:r>
+              <a:rPr sz="1200" b="0">
+                <a:solidFill>
+                  <a:srgbClr val="5C5C5C"/>
                 </a:solidFill>
                 <a:latin typeface="Golos Text"/>
                 <a:rFonts ascii="Golos Text" hAnsi="Golos Text" cs="Golos Text" eastAsia="Golos Text"/>
               </a:rPr>
-              <a:t>Диагноз бренд-менеджера за 2 недели</a:t>
-            </a:r>
-          </a:p>
-          <a:p>
-            <a:pPr algn="l">
-              <a:lnSpc>
-                <a:spcPct val="118000"/>
-              </a:lnSpc>
-              <a:spcBef>
-                <a:spcPts val="0"/>
-              </a:spcBef>
-              <a:spcAft>
-                <a:spcPts val="800"/>
-              </a:spcAft>
-            </a:pPr>
-            <a:r>
-              <a:rPr sz="1600" b="0">
-                <a:solidFill>
-                  <a:srgbClr val="1A1A1A"/>
-                </a:solidFill>
-                <a:latin typeface="Golos Text"/>
-                <a:rFonts ascii="Golos Text" hAnsi="Golos Text" cs="Golos Text" eastAsia="Golos Text"/>
-              </a:rPr>
-              <a:t>Второй круг снова провален</a:t>
-            </a:r>
-          </a:p>
-          <a:p>
-            <a:pPr algn="l">
-              <a:lnSpc>
-                <a:spcPct val="118000"/>
-              </a:lnSpc>
-              <a:spcBef>
-                <a:spcPts val="0"/>
-              </a:spcBef>
-              <a:spcAft>
-                <a:spcPts val="800"/>
-              </a:spcAft>
-            </a:pPr>
-            <a:r>
-              <a:rPr sz="1600" b="1">
-                <a:solidFill>
-                  <a:srgbClr val="1A1A1A"/>
-                </a:solidFill>
-                <a:latin typeface="Manrope"/>
-                <a:rFonts ascii="Manrope" hAnsi="Manrope" cs="Manrope" eastAsia="Manrope"/>
-              </a:rPr>
-              <a:t>→ Закрываем линейку</a:t>
+              <a:t>Пороги — для учебного сценария в пульте, не KPI завода.</a:t>
             </a:r>
           </a:p>
         </p:txBody>

</xml_diff>

<commit_message>
fix(presentation): footer Natural пример, убрать IT-roadmap со слайда 2
Co-authored-by: pagasbot-coder <pagasbot-coder@users.noreply.github.com>
</commit_message>
<xml_diff>
--- a/knowledge-base/presentation-travelplus-interview.pptx
+++ b/knowledge-base/presentation-travelplus-interview.pptx
@@ -3709,7 +3709,7 @@
                 <a:latin typeface="Golos Text"/>
                 <a:rFonts ascii="Golos Text" hAnsi="Golos Text" cs="Golos Text" eastAsia="Golos Text"/>
               </a:rPr>
-              <a:t>Travel+ Natural  ·  образец презентации</a:t>
+              <a:t>Natural · пример презентации</a:t>
             </a:r>
           </a:p>
         </p:txBody>
@@ -4572,7 +4572,7 @@
                 <a:latin typeface="Golos Text"/>
                 <a:rFonts ascii="Golos Text" hAnsi="Golos Text" cs="Golos Text" eastAsia="Golos Text"/>
               </a:rPr>
-              <a:t>Travel+ Natural  ·  образец презентации</a:t>
+              <a:t>Natural · пример презентации</a:t>
             </a:r>
           </a:p>
         </p:txBody>
@@ -5389,7 +5389,7 @@
                 <a:latin typeface="Golos Text"/>
                 <a:rFonts ascii="Golos Text" hAnsi="Golos Text" cs="Golos Text" eastAsia="Golos Text"/>
               </a:rPr>
-              <a:t>Travel+ Natural  ·  образец презентации</a:t>
+              <a:t>Natural · пример презентации</a:t>
             </a:r>
           </a:p>
         </p:txBody>
@@ -6137,7 +6137,7 @@
                 <a:latin typeface="Golos Text"/>
                 <a:rFonts ascii="Golos Text" hAnsi="Golos Text" cs="Golos Text" eastAsia="Golos Text"/>
               </a:rPr>
-              <a:t>Travel+ Natural  ·  образец презентации</a:t>
+              <a:t>Natural · пример презентации</a:t>
             </a:r>
           </a:p>
         </p:txBody>
@@ -6490,29 +6490,6 @@
                 <a:rFonts ascii="Golos Text" hAnsi="Golos Text" cs="Golos Text" eastAsia="Golos Text"/>
               </a:rPr>
               <a:t>• Наборы</a:t>
-            </a:r>
-          </a:p>
-          <a:p>
-            <a:pPr algn="l">
-              <a:lnSpc>
-                <a:spcPct val="118000"/>
-              </a:lnSpc>
-              <a:spcBef>
-                <a:spcPts val="0"/>
-              </a:spcBef>
-              <a:spcAft>
-                <a:spcPts val="800"/>
-              </a:spcAft>
-            </a:pPr>
-            <a:r>
-              <a:rPr sz="1600" b="1">
-                <a:solidFill>
-                  <a:srgbClr val="1A1A1A"/>
-                </a:solidFill>
-                <a:latin typeface="Manrope"/>
-                <a:rFonts ascii="Manrope" hAnsi="Manrope" cs="Manrope" eastAsia="Manrope"/>
-              </a:rPr>
-              <a:t>Не IT-roadmap.</a:t>
             </a:r>
           </a:p>
           <a:p>
@@ -6931,7 +6908,7 @@
                 <a:latin typeface="Golos Text"/>
                 <a:rFonts ascii="Golos Text" hAnsi="Golos Text" cs="Golos Text" eastAsia="Golos Text"/>
               </a:rPr>
-              <a:t>Travel+ Natural  ·  образец презентации</a:t>
+              <a:t>Natural · пример презентации</a:t>
             </a:r>
           </a:p>
         </p:txBody>
@@ -7702,7 +7679,7 @@
                 <a:latin typeface="Golos Text"/>
                 <a:rFonts ascii="Golos Text" hAnsi="Golos Text" cs="Golos Text" eastAsia="Golos Text"/>
               </a:rPr>
-              <a:t>Travel+ Natural  ·  образец презентации</a:t>
+              <a:t>Natural · пример презентации</a:t>
             </a:r>
           </a:p>
         </p:txBody>
@@ -8473,7 +8450,7 @@
                 <a:latin typeface="Golos Text"/>
                 <a:rFonts ascii="Golos Text" hAnsi="Golos Text" cs="Golos Text" eastAsia="Golos Text"/>
               </a:rPr>
-              <a:t>Travel+ Natural  ·  образец презентации</a:t>
+              <a:t>Natural · пример презентации</a:t>
             </a:r>
           </a:p>
         </p:txBody>
@@ -9474,7 +9451,7 @@
                 <a:latin typeface="Golos Text"/>
                 <a:rFonts ascii="Golos Text" hAnsi="Golos Text" cs="Golos Text" eastAsia="Golos Text"/>
               </a:rPr>
-              <a:t>Travel+ Natural  ·  образец презентации</a:t>
+              <a:t>Natural · пример презентации</a:t>
             </a:r>
           </a:p>
         </p:txBody>
@@ -10314,7 +10291,7 @@
                 <a:latin typeface="Golos Text"/>
                 <a:rFonts ascii="Golos Text" hAnsi="Golos Text" cs="Golos Text" eastAsia="Golos Text"/>
               </a:rPr>
-              <a:t>Travel+ Natural  ·  образец презентации</a:t>
+              <a:t>Natural · пример презентации</a:t>
             </a:r>
           </a:p>
         </p:txBody>
@@ -10995,7 +10972,7 @@
                 <a:latin typeface="Golos Text"/>
                 <a:rFonts ascii="Golos Text" hAnsi="Golos Text" cs="Golos Text" eastAsia="Golos Text"/>
               </a:rPr>
-              <a:t>Travel+ Natural  ·  образец презентации</a:t>
+              <a:t>Natural · пример презентации</a:t>
             </a:r>
           </a:p>
         </p:txBody>
@@ -11835,7 +11812,7 @@
                 <a:latin typeface="Golos Text"/>
                 <a:rFonts ascii="Golos Text" hAnsi="Golos Text" cs="Golos Text" eastAsia="Golos Text"/>
               </a:rPr>
-              <a:t>Travel+ Natural  ·  образец презентации</a:t>
+              <a:t>Natural · пример презентации</a:t>
             </a:r>
           </a:p>
         </p:txBody>

</xml_diff>

<commit_message>
content(presentation): slide 2 variant B with labeled theses
Co-authored-by: pagasbot-coder <pagasbot-coder@users.noreply.github.com>
</commit_message>
<xml_diff>
--- a/knowledge-base/presentation-travelplus-interview.pptx
+++ b/knowledge-base/presentation-travelplus-interview.pptx
@@ -6409,246 +6409,315 @@
                 <a:spcPts val="0"/>
               </a:spcBef>
               <a:spcAft>
-                <a:spcPts val="800"/>
-              </a:spcAft>
-            </a:pPr>
-            <a:r>
-              <a:rPr sz="1600" b="0">
+                <a:spcPts val="200"/>
+              </a:spcAft>
+            </a:pPr>
+            <a:r>
+              <a:rPr sz="1500" b="1">
+                <a:solidFill>
+                  <a:srgbClr val="1A1A1A"/>
+                </a:solidFill>
+                <a:latin typeface="Manrope"/>
+                <a:rFonts ascii="Manrope" hAnsi="Manrope" cs="Manrope" eastAsia="Manrope"/>
+              </a:rPr>
+              <a:t>Поставка на номер</a:t>
+            </a:r>
+          </a:p>
+          <a:p>
+            <a:pPr algn="l">
+              <a:lnSpc>
+                <a:spcPct val="118000"/>
+              </a:lnSpc>
+              <a:spcBef>
+                <a:spcPts val="0"/>
+              </a:spcBef>
+              <a:spcAft>
+                <a:spcPts val="1000"/>
+              </a:spcAft>
+            </a:pPr>
+            <a:r>
+              <a:rPr sz="1500" b="0">
                 <a:solidFill>
                   <a:srgbClr val="1A1A1A"/>
                 </a:solidFill>
                 <a:latin typeface="Golos Text"/>
                 <a:rFonts ascii="Golos Text" hAnsi="Golos Text" cs="Golos Text" eastAsia="Golos Text"/>
               </a:rPr>
-              <a:t>Производство и one-stop на номер:</a:t>
-            </a:r>
-          </a:p>
-          <a:p>
-            <a:pPr algn="l">
-              <a:lnSpc>
-                <a:spcPct val="118000"/>
-              </a:lnSpc>
-              <a:spcBef>
-                <a:spcPts val="0"/>
-              </a:spcBef>
-              <a:spcAft>
-                <a:spcPts val="800"/>
-              </a:spcAft>
-            </a:pPr>
-            <a:r>
-              <a:rPr sz="1600" b="0">
+              <a:t>One-stop: косметика, тапочки, наборы</a:t>
+            </a:r>
+          </a:p>
+          <a:p>
+            <a:pPr algn="l">
+              <a:lnSpc>
+                <a:spcPct val="118000"/>
+              </a:lnSpc>
+              <a:spcBef>
+                <a:spcPts val="0"/>
+              </a:spcBef>
+              <a:spcAft>
+                <a:spcPts val="200"/>
+              </a:spcAft>
+            </a:pPr>
+            <a:r>
+              <a:rPr sz="1500" b="1">
+                <a:solidFill>
+                  <a:srgbClr val="1A1A1A"/>
+                </a:solidFill>
+                <a:latin typeface="Manrope"/>
+                <a:rFonts ascii="Manrope" hAnsi="Manrope" cs="Manrope" eastAsia="Manrope"/>
+              </a:rPr>
+              <a:t>Контур производства</a:t>
+            </a:r>
+          </a:p>
+          <a:p>
+            <a:pPr algn="l">
+              <a:lnSpc>
+                <a:spcPct val="118000"/>
+              </a:lnSpc>
+              <a:spcBef>
+                <a:spcPts val="0"/>
+              </a:spcBef>
+              <a:spcAft>
+                <a:spcPts val="1000"/>
+              </a:spcAft>
+            </a:pPr>
+            <a:r>
+              <a:rPr sz="1500" b="0">
                 <a:solidFill>
                   <a:srgbClr val="1A1A1A"/>
                 </a:solidFill>
                 <a:latin typeface="Golos Text"/>
                 <a:rFonts ascii="Golos Text" hAnsi="Golos Text" cs="Golos Text" eastAsia="Golos Text"/>
               </a:rPr>
-              <a:t>• Косметика</a:t>
-            </a:r>
-          </a:p>
-          <a:p>
-            <a:pPr algn="l">
-              <a:lnSpc>
-                <a:spcPct val="118000"/>
-              </a:lnSpc>
-              <a:spcBef>
-                <a:spcPts val="0"/>
-              </a:spcBef>
-              <a:spcAft>
-                <a:spcPts val="800"/>
-              </a:spcAft>
-            </a:pPr>
-            <a:r>
-              <a:rPr sz="1600" b="0">
+              <a:t>Своё производство и сборка; закупки и производство в Китае</a:t>
+            </a:r>
+          </a:p>
+          <a:p>
+            <a:pPr algn="l">
+              <a:lnSpc>
+                <a:spcPct val="118000"/>
+              </a:lnSpc>
+              <a:spcBef>
+                <a:spcPts val="0"/>
+              </a:spcBef>
+              <a:spcAft>
+                <a:spcPts val="200"/>
+              </a:spcAft>
+            </a:pPr>
+            <a:r>
+              <a:rPr sz="1500" b="1">
+                <a:solidFill>
+                  <a:srgbClr val="1A1A1A"/>
+                </a:solidFill>
+                <a:latin typeface="Manrope"/>
+                <a:rFonts ascii="Manrope" hAnsi="Manrope" cs="Manrope" eastAsia="Manrope"/>
+              </a:rPr>
+              <a:t>Фокус роли</a:t>
+            </a:r>
+          </a:p>
+          <a:p>
+            <a:pPr algn="l">
+              <a:lnSpc>
+                <a:spcPct val="118000"/>
+              </a:lnSpc>
+              <a:spcBef>
+                <a:spcPts val="0"/>
+              </a:spcBef>
+              <a:spcAft>
+                <a:spcPts val="0"/>
+              </a:spcAft>
+            </a:pPr>
+            <a:r>
+              <a:rPr sz="1500" b="0">
                 <a:solidFill>
                   <a:srgbClr val="1A1A1A"/>
                 </a:solidFill>
                 <a:latin typeface="Golos Text"/>
                 <a:rFonts ascii="Golos Text" hAnsi="Golos Text" cs="Golos Text" eastAsia="Golos Text"/>
               </a:rPr>
-              <a:t>• Тапочки</a:t>
-            </a:r>
-          </a:p>
-          <a:p>
-            <a:pPr algn="l">
-              <a:lnSpc>
-                <a:spcPct val="118000"/>
-              </a:lnSpc>
-              <a:spcBef>
-                <a:spcPts val="0"/>
-              </a:spcBef>
-              <a:spcAft>
-                <a:spcPts val="1400"/>
-              </a:spcAft>
-            </a:pPr>
-            <a:r>
-              <a:rPr sz="1600" b="0">
+              <a:t>Товар от идеи до полки и маржи.</a:t>
+            </a:r>
+          </a:p>
+        </p:txBody>
+      </p:sp>
+      <p:sp>
+        <p:nvSpPr>
+          <p:cNvPr id="14" name="TextBox 13"/>
+          <p:cNvSpPr txBox="1"/>
+          <p:nvPr/>
+        </p:nvSpPr>
+        <p:spPr>
+          <a:xfrm>
+            <a:off x="6571335" y="1426464"/>
+            <a:ext cx="4815687" cy="4334256"/>
+          </a:xfrm>
+          <a:prstGeom prst="rect">
+            <a:avLst/>
+          </a:prstGeom>
+          <a:noFill/>
+        </p:spPr>
+        <p:txBody>
+          <a:bodyPr wrap="square" anchor="t" lIns="50800" rIns="50800" tIns="25400" bIns="25400"/>
+          <a:lstStyle/>
+          <a:p>
+            <a:pPr algn="l">
+              <a:lnSpc>
+                <a:spcPct val="118000"/>
+              </a:lnSpc>
+              <a:spcBef>
+                <a:spcPts val="0"/>
+              </a:spcBef>
+              <a:spcAft>
+                <a:spcPts val="1200"/>
+              </a:spcAft>
+            </a:pPr>
+            <a:r>
+              <a:rPr sz="1500" b="1">
+                <a:solidFill>
+                  <a:srgbClr val="2A554A"/>
+                </a:solidFill>
+                <a:latin typeface="Manrope"/>
+                <a:rFonts ascii="Manrope" hAnsi="Manrope" cs="Manrope" eastAsia="Manrope"/>
+              </a:rPr>
+              <a:t>Роль здесь</a:t>
+            </a:r>
+          </a:p>
+          <a:p>
+            <a:pPr algn="l">
+              <a:lnSpc>
+                <a:spcPct val="118000"/>
+              </a:lnSpc>
+              <a:spcBef>
+                <a:spcPts val="0"/>
+              </a:spcBef>
+              <a:spcAft>
+                <a:spcPts val="200"/>
+              </a:spcAft>
+            </a:pPr>
+            <a:r>
+              <a:rPr sz="1500" b="1">
+                <a:solidFill>
+                  <a:srgbClr val="1A1A1A"/>
+                </a:solidFill>
+                <a:latin typeface="Manrope"/>
+                <a:rFonts ascii="Manrope" hAnsi="Manrope" cs="Manrope" eastAsia="Manrope"/>
+              </a:rPr>
+              <a:t>Ассортимент</a:t>
+            </a:r>
+          </a:p>
+          <a:p>
+            <a:pPr algn="l">
+              <a:lnSpc>
+                <a:spcPct val="118000"/>
+              </a:lnSpc>
+              <a:spcBef>
+                <a:spcPts val="0"/>
+              </a:spcBef>
+              <a:spcAft>
+                <a:spcPts val="1000"/>
+              </a:spcAft>
+            </a:pPr>
+            <a:r>
+              <a:rPr sz="1500" b="0">
                 <a:solidFill>
                   <a:srgbClr val="1A1A1A"/>
                 </a:solidFill>
                 <a:latin typeface="Golos Text"/>
                 <a:rFonts ascii="Golos Text" hAnsi="Golos Text" cs="Golos Text" eastAsia="Golos Text"/>
               </a:rPr>
-              <a:t>• Наборы</a:t>
-            </a:r>
-          </a:p>
-          <a:p>
-            <a:pPr algn="l">
-              <a:lnSpc>
-                <a:spcPct val="118000"/>
-              </a:lnSpc>
-              <a:spcBef>
-                <a:spcPts val="0"/>
-              </a:spcBef>
-              <a:spcAft>
-                <a:spcPts val="800"/>
-              </a:spcAft>
-            </a:pPr>
-            <a:r>
-              <a:rPr sz="1600" b="0">
+              <a:t>Новинки и позиция в доме брендов</a:t>
+            </a:r>
+          </a:p>
+          <a:p>
+            <a:pPr algn="l">
+              <a:lnSpc>
+                <a:spcPct val="118000"/>
+              </a:lnSpc>
+              <a:spcBef>
+                <a:spcPts val="0"/>
+              </a:spcBef>
+              <a:spcAft>
+                <a:spcPts val="200"/>
+              </a:spcAft>
+            </a:pPr>
+            <a:r>
+              <a:rPr sz="1500" b="1">
+                <a:solidFill>
+                  <a:srgbClr val="1A1A1A"/>
+                </a:solidFill>
+                <a:latin typeface="Manrope"/>
+                <a:rFonts ascii="Manrope" hAnsi="Manrope" cs="Manrope" eastAsia="Manrope"/>
+              </a:rPr>
+              <a:t>Продукт</a:t>
+            </a:r>
+          </a:p>
+          <a:p>
+            <a:pPr algn="l">
+              <a:lnSpc>
+                <a:spcPct val="118000"/>
+              </a:lnSpc>
+              <a:spcBef>
+                <a:spcPts val="0"/>
+              </a:spcBef>
+              <a:spcAft>
+                <a:spcPts val="1000"/>
+              </a:spcAft>
+            </a:pPr>
+            <a:r>
+              <a:rPr sz="1500" b="0">
                 <a:solidFill>
                   <a:srgbClr val="1A1A1A"/>
                 </a:solidFill>
                 <a:latin typeface="Golos Text"/>
                 <a:rFonts ascii="Golos Text" hAnsi="Golos Text" cs="Golos Text" eastAsia="Golos Text"/>
               </a:rPr>
-              <a:t>Товар от идеи до полки и маржи.</a:t>
-            </a:r>
-          </a:p>
-        </p:txBody>
-      </p:sp>
-      <p:sp>
-        <p:nvSpPr>
-          <p:cNvPr id="14" name="TextBox 13"/>
-          <p:cNvSpPr txBox="1"/>
-          <p:nvPr/>
-        </p:nvSpPr>
-        <p:spPr>
-          <a:xfrm>
-            <a:off x="6571335" y="1426464"/>
-            <a:ext cx="4815687" cy="4334256"/>
-          </a:xfrm>
-          <a:prstGeom prst="rect">
-            <a:avLst/>
-          </a:prstGeom>
-          <a:noFill/>
-        </p:spPr>
-        <p:txBody>
-          <a:bodyPr wrap="square" anchor="t" lIns="50800" rIns="50800" tIns="25400" bIns="25400"/>
-          <a:lstStyle/>
-          <a:p>
-            <a:pPr algn="l">
-              <a:lnSpc>
-                <a:spcPct val="118000"/>
-              </a:lnSpc>
-              <a:spcBef>
-                <a:spcPts val="0"/>
-              </a:spcBef>
-              <a:spcAft>
-                <a:spcPts val="1200"/>
+              <a:t>Доказательства до выхода на витрину</a:t>
+            </a:r>
+          </a:p>
+          <a:p>
+            <a:pPr algn="l">
+              <a:lnSpc>
+                <a:spcPct val="118000"/>
+              </a:lnSpc>
+              <a:spcBef>
+                <a:spcPts val="0"/>
+              </a:spcBef>
+              <a:spcAft>
+                <a:spcPts val="200"/>
               </a:spcAft>
             </a:pPr>
             <a:r>
               <a:rPr sz="1500" b="1">
                 <a:solidFill>
-                  <a:srgbClr val="2A554A"/>
+                  <a:srgbClr val="1A1A1A"/>
                 </a:solidFill>
                 <a:latin typeface="Manrope"/>
                 <a:rFonts ascii="Manrope" hAnsi="Manrope" cs="Manrope" eastAsia="Manrope"/>
               </a:rPr>
-              <a:t>Роль здесь</a:t>
-            </a:r>
-          </a:p>
-          <a:p>
-            <a:pPr algn="l">
-              <a:lnSpc>
-                <a:spcPct val="118000"/>
-              </a:lnSpc>
-              <a:spcBef>
-                <a:spcPts val="0"/>
-              </a:spcBef>
-              <a:spcAft>
-                <a:spcPts val="800"/>
-              </a:spcAft>
-            </a:pPr>
-            <a:r>
-              <a:rPr sz="1600" b="0">
+              <a:t>Связка</a:t>
+            </a:r>
+          </a:p>
+          <a:p>
+            <a:pPr algn="l">
+              <a:lnSpc>
+                <a:spcPct val="118000"/>
+              </a:lnSpc>
+              <a:spcBef>
+                <a:spcPts val="0"/>
+              </a:spcBef>
+              <a:spcAft>
+                <a:spcPts val="0"/>
+              </a:spcAft>
+            </a:pPr>
+            <a:r>
+              <a:rPr sz="1500" b="0">
                 <a:solidFill>
                   <a:srgbClr val="1A1A1A"/>
                 </a:solidFill>
                 <a:latin typeface="Golos Text"/>
                 <a:rFonts ascii="Golos Text" hAnsi="Golos Text" cs="Golos Text" eastAsia="Golos Text"/>
               </a:rPr>
-              <a:t>• Ассортимент и новинки</a:t>
-            </a:r>
-          </a:p>
-          <a:p>
-            <a:pPr algn="l">
-              <a:lnSpc>
-                <a:spcPct val="118000"/>
-              </a:lnSpc>
-              <a:spcBef>
-                <a:spcPts val="0"/>
-              </a:spcBef>
-              <a:spcAft>
-                <a:spcPts val="800"/>
-              </a:spcAft>
-            </a:pPr>
-            <a:r>
-              <a:rPr sz="1600" b="0">
-                <a:solidFill>
-                  <a:srgbClr val="1A1A1A"/>
-                </a:solidFill>
-                <a:latin typeface="Golos Text"/>
-                <a:rFonts ascii="Golos Text" hAnsi="Golos Text" cs="Golos Text" eastAsia="Golos Text"/>
-              </a:rPr>
-              <a:t>• Позиция линейки в доме брендов</a:t>
-            </a:r>
-          </a:p>
-          <a:p>
-            <a:pPr algn="l">
-              <a:lnSpc>
-                <a:spcPct val="118000"/>
-              </a:lnSpc>
-              <a:spcBef>
-                <a:spcPts val="0"/>
-              </a:spcBef>
-              <a:spcAft>
-                <a:spcPts val="800"/>
-              </a:spcAft>
-            </a:pPr>
-            <a:r>
-              <a:rPr sz="1600" b="0">
-                <a:solidFill>
-                  <a:srgbClr val="1A1A1A"/>
-                </a:solidFill>
-                <a:latin typeface="Golos Text"/>
-                <a:rFonts ascii="Golos Text" hAnsi="Golos Text" cs="Golos Text" eastAsia="Golos Text"/>
-              </a:rPr>
-              <a:t>• Продукт и доказательства до витрины</a:t>
-            </a:r>
-          </a:p>
-          <a:p>
-            <a:pPr algn="l">
-              <a:lnSpc>
-                <a:spcPct val="118000"/>
-              </a:lnSpc>
-              <a:spcBef>
-                <a:spcPts val="0"/>
-              </a:spcBef>
-              <a:spcAft>
-                <a:spcPts val="800"/>
-              </a:spcAft>
-            </a:pPr>
-            <a:r>
-              <a:rPr sz="1600" b="0">
-                <a:solidFill>
-                  <a:srgbClr val="1A1A1A"/>
-                </a:solidFill>
-                <a:latin typeface="Golos Text"/>
-                <a:rFonts ascii="Golos Text" hAnsi="Golos Text" cs="Golos Text" eastAsia="Golos Text"/>
-              </a:rPr>
-              <a:t>• Связка: технолог → продажи → экономика → поставка</a:t>
+              <a:t>Технолог → продажи → экономика → поставка</a:t>
             </a:r>
           </a:p>
         </p:txBody>

</xml_diff>

<commit_message>
content(presentation): slide 4 portfolio with labeled theses
Co-authored-by: pagasbot-coder <pagasbot-coder@users.noreply.github.com>
</commit_message>
<xml_diff>
--- a/knowledge-base/presentation-travelplus-interview.pptx
+++ b/knowledge-base/presentation-travelplus-interview.pptx
@@ -7249,7 +7249,30 @@
                 <a:spcPts val="0"/>
               </a:spcBef>
               <a:spcAft>
-                <a:spcPts val="600"/>
+                <a:spcPts val="200"/>
+              </a:spcAft>
+            </a:pPr>
+            <a:r>
+              <a:rPr sz="1500" b="1">
+                <a:solidFill>
+                  <a:srgbClr val="1A1A1A"/>
+                </a:solidFill>
+                <a:latin typeface="Manrope"/>
+                <a:rFonts ascii="Manrope" hAnsi="Manrope" cs="Manrope" eastAsia="Manrope"/>
+              </a:rPr>
+              <a:t>Конкуренты</a:t>
+            </a:r>
+          </a:p>
+          <a:p>
+            <a:pPr algn="l">
+              <a:lnSpc>
+                <a:spcPct val="118000"/>
+              </a:lnSpc>
+              <a:spcBef>
+                <a:spcPts val="0"/>
+              </a:spcBef>
+              <a:spcAft>
+                <a:spcPts val="1000"/>
               </a:spcAft>
             </a:pPr>
             <a:r>
@@ -7260,7 +7283,30 @@
                 <a:latin typeface="Golos Text"/>
                 <a:rFonts ascii="Golos Text" hAnsi="Golos Text" cs="Golos Text" eastAsia="Golos Text"/>
               </a:rPr>
-              <a:t>Конкуренты на полке: ЕТС Natural, MEZO, Natura Siberica.</a:t>
+              <a:t>ЕТС Natural · MEZO · Natura Siberica (чужой премиум в каталоге)</a:t>
+            </a:r>
+          </a:p>
+          <a:p>
+            <a:pPr algn="l">
+              <a:lnSpc>
+                <a:spcPct val="118000"/>
+              </a:lnSpc>
+              <a:spcBef>
+                <a:spcPts val="0"/>
+              </a:spcBef>
+              <a:spcAft>
+                <a:spcPts val="200"/>
+              </a:spcAft>
+            </a:pPr>
+            <a:r>
+              <a:rPr sz="1500" b="1">
+                <a:solidFill>
+                  <a:srgbClr val="1A1A1A"/>
+                </a:solidFill>
+                <a:latin typeface="Manrope"/>
+                <a:rFonts ascii="Manrope" hAnsi="Manrope" cs="Manrope" eastAsia="Manrope"/>
+              </a:rPr>
+              <a:t>Сила Travel+</a:t>
             </a:r>
           </a:p>
           <a:p>
@@ -7276,26 +7322,49 @@
               </a:spcAft>
             </a:pPr>
             <a:r>
-              <a:rPr sz="1400" b="0">
-                <a:solidFill>
-                  <a:srgbClr val="5C5C5C"/>
+              <a:rPr sz="1500" b="0">
+                <a:solidFill>
+                  <a:srgbClr val="1A1A1A"/>
                 </a:solidFill>
                 <a:latin typeface="Golos Text"/>
                 <a:rFonts ascii="Golos Text" hAnsi="Golos Text" cs="Golos Text" eastAsia="Golos Text"/>
               </a:rPr>
-              <a:t>(Natura Siberica — чужой премиум в каталоге Travel+)</a:t>
-            </a:r>
-          </a:p>
-          <a:p>
-            <a:pPr algn="l">
-              <a:lnSpc>
-                <a:spcPct val="118000"/>
-              </a:lnSpc>
-              <a:spcBef>
-                <a:spcPts val="0"/>
-              </a:spcBef>
-              <a:spcAft>
-                <a:spcPts val="600"/>
+              <a:t>Массовый и средний сегмент</a:t>
+            </a:r>
+          </a:p>
+          <a:p>
+            <a:pPr algn="l">
+              <a:lnSpc>
+                <a:spcPct val="118000"/>
+              </a:lnSpc>
+              <a:spcBef>
+                <a:spcPts val="0"/>
+              </a:spcBef>
+              <a:spcAft>
+                <a:spcPts val="200"/>
+              </a:spcAft>
+            </a:pPr>
+            <a:r>
+              <a:rPr sz="1500" b="1">
+                <a:solidFill>
+                  <a:srgbClr val="1A1A1A"/>
+                </a:solidFill>
+                <a:latin typeface="Manrope"/>
+                <a:rFonts ascii="Manrope" hAnsi="Manrope" cs="Manrope" eastAsia="Manrope"/>
+              </a:rPr>
+              <a:t>Дыра</a:t>
+            </a:r>
+          </a:p>
+          <a:p>
+            <a:pPr algn="l">
+              <a:lnSpc>
+                <a:spcPct val="118000"/>
+              </a:lnSpc>
+              <a:spcBef>
+                <a:spcPts val="0"/>
+              </a:spcBef>
+              <a:spcAft>
+                <a:spcPts val="0"/>
               </a:spcAft>
             </a:pPr>
             <a:r>
@@ -7306,86 +7375,86 @@
                 <a:latin typeface="Golos Text"/>
                 <a:rFonts ascii="Golos Text" hAnsi="Golos Text" cs="Golos Text" eastAsia="Golos Text"/>
               </a:rPr>
-              <a:t>Travel+ силён в массовом и среднем сегменте.</a:t>
-            </a:r>
-          </a:p>
-          <a:p>
-            <a:pPr algn="l">
-              <a:lnSpc>
-                <a:spcPct val="118000"/>
-              </a:lnSpc>
-              <a:spcBef>
-                <a:spcPts val="0"/>
-              </a:spcBef>
-              <a:spcAft>
-                <a:spcPts val="800"/>
+              <a:t>Своей Natural с документами нет</a:t>
+            </a:r>
+          </a:p>
+        </p:txBody>
+      </p:sp>
+      <p:sp>
+        <p:nvSpPr>
+          <p:cNvPr id="14" name="TextBox 13"/>
+          <p:cNvSpPr txBox="1"/>
+          <p:nvPr/>
+        </p:nvSpPr>
+        <p:spPr>
+          <a:xfrm>
+            <a:off x="6571335" y="1426464"/>
+            <a:ext cx="4815687" cy="4334256"/>
+          </a:xfrm>
+          <a:prstGeom prst="rect">
+            <a:avLst/>
+          </a:prstGeom>
+          <a:noFill/>
+        </p:spPr>
+        <p:txBody>
+          <a:bodyPr wrap="square" anchor="t" lIns="50800" rIns="50800" tIns="25400" bIns="25400"/>
+          <a:lstStyle/>
+          <a:p>
+            <a:pPr algn="l">
+              <a:lnSpc>
+                <a:spcPct val="118000"/>
+              </a:lnSpc>
+              <a:spcBef>
+                <a:spcPts val="0"/>
+              </a:spcBef>
+              <a:spcAft>
+                <a:spcPts val="1200"/>
               </a:spcAft>
             </a:pPr>
             <a:r>
               <a:rPr sz="1500" b="1">
                 <a:solidFill>
-                  <a:srgbClr val="1A1A1A"/>
+                  <a:srgbClr val="2A554A"/>
                 </a:solidFill>
                 <a:latin typeface="Manrope"/>
                 <a:rFonts ascii="Manrope" hAnsi="Manrope" cs="Manrope" eastAsia="Manrope"/>
               </a:rPr>
-              <a:t>Слабое место: своей линейки Natural с документами нет.</a:t>
-            </a:r>
-          </a:p>
-        </p:txBody>
-      </p:sp>
-      <p:sp>
-        <p:nvSpPr>
-          <p:cNvPr id="14" name="TextBox 13"/>
-          <p:cNvSpPr txBox="1"/>
-          <p:nvPr/>
-        </p:nvSpPr>
-        <p:spPr>
-          <a:xfrm>
-            <a:off x="6571335" y="1426464"/>
-            <a:ext cx="4815687" cy="4334256"/>
-          </a:xfrm>
-          <a:prstGeom prst="rect">
-            <a:avLst/>
-          </a:prstGeom>
-          <a:noFill/>
-        </p:spPr>
-        <p:txBody>
-          <a:bodyPr wrap="square" anchor="t" lIns="50800" rIns="50800" tIns="25400" bIns="25400"/>
-          <a:lstStyle/>
-          <a:p>
-            <a:pPr algn="l">
-              <a:lnSpc>
-                <a:spcPct val="118000"/>
-              </a:lnSpc>
-              <a:spcBef>
-                <a:spcPts val="0"/>
-              </a:spcBef>
-              <a:spcAft>
-                <a:spcPts val="1200"/>
+              <a:t>Ценовая лестка (не оферта)</a:t>
+            </a:r>
+          </a:p>
+          <a:p>
+            <a:pPr algn="l">
+              <a:lnSpc>
+                <a:spcPct val="118000"/>
+              </a:lnSpc>
+              <a:spcBef>
+                <a:spcPts val="0"/>
+              </a:spcBef>
+              <a:spcAft>
+                <a:spcPts val="200"/>
               </a:spcAft>
             </a:pPr>
             <a:r>
               <a:rPr sz="1500" b="1">
                 <a:solidFill>
-                  <a:srgbClr val="2A554A"/>
+                  <a:srgbClr val="1A1A1A"/>
                 </a:solidFill>
                 <a:latin typeface="Manrope"/>
                 <a:rFonts ascii="Manrope" hAnsi="Manrope" cs="Manrope" eastAsia="Manrope"/>
               </a:rPr>
-              <a:t>Ориентир цен (не оферта)</a:t>
-            </a:r>
-          </a:p>
-          <a:p>
-            <a:pPr algn="l">
-              <a:lnSpc>
-                <a:spcPct val="118000"/>
-              </a:lnSpc>
-              <a:spcBef>
-                <a:spcPts val="0"/>
-              </a:spcBef>
-              <a:spcAft>
-                <a:spcPts val="600"/>
+              <a:t>Hotel Line</a:t>
+            </a:r>
+          </a:p>
+          <a:p>
+            <a:pPr algn="l">
+              <a:lnSpc>
+                <a:spcPct val="118000"/>
+              </a:lnSpc>
+              <a:spcBef>
+                <a:spcPts val="0"/>
+              </a:spcBef>
+              <a:spcAft>
+                <a:spcPts val="1000"/>
               </a:spcAft>
             </a:pPr>
             <a:r>
@@ -7396,19 +7465,42 @@
                 <a:latin typeface="Golos Text"/>
                 <a:rFonts ascii="Golos Text" hAnsi="Golos Text" cs="Golos Text" eastAsia="Golos Text"/>
               </a:rPr>
-              <a:t>Hotel Line — ориентир 12–15 ₽ / 30 мл</a:t>
-            </a:r>
-          </a:p>
-          <a:p>
-            <a:pPr algn="l">
-              <a:lnSpc>
-                <a:spcPct val="118000"/>
-              </a:lnSpc>
-              <a:spcBef>
-                <a:spcPts val="0"/>
-              </a:spcBef>
-              <a:spcAft>
-                <a:spcPts val="600"/>
+              <a:t>12–15 ₽ / 30 мл</a:t>
+            </a:r>
+          </a:p>
+          <a:p>
+            <a:pPr algn="l">
+              <a:lnSpc>
+                <a:spcPct val="118000"/>
+              </a:lnSpc>
+              <a:spcBef>
+                <a:spcPts val="0"/>
+              </a:spcBef>
+              <a:spcAft>
+                <a:spcPts val="200"/>
+              </a:spcAft>
+            </a:pPr>
+            <a:r>
+              <a:rPr sz="1500" b="1">
+                <a:solidFill>
+                  <a:srgbClr val="1A1A1A"/>
+                </a:solidFill>
+                <a:latin typeface="Manrope"/>
+                <a:rFonts ascii="Manrope" hAnsi="Manrope" cs="Manrope" eastAsia="Manrope"/>
+              </a:rPr>
+              <a:t>ЕТС Natural</a:t>
+            </a:r>
+          </a:p>
+          <a:p>
+            <a:pPr algn="l">
+              <a:lnSpc>
+                <a:spcPct val="118000"/>
+              </a:lnSpc>
+              <a:spcBef>
+                <a:spcPts val="0"/>
+              </a:spcBef>
+              <a:spcAft>
+                <a:spcPts val="1000"/>
               </a:spcAft>
             </a:pPr>
             <a:r>
@@ -7419,19 +7511,42 @@
                 <a:latin typeface="Golos Text"/>
                 <a:rFonts ascii="Golos Text" hAnsi="Golos Text" cs="Golos Text" eastAsia="Golos Text"/>
               </a:rPr>
-              <a:t>ЕТС Natural — ориентир 18 ₽ / 25 мл</a:t>
-            </a:r>
-          </a:p>
-          <a:p>
-            <a:pPr algn="l">
-              <a:lnSpc>
-                <a:spcPct val="118000"/>
-              </a:lnSpc>
-              <a:spcBef>
-                <a:spcPts val="0"/>
-              </a:spcBef>
-              <a:spcAft>
-                <a:spcPts val="1200"/>
+              <a:t>18 ₽ / 25 мл</a:t>
+            </a:r>
+          </a:p>
+          <a:p>
+            <a:pPr algn="l">
+              <a:lnSpc>
+                <a:spcPct val="118000"/>
+              </a:lnSpc>
+              <a:spcBef>
+                <a:spcPts val="0"/>
+              </a:spcBef>
+              <a:spcAft>
+                <a:spcPts val="200"/>
+              </a:spcAft>
+            </a:pPr>
+            <a:r>
+              <a:rPr sz="1500" b="1">
+                <a:solidFill>
+                  <a:srgbClr val="1A1A1A"/>
+                </a:solidFill>
+                <a:latin typeface="Manrope"/>
+                <a:rFonts ascii="Manrope" hAnsi="Manrope" cs="Manrope" eastAsia="Manrope"/>
+              </a:rPr>
+              <a:t>Natura Siberica</a:t>
+            </a:r>
+          </a:p>
+          <a:p>
+            <a:pPr algn="l">
+              <a:lnSpc>
+                <a:spcPct val="118000"/>
+              </a:lnSpc>
+              <a:spcBef>
+                <a:spcPts val="0"/>
+              </a:spcBef>
+              <a:spcAft>
+                <a:spcPts val="1000"/>
               </a:spcAft>
             </a:pPr>
             <a:r>
@@ -7442,19 +7557,19 @@
                 <a:latin typeface="Golos Text"/>
                 <a:rFonts ascii="Golos Text" hAnsi="Golos Text" cs="Golos Text" eastAsia="Golos Text"/>
               </a:rPr>
-              <a:t>Natura Siberica — ориентир 30–40 ₽ и выше</a:t>
-            </a:r>
-          </a:p>
-          <a:p>
-            <a:pPr algn="l">
-              <a:lnSpc>
-                <a:spcPct val="118000"/>
-              </a:lnSpc>
-              <a:spcBef>
-                <a:spcPts val="0"/>
-              </a:spcBef>
-              <a:spcAft>
-                <a:spcPts val="800"/>
+              <a:t>30–40 ₽ и выше</a:t>
+            </a:r>
+          </a:p>
+          <a:p>
+            <a:pPr algn="l">
+              <a:lnSpc>
+                <a:spcPct val="118000"/>
+              </a:lnSpc>
+              <a:spcBef>
+                <a:spcPts val="0"/>
+              </a:spcBef>
+              <a:spcAft>
+                <a:spcPts val="200"/>
               </a:spcAft>
             </a:pPr>
             <a:r>
@@ -7465,19 +7580,19 @@
                 <a:latin typeface="Manrope"/>
                 <a:rFonts ascii="Manrope" hAnsi="Manrope" cs="Manrope" eastAsia="Manrope"/>
               </a:rPr>
-              <a:t>Ставка Natural: между Hotel Line и Natura Siberica</a:t>
-            </a:r>
-          </a:p>
-          <a:p>
-            <a:pPr algn="l">
-              <a:lnSpc>
-                <a:spcPct val="118000"/>
-              </a:lnSpc>
-              <a:spcBef>
-                <a:spcPts val="0"/>
-              </a:spcBef>
-              <a:spcAft>
-                <a:spcPts val="600"/>
+              <a:t>Место Natural</a:t>
+            </a:r>
+          </a:p>
+          <a:p>
+            <a:pPr algn="l">
+              <a:lnSpc>
+                <a:spcPct val="118000"/>
+              </a:lnSpc>
+              <a:spcBef>
+                <a:spcPts val="0"/>
+              </a:spcBef>
+              <a:spcAft>
+                <a:spcPts val="0"/>
               </a:spcAft>
             </a:pPr>
             <a:r>
@@ -7488,7 +7603,7 @@
                 <a:latin typeface="Golos Text"/>
                 <a:rFonts ascii="Golos Text" hAnsi="Golos Text" cs="Golos Text" eastAsia="Golos Text"/>
               </a:rPr>
-              <a:t>Натуральность, пакет документов, один поставщик на номер.</a:t>
+              <a:t>Между Hotel Line и Natura Siberica</a:t>
             </a:r>
           </a:p>
         </p:txBody>

</xml_diff>

<commit_message>
content(presentation): slide 5 labeled theses like slide 4
Co-authored-by: pagasbot-coder <pagasbot-coder@users.noreply.github.com>
</commit_message>
<xml_diff>
--- a/knowledge-base/presentation-travelplus-interview.pptx
+++ b/knowledge-base/presentation-travelplus-interview.pptx
@@ -8123,19 +8123,42 @@
                 <a:latin typeface="Manrope"/>
                 <a:rFonts ascii="Manrope" hAnsi="Manrope" cs="Manrope" eastAsia="Manrope"/>
               </a:rPr>
-              <a:t>Карта портфеля</a:t>
-            </a:r>
-          </a:p>
-          <a:p>
-            <a:pPr algn="l">
-              <a:lnSpc>
-                <a:spcPct val="118000"/>
-              </a:lnSpc>
-              <a:spcBef>
-                <a:spcPts val="0"/>
-              </a:spcBef>
-              <a:spcAft>
-                <a:spcPts val="600"/>
+              <a:t>Портфель</a:t>
+            </a:r>
+          </a:p>
+          <a:p>
+            <a:pPr algn="l">
+              <a:lnSpc>
+                <a:spcPct val="118000"/>
+              </a:lnSpc>
+              <a:spcBef>
+                <a:spcPts val="0"/>
+              </a:spcBef>
+              <a:spcAft>
+                <a:spcPts val="200"/>
+              </a:spcAft>
+            </a:pPr>
+            <a:r>
+              <a:rPr sz="1500" b="1">
+                <a:solidFill>
+                  <a:srgbClr val="1A1A1A"/>
+                </a:solidFill>
+                <a:latin typeface="Manrope"/>
+                <a:rFonts ascii="Manrope" hAnsi="Manrope" cs="Manrope" eastAsia="Manrope"/>
+              </a:rPr>
+              <a:t>Hotel Line</a:t>
+            </a:r>
+          </a:p>
+          <a:p>
+            <a:pPr algn="l">
+              <a:lnSpc>
+                <a:spcPct val="118000"/>
+              </a:lnSpc>
+              <a:spcBef>
+                <a:spcPts val="0"/>
+              </a:spcBef>
+              <a:spcAft>
+                <a:spcPts val="1000"/>
               </a:spcAft>
             </a:pPr>
             <a:r>
@@ -8146,19 +8169,42 @@
                 <a:latin typeface="Golos Text"/>
                 <a:rFonts ascii="Golos Text" hAnsi="Golos Text" cs="Golos Text" eastAsia="Golos Text"/>
               </a:rPr>
-              <a:t>Hotel Line — цена и базовый сегмент</a:t>
-            </a:r>
-          </a:p>
-          <a:p>
-            <a:pPr algn="l">
-              <a:lnSpc>
-                <a:spcPct val="118000"/>
-              </a:lnSpc>
-              <a:spcBef>
-                <a:spcPts val="0"/>
-              </a:spcBef>
-              <a:spcAft>
-                <a:spcPts val="600"/>
+              <a:t>Цена и базовый сегмент</a:t>
+            </a:r>
+          </a:p>
+          <a:p>
+            <a:pPr algn="l">
+              <a:lnSpc>
+                <a:spcPct val="118000"/>
+              </a:lnSpc>
+              <a:spcBef>
+                <a:spcPts val="0"/>
+              </a:spcBef>
+              <a:spcAft>
+                <a:spcPts val="200"/>
+              </a:spcAft>
+            </a:pPr>
+            <a:r>
+              <a:rPr sz="1500" b="1">
+                <a:solidFill>
+                  <a:srgbClr val="1A1A1A"/>
+                </a:solidFill>
+                <a:latin typeface="Manrope"/>
+                <a:rFonts ascii="Manrope" hAnsi="Manrope" cs="Manrope" eastAsia="Manrope"/>
+              </a:rPr>
+              <a:t>Fleur / Aquatique / La Nuit</a:t>
+            </a:r>
+          </a:p>
+          <a:p>
+            <a:pPr algn="l">
+              <a:lnSpc>
+                <a:spcPct val="118000"/>
+              </a:lnSpc>
+              <a:spcBef>
+                <a:spcPts val="0"/>
+              </a:spcBef>
+              <a:spcAft>
+                <a:spcPts val="1000"/>
               </a:spcAft>
             </a:pPr>
             <a:r>
@@ -8169,19 +8215,19 @@
                 <a:latin typeface="Golos Text"/>
                 <a:rFonts ascii="Golos Text" hAnsi="Golos Text" cs="Golos Text" eastAsia="Golos Text"/>
               </a:rPr>
-              <a:t>Fleur / Aquatique / La Nuit — дизайн и аромат</a:t>
-            </a:r>
-          </a:p>
-          <a:p>
-            <a:pPr algn="l">
-              <a:lnSpc>
-                <a:spcPct val="118000"/>
-              </a:lnSpc>
-              <a:spcBef>
-                <a:spcPts val="0"/>
-              </a:spcBef>
-              <a:spcAft>
-                <a:spcPts val="800"/>
+              <a:t>Дизайн и аромат</a:t>
+            </a:r>
+          </a:p>
+          <a:p>
+            <a:pPr algn="l">
+              <a:lnSpc>
+                <a:spcPct val="118000"/>
+              </a:lnSpc>
+              <a:spcBef>
+                <a:spcPts val="0"/>
+              </a:spcBef>
+              <a:spcAft>
+                <a:spcPts val="200"/>
               </a:spcAft>
             </a:pPr>
             <a:r>
@@ -8192,19 +8238,19 @@
                 <a:latin typeface="Manrope"/>
                 <a:rFonts ascii="Manrope" hAnsi="Manrope" cs="Manrope" eastAsia="Manrope"/>
               </a:rPr>
-              <a:t>Natural — натуральность и документы</a:t>
-            </a:r>
-          </a:p>
-          <a:p>
-            <a:pPr algn="l">
-              <a:lnSpc>
-                <a:spcPct val="118000"/>
-              </a:lnSpc>
-              <a:spcBef>
-                <a:spcPts val="0"/>
-              </a:spcBef>
-              <a:spcAft>
-                <a:spcPts val="600"/>
+              <a:t>Natural</a:t>
+            </a:r>
+          </a:p>
+          <a:p>
+            <a:pPr algn="l">
+              <a:lnSpc>
+                <a:spcPct val="118000"/>
+              </a:lnSpc>
+              <a:spcBef>
+                <a:spcPts val="0"/>
+              </a:spcBef>
+              <a:spcAft>
+                <a:spcPts val="1000"/>
               </a:spcAft>
             </a:pPr>
             <a:r>
@@ -8215,19 +8261,42 @@
                 <a:latin typeface="Golos Text"/>
                 <a:rFonts ascii="Golos Text" hAnsi="Golos Text" cs="Golos Text" eastAsia="Golos Text"/>
               </a:rPr>
-              <a:t>Natura Siberica — чужой премиум в каталоге</a:t>
-            </a:r>
-          </a:p>
-          <a:p>
-            <a:pPr algn="l">
-              <a:lnSpc>
-                <a:spcPct val="118000"/>
-              </a:lnSpc>
-              <a:spcBef>
-                <a:spcPts val="0"/>
-              </a:spcBef>
-              <a:spcAft>
-                <a:spcPts val="600"/>
+              <a:t>Натуральность и документы</a:t>
+            </a:r>
+          </a:p>
+          <a:p>
+            <a:pPr algn="l">
+              <a:lnSpc>
+                <a:spcPct val="118000"/>
+              </a:lnSpc>
+              <a:spcBef>
+                <a:spcPts val="0"/>
+              </a:spcBef>
+              <a:spcAft>
+                <a:spcPts val="200"/>
+              </a:spcAft>
+            </a:pPr>
+            <a:r>
+              <a:rPr sz="1500" b="1">
+                <a:solidFill>
+                  <a:srgbClr val="1A1A1A"/>
+                </a:solidFill>
+                <a:latin typeface="Manrope"/>
+                <a:rFonts ascii="Manrope" hAnsi="Manrope" cs="Manrope" eastAsia="Manrope"/>
+              </a:rPr>
+              <a:t>Natura Siberica</a:t>
+            </a:r>
+          </a:p>
+          <a:p>
+            <a:pPr algn="l">
+              <a:lnSpc>
+                <a:spcPct val="118000"/>
+              </a:lnSpc>
+              <a:spcBef>
+                <a:spcPts val="0"/>
+              </a:spcBef>
+              <a:spcAft>
+                <a:spcPts val="1000"/>
               </a:spcAft>
             </a:pPr>
             <a:r>
@@ -8238,7 +8307,53 @@
                 <a:latin typeface="Golos Text"/>
                 <a:rFonts ascii="Golos Text" hAnsi="Golos Text" cs="Golos Text" eastAsia="Golos Text"/>
               </a:rPr>
-              <a:t>СТМ с логотипом отеля — отдельный проект</a:t>
+              <a:t>Чужой премиум в каталоге</a:t>
+            </a:r>
+          </a:p>
+          <a:p>
+            <a:pPr algn="l">
+              <a:lnSpc>
+                <a:spcPct val="118000"/>
+              </a:lnSpc>
+              <a:spcBef>
+                <a:spcPts val="0"/>
+              </a:spcBef>
+              <a:spcAft>
+                <a:spcPts val="200"/>
+              </a:spcAft>
+            </a:pPr>
+            <a:r>
+              <a:rPr sz="1500" b="1">
+                <a:solidFill>
+                  <a:srgbClr val="1A1A1A"/>
+                </a:solidFill>
+                <a:latin typeface="Manrope"/>
+                <a:rFonts ascii="Manrope" hAnsi="Manrope" cs="Manrope" eastAsia="Manrope"/>
+              </a:rPr>
+              <a:t>СТМ</a:t>
+            </a:r>
+          </a:p>
+          <a:p>
+            <a:pPr algn="l">
+              <a:lnSpc>
+                <a:spcPct val="118000"/>
+              </a:lnSpc>
+              <a:spcBef>
+                <a:spcPts val="0"/>
+              </a:spcBef>
+              <a:spcAft>
+                <a:spcPts val="0"/>
+              </a:spcAft>
+            </a:pPr>
+            <a:r>
+              <a:rPr sz="1500" b="0">
+                <a:solidFill>
+                  <a:srgbClr val="1A1A1A"/>
+                </a:solidFill>
+                <a:latin typeface="Golos Text"/>
+                <a:rFonts ascii="Golos Text" hAnsi="Golos Text" cs="Golos Text" eastAsia="Golos Text"/>
+              </a:rPr>
+              <a:t>Отдельный проект под логотип отеля</a:t>
             </a:r>
           </a:p>
         </p:txBody>
@@ -8282,19 +8397,42 @@
                 <a:latin typeface="Manrope"/>
                 <a:rFonts ascii="Manrope" hAnsi="Manrope" cs="Manrope" eastAsia="Manrope"/>
               </a:rPr>
-              <a:t>Мостик для продаж</a:t>
-            </a:r>
-          </a:p>
-          <a:p>
-            <a:pPr algn="l">
-              <a:lnSpc>
-                <a:spcPct val="118000"/>
-              </a:lnSpc>
-              <a:spcBef>
-                <a:spcPts val="0"/>
-              </a:spcBef>
-              <a:spcAft>
-                <a:spcPts val="600"/>
+              <a:t>Как не мешать линейки</a:t>
+            </a:r>
+          </a:p>
+          <a:p>
+            <a:pPr algn="l">
+              <a:lnSpc>
+                <a:spcPct val="118000"/>
+              </a:lnSpc>
+              <a:spcBef>
+                <a:spcPts val="0"/>
+              </a:spcBef>
+              <a:spcAft>
+                <a:spcPts val="200"/>
+              </a:spcAft>
+            </a:pPr>
+            <a:r>
+              <a:rPr sz="1500" b="1">
+                <a:solidFill>
+                  <a:srgbClr val="1A1A1A"/>
+                </a:solidFill>
+                <a:latin typeface="Manrope"/>
+                <a:rFonts ascii="Manrope" hAnsi="Manrope" cs="Manrope" eastAsia="Manrope"/>
+              </a:rPr>
+              <a:t>Fleur</a:t>
+            </a:r>
+          </a:p>
+          <a:p>
+            <a:pPr algn="l">
+              <a:lnSpc>
+                <a:spcPct val="118000"/>
+              </a:lnSpc>
+              <a:spcBef>
+                <a:spcPts val="0"/>
+              </a:spcBef>
+              <a:spcAft>
+                <a:spcPts val="1000"/>
               </a:spcAft>
             </a:pPr>
             <a:r>
@@ -8305,19 +8443,42 @@
                 <a:latin typeface="Golos Text"/>
                 <a:rFonts ascii="Golos Text" hAnsi="Golos Text" cs="Golos Text" eastAsia="Golos Text"/>
               </a:rPr>
-              <a:t>Fleur закрывает дизайн и аромат в номере.</a:t>
-            </a:r>
-          </a:p>
-          <a:p>
-            <a:pPr algn="l">
-              <a:lnSpc>
-                <a:spcPct val="118000"/>
-              </a:lnSpc>
-              <a:spcBef>
-                <a:spcPts val="0"/>
-              </a:spcBef>
-              <a:spcAft>
-                <a:spcPts val="600"/>
+              <a:t>Закрывает дизайн и аромат в номере</a:t>
+            </a:r>
+          </a:p>
+          <a:p>
+            <a:pPr algn="l">
+              <a:lnSpc>
+                <a:spcPct val="118000"/>
+              </a:lnSpc>
+              <a:spcBef>
+                <a:spcPts val="0"/>
+              </a:spcBef>
+              <a:spcAft>
+                <a:spcPts val="200"/>
+              </a:spcAft>
+            </a:pPr>
+            <a:r>
+              <a:rPr sz="1500" b="1">
+                <a:solidFill>
+                  <a:srgbClr val="1A1A1A"/>
+                </a:solidFill>
+                <a:latin typeface="Manrope"/>
+                <a:rFonts ascii="Manrope" hAnsi="Manrope" cs="Manrope" eastAsia="Manrope"/>
+              </a:rPr>
+              <a:t>Natural</a:t>
+            </a:r>
+          </a:p>
+          <a:p>
+            <a:pPr algn="l">
+              <a:lnSpc>
+                <a:spcPct val="118000"/>
+              </a:lnSpc>
+              <a:spcBef>
+                <a:spcPts val="0"/>
+              </a:spcBef>
+              <a:spcAft>
+                <a:spcPts val="1000"/>
               </a:spcAft>
             </a:pPr>
             <a:r>
@@ -8328,19 +8489,19 @@
                 <a:latin typeface="Golos Text"/>
                 <a:rFonts ascii="Golos Text" hAnsi="Golos Text" cs="Golos Text" eastAsia="Golos Text"/>
               </a:rPr>
-              <a:t>Natural — запрос на натуральность и полный пакет документов.</a:t>
-            </a:r>
-          </a:p>
-          <a:p>
-            <a:pPr algn="l">
-              <a:lnSpc>
-                <a:spcPct val="118000"/>
-              </a:lnSpc>
-              <a:spcBef>
-                <a:spcPts val="0"/>
-              </a:spcBef>
-              <a:spcAft>
-                <a:spcPts val="1000"/>
+              <a:t>Закрывает запрос eco и пакет документов</a:t>
+            </a:r>
+          </a:p>
+          <a:p>
+            <a:pPr algn="l">
+              <a:lnSpc>
+                <a:spcPct val="118000"/>
+              </a:lnSpc>
+              <a:spcBef>
+                <a:spcPts val="0"/>
+              </a:spcBef>
+              <a:spcAft>
+                <a:spcPts val="200"/>
               </a:spcAft>
             </a:pPr>
             <a:r>
@@ -8351,19 +8512,19 @@
                 <a:latin typeface="Manrope"/>
                 <a:rFonts ascii="Manrope" hAnsi="Manrope" cs="Manrope" eastAsia="Manrope"/>
               </a:rPr>
-              <a:t>Fleur и Natural не конкурируют — разные задачи.</a:t>
-            </a:r>
-          </a:p>
-          <a:p>
-            <a:pPr algn="l">
-              <a:lnSpc>
-                <a:spcPct val="118000"/>
-              </a:lnSpc>
-              <a:spcBef>
-                <a:spcPts val="0"/>
-              </a:spcBef>
-              <a:spcAft>
-                <a:spcPts val="600"/>
+              <a:t>Между собой</a:t>
+            </a:r>
+          </a:p>
+          <a:p>
+            <a:pPr algn="l">
+              <a:lnSpc>
+                <a:spcPct val="118000"/>
+              </a:lnSpc>
+              <a:spcBef>
+                <a:spcPts val="0"/>
+              </a:spcBef>
+              <a:spcAft>
+                <a:spcPts val="1000"/>
               </a:spcAft>
             </a:pPr>
             <a:r>
@@ -8374,7 +8535,53 @@
                 <a:latin typeface="Golos Text"/>
                 <a:rFonts ascii="Golos Text" hAnsi="Golos Text" cs="Golos Text" eastAsia="Golos Text"/>
               </a:rPr>
-              <a:t>На одном объекте: стандартные номера — Hotel Line или Fleur; wellness-корпус или этаж с eco-запросом — Natural.</a:t>
+              <a:t>Не конкурируют — разные задачи</a:t>
+            </a:r>
+          </a:p>
+          <a:p>
+            <a:pPr algn="l">
+              <a:lnSpc>
+                <a:spcPct val="118000"/>
+              </a:lnSpc>
+              <a:spcBef>
+                <a:spcPts val="0"/>
+              </a:spcBef>
+              <a:spcAft>
+                <a:spcPts val="200"/>
+              </a:spcAft>
+            </a:pPr>
+            <a:r>
+              <a:rPr sz="1500" b="1">
+                <a:solidFill>
+                  <a:srgbClr val="1A1A1A"/>
+                </a:solidFill>
+                <a:latin typeface="Manrope"/>
+                <a:rFonts ascii="Manrope" hAnsi="Manrope" cs="Manrope" eastAsia="Manrope"/>
+              </a:rPr>
+              <a:t>На объекте</a:t>
+            </a:r>
+          </a:p>
+          <a:p>
+            <a:pPr algn="l">
+              <a:lnSpc>
+                <a:spcPct val="118000"/>
+              </a:lnSpc>
+              <a:spcBef>
+                <a:spcPts val="0"/>
+              </a:spcBef>
+              <a:spcAft>
+                <a:spcPts val="0"/>
+              </a:spcAft>
+            </a:pPr>
+            <a:r>
+              <a:rPr sz="1500" b="0">
+                <a:solidFill>
+                  <a:srgbClr val="1A1A1A"/>
+                </a:solidFill>
+                <a:latin typeface="Golos Text"/>
+                <a:rFonts ascii="Golos Text" hAnsi="Golos Text" cs="Golos Text" eastAsia="Golos Text"/>
+              </a:rPr>
+              <a:t>Стандартные номера — Hotel Line или Fleur; wellness-этаж — Natural</a:t>
             </a:r>
           </a:p>
         </p:txBody>

</xml_diff>

<commit_message>
content(presentation): slide 6 checklist labeled, drop stages 3-6 note
Co-authored-by: pagasbot-coder <pagasbot-coder@users.noreply.github.com>
</commit_message>
<xml_diff>
--- a/knowledge-base/presentation-travelplus-interview.pptx
+++ b/knowledge-base/presentation-travelplus-interview.pptx
@@ -9113,7 +9113,7 @@
                 <a:spcPts val="0"/>
               </a:spcBef>
               <a:spcAft>
-                <a:spcPts val="800"/>
+                <a:spcPts val="200"/>
               </a:spcAft>
             </a:pPr>
             <a:r>
@@ -9124,7 +9124,7 @@
                 <a:latin typeface="Manrope"/>
                 <a:rFonts ascii="Manrope" hAnsi="Manrope" cs="Manrope" eastAsia="Manrope"/>
               </a:rPr>
-              <a:t>Мягкий уход с понятной натуральностью</a:t>
+              <a:t>Суть</a:t>
             </a:r>
           </a:p>
           <a:p>
@@ -9147,42 +9147,88 @@
                 <a:latin typeface="Golos Text"/>
                 <a:rFonts ascii="Golos Text" hAnsi="Golos Text" cs="Golos Text" eastAsia="Golos Text"/>
               </a:rPr>
-              <a:t>Для отеля, которому важен комфорт гостя и спокойная проверка документов.</a:t>
-            </a:r>
-          </a:p>
-          <a:p>
-            <a:pPr algn="l">
-              <a:lnSpc>
-                <a:spcPct val="118000"/>
-              </a:lnSpc>
-              <a:spcBef>
-                <a:spcPts val="0"/>
-              </a:spcBef>
-              <a:spcAft>
-                <a:spcPts val="400"/>
-              </a:spcAft>
-            </a:pPr>
-            <a:r>
-              <a:rPr sz="1400" b="0">
-                <a:solidFill>
-                  <a:srgbClr val="5C5C5C"/>
+              <a:t>Мягкий уход с понятной натуральностью</a:t>
+            </a:r>
+          </a:p>
+          <a:p>
+            <a:pPr algn="l">
+              <a:lnSpc>
+                <a:spcPct val="118000"/>
+              </a:lnSpc>
+              <a:spcBef>
+                <a:spcPts val="0"/>
+              </a:spcBef>
+              <a:spcAft>
+                <a:spcPts val="200"/>
+              </a:spcAft>
+            </a:pPr>
+            <a:r>
+              <a:rPr sz="1500" b="1">
+                <a:solidFill>
+                  <a:srgbClr val="1A1A1A"/>
+                </a:solidFill>
+                <a:latin typeface="Manrope"/>
+                <a:rFonts ascii="Manrope" hAnsi="Manrope" cs="Manrope" eastAsia="Manrope"/>
+              </a:rPr>
+              <a:t>Для кого</a:t>
+            </a:r>
+          </a:p>
+          <a:p>
+            <a:pPr algn="l">
+              <a:lnSpc>
+                <a:spcPct val="118000"/>
+              </a:lnSpc>
+              <a:spcBef>
+                <a:spcPts val="0"/>
+              </a:spcBef>
+              <a:spcAft>
+                <a:spcPts val="1000"/>
+              </a:spcAft>
+            </a:pPr>
+            <a:r>
+              <a:rPr sz="1500" b="0">
+                <a:solidFill>
+                  <a:srgbClr val="1A1A1A"/>
                 </a:solidFill>
                 <a:latin typeface="Golos Text"/>
                 <a:rFonts ascii="Golos Text" hAnsi="Golos Text" cs="Golos Text" eastAsia="Golos Text"/>
               </a:rPr>
-              <a:t>Доказательства:</a:t>
-            </a:r>
-          </a:p>
-          <a:p>
-            <a:pPr algn="l">
-              <a:lnSpc>
-                <a:spcPct val="118000"/>
-              </a:lnSpc>
-              <a:spcBef>
-                <a:spcPts val="0"/>
-              </a:spcBef>
-              <a:spcAft>
-                <a:spcPts val="600"/>
+              <a:t>Отель, которому важен комфорт гостя и спокойная проверка документов</a:t>
+            </a:r>
+          </a:p>
+          <a:p>
+            <a:pPr algn="l">
+              <a:lnSpc>
+                <a:spcPct val="118000"/>
+              </a:lnSpc>
+              <a:spcBef>
+                <a:spcPts val="0"/>
+              </a:spcBef>
+              <a:spcAft>
+                <a:spcPts val="200"/>
+              </a:spcAft>
+            </a:pPr>
+            <a:r>
+              <a:rPr sz="1500" b="1">
+                <a:solidFill>
+                  <a:srgbClr val="1A1A1A"/>
+                </a:solidFill>
+                <a:latin typeface="Manrope"/>
+                <a:rFonts ascii="Manrope" hAnsi="Manrope" cs="Manrope" eastAsia="Manrope"/>
+              </a:rPr>
+              <a:t>Состав</a:t>
+            </a:r>
+          </a:p>
+          <a:p>
+            <a:pPr algn="l">
+              <a:lnSpc>
+                <a:spcPct val="118000"/>
+              </a:lnSpc>
+              <a:spcBef>
+                <a:spcPts val="0"/>
+              </a:spcBef>
+              <a:spcAft>
+                <a:spcPts val="1000"/>
               </a:spcAft>
             </a:pPr>
             <a:r>
@@ -9193,19 +9239,42 @@
                 <a:latin typeface="Golos Text"/>
                 <a:rFonts ascii="Golos Text" hAnsi="Golos Text" cs="Golos Text" eastAsia="Golos Text"/>
               </a:rPr>
-              <a:t>• Состав в согласованных границах</a:t>
-            </a:r>
-          </a:p>
-          <a:p>
-            <a:pPr algn="l">
-              <a:lnSpc>
-                <a:spcPct val="118000"/>
-              </a:lnSpc>
-              <a:spcBef>
-                <a:spcPts val="0"/>
-              </a:spcBef>
-              <a:spcAft>
-                <a:spcPts val="600"/>
+              <a:t>Согласованные границы + блок «простыми словами» на этикетке</a:t>
+            </a:r>
+          </a:p>
+          <a:p>
+            <a:pPr algn="l">
+              <a:lnSpc>
+                <a:spcPct val="118000"/>
+              </a:lnSpc>
+              <a:spcBef>
+                <a:spcPts val="0"/>
+              </a:spcBef>
+              <a:spcAft>
+                <a:spcPts val="200"/>
+              </a:spcAft>
+            </a:pPr>
+            <a:r>
+              <a:rPr sz="1500" b="1">
+                <a:solidFill>
+                  <a:srgbClr val="1A1A1A"/>
+                </a:solidFill>
+                <a:latin typeface="Manrope"/>
+                <a:rFonts ascii="Manrope" hAnsi="Manrope" cs="Manrope" eastAsia="Manrope"/>
+              </a:rPr>
+              <a:t>Пакет</a:t>
+            </a:r>
+          </a:p>
+          <a:p>
+            <a:pPr algn="l">
+              <a:lnSpc>
+                <a:spcPct val="118000"/>
+              </a:lnSpc>
+              <a:spcBef>
+                <a:spcPts val="0"/>
+              </a:spcBef>
+              <a:spcAft>
+                <a:spcPts val="1000"/>
               </a:spcAft>
             </a:pPr>
             <a:r>
@@ -9216,19 +9285,42 @@
                 <a:latin typeface="Golos Text"/>
                 <a:rFonts ascii="Golos Text" hAnsi="Golos Text" cs="Golos Text" eastAsia="Golos Text"/>
               </a:rPr>
-              <a:t>• Пакет документов Travel+</a:t>
-            </a:r>
-          </a:p>
-          <a:p>
-            <a:pPr algn="l">
-              <a:lnSpc>
-                <a:spcPct val="118000"/>
-              </a:lnSpc>
-              <a:spcBef>
-                <a:spcPts val="0"/>
-              </a:spcBef>
-              <a:spcAft>
-                <a:spcPts val="600"/>
+              <a:t>Документы Travel+, one-stop на номер</a:t>
+            </a:r>
+          </a:p>
+          <a:p>
+            <a:pPr algn="l">
+              <a:lnSpc>
+                <a:spcPct val="118000"/>
+              </a:lnSpc>
+              <a:spcBef>
+                <a:spcPts val="0"/>
+              </a:spcBef>
+              <a:spcAft>
+                <a:spcPts val="200"/>
+              </a:spcAft>
+            </a:pPr>
+            <a:r>
+              <a:rPr sz="1500" b="1">
+                <a:solidFill>
+                  <a:srgbClr val="1A1A1A"/>
+                </a:solidFill>
+                <a:latin typeface="Manrope"/>
+                <a:rFonts ascii="Manrope" hAnsi="Manrope" cs="Manrope" eastAsia="Manrope"/>
+              </a:rPr>
+              <a:t>В номере</a:t>
+            </a:r>
+          </a:p>
+          <a:p>
+            <a:pPr algn="l">
+              <a:lnSpc>
+                <a:spcPct val="118000"/>
+              </a:lnSpc>
+              <a:spcBef>
+                <a:spcPts val="0"/>
+              </a:spcBef>
+              <a:spcAft>
+                <a:spcPts val="0"/>
               </a:spcAft>
             </a:pPr>
             <a:r>
@@ -9239,19 +9331,86 @@
                 <a:latin typeface="Golos Text"/>
                 <a:rFonts ascii="Golos Text" hAnsi="Golos Text" cs="Golos Text" eastAsia="Golos Text"/>
               </a:rPr>
-              <a:t>• Ощущение в номере после использования</a:t>
-            </a:r>
-          </a:p>
-          <a:p>
-            <a:pPr algn="l">
-              <a:lnSpc>
-                <a:spcPct val="118000"/>
-              </a:lnSpc>
-              <a:spcBef>
-                <a:spcPts val="0"/>
-              </a:spcBef>
-              <a:spcAft>
-                <a:spcPts val="600"/>
+              <a:t>Ощущение после использования, не только надпись на флаконе</a:t>
+            </a:r>
+          </a:p>
+        </p:txBody>
+      </p:sp>
+      <p:sp>
+        <p:nvSpPr>
+          <p:cNvPr id="14" name="TextBox 13"/>
+          <p:cNvSpPr txBox="1"/>
+          <p:nvPr/>
+        </p:nvSpPr>
+        <p:spPr>
+          <a:xfrm>
+            <a:off x="6571335" y="1426464"/>
+            <a:ext cx="4815687" cy="4334256"/>
+          </a:xfrm>
+          <a:prstGeom prst="rect">
+            <a:avLst/>
+          </a:prstGeom>
+          <a:noFill/>
+        </p:spPr>
+        <p:txBody>
+          <a:bodyPr wrap="square" anchor="t" lIns="50800" rIns="50800" tIns="25400" bIns="25400"/>
+          <a:lstStyle/>
+          <a:p>
+            <a:pPr algn="l">
+              <a:lnSpc>
+                <a:spcPct val="118000"/>
+              </a:lnSpc>
+              <a:spcBef>
+                <a:spcPts val="0"/>
+              </a:spcBef>
+              <a:spcAft>
+                <a:spcPts val="1200"/>
+              </a:spcAft>
+            </a:pPr>
+            <a:r>
+              <a:rPr sz="1500" b="1">
+                <a:solidFill>
+                  <a:srgbClr val="2A554A"/>
+                </a:solidFill>
+                <a:latin typeface="Manrope"/>
+                <a:rFonts ascii="Manrope" hAnsi="Manrope" cs="Manrope" eastAsia="Manrope"/>
+              </a:rPr>
+              <a:t>BrandScript</a:t>
+            </a:r>
+          </a:p>
+          <a:p>
+            <a:pPr algn="l">
+              <a:lnSpc>
+                <a:spcPct val="118000"/>
+              </a:lnSpc>
+              <a:spcBef>
+                <a:spcPts val="0"/>
+              </a:spcBef>
+              <a:spcAft>
+                <a:spcPts val="200"/>
+              </a:spcAft>
+            </a:pPr>
+            <a:r>
+              <a:rPr sz="1500" b="1">
+                <a:solidFill>
+                  <a:srgbClr val="1A1A1A"/>
+                </a:solidFill>
+                <a:latin typeface="Manrope"/>
+                <a:rFonts ascii="Manrope" hAnsi="Manrope" cs="Manrope" eastAsia="Manrope"/>
+              </a:rPr>
+              <a:t>Герой</a:t>
+            </a:r>
+          </a:p>
+          <a:p>
+            <a:pPr algn="l">
+              <a:lnSpc>
+                <a:spcPct val="118000"/>
+              </a:lnSpc>
+              <a:spcBef>
+                <a:spcPts val="0"/>
+              </a:spcBef>
+              <a:spcAft>
+                <a:spcPts val="1000"/>
               </a:spcAft>
             </a:pPr>
             <a:r>
@@ -9262,19 +9421,42 @@
                 <a:latin typeface="Golos Text"/>
                 <a:rFonts ascii="Golos Text" hAnsi="Golos Text" cs="Golos Text" eastAsia="Golos Text"/>
               </a:rPr>
-              <a:t>• Один поставщик на весь номер</a:t>
-            </a:r>
-          </a:p>
-          <a:p>
-            <a:pPr algn="l">
-              <a:lnSpc>
-                <a:spcPct val="118000"/>
-              </a:lnSpc>
-              <a:spcBef>
-                <a:spcPts val="0"/>
-              </a:spcBef>
-              <a:spcAft>
-                <a:spcPts val="600"/>
+              <a:t>Закупщик eco / wellness: выглядеть «зеленее» без дыры в бюджете и в бумагах</a:t>
+            </a:r>
+          </a:p>
+          <a:p>
+            <a:pPr algn="l">
+              <a:lnSpc>
+                <a:spcPct val="118000"/>
+              </a:lnSpc>
+              <a:spcBef>
+                <a:spcPts val="0"/>
+              </a:spcBef>
+              <a:spcAft>
+                <a:spcPts val="200"/>
+              </a:spcAft>
+            </a:pPr>
+            <a:r>
+              <a:rPr sz="1500" b="1">
+                <a:solidFill>
+                  <a:srgbClr val="1A1A1A"/>
+                </a:solidFill>
+                <a:latin typeface="Manrope"/>
+                <a:rFonts ascii="Manrope" hAnsi="Manrope" cs="Manrope" eastAsia="Manrope"/>
+              </a:rPr>
+              <a:t>Проводник</a:t>
+            </a:r>
+          </a:p>
+          <a:p>
+            <a:pPr algn="l">
+              <a:lnSpc>
+                <a:spcPct val="118000"/>
+              </a:lnSpc>
+              <a:spcBef>
+                <a:spcPts val="0"/>
+              </a:spcBef>
+              <a:spcAft>
+                <a:spcPts val="1000"/>
               </a:spcAft>
             </a:pPr>
             <a:r>
@@ -9285,51 +9467,53 @@
                 <a:latin typeface="Golos Text"/>
                 <a:rFonts ascii="Golos Text" hAnsi="Golos Text" cs="Golos Text" eastAsia="Golos Text"/>
               </a:rPr>
-              <a:t>• Блок «простыми словами» на этикетке</a:t>
-            </a:r>
-          </a:p>
-        </p:txBody>
-      </p:sp>
-      <p:sp>
-        <p:nvSpPr>
-          <p:cNvPr id="14" name="TextBox 13"/>
-          <p:cNvSpPr txBox="1"/>
-          <p:nvPr/>
-        </p:nvSpPr>
-        <p:spPr>
-          <a:xfrm>
-            <a:off x="6571335" y="1426464"/>
-            <a:ext cx="4815687" cy="4334256"/>
-          </a:xfrm>
-          <a:prstGeom prst="rect">
-            <a:avLst/>
-          </a:prstGeom>
-          <a:noFill/>
-        </p:spPr>
-        <p:txBody>
-          <a:bodyPr wrap="square" anchor="t" lIns="50800" rIns="50800" tIns="25400" bIns="25400"/>
-          <a:lstStyle/>
-          <a:p>
-            <a:pPr algn="l">
-              <a:lnSpc>
-                <a:spcPct val="118000"/>
-              </a:lnSpc>
-              <a:spcBef>
-                <a:spcPts val="0"/>
-              </a:spcBef>
-              <a:spcAft>
-                <a:spcPts val="1200"/>
+              <a:t>Travel+ Natural — своя линейка и один договор на номер</a:t>
+            </a:r>
+          </a:p>
+          <a:p>
+            <a:pPr algn="l">
+              <a:lnSpc>
+                <a:spcPct val="118000"/>
+              </a:lnSpc>
+              <a:spcBef>
+                <a:spcPts val="0"/>
+              </a:spcBef>
+              <a:spcAft>
+                <a:spcPts val="200"/>
               </a:spcAft>
             </a:pPr>
             <a:r>
               <a:rPr sz="1500" b="1">
                 <a:solidFill>
-                  <a:srgbClr val="2A554A"/>
+                  <a:srgbClr val="1A1A1A"/>
                 </a:solidFill>
                 <a:latin typeface="Manrope"/>
                 <a:rFonts ascii="Manrope" hAnsi="Manrope" cs="Manrope" eastAsia="Manrope"/>
               </a:rPr>
-              <a:t>BrandScript</a:t>
+              <a:t>План</a:t>
+            </a:r>
+          </a:p>
+          <a:p>
+            <a:pPr algn="l">
+              <a:lnSpc>
+                <a:spcPct val="118000"/>
+              </a:lnSpc>
+              <a:spcBef>
+                <a:spcPts val="0"/>
+              </a:spcBef>
+              <a:spcAft>
+                <a:spcPts val="1000"/>
+              </a:spcAft>
+            </a:pPr>
+            <a:r>
+              <a:rPr sz="1500" b="0">
+                <a:solidFill>
+                  <a:srgbClr val="1A1A1A"/>
+                </a:solidFill>
+                <a:latin typeface="Golos Text"/>
+                <a:rFonts ascii="Golos Text" hAnsi="Golos Text" cs="Golos Text" eastAsia="Golos Text"/>
+              </a:rPr>
+              <a:t>Сегмент → образец с документами → пилот на этаже</a:t>
             </a:r>
           </a:p>
           <a:p>
@@ -9352,19 +9536,19 @@
                 <a:latin typeface="Manrope"/>
                 <a:rFonts ascii="Manrope" hAnsi="Manrope" cs="Manrope" eastAsia="Manrope"/>
               </a:rPr>
-              <a:t>Герой</a:t>
-            </a:r>
-          </a:p>
-          <a:p>
-            <a:pPr algn="l">
-              <a:lnSpc>
-                <a:spcPct val="118000"/>
-              </a:lnSpc>
-              <a:spcBef>
-                <a:spcPts val="0"/>
-              </a:spcBef>
-              <a:spcAft>
-                <a:spcPts val="800"/>
+              <a:t>Гость</a:t>
+            </a:r>
+          </a:p>
+          <a:p>
+            <a:pPr algn="l">
+              <a:lnSpc>
+                <a:spcPct val="118000"/>
+              </a:lnSpc>
+              <a:spcBef>
+                <a:spcPts val="0"/>
+              </a:spcBef>
+              <a:spcAft>
+                <a:spcPts val="0"/>
               </a:spcAft>
             </a:pPr>
             <a:r>
@@ -9375,214 +9559,7 @@
                 <a:latin typeface="Golos Text"/>
                 <a:rFonts ascii="Golos Text" hAnsi="Golos Text" cs="Golos Text" eastAsia="Golos Text"/>
               </a:rPr>
-              <a:t>Закупщик отеля с запросом eco / wellness: выглядеть «зеленее» без дыры в бюджете и в бумагах.</a:t>
-            </a:r>
-          </a:p>
-          <a:p>
-            <a:pPr algn="l">
-              <a:lnSpc>
-                <a:spcPct val="118000"/>
-              </a:lnSpc>
-              <a:spcBef>
-                <a:spcPts val="0"/>
-              </a:spcBef>
-              <a:spcAft>
-                <a:spcPts val="200"/>
-              </a:spcAft>
-            </a:pPr>
-            <a:r>
-              <a:rPr sz="1500" b="1">
-                <a:solidFill>
-                  <a:srgbClr val="1A1A1A"/>
-                </a:solidFill>
-                <a:latin typeface="Manrope"/>
-                <a:rFonts ascii="Manrope" hAnsi="Manrope" cs="Manrope" eastAsia="Manrope"/>
-              </a:rPr>
-              <a:t>Проводник</a:t>
-            </a:r>
-          </a:p>
-          <a:p>
-            <a:pPr algn="l">
-              <a:lnSpc>
-                <a:spcPct val="118000"/>
-              </a:lnSpc>
-              <a:spcBef>
-                <a:spcPts val="0"/>
-              </a:spcBef>
-              <a:spcAft>
-                <a:spcPts val="800"/>
-              </a:spcAft>
-            </a:pPr>
-            <a:r>
-              <a:rPr sz="1500" b="0">
-                <a:solidFill>
-                  <a:srgbClr val="1A1A1A"/>
-                </a:solidFill>
-                <a:latin typeface="Golos Text"/>
-                <a:rFonts ascii="Golos Text" hAnsi="Golos Text" cs="Golos Text" eastAsia="Golos Text"/>
-              </a:rPr>
-              <a:t>Travel+ Natural — своя линейка, документы и one-stop на номер.</a:t>
-            </a:r>
-          </a:p>
-          <a:p>
-            <a:pPr algn="l">
-              <a:lnSpc>
-                <a:spcPct val="118000"/>
-              </a:lnSpc>
-              <a:spcBef>
-                <a:spcPts val="0"/>
-              </a:spcBef>
-              <a:spcAft>
-                <a:spcPts val="200"/>
-              </a:spcAft>
-            </a:pPr>
-            <a:r>
-              <a:rPr sz="1500" b="1">
-                <a:solidFill>
-                  <a:srgbClr val="1A1A1A"/>
-                </a:solidFill>
-                <a:latin typeface="Manrope"/>
-                <a:rFonts ascii="Manrope" hAnsi="Manrope" cs="Manrope" eastAsia="Manrope"/>
-              </a:rPr>
-              <a:t>План</a:t>
-            </a:r>
-          </a:p>
-          <a:p>
-            <a:pPr algn="l">
-              <a:lnSpc>
-                <a:spcPct val="118000"/>
-              </a:lnSpc>
-              <a:spcBef>
-                <a:spcPts val="0"/>
-              </a:spcBef>
-              <a:spcAft>
-                <a:spcPts val="600"/>
-              </a:spcAft>
-            </a:pPr>
-            <a:r>
-              <a:rPr sz="1500" b="0">
-                <a:solidFill>
-                  <a:srgbClr val="1A1A1A"/>
-                </a:solidFill>
-                <a:latin typeface="Golos Text"/>
-                <a:rFonts ascii="Golos Text" hAnsi="Golos Text" cs="Golos Text" eastAsia="Golos Text"/>
-              </a:rPr>
-              <a:t>1. Согласовать сегмент и объект</a:t>
-            </a:r>
-          </a:p>
-          <a:p>
-            <a:pPr algn="l">
-              <a:lnSpc>
-                <a:spcPct val="118000"/>
-              </a:lnSpc>
-              <a:spcBef>
-                <a:spcPts val="0"/>
-              </a:spcBef>
-              <a:spcAft>
-                <a:spcPts val="600"/>
-              </a:spcAft>
-            </a:pPr>
-            <a:r>
-              <a:rPr sz="1500" b="0">
-                <a:solidFill>
-                  <a:srgbClr val="1A1A1A"/>
-                </a:solidFill>
-                <a:latin typeface="Golos Text"/>
-                <a:rFonts ascii="Golos Text" hAnsi="Golos Text" cs="Golos Text" eastAsia="Golos Text"/>
-              </a:rPr>
-              <a:t>2. Образец с этикеткой и пакетом документов</a:t>
-            </a:r>
-          </a:p>
-          <a:p>
-            <a:pPr algn="l">
-              <a:lnSpc>
-                <a:spcPct val="118000"/>
-              </a:lnSpc>
-              <a:spcBef>
-                <a:spcPts val="0"/>
-              </a:spcBef>
-              <a:spcAft>
-                <a:spcPts val="1000"/>
-              </a:spcAft>
-            </a:pPr>
-            <a:r>
-              <a:rPr sz="1500" b="0">
-                <a:solidFill>
-                  <a:srgbClr val="1A1A1A"/>
-                </a:solidFill>
-                <a:latin typeface="Golos Text"/>
-                <a:rFonts ascii="Golos Text" hAnsi="Golos Text" cs="Golos Text" eastAsia="Golos Text"/>
-              </a:rPr>
-              <a:t>3. Пилот на этаже или в корпусе</a:t>
-            </a:r>
-          </a:p>
-          <a:p>
-            <a:pPr algn="l">
-              <a:lnSpc>
-                <a:spcPct val="118000"/>
-              </a:lnSpc>
-              <a:spcBef>
-                <a:spcPts val="0"/>
-              </a:spcBef>
-              <a:spcAft>
-                <a:spcPts val="400"/>
-              </a:spcAft>
-            </a:pPr>
-            <a:r>
-              <a:rPr sz="1400" b="0">
-                <a:solidFill>
-                  <a:srgbClr val="5C5C5C"/>
-                </a:solidFill>
-                <a:latin typeface="Golos Text"/>
-                <a:rFonts ascii="Golos Text" hAnsi="Golos Text" cs="Golos Text" eastAsia="Golos Text"/>
-              </a:rPr>
-              <a:t>Гость после дороги:</a:t>
-            </a:r>
-          </a:p>
-          <a:p>
-            <a:pPr algn="l">
-              <a:lnSpc>
-                <a:spcPct val="118000"/>
-              </a:lnSpc>
-              <a:spcBef>
-                <a:spcPts val="0"/>
-              </a:spcBef>
-              <a:spcAft>
-                <a:spcPts val="200"/>
-              </a:spcAft>
-            </a:pPr>
-            <a:r>
-              <a:rPr sz="1500" b="1">
-                <a:solidFill>
-                  <a:srgbClr val="1A1A1A"/>
-                </a:solidFill>
-                <a:latin typeface="Manrope"/>
-                <a:rFonts ascii="Manrope" hAnsi="Manrope" cs="Manrope" eastAsia="Manrope"/>
-              </a:rPr>
-              <a:t>Ощущение мягче, чем ожидал.</a:t>
-            </a:r>
-          </a:p>
-          <a:p>
-            <a:pPr algn="l">
-              <a:lnSpc>
-                <a:spcPct val="118000"/>
-              </a:lnSpc>
-              <a:spcBef>
-                <a:spcPts val="0"/>
-              </a:spcBef>
-              <a:spcAft>
-                <a:spcPts val="600"/>
-              </a:spcAft>
-            </a:pPr>
-            <a:r>
-              <a:rPr sz="1500" b="0">
-                <a:solidFill>
-                  <a:srgbClr val="1A1A1A"/>
-                </a:solidFill>
-                <a:latin typeface="Golos Text"/>
-                <a:rFonts ascii="Golos Text" hAnsi="Golos Text" cs="Golos Text" eastAsia="Golos Text"/>
-              </a:rPr>
-              <a:t>Понятная натуральность — без громких обещаний на этикетке.</a:t>
+              <a:t>После дороги — мягче, чем ожидал; натуральность без громких обещаний</a:t>
             </a:r>
           </a:p>
         </p:txBody>

</xml_diff>

<commit_message>
fix(presentation): slide 7 footnote inside card bottom, labeled pitch
Co-authored-by: pagasbot-coder <pagasbot-coder@users.noreply.github.com>
</commit_message>
<xml_diff>
--- a/knowledge-base/presentation-travelplus-interview.pptx
+++ b/knowledge-base/presentation-travelplus-interview.pptx
@@ -10079,19 +10079,42 @@
                 <a:latin typeface="Manrope"/>
                 <a:rFonts ascii="Manrope" hAnsi="Manrope" cs="Manrope" eastAsia="Manrope"/>
               </a:rPr>
-              <a:t>Чеклист: без этого — не в продажи</a:t>
-            </a:r>
-          </a:p>
-          <a:p>
-            <a:pPr algn="l">
-              <a:lnSpc>
-                <a:spcPct val="118000"/>
-              </a:lnSpc>
-              <a:spcBef>
-                <a:spcPts val="0"/>
-              </a:spcBef>
-              <a:spcAft>
-                <a:spcPts val="600"/>
+              <a:t>Чеклист</a:t>
+            </a:r>
+          </a:p>
+          <a:p>
+            <a:pPr algn="l">
+              <a:lnSpc>
+                <a:spcPct val="118000"/>
+              </a:lnSpc>
+              <a:spcBef>
+                <a:spcPts val="0"/>
+              </a:spcBef>
+              <a:spcAft>
+                <a:spcPts val="200"/>
+              </a:spcAft>
+            </a:pPr>
+            <a:r>
+              <a:rPr sz="1500" b="1">
+                <a:solidFill>
+                  <a:srgbClr val="1A1A1A"/>
+                </a:solidFill>
+                <a:latin typeface="Manrope"/>
+                <a:rFonts ascii="Manrope" hAnsi="Manrope" cs="Manrope" eastAsia="Manrope"/>
+              </a:rPr>
+              <a:t>Натуральность</a:t>
+            </a:r>
+          </a:p>
+          <a:p>
+            <a:pPr algn="l">
+              <a:lnSpc>
+                <a:spcPct val="118000"/>
+              </a:lnSpc>
+              <a:spcBef>
+                <a:spcPts val="0"/>
+              </a:spcBef>
+              <a:spcAft>
+                <a:spcPts val="800"/>
               </a:spcAft>
             </a:pPr>
             <a:r>
@@ -10102,19 +10125,42 @@
                 <a:latin typeface="Golos Text"/>
                 <a:rFonts ascii="Golos Text" hAnsi="Golos Text" cs="Golos Text" eastAsia="Golos Text"/>
               </a:rPr>
-              <a:t>□ Метод расчёта и доля натуральных ингредиентов</a:t>
-            </a:r>
-          </a:p>
-          <a:p>
-            <a:pPr algn="l">
-              <a:lnSpc>
-                <a:spcPct val="118000"/>
-              </a:lnSpc>
-              <a:spcBef>
-                <a:spcPts val="0"/>
-              </a:spcBef>
-              <a:spcAft>
-                <a:spcPts val="600"/>
+              <a:t>Метод расчёта и доля ингредиентов</a:t>
+            </a:r>
+          </a:p>
+          <a:p>
+            <a:pPr algn="l">
+              <a:lnSpc>
+                <a:spcPct val="118000"/>
+              </a:lnSpc>
+              <a:spcBef>
+                <a:spcPts val="0"/>
+              </a:spcBef>
+              <a:spcAft>
+                <a:spcPts val="200"/>
+              </a:spcAft>
+            </a:pPr>
+            <a:r>
+              <a:rPr sz="1500" b="1">
+                <a:solidFill>
+                  <a:srgbClr val="1A1A1A"/>
+                </a:solidFill>
+                <a:latin typeface="Manrope"/>
+                <a:rFonts ascii="Manrope" hAnsi="Manrope" cs="Manrope" eastAsia="Manrope"/>
+              </a:rPr>
+              <a:t>Документы</a:t>
+            </a:r>
+          </a:p>
+          <a:p>
+            <a:pPr algn="l">
+              <a:lnSpc>
+                <a:spcPct val="118000"/>
+              </a:lnSpc>
+              <a:spcBef>
+                <a:spcPts val="0"/>
+              </a:spcBef>
+              <a:spcAft>
+                <a:spcPts val="800"/>
               </a:spcAft>
             </a:pPr>
             <a:r>
@@ -10125,19 +10171,42 @@
                 <a:latin typeface="Golos Text"/>
                 <a:rFonts ascii="Golos Text" hAnsi="Golos Text" cs="Golos Text" eastAsia="Golos Text"/>
               </a:rPr>
-              <a:t>□ Пакет документов как у Hotel Line и Fleur + лист состава Natural</a:t>
-            </a:r>
-          </a:p>
-          <a:p>
-            <a:pPr algn="l">
-              <a:lnSpc>
-                <a:spcPct val="118000"/>
-              </a:lnSpc>
-              <a:spcBef>
-                <a:spcPts val="0"/>
-              </a:spcBef>
-              <a:spcAft>
-                <a:spcPts val="600"/>
+              <a:t>Пакет как у Hotel Line и Fleur + лист состава Natural</a:t>
+            </a:r>
+          </a:p>
+          <a:p>
+            <a:pPr algn="l">
+              <a:lnSpc>
+                <a:spcPct val="118000"/>
+              </a:lnSpc>
+              <a:spcBef>
+                <a:spcPts val="0"/>
+              </a:spcBef>
+              <a:spcAft>
+                <a:spcPts val="200"/>
+              </a:spcAft>
+            </a:pPr>
+            <a:r>
+              <a:rPr sz="1500" b="1">
+                <a:solidFill>
+                  <a:srgbClr val="1A1A1A"/>
+                </a:solidFill>
+                <a:latin typeface="Manrope"/>
+                <a:rFonts ascii="Manrope" hAnsi="Manrope" cs="Manrope" eastAsia="Manrope"/>
+              </a:rPr>
+              <a:t>Происхождение</a:t>
+            </a:r>
+          </a:p>
+          <a:p>
+            <a:pPr algn="l">
+              <a:lnSpc>
+                <a:spcPct val="118000"/>
+              </a:lnSpc>
+              <a:spcBef>
+                <a:spcPts val="0"/>
+              </a:spcBef>
+              <a:spcAft>
+                <a:spcPts val="800"/>
               </a:spcAft>
             </a:pPr>
             <a:r>
@@ -10148,19 +10217,42 @@
                 <a:latin typeface="Golos Text"/>
                 <a:rFonts ascii="Golos Text" hAnsi="Golos Text" cs="Golos Text" eastAsia="Golos Text"/>
               </a:rPr>
-              <a:t>□ Происхождение (origin) зафиксировано письменно</a:t>
-            </a:r>
-          </a:p>
-          <a:p>
-            <a:pPr algn="l">
-              <a:lnSpc>
-                <a:spcPct val="118000"/>
-              </a:lnSpc>
-              <a:spcBef>
-                <a:spcPts val="0"/>
-              </a:spcBef>
-              <a:spcAft>
-                <a:spcPts val="600"/>
+              <a:t>Origin зафиксирован письменно</a:t>
+            </a:r>
+          </a:p>
+          <a:p>
+            <a:pPr algn="l">
+              <a:lnSpc>
+                <a:spcPct val="118000"/>
+              </a:lnSpc>
+              <a:spcBef>
+                <a:spcPts val="0"/>
+              </a:spcBef>
+              <a:spcAft>
+                <a:spcPts val="200"/>
+              </a:spcAft>
+            </a:pPr>
+            <a:r>
+              <a:rPr sz="1500" b="1">
+                <a:solidFill>
+                  <a:srgbClr val="1A1A1A"/>
+                </a:solidFill>
+                <a:latin typeface="Manrope"/>
+                <a:rFonts ascii="Manrope" hAnsi="Manrope" cs="Manrope" eastAsia="Manrope"/>
+              </a:rPr>
+              <a:t>Тест</a:t>
+            </a:r>
+          </a:p>
+          <a:p>
+            <a:pPr algn="l">
+              <a:lnSpc>
+                <a:spcPct val="118000"/>
+              </a:lnSpc>
+              <a:spcBef>
+                <a:spcPts val="0"/>
+              </a:spcBef>
+              <a:spcAft>
+                <a:spcPts val="800"/>
               </a:spcAft>
             </a:pPr>
             <a:r>
@@ -10171,19 +10263,42 @@
                 <a:latin typeface="Golos Text"/>
                 <a:rFonts ascii="Golos Text" hAnsi="Golos Text" cs="Golos Text" eastAsia="Golos Text"/>
               </a:rPr>
-              <a:t>□ Слепой тест запаха и ощущения с гостями</a:t>
-            </a:r>
-          </a:p>
-          <a:p>
-            <a:pPr algn="l">
-              <a:lnSpc>
-                <a:spcPct val="118000"/>
-              </a:lnSpc>
-              <a:spcBef>
-                <a:spcPts val="0"/>
-              </a:spcBef>
-              <a:spcAft>
-                <a:spcPts val="600"/>
+              <a:t>Слепой тест запаха и ощущения с гостями</a:t>
+            </a:r>
+          </a:p>
+          <a:p>
+            <a:pPr algn="l">
+              <a:lnSpc>
+                <a:spcPct val="118000"/>
+              </a:lnSpc>
+              <a:spcBef>
+                <a:spcPts val="0"/>
+              </a:spcBef>
+              <a:spcAft>
+                <a:spcPts val="200"/>
+              </a:spcAft>
+            </a:pPr>
+            <a:r>
+              <a:rPr sz="1500" b="1">
+                <a:solidFill>
+                  <a:srgbClr val="1A1A1A"/>
+                </a:solidFill>
+                <a:latin typeface="Manrope"/>
+                <a:rFonts ascii="Manrope" hAnsi="Manrope" cs="Manrope" eastAsia="Manrope"/>
+              </a:rPr>
+              <a:t>Этикетка</a:t>
+            </a:r>
+          </a:p>
+          <a:p>
+            <a:pPr algn="l">
+              <a:lnSpc>
+                <a:spcPct val="118000"/>
+              </a:lnSpc>
+              <a:spcBef>
+                <a:spcPts val="0"/>
+              </a:spcBef>
+              <a:spcAft>
+                <a:spcPts val="800"/>
               </a:spcAft>
             </a:pPr>
             <a:r>
@@ -10194,19 +10309,42 @@
                 <a:latin typeface="Golos Text"/>
                 <a:rFonts ascii="Golos Text" hAnsi="Golos Text" cs="Golos Text" eastAsia="Golos Text"/>
               </a:rPr>
-              <a:t>□ Этикетка с блоком «простыми словами»</a:t>
-            </a:r>
-          </a:p>
-          <a:p>
-            <a:pPr algn="l">
-              <a:lnSpc>
-                <a:spcPct val="118000"/>
-              </a:lnSpc>
-              <a:spcBef>
-                <a:spcPts val="0"/>
-              </a:spcBef>
-              <a:spcAft>
-                <a:spcPts val="600"/>
+              <a:t>Блок «простыми словами»</a:t>
+            </a:r>
+          </a:p>
+          <a:p>
+            <a:pPr algn="l">
+              <a:lnSpc>
+                <a:spcPct val="118000"/>
+              </a:lnSpc>
+              <a:spcBef>
+                <a:spcPts val="0"/>
+              </a:spcBef>
+              <a:spcAft>
+                <a:spcPts val="200"/>
+              </a:spcAft>
+            </a:pPr>
+            <a:r>
+              <a:rPr sz="1500" b="1">
+                <a:solidFill>
+                  <a:srgbClr val="1A1A1A"/>
+                </a:solidFill>
+                <a:latin typeface="Manrope"/>
+                <a:rFonts ascii="Manrope" hAnsi="Manrope" cs="Manrope" eastAsia="Manrope"/>
+              </a:rPr>
+              <a:t>Экономика</a:t>
+            </a:r>
+          </a:p>
+          <a:p>
+            <a:pPr algn="l">
+              <a:lnSpc>
+                <a:spcPct val="118000"/>
+              </a:lnSpc>
+              <a:spcBef>
+                <a:spcPts val="0"/>
+              </a:spcBef>
+              <a:spcAft>
+                <a:spcPts val="800"/>
               </a:spcAft>
             </a:pPr>
             <a:r>
@@ -10217,19 +10355,42 @@
                 <a:latin typeface="Golos Text"/>
                 <a:rFonts ascii="Golos Text" hAnsi="Golos Text" cs="Golos Text" eastAsia="Golos Text"/>
               </a:rPr>
-              <a:t>□ Себестоимость и коридор цены на полке</a:t>
-            </a:r>
-          </a:p>
-          <a:p>
-            <a:pPr algn="l">
-              <a:lnSpc>
-                <a:spcPct val="118000"/>
-              </a:lnSpc>
-              <a:spcBef>
-                <a:spcPts val="0"/>
-              </a:spcBef>
-              <a:spcAft>
-                <a:spcPts val="600"/>
+              <a:t>Себестоимость и коридор цены на полке</a:t>
+            </a:r>
+          </a:p>
+          <a:p>
+            <a:pPr algn="l">
+              <a:lnSpc>
+                <a:spcPct val="118000"/>
+              </a:lnSpc>
+              <a:spcBef>
+                <a:spcPts val="0"/>
+              </a:spcBef>
+              <a:spcAft>
+                <a:spcPts val="200"/>
+              </a:spcAft>
+            </a:pPr>
+            <a:r>
+              <a:rPr sz="1500" b="1">
+                <a:solidFill>
+                  <a:srgbClr val="1A1A1A"/>
+                </a:solidFill>
+                <a:latin typeface="Manrope"/>
+                <a:rFonts ascii="Manrope" hAnsi="Manrope" cs="Manrope" eastAsia="Manrope"/>
+              </a:rPr>
+              <a:t>Поставка</a:t>
+            </a:r>
+          </a:p>
+          <a:p>
+            <a:pPr algn="l">
+              <a:lnSpc>
+                <a:spcPct val="118000"/>
+              </a:lnSpc>
+              <a:spcBef>
+                <a:spcPts val="0"/>
+              </a:spcBef>
+              <a:spcAft>
+                <a:spcPts val="0"/>
               </a:spcAft>
             </a:pPr>
             <a:r>
@@ -10240,7 +10401,7 @@
                 <a:latin typeface="Golos Text"/>
                 <a:rFonts ascii="Golos Text" hAnsi="Golos Text" cs="Golos Text" eastAsia="Golos Text"/>
               </a:rPr>
-              <a:t>□ Срок поставки, минимальный заказ, правила брака</a:t>
+              <a:t>Срок, минимальный заказ, правила брака</a:t>
             </a:r>
           </a:p>
         </p:txBody>
@@ -10284,19 +10445,42 @@
                 <a:latin typeface="Manrope"/>
                 <a:rFonts ascii="Manrope" hAnsi="Manrope" cs="Manrope" eastAsia="Manrope"/>
               </a:rPr>
-              <a:t>Как читать список</a:t>
-            </a:r>
-          </a:p>
-          <a:p>
-            <a:pPr algn="l">
-              <a:lnSpc>
-                <a:spcPct val="118000"/>
-              </a:lnSpc>
-              <a:spcBef>
-                <a:spcPts val="0"/>
-              </a:spcBef>
-              <a:spcAft>
-                <a:spcPts val="600"/>
+              <a:t>Как читать</a:t>
+            </a:r>
+          </a:p>
+          <a:p>
+            <a:pPr algn="l">
+              <a:lnSpc>
+                <a:spcPct val="118000"/>
+              </a:lnSpc>
+              <a:spcBef>
+                <a:spcPts val="0"/>
+              </a:spcBef>
+              <a:spcAft>
+                <a:spcPts val="200"/>
+              </a:spcAft>
+            </a:pPr>
+            <a:r>
+              <a:rPr sz="1500" b="1">
+                <a:solidFill>
+                  <a:srgbClr val="1A1A1A"/>
+                </a:solidFill>
+                <a:latin typeface="Manrope"/>
+                <a:rFonts ascii="Manrope" hAnsi="Manrope" cs="Manrope" eastAsia="Manrope"/>
+              </a:rPr>
+              <a:t>Правило</a:t>
+            </a:r>
+          </a:p>
+          <a:p>
+            <a:pPr algn="l">
+              <a:lnSpc>
+                <a:spcPct val="118000"/>
+              </a:lnSpc>
+              <a:spcBef>
+                <a:spcPts val="0"/>
+              </a:spcBef>
+              <a:spcAft>
+                <a:spcPts val="1000"/>
               </a:spcAft>
             </a:pPr>
             <a:r>
@@ -10307,19 +10491,42 @@
                 <a:latin typeface="Golos Text"/>
                 <a:rFonts ascii="Golos Text" hAnsi="Golos Text" cs="Golos Text" eastAsia="Golos Text"/>
               </a:rPr>
-              <a:t>Каждый пункт — обязательное условие.</a:t>
-            </a:r>
-          </a:p>
-          <a:p>
-            <a:pPr algn="l">
-              <a:lnSpc>
-                <a:spcPct val="118000"/>
-              </a:lnSpc>
-              <a:spcBef>
-                <a:spcPts val="0"/>
-              </a:spcBef>
-              <a:spcAft>
-                <a:spcPts val="600"/>
+              <a:t>Каждый пункт обязателен; пока не закрыт — в продажи и на витрину не выходим</a:t>
+            </a:r>
+          </a:p>
+          <a:p>
+            <a:pPr algn="l">
+              <a:lnSpc>
+                <a:spcPct val="118000"/>
+              </a:lnSpc>
+              <a:spcBef>
+                <a:spcPts val="0"/>
+              </a:spcBef>
+              <a:spcAft>
+                <a:spcPts val="200"/>
+              </a:spcAft>
+            </a:pPr>
+            <a:r>
+              <a:rPr sz="1500" b="1">
+                <a:solidFill>
+                  <a:srgbClr val="1A1A1A"/>
+                </a:solidFill>
+                <a:latin typeface="Manrope"/>
+                <a:rFonts ascii="Manrope" hAnsi="Manrope" cs="Manrope" eastAsia="Manrope"/>
+              </a:rPr>
+              <a:t>COSMOS</a:t>
+            </a:r>
+          </a:p>
+          <a:p>
+            <a:pPr algn="l">
+              <a:lnSpc>
+                <a:spcPct val="118000"/>
+              </a:lnSpc>
+              <a:spcBef>
+                <a:spcPts val="0"/>
+              </a:spcBef>
+              <a:spcAft>
+                <a:spcPts val="0"/>
               </a:spcAft>
             </a:pPr>
             <a:r>
@@ -10330,76 +10537,7 @@
                 <a:latin typeface="Golos Text"/>
                 <a:rFonts ascii="Golos Text" hAnsi="Golos Text" cs="Golos Text" eastAsia="Golos Text"/>
               </a:rPr>
-              <a:t>Пока хотя бы один не закрыт — коммерческое предложение и выход на витрину стоп.</a:t>
-            </a:r>
-          </a:p>
-          <a:p>
-            <a:pPr algn="l">
-              <a:lnSpc>
-                <a:spcPct val="118000"/>
-              </a:lnSpc>
-              <a:spcBef>
-                <a:spcPts val="0"/>
-              </a:spcBef>
-              <a:spcAft>
-                <a:spcPts val="1000"/>
-              </a:spcAft>
-            </a:pPr>
-            <a:r>
-              <a:rPr sz="1500" b="0">
-                <a:solidFill>
-                  <a:srgbClr val="1A1A1A"/>
-                </a:solidFill>
-                <a:latin typeface="Golos Text"/>
-                <a:rFonts ascii="Golos Text" hAnsi="Golos Text" cs="Golos Text" eastAsia="Golos Text"/>
-              </a:rPr>
-              <a:t>На старте без знака COSMOS, если его нет — говорим честно.</a:t>
-            </a:r>
-          </a:p>
-          <a:p>
-            <a:pPr algn="l">
-              <a:lnSpc>
-                <a:spcPct val="118000"/>
-              </a:lnSpc>
-              <a:spcBef>
-                <a:spcPts val="0"/>
-              </a:spcBef>
-              <a:spcAft>
-                <a:spcPts val="200"/>
-              </a:spcAft>
-            </a:pPr>
-            <a:r>
-              <a:rPr sz="1500" b="1">
-                <a:solidFill>
-                  <a:srgbClr val="1A1A1A"/>
-                </a:solidFill>
-                <a:latin typeface="Manrope"/>
-                <a:rFonts ascii="Manrope" hAnsi="Manrope" cs="Manrope" eastAsia="Manrope"/>
-              </a:rPr>
-              <a:t>Этапы 3–6 в пульте — учебный сценарий,</a:t>
-            </a:r>
-          </a:p>
-          <a:p>
-            <a:pPr algn="l">
-              <a:lnSpc>
-                <a:spcPct val="118000"/>
-              </a:lnSpc>
-              <a:spcBef>
-                <a:spcPts val="0"/>
-              </a:spcBef>
-              <a:spcAft>
-                <a:spcPts val="600"/>
-              </a:spcAft>
-            </a:pPr>
-            <a:r>
-              <a:rPr sz="1500" b="0">
-                <a:solidFill>
-                  <a:srgbClr val="1A1A1A"/>
-                </a:solidFill>
-                <a:latin typeface="Golos Text"/>
-                <a:rFonts ascii="Golos Text" hAnsi="Golos Text" cs="Golos Text" eastAsia="Golos Text"/>
-              </a:rPr>
-              <a:t>а не отчёт завода и не основание для КП.</a:t>
+              <a:t>Знака нет — говорим честно, не обещаем сертификат</a:t>
             </a:r>
           </a:p>
         </p:txBody>

</xml_diff>

<commit_message>
content(presentation): slides 8-12 labeled theses, footnotes in blocks
Co-authored-by: pagasbot-coder <pagasbot-coder@users.noreply.github.com>
</commit_message>
<xml_diff>
--- a/knowledge-base/presentation-travelplus-interview.pptx
+++ b/knowledge-base/presentation-travelplus-interview.pptx
@@ -3969,19 +3969,42 @@
                 <a:latin typeface="Manrope"/>
                 <a:rFonts ascii="Manrope" hAnsi="Manrope" cs="Manrope" eastAsia="Manrope"/>
               </a:rPr>
-              <a:t>Экономика и цена</a:t>
-            </a:r>
-          </a:p>
-          <a:p>
-            <a:pPr algn="l">
-              <a:lnSpc>
-                <a:spcPct val="118000"/>
-              </a:lnSpc>
-              <a:spcBef>
-                <a:spcPts val="0"/>
-              </a:spcBef>
-              <a:spcAft>
-                <a:spcPts val="600"/>
+              <a:t>Экономика</a:t>
+            </a:r>
+          </a:p>
+          <a:p>
+            <a:pPr algn="l">
+              <a:lnSpc>
+                <a:spcPct val="118000"/>
+              </a:lnSpc>
+              <a:spcBef>
+                <a:spcPts val="0"/>
+              </a:spcBef>
+              <a:spcAft>
+                <a:spcPts val="200"/>
+              </a:spcAft>
+            </a:pPr>
+            <a:r>
+              <a:rPr sz="1500" b="1">
+                <a:solidFill>
+                  <a:srgbClr val="1A1A1A"/>
+                </a:solidFill>
+                <a:latin typeface="Manrope"/>
+                <a:rFonts ascii="Manrope" hAnsi="Manrope" cs="Manrope" eastAsia="Manrope"/>
+              </a:rPr>
+              <a:t>Прайс</a:t>
+            </a:r>
+          </a:p>
+          <a:p>
+            <a:pPr algn="l">
+              <a:lnSpc>
+                <a:spcPct val="118000"/>
+              </a:lnSpc>
+              <a:spcBef>
+                <a:spcPts val="0"/>
+              </a:spcBef>
+              <a:spcAft>
+                <a:spcPts val="1000"/>
               </a:spcAft>
             </a:pPr>
             <a:r>
@@ -3992,19 +4015,42 @@
                 <a:latin typeface="Golos Text"/>
                 <a:rFonts ascii="Golos Text" hAnsi="Golos Text" cs="Golos Text" eastAsia="Golos Text"/>
               </a:rPr>
-              <a:t>Прайс утверждаем только после себестоимости на складе в Киришах.</a:t>
-            </a:r>
-          </a:p>
-          <a:p>
-            <a:pPr algn="l">
-              <a:lnSpc>
-                <a:spcPct val="118000"/>
-              </a:lnSpc>
-              <a:spcBef>
-                <a:spcPts val="0"/>
-              </a:spcBef>
-              <a:spcAft>
-                <a:spcPts val="400"/>
+              <a:t>Только после себестоимости на складе в Киришах</a:t>
+            </a:r>
+          </a:p>
+          <a:p>
+            <a:pPr algn="l">
+              <a:lnSpc>
+                <a:spcPct val="118000"/>
+              </a:lnSpc>
+              <a:spcBef>
+                <a:spcPts val="0"/>
+              </a:spcBef>
+              <a:spcAft>
+                <a:spcPts val="200"/>
+              </a:spcAft>
+            </a:pPr>
+            <a:r>
+              <a:rPr sz="1500" b="1">
+                <a:solidFill>
+                  <a:srgbClr val="1A1A1A"/>
+                </a:solidFill>
+                <a:latin typeface="Manrope"/>
+                <a:rFonts ascii="Manrope" hAnsi="Manrope" cs="Manrope" eastAsia="Manrope"/>
+              </a:rPr>
+              <a:t>Hotel Line</a:t>
+            </a:r>
+          </a:p>
+          <a:p>
+            <a:pPr algn="l">
+              <a:lnSpc>
+                <a:spcPct val="118000"/>
+              </a:lnSpc>
+              <a:spcBef>
+                <a:spcPts val="0"/>
+              </a:spcBef>
+              <a:spcAft>
+                <a:spcPts val="800"/>
               </a:spcAft>
             </a:pPr>
             <a:r>
@@ -4015,19 +4061,42 @@
                 <a:latin typeface="Golos Text"/>
                 <a:rFonts ascii="Golos Text" hAnsi="Golos Text" cs="Golos Text" eastAsia="Golos Text"/>
               </a:rPr>
-              <a:t>Ориентир по полке:</a:t>
-            </a:r>
-          </a:p>
-          <a:p>
-            <a:pPr algn="l">
-              <a:lnSpc>
-                <a:spcPct val="118000"/>
-              </a:lnSpc>
-              <a:spcBef>
-                <a:spcPts val="0"/>
-              </a:spcBef>
-              <a:spcAft>
-                <a:spcPts val="600"/>
+              <a:t>Выше по цене</a:t>
+            </a:r>
+          </a:p>
+          <a:p>
+            <a:pPr algn="l">
+              <a:lnSpc>
+                <a:spcPct val="118000"/>
+              </a:lnSpc>
+              <a:spcBef>
+                <a:spcPts val="0"/>
+              </a:spcBef>
+              <a:spcAft>
+                <a:spcPts val="200"/>
+              </a:spcAft>
+            </a:pPr>
+            <a:r>
+              <a:rPr sz="1500" b="1">
+                <a:solidFill>
+                  <a:srgbClr val="1A1A1A"/>
+                </a:solidFill>
+                <a:latin typeface="Manrope"/>
+                <a:rFonts ascii="Manrope" hAnsi="Manrope" cs="Manrope" eastAsia="Manrope"/>
+              </a:rPr>
+              <a:t>ЕТС Natural</a:t>
+            </a:r>
+          </a:p>
+          <a:p>
+            <a:pPr algn="l">
+              <a:lnSpc>
+                <a:spcPct val="118000"/>
+              </a:lnSpc>
+              <a:spcBef>
+                <a:spcPts val="0"/>
+              </a:spcBef>
+              <a:spcAft>
+                <a:spcPts val="800"/>
               </a:spcAft>
             </a:pPr>
             <a:r>
@@ -4038,19 +4107,42 @@
                 <a:latin typeface="Golos Text"/>
                 <a:rFonts ascii="Golos Text" hAnsi="Golos Text" cs="Golos Text" eastAsia="Golos Text"/>
               </a:rPr>
-              <a:t>• выше Hotel Line</a:t>
-            </a:r>
-          </a:p>
-          <a:p>
-            <a:pPr algn="l">
-              <a:lnSpc>
-                <a:spcPct val="118000"/>
-              </a:lnSpc>
-              <a:spcBef>
-                <a:spcPts val="0"/>
-              </a:spcBef>
-              <a:spcAft>
-                <a:spcPts val="600"/>
+              <a:t>Рядом по цене</a:t>
+            </a:r>
+          </a:p>
+          <a:p>
+            <a:pPr algn="l">
+              <a:lnSpc>
+                <a:spcPct val="118000"/>
+              </a:lnSpc>
+              <a:spcBef>
+                <a:spcPts val="0"/>
+              </a:spcBef>
+              <a:spcAft>
+                <a:spcPts val="200"/>
+              </a:spcAft>
+            </a:pPr>
+            <a:r>
+              <a:rPr sz="1500" b="1">
+                <a:solidFill>
+                  <a:srgbClr val="1A1A1A"/>
+                </a:solidFill>
+                <a:latin typeface="Manrope"/>
+                <a:rFonts ascii="Manrope" hAnsi="Manrope" cs="Manrope" eastAsia="Manrope"/>
+              </a:rPr>
+              <a:t>Natura Siberica</a:t>
+            </a:r>
+          </a:p>
+          <a:p>
+            <a:pPr algn="l">
+              <a:lnSpc>
+                <a:spcPct val="118000"/>
+              </a:lnSpc>
+              <a:spcBef>
+                <a:spcPts val="0"/>
+              </a:spcBef>
+              <a:spcAft>
+                <a:spcPts val="800"/>
               </a:spcAft>
             </a:pPr>
             <a:r>
@@ -4061,19 +4153,42 @@
                 <a:latin typeface="Golos Text"/>
                 <a:rFonts ascii="Golos Text" hAnsi="Golos Text" cs="Golos Text" eastAsia="Golos Text"/>
               </a:rPr>
-              <a:t>• рядом с ЕТС Natural</a:t>
-            </a:r>
-          </a:p>
-          <a:p>
-            <a:pPr algn="l">
-              <a:lnSpc>
-                <a:spcPct val="118000"/>
-              </a:lnSpc>
-              <a:spcBef>
-                <a:spcPts val="0"/>
-              </a:spcBef>
-              <a:spcAft>
-                <a:spcPts val="1000"/>
+              <a:t>Ниже по цене</a:t>
+            </a:r>
+          </a:p>
+          <a:p>
+            <a:pPr algn="l">
+              <a:lnSpc>
+                <a:spcPct val="118000"/>
+              </a:lnSpc>
+              <a:spcBef>
+                <a:spcPts val="0"/>
+              </a:spcBef>
+              <a:spcAft>
+                <a:spcPts val="200"/>
+              </a:spcAft>
+            </a:pPr>
+            <a:r>
+              <a:rPr sz="1500" b="1">
+                <a:solidFill>
+                  <a:srgbClr val="1A1A1A"/>
+                </a:solidFill>
+                <a:latin typeface="Manrope"/>
+                <a:rFonts ascii="Manrope" hAnsi="Manrope" cs="Manrope" eastAsia="Manrope"/>
+              </a:rPr>
+              <a:t>Стратегия</a:t>
+            </a:r>
+          </a:p>
+          <a:p>
+            <a:pPr algn="l">
+              <a:lnSpc>
+                <a:spcPct val="118000"/>
+              </a:lnSpc>
+              <a:spcBef>
+                <a:spcPts val="0"/>
+              </a:spcBef>
+              <a:spcAft>
+                <a:spcPts val="800"/>
               </a:spcAft>
             </a:pPr>
             <a:r>
@@ -4084,19 +4199,19 @@
                 <a:latin typeface="Golos Text"/>
                 <a:rFonts ascii="Golos Text" hAnsi="Golos Text" cs="Golos Text" eastAsia="Golos Text"/>
               </a:rPr>
-              <a:t>• ниже Natura Siberica</a:t>
-            </a:r>
-          </a:p>
-          <a:p>
-            <a:pPr algn="l">
-              <a:lnSpc>
-                <a:spcPct val="118000"/>
-              </a:lnSpc>
-              <a:spcBef>
-                <a:spcPts val="0"/>
-              </a:spcBef>
-              <a:spcAft>
-                <a:spcPts val="400"/>
+              <a:t>Не воюем копейкой с ЕТС</a:t>
+            </a:r>
+          </a:p>
+          <a:p>
+            <a:pPr algn="l">
+              <a:lnSpc>
+                <a:spcPct val="118000"/>
+              </a:lnSpc>
+              <a:spcBef>
+                <a:spcPts val="0"/>
+              </a:spcBef>
+              <a:spcAft>
+                <a:spcPts val="200"/>
               </a:spcAft>
             </a:pPr>
             <a:r>
@@ -4107,19 +4222,19 @@
                 <a:latin typeface="Manrope"/>
                 <a:rFonts ascii="Manrope" hAnsi="Manrope" cs="Manrope" eastAsia="Manrope"/>
               </a:rPr>
-              <a:t>Не воюем копейкой с ЕТС.</a:t>
-            </a:r>
-          </a:p>
-          <a:p>
-            <a:pPr algn="l">
-              <a:lnSpc>
-                <a:spcPct val="118000"/>
-              </a:lnSpc>
-              <a:spcBef>
-                <a:spcPts val="0"/>
-              </a:spcBef>
-              <a:spcAft>
-                <a:spcPts val="600"/>
+              <a:t>Выигрыш</a:t>
+            </a:r>
+          </a:p>
+          <a:p>
+            <a:pPr algn="l">
+              <a:lnSpc>
+                <a:spcPct val="118000"/>
+              </a:lnSpc>
+              <a:spcBef>
+                <a:spcPts val="0"/>
+              </a:spcBef>
+              <a:spcAft>
+                <a:spcPts val="0"/>
               </a:spcAft>
             </a:pPr>
             <a:r>
@@ -4130,7 +4245,7 @@
                 <a:latin typeface="Golos Text"/>
                 <a:rFonts ascii="Golos Text" hAnsi="Golos Text" cs="Golos Text" eastAsia="Golos Text"/>
               </a:rPr>
-              <a:t>Выигрываем пакетом документов и ощущением в номере.</a:t>
+              <a:t>Пакет документов и ощущение в номере</a:t>
             </a:r>
           </a:p>
         </p:txBody>
@@ -4174,19 +4289,42 @@
                 <a:latin typeface="Manrope"/>
                 <a:rFonts ascii="Manrope" hAnsi="Manrope" cs="Manrope" eastAsia="Manrope"/>
               </a:rPr>
-              <a:t>Если поставка из Китая</a:t>
-            </a:r>
-          </a:p>
-          <a:p>
-            <a:pPr algn="l">
-              <a:lnSpc>
-                <a:spcPct val="118000"/>
-              </a:lnSpc>
-              <a:spcBef>
-                <a:spcPts val="0"/>
-              </a:spcBef>
-              <a:spcAft>
-                <a:spcPts val="600"/>
+              <a:t>Поставка из Китая</a:t>
+            </a:r>
+          </a:p>
+          <a:p>
+            <a:pPr algn="l">
+              <a:lnSpc>
+                <a:spcPct val="118000"/>
+              </a:lnSpc>
+              <a:spcBef>
+                <a:spcPts val="0"/>
+              </a:spcBef>
+              <a:spcAft>
+                <a:spcPts val="200"/>
+              </a:spcAft>
+            </a:pPr>
+            <a:r>
+              <a:rPr sz="1500" b="1">
+                <a:solidFill>
+                  <a:srgbClr val="1A1A1A"/>
+                </a:solidFill>
+                <a:latin typeface="Manrope"/>
+                <a:rFonts ascii="Manrope" hAnsi="Manrope" cs="Manrope" eastAsia="Manrope"/>
+              </a:rPr>
+              <a:t>Шаг 1</a:t>
+            </a:r>
+          </a:p>
+          <a:p>
+            <a:pPr algn="l">
+              <a:lnSpc>
+                <a:spcPct val="118000"/>
+              </a:lnSpc>
+              <a:spcBef>
+                <a:spcPts val="0"/>
+              </a:spcBef>
+              <a:spcAft>
+                <a:spcPts val="800"/>
               </a:spcAft>
             </a:pPr>
             <a:r>
@@ -4197,19 +4335,42 @@
                 <a:latin typeface="Golos Text"/>
                 <a:rFonts ascii="Golos Text" hAnsi="Golos Text" cs="Golos Text" eastAsia="Golos Text"/>
               </a:rPr>
-              <a:t>1. Сравниваем заводы в цене FOB</a:t>
-            </a:r>
-          </a:p>
-          <a:p>
-            <a:pPr algn="l">
-              <a:lnSpc>
-                <a:spcPct val="118000"/>
-              </a:lnSpc>
-              <a:spcBef>
-                <a:spcPts val="0"/>
-              </a:spcBef>
-              <a:spcAft>
-                <a:spcPts val="600"/>
+              <a:t>Сравниваем заводы в цене FOB</a:t>
+            </a:r>
+          </a:p>
+          <a:p>
+            <a:pPr algn="l">
+              <a:lnSpc>
+                <a:spcPct val="118000"/>
+              </a:lnSpc>
+              <a:spcBef>
+                <a:spcPts val="0"/>
+              </a:spcBef>
+              <a:spcAft>
+                <a:spcPts val="200"/>
+              </a:spcAft>
+            </a:pPr>
+            <a:r>
+              <a:rPr sz="1500" b="1">
+                <a:solidFill>
+                  <a:srgbClr val="1A1A1A"/>
+                </a:solidFill>
+                <a:latin typeface="Manrope"/>
+                <a:rFonts ascii="Manrope" hAnsi="Manrope" cs="Manrope" eastAsia="Manrope"/>
+              </a:rPr>
+              <a:t>Шаг 2</a:t>
+            </a:r>
+          </a:p>
+          <a:p>
+            <a:pPr algn="l">
+              <a:lnSpc>
+                <a:spcPct val="118000"/>
+              </a:lnSpc>
+              <a:spcBef>
+                <a:spcPts val="0"/>
+              </a:spcBef>
+              <a:spcAft>
+                <a:spcPts val="800"/>
               </a:spcAft>
             </a:pPr>
             <a:r>
@@ -4220,19 +4381,42 @@
                 <a:latin typeface="Golos Text"/>
                 <a:rFonts ascii="Golos Text" hAnsi="Golos Text" cs="Golos Text" eastAsia="Golos Text"/>
               </a:rPr>
-              <a:t>2. Логистику до Кириши считаем отдельной строкой</a:t>
-            </a:r>
-          </a:p>
-          <a:p>
-            <a:pPr algn="l">
-              <a:lnSpc>
-                <a:spcPct val="118000"/>
-              </a:lnSpc>
-              <a:spcBef>
-                <a:spcPts val="0"/>
-              </a:spcBef>
-              <a:spcAft>
-                <a:spcPts val="1000"/>
+              <a:t>Логистику до Кириши — отдельной строкой</a:t>
+            </a:r>
+          </a:p>
+          <a:p>
+            <a:pPr algn="l">
+              <a:lnSpc>
+                <a:spcPct val="118000"/>
+              </a:lnSpc>
+              <a:spcBef>
+                <a:spcPts val="0"/>
+              </a:spcBef>
+              <a:spcAft>
+                <a:spcPts val="200"/>
+              </a:spcAft>
+            </a:pPr>
+            <a:r>
+              <a:rPr sz="1500" b="1">
+                <a:solidFill>
+                  <a:srgbClr val="1A1A1A"/>
+                </a:solidFill>
+                <a:latin typeface="Manrope"/>
+                <a:rFonts ascii="Manrope" hAnsi="Manrope" cs="Manrope" eastAsia="Manrope"/>
+              </a:rPr>
+              <a:t>Шаг 3</a:t>
+            </a:r>
+          </a:p>
+          <a:p>
+            <a:pPr algn="l">
+              <a:lnSpc>
+                <a:spcPct val="118000"/>
+              </a:lnSpc>
+              <a:spcBef>
+                <a:spcPts val="0"/>
+              </a:spcBef>
+              <a:spcAft>
+                <a:spcPts val="800"/>
               </a:spcAft>
             </a:pPr>
             <a:r>
@@ -4243,7 +4427,7 @@
                 <a:latin typeface="Golos Text"/>
                 <a:rFonts ascii="Golos Text" hAnsi="Golos Text" cs="Golos Text" eastAsia="Golos Text"/>
               </a:rPr>
-              <a:t>3. Полная цена = FOB + фрахт + таможня + довоз + запас</a:t>
+              <a:t>Полная цена = FOB + фрахт + таможня + довоз + запас</a:t>
             </a:r>
           </a:p>
           <a:p>
@@ -4266,19 +4450,19 @@
                 <a:latin typeface="Manrope"/>
                 <a:rFonts ascii="Manrope" hAnsi="Manrope" cs="Manrope" eastAsia="Manrope"/>
               </a:rPr>
-              <a:t>Срок пилота — дата «на складе»,</a:t>
-            </a:r>
-          </a:p>
-          <a:p>
-            <a:pPr algn="l">
-              <a:lnSpc>
-                <a:spcPct val="118000"/>
-              </a:lnSpc>
-              <a:spcBef>
-                <a:spcPts val="0"/>
-              </a:spcBef>
-              <a:spcAft>
-                <a:spcPts val="600"/>
+              <a:t>Срок</a:t>
+            </a:r>
+          </a:p>
+          <a:p>
+            <a:pPr algn="l">
+              <a:lnSpc>
+                <a:spcPct val="118000"/>
+              </a:lnSpc>
+              <a:spcBef>
+                <a:spcPts val="0"/>
+              </a:spcBef>
+              <a:spcAft>
+                <a:spcPts val="800"/>
               </a:spcAft>
             </a:pPr>
             <a:r>
@@ -4289,19 +4473,42 @@
                 <a:latin typeface="Golos Text"/>
                 <a:rFonts ascii="Golos Text" hAnsi="Golos Text" cs="Golos Text" eastAsia="Golos Text"/>
               </a:rPr>
-              <a:t>а не формулировка «завод отгрузил».</a:t>
-            </a:r>
-          </a:p>
-          <a:p>
-            <a:pPr algn="l">
-              <a:lnSpc>
-                <a:spcPct val="118000"/>
-              </a:lnSpc>
-              <a:spcBef>
-                <a:spcPts val="0"/>
-              </a:spcBef>
-              <a:spcAft>
-                <a:spcPts val="600"/>
+              <a:t>Дата «на складе», не «завод отгрузил»</a:t>
+            </a:r>
+          </a:p>
+          <a:p>
+            <a:pPr algn="l">
+              <a:lnSpc>
+                <a:spcPct val="118000"/>
+              </a:lnSpc>
+              <a:spcBef>
+                <a:spcPts val="0"/>
+              </a:spcBef>
+              <a:spcAft>
+                <a:spcPts val="200"/>
+              </a:spcAft>
+            </a:pPr>
+            <a:r>
+              <a:rPr sz="1500" b="1">
+                <a:solidFill>
+                  <a:srgbClr val="1A1A1A"/>
+                </a:solidFill>
+                <a:latin typeface="Manrope"/>
+                <a:rFonts ascii="Manrope" hAnsi="Manrope" cs="Manrope" eastAsia="Manrope"/>
+              </a:rPr>
+              <a:t>Происхождение</a:t>
+            </a:r>
+          </a:p>
+          <a:p>
+            <a:pPr algn="l">
+              <a:lnSpc>
+                <a:spcPct val="118000"/>
+              </a:lnSpc>
+              <a:spcBef>
+                <a:spcPts val="0"/>
+              </a:spcBef>
+              <a:spcAft>
+                <a:spcPts val="0"/>
               </a:spcAft>
             </a:pPr>
             <a:r>
@@ -4312,7 +4519,7 @@
                 <a:latin typeface="Golos Text"/>
                 <a:rFonts ascii="Golos Text" hAnsi="Golos Text" cs="Golos Text" eastAsia="Golos Text"/>
               </a:rPr>
-              <a:t>Происхождение не зафиксировано — не называем «российское».</a:t>
+              <a:t>Не зафиксировано — не называем «российское»</a:t>
             </a:r>
           </a:p>
         </p:txBody>
@@ -4832,19 +5039,42 @@
                 <a:latin typeface="Manrope"/>
                 <a:rFonts ascii="Manrope" hAnsi="Manrope" cs="Manrope" eastAsia="Manrope"/>
               </a:rPr>
-              <a:t>Содержание пульта v1.14</a:t>
-            </a:r>
-          </a:p>
-          <a:p>
-            <a:pPr algn="l">
-              <a:lnSpc>
-                <a:spcPct val="118000"/>
-              </a:lnSpc>
-              <a:spcBef>
-                <a:spcPts val="0"/>
-              </a:spcBef>
-              <a:spcAft>
-                <a:spcPts val="600"/>
+              <a:t>Содержание v1.14</a:t>
+            </a:r>
+          </a:p>
+          <a:p>
+            <a:pPr algn="l">
+              <a:lnSpc>
+                <a:spcPct val="118000"/>
+              </a:lnSpc>
+              <a:spcBef>
+                <a:spcPts val="0"/>
+              </a:spcBef>
+              <a:spcAft>
+                <a:spcPts val="200"/>
+              </a:spcAft>
+            </a:pPr>
+            <a:r>
+              <a:rPr sz="1500" b="1">
+                <a:solidFill>
+                  <a:srgbClr val="1A1A1A"/>
+                </a:solidFill>
+                <a:latin typeface="Manrope"/>
+                <a:rFonts ascii="Manrope" hAnsi="Manrope" cs="Manrope" eastAsia="Manrope"/>
+              </a:rPr>
+              <a:t>Этапы 0–2</a:t>
+            </a:r>
+          </a:p>
+          <a:p>
+            <a:pPr algn="l">
+              <a:lnSpc>
+                <a:spcPct val="118000"/>
+              </a:lnSpc>
+              <a:spcBef>
+                <a:spcPts val="0"/>
+              </a:spcBef>
+              <a:spcAft>
+                <a:spcPts val="800"/>
               </a:spcAft>
             </a:pPr>
             <a:r>
@@ -4855,19 +5085,42 @@
                 <a:latin typeface="Golos Text"/>
                 <a:rFonts ascii="Golos Text" hAnsi="Golos Text" cs="Golos Text" eastAsia="Golos Text"/>
               </a:rPr>
-              <a:t>Этапы 0–2: разведка, правила, границы продукта</a:t>
-            </a:r>
-          </a:p>
-          <a:p>
-            <a:pPr algn="l">
-              <a:lnSpc>
-                <a:spcPct val="118000"/>
-              </a:lnSpc>
-              <a:spcBef>
-                <a:spcPts val="0"/>
-              </a:spcBef>
-              <a:spcAft>
-                <a:spcPts val="600"/>
+              <a:t>Разведка, правила, границы продукта</a:t>
+            </a:r>
+          </a:p>
+          <a:p>
+            <a:pPr algn="l">
+              <a:lnSpc>
+                <a:spcPct val="118000"/>
+              </a:lnSpc>
+              <a:spcBef>
+                <a:spcPts val="0"/>
+              </a:spcBef>
+              <a:spcAft>
+                <a:spcPts val="200"/>
+              </a:spcAft>
+            </a:pPr>
+            <a:r>
+              <a:rPr sz="1500" b="1">
+                <a:solidFill>
+                  <a:srgbClr val="1A1A1A"/>
+                </a:solidFill>
+                <a:latin typeface="Manrope"/>
+                <a:rFonts ascii="Manrope" hAnsi="Manrope" cs="Manrope" eastAsia="Manrope"/>
+              </a:rPr>
+              <a:t>Этапы 3–6</a:t>
+            </a:r>
+          </a:p>
+          <a:p>
+            <a:pPr algn="l">
+              <a:lnSpc>
+                <a:spcPct val="118000"/>
+              </a:lnSpc>
+              <a:spcBef>
+                <a:spcPts val="0"/>
+              </a:spcBef>
+              <a:spcAft>
+                <a:spcPts val="800"/>
               </a:spcAft>
             </a:pPr>
             <a:r>
@@ -4878,19 +5131,42 @@
                 <a:latin typeface="Golos Text"/>
                 <a:rFonts ascii="Golos Text" hAnsi="Golos Text" cs="Golos Text" eastAsia="Golos Text"/>
               </a:rPr>
-              <a:t>Этапы 3–6: учебный сценарий «как вести дело»</a:t>
-            </a:r>
-          </a:p>
-          <a:p>
-            <a:pPr algn="l">
-              <a:lnSpc>
-                <a:spcPct val="118000"/>
-              </a:lnSpc>
-              <a:spcBef>
-                <a:spcPts val="0"/>
-              </a:spcBef>
-              <a:spcAft>
-                <a:spcPts val="600"/>
+              <a:t>Сценарий «как вести дело»</a:t>
+            </a:r>
+          </a:p>
+          <a:p>
+            <a:pPr algn="l">
+              <a:lnSpc>
+                <a:spcPct val="118000"/>
+              </a:lnSpc>
+              <a:spcBef>
+                <a:spcPts val="0"/>
+              </a:spcBef>
+              <a:spcAft>
+                <a:spcPts val="200"/>
+              </a:spcAft>
+            </a:pPr>
+            <a:r>
+              <a:rPr sz="1500" b="1">
+                <a:solidFill>
+                  <a:srgbClr val="1A1A1A"/>
+                </a:solidFill>
+                <a:latin typeface="Manrope"/>
+                <a:rFonts ascii="Manrope" hAnsi="Manrope" cs="Manrope" eastAsia="Manrope"/>
+              </a:rPr>
+              <a:t>Инструменты</a:t>
+            </a:r>
+          </a:p>
+          <a:p>
+            <a:pPr algn="l">
+              <a:lnSpc>
+                <a:spcPct val="118000"/>
+              </a:lnSpc>
+              <a:spcBef>
+                <a:spcPts val="0"/>
+              </a:spcBef>
+              <a:spcAft>
+                <a:spcPts val="800"/>
               </a:spcAft>
             </a:pPr>
             <a:r>
@@ -4901,19 +5177,42 @@
                 <a:latin typeface="Golos Text"/>
                 <a:rFonts ascii="Golos Text" hAnsi="Golos Text" cs="Golos Text" eastAsia="Golos Text"/>
               </a:rPr>
-              <a:t>StoryBrand, чеклист готовности, реестр рисков</a:t>
-            </a:r>
-          </a:p>
-          <a:p>
-            <a:pPr algn="l">
-              <a:lnSpc>
-                <a:spcPct val="118000"/>
-              </a:lnSpc>
-              <a:spcBef>
-                <a:spcPts val="0"/>
-              </a:spcBef>
-              <a:spcAft>
-                <a:spcPts val="600"/>
+              <a:t>StoryBrand, чеклист, реестр рисков, пилот</a:t>
+            </a:r>
+          </a:p>
+          <a:p>
+            <a:pPr algn="l">
+              <a:lnSpc>
+                <a:spcPct val="118000"/>
+              </a:lnSpc>
+              <a:spcBef>
+                <a:spcPts val="0"/>
+              </a:spcBef>
+              <a:spcAft>
+                <a:spcPts val="200"/>
+              </a:spcAft>
+            </a:pPr>
+            <a:r>
+              <a:rPr sz="1500" b="1">
+                <a:solidFill>
+                  <a:srgbClr val="1A1A1A"/>
+                </a:solidFill>
+                <a:latin typeface="Manrope"/>
+                <a:rFonts ascii="Manrope" hAnsi="Manrope" cs="Manrope" eastAsia="Manrope"/>
+              </a:rPr>
+              <a:t>Портфель</a:t>
+            </a:r>
+          </a:p>
+          <a:p>
+            <a:pPr algn="l">
+              <a:lnSpc>
+                <a:spcPct val="118000"/>
+              </a:lnSpc>
+              <a:spcBef>
+                <a:spcPts val="0"/>
+              </a:spcBef>
+              <a:spcAft>
+                <a:spcPts val="800"/>
               </a:spcAft>
             </a:pPr>
             <a:r>
@@ -4924,109 +5223,155 @@
                 <a:latin typeface="Golos Text"/>
                 <a:rFonts ascii="Golos Text" hAnsi="Golos Text" cs="Golos Text" eastAsia="Golos Text"/>
               </a:rPr>
-              <a:t>Правила пилота: успех, провал, выход</a:t>
-            </a:r>
-          </a:p>
-          <a:p>
-            <a:pPr algn="l">
-              <a:lnSpc>
-                <a:spcPct val="118000"/>
-              </a:lnSpc>
-              <a:spcBef>
-                <a:spcPts val="0"/>
-              </a:spcBef>
-              <a:spcAft>
-                <a:spcPts val="600"/>
-              </a:spcAft>
-            </a:pPr>
-            <a:r>
-              <a:rPr sz="1500" b="0">
-                <a:solidFill>
-                  <a:srgbClr val="1A1A1A"/>
+              <a:t>Мостик Travel+: Hotel Line, Fleur, Natural, СТМ</a:t>
+            </a:r>
+          </a:p>
+          <a:p>
+            <a:pPr algn="l">
+              <a:lnSpc>
+                <a:spcPct val="118000"/>
+              </a:lnSpc>
+              <a:spcBef>
+                <a:spcPts val="1800"/>
+              </a:spcBef>
+              <a:spcAft>
+                <a:spcPts val="0"/>
+              </a:spcAft>
+            </a:pPr>
+            <a:r>
+              <a:rPr sz="1200" b="0">
+                <a:solidFill>
+                  <a:srgbClr val="5C5C5C"/>
                 </a:solidFill>
                 <a:latin typeface="Golos Text"/>
                 <a:rFonts ascii="Golos Text" hAnsi="Golos Text" cs="Golos Text" eastAsia="Golos Text"/>
               </a:rPr>
-              <a:t>Мостик портфеля Travel+ (Hotel Line, Fleur, Natural, СТМ)</a:t>
-            </a:r>
-          </a:p>
-          <a:p>
-            <a:pPr algn="l">
-              <a:lnSpc>
-                <a:spcPct val="118000"/>
-              </a:lnSpc>
-              <a:spcBef>
-                <a:spcPts val="1800"/>
-              </a:spcBef>
-              <a:spcAft>
-                <a:spcPts val="0"/>
-              </a:spcAft>
-            </a:pPr>
-            <a:r>
-              <a:rPr sz="1200" b="0">
-                <a:solidFill>
-                  <a:srgbClr val="5C5C5C"/>
+              <a:t>Образец для поля и собеседования. Не коммерческое предложение.</a:t>
+            </a:r>
+          </a:p>
+        </p:txBody>
+      </p:sp>
+      <p:sp>
+        <p:nvSpPr>
+          <p:cNvPr id="14" name="TextBox 13"/>
+          <p:cNvSpPr txBox="1"/>
+          <p:nvPr/>
+        </p:nvSpPr>
+        <p:spPr>
+          <a:xfrm>
+            <a:off x="6571335" y="1426464"/>
+            <a:ext cx="4815687" cy="4334256"/>
+          </a:xfrm>
+          <a:prstGeom prst="rect">
+            <a:avLst/>
+          </a:prstGeom>
+          <a:noFill/>
+        </p:spPr>
+        <p:txBody>
+          <a:bodyPr wrap="square" anchor="t" lIns="50800" rIns="50800" tIns="25400" bIns="25400"/>
+          <a:lstStyle/>
+          <a:p>
+            <a:pPr algn="l">
+              <a:lnSpc>
+                <a:spcPct val="118000"/>
+              </a:lnSpc>
+              <a:spcBef>
+                <a:spcPts val="0"/>
+              </a:spcBef>
+              <a:spcAft>
+                <a:spcPts val="1200"/>
+              </a:spcAft>
+            </a:pPr>
+            <a:r>
+              <a:rPr sz="1500" b="1">
+                <a:solidFill>
+                  <a:srgbClr val="2A554A"/>
+                </a:solidFill>
+                <a:latin typeface="Manrope"/>
+                <a:rFonts ascii="Manrope" hAnsi="Manrope" cs="Manrope" eastAsia="Manrope"/>
+              </a:rPr>
+              <a:t>Справочники</a:t>
+            </a:r>
+          </a:p>
+          <a:p>
+            <a:pPr algn="l">
+              <a:lnSpc>
+                <a:spcPct val="118000"/>
+              </a:lnSpc>
+              <a:spcBef>
+                <a:spcPts val="0"/>
+              </a:spcBef>
+              <a:spcAft>
+                <a:spcPts val="200"/>
+              </a:spcAft>
+            </a:pPr>
+            <a:r>
+              <a:rPr sz="1500" b="1">
+                <a:solidFill>
+                  <a:srgbClr val="1A1A1A"/>
+                </a:solidFill>
+                <a:latin typeface="Manrope"/>
+                <a:rFonts ascii="Manrope" hAnsi="Manrope" cs="Manrope" eastAsia="Manrope"/>
+              </a:rPr>
+              <a:t>Глоссарии</a:t>
+            </a:r>
+          </a:p>
+          <a:p>
+            <a:pPr algn="l">
+              <a:lnSpc>
+                <a:spcPct val="118000"/>
+              </a:lnSpc>
+              <a:spcBef>
+                <a:spcPts val="0"/>
+              </a:spcBef>
+              <a:spcAft>
+                <a:spcPts val="800"/>
+              </a:spcAft>
+            </a:pPr>
+            <a:r>
+              <a:rPr sz="1500" b="0">
+                <a:solidFill>
+                  <a:srgbClr val="1A1A1A"/>
                 </a:solidFill>
                 <a:latin typeface="Golos Text"/>
                 <a:rFonts ascii="Golos Text" hAnsi="Golos Text" cs="Golos Text" eastAsia="Golos Text"/>
               </a:rPr>
-              <a:t>Статус: образец для поля и собеседования. Не коммерческое предложение.</a:t>
-            </a:r>
-          </a:p>
-        </p:txBody>
-      </p:sp>
-      <p:sp>
-        <p:nvSpPr>
-          <p:cNvPr id="14" name="TextBox 13"/>
-          <p:cNvSpPr txBox="1"/>
-          <p:nvPr/>
-        </p:nvSpPr>
-        <p:spPr>
-          <a:xfrm>
-            <a:off x="6571335" y="1426464"/>
-            <a:ext cx="4815687" cy="4334256"/>
-          </a:xfrm>
-          <a:prstGeom prst="rect">
-            <a:avLst/>
-          </a:prstGeom>
-          <a:noFill/>
-        </p:spPr>
-        <p:txBody>
-          <a:bodyPr wrap="square" anchor="t" lIns="50800" rIns="50800" tIns="25400" bIns="25400"/>
-          <a:lstStyle/>
-          <a:p>
-            <a:pPr algn="l">
-              <a:lnSpc>
-                <a:spcPct val="118000"/>
-              </a:lnSpc>
-              <a:spcBef>
-                <a:spcPts val="0"/>
-              </a:spcBef>
-              <a:spcAft>
-                <a:spcPts val="1200"/>
+              <a:t>Бренд и ВЭД</a:t>
+            </a:r>
+          </a:p>
+          <a:p>
+            <a:pPr algn="l">
+              <a:lnSpc>
+                <a:spcPct val="118000"/>
+              </a:lnSpc>
+              <a:spcBef>
+                <a:spcPts val="0"/>
+              </a:spcBef>
+              <a:spcAft>
+                <a:spcPts val="200"/>
               </a:spcAft>
             </a:pPr>
             <a:r>
               <a:rPr sz="1500" b="1">
                 <a:solidFill>
-                  <a:srgbClr val="2A554A"/>
+                  <a:srgbClr val="1A1A1A"/>
                 </a:solidFill>
                 <a:latin typeface="Manrope"/>
                 <a:rFonts ascii="Manrope" hAnsi="Manrope" cs="Manrope" eastAsia="Manrope"/>
               </a:rPr>
-              <a:t>Справочники и логистика</a:t>
-            </a:r>
-          </a:p>
-          <a:p>
-            <a:pPr algn="l">
-              <a:lnSpc>
-                <a:spcPct val="118000"/>
-              </a:lnSpc>
-              <a:spcBef>
-                <a:spcPts val="0"/>
-              </a:spcBef>
-              <a:spcAft>
-                <a:spcPts val="600"/>
+              <a:t>Раздел L</a:t>
+            </a:r>
+          </a:p>
+          <a:p>
+            <a:pPr algn="l">
+              <a:lnSpc>
+                <a:spcPct val="118000"/>
+              </a:lnSpc>
+              <a:spcBef>
+                <a:spcPts val="0"/>
+              </a:spcBef>
+              <a:spcAft>
+                <a:spcPts val="800"/>
               </a:spcAft>
             </a:pPr>
             <a:r>
@@ -5037,19 +5382,42 @@
                 <a:latin typeface="Golos Text"/>
                 <a:rFonts ascii="Golos Text" hAnsi="Golos Text" cs="Golos Text" eastAsia="Golos Text"/>
               </a:rPr>
-              <a:t>Глоссарий бренда и глоссарий ВЭД</a:t>
-            </a:r>
-          </a:p>
-          <a:p>
-            <a:pPr algn="l">
-              <a:lnSpc>
-                <a:spcPct val="118000"/>
-              </a:lnSpc>
-              <a:spcBef>
-                <a:spcPts val="0"/>
-              </a:spcBef>
-              <a:spcAft>
-                <a:spcPts val="600"/>
+              <a:t>Путь товара, Incoterms, RFQ, приёмка</a:t>
+            </a:r>
+          </a:p>
+          <a:p>
+            <a:pPr algn="l">
+              <a:lnSpc>
+                <a:spcPct val="118000"/>
+              </a:lnSpc>
+              <a:spcBef>
+                <a:spcPts val="0"/>
+              </a:spcBef>
+              <a:spcAft>
+                <a:spcPts val="200"/>
+              </a:spcAft>
+            </a:pPr>
+            <a:r>
+              <a:rPr sz="1500" b="1">
+                <a:solidFill>
+                  <a:srgbClr val="1A1A1A"/>
+                </a:solidFill>
+                <a:latin typeface="Manrope"/>
+                <a:rFonts ascii="Manrope" hAnsi="Manrope" cs="Manrope" eastAsia="Manrope"/>
+              </a:rPr>
+              <a:t>Волна A</a:t>
+            </a:r>
+          </a:p>
+          <a:p>
+            <a:pPr algn="l">
+              <a:lnSpc>
+                <a:spcPct val="118000"/>
+              </a:lnSpc>
+              <a:spcBef>
+                <a:spcPts val="0"/>
+              </a:spcBef>
+              <a:spcAft>
+                <a:spcPts val="800"/>
               </a:spcAft>
             </a:pPr>
             <a:r>
@@ -5060,19 +5428,42 @@
                 <a:latin typeface="Golos Text"/>
                 <a:rFonts ascii="Golos Text" hAnsi="Golos Text" cs="Golos Text" eastAsia="Golos Text"/>
               </a:rPr>
-              <a:t>Раздел L: путь товара, Incoterms, RFQ, приёмка на складе</a:t>
-            </a:r>
-          </a:p>
-          <a:p>
-            <a:pPr algn="l">
-              <a:lnSpc>
-                <a:spcPct val="118000"/>
-              </a:lnSpc>
-              <a:spcBef>
-                <a:spcPts val="0"/>
-              </a:spcBef>
-              <a:spcAft>
-                <a:spcPts val="600"/>
+              <a:t>Markdown-реестры в папке brand-pult/</a:t>
+            </a:r>
+          </a:p>
+          <a:p>
+            <a:pPr algn="l">
+              <a:lnSpc>
+                <a:spcPct val="118000"/>
+              </a:lnSpc>
+              <a:spcBef>
+                <a:spcPts val="0"/>
+              </a:spcBef>
+              <a:spcAft>
+                <a:spcPts val="200"/>
+              </a:spcAft>
+            </a:pPr>
+            <a:r>
+              <a:rPr sz="1500" b="1">
+                <a:solidFill>
+                  <a:srgbClr val="1A1A1A"/>
+                </a:solidFill>
+                <a:latin typeface="Manrope"/>
+                <a:rFonts ascii="Manrope" hAnsi="Manrope" cs="Manrope" eastAsia="Manrope"/>
+              </a:rPr>
+              <a:t>Синхрон</a:t>
+            </a:r>
+          </a:p>
+          <a:p>
+            <a:pPr algn="l">
+              <a:lnSpc>
+                <a:spcPct val="118000"/>
+              </a:lnSpc>
+              <a:spcBef>
+                <a:spcPts val="0"/>
+              </a:spcBef>
+              <a:spcAft>
+                <a:spcPts val="800"/>
               </a:spcAft>
             </a:pPr>
             <a:r>
@@ -5083,19 +5474,42 @@
                 <a:latin typeface="Golos Text"/>
                 <a:rFonts ascii="Golos Text" hAnsi="Golos Text" cs="Golos Text" eastAsia="Golos Text"/>
               </a:rPr>
-              <a:t>Волна A: markdown-реестры в папке brand-pult/</a:t>
-            </a:r>
-          </a:p>
-          <a:p>
-            <a:pPr algn="l">
-              <a:lnSpc>
-                <a:spcPct val="118000"/>
-              </a:lnSpc>
-              <a:spcBef>
-                <a:spcPts val="0"/>
-              </a:spcBef>
-              <a:spcAft>
-                <a:spcPts val="1000"/>
+              <a:t>Презентация и скрипт с пультом</a:t>
+            </a:r>
+          </a:p>
+          <a:p>
+            <a:pPr algn="l">
+              <a:lnSpc>
+                <a:spcPct val="118000"/>
+              </a:lnSpc>
+              <a:spcBef>
+                <a:spcPts val="0"/>
+              </a:spcBef>
+              <a:spcAft>
+                <a:spcPts val="200"/>
+              </a:spcAft>
+            </a:pPr>
+            <a:r>
+              <a:rPr sz="1500" b="1">
+                <a:solidFill>
+                  <a:srgbClr val="1A1A1A"/>
+                </a:solidFill>
+                <a:latin typeface="Manrope"/>
+                <a:rFonts ascii="Manrope" hAnsi="Manrope" cs="Manrope" eastAsia="Manrope"/>
+              </a:rPr>
+              <a:t>Версия 2.0</a:t>
+            </a:r>
+          </a:p>
+          <a:p>
+            <a:pPr algn="l">
+              <a:lnSpc>
+                <a:spcPct val="118000"/>
+              </a:lnSpc>
+              <a:spcBef>
+                <a:spcPts val="0"/>
+              </a:spcBef>
+              <a:spcAft>
+                <a:spcPts val="0"/>
               </a:spcAft>
             </a:pPr>
             <a:r>
@@ -5106,30 +5520,7 @@
                 <a:latin typeface="Golos Text"/>
                 <a:rFonts ascii="Golos Text" hAnsi="Golos Text" cs="Golos Text" eastAsia="Golos Text"/>
               </a:rPr>
-              <a:t>Презентация и скрипт — синхрон с пультом</a:t>
-            </a:r>
-          </a:p>
-          <a:p>
-            <a:pPr algn="l">
-              <a:lnSpc>
-                <a:spcPct val="118000"/>
-              </a:lnSpc>
-              <a:spcBef>
-                <a:spcPts val="0"/>
-              </a:spcBef>
-              <a:spcAft>
-                <a:spcPts val="800"/>
-              </a:spcAft>
-            </a:pPr>
-            <a:r>
-              <a:rPr sz="1500" b="1">
-                <a:solidFill>
-                  <a:srgbClr val="1A1A1A"/>
-                </a:solidFill>
-                <a:latin typeface="Manrope"/>
-                <a:rFonts ascii="Manrope" hAnsi="Manrope" cs="Manrope" eastAsia="Manrope"/>
-              </a:rPr>
-              <a:t>Версия 2.0 — когда технолог закроет цифры завода.</a:t>
+              <a:t>Когда технолог закроет цифры завода</a:t>
             </a:r>
           </a:p>
         </p:txBody>
@@ -5661,18 +6052,64 @@
                 <a:spcPts val="0"/>
               </a:spcBef>
               <a:spcAft>
+                <a:spcPts val="200"/>
+              </a:spcAft>
+            </a:pPr>
+            <a:r>
+              <a:rPr sz="1500" b="1">
+                <a:solidFill>
+                  <a:srgbClr val="1A1A1A"/>
+                </a:solidFill>
+                <a:latin typeface="Manrope"/>
+                <a:rFonts ascii="Manrope" hAnsi="Manrope" cs="Manrope" eastAsia="Manrope"/>
+              </a:rPr>
+              <a:t>ДНК</a:t>
+            </a:r>
+          </a:p>
+          <a:p>
+            <a:pPr algn="l">
+              <a:lnSpc>
+                <a:spcPct val="118000"/>
+              </a:lnSpc>
+              <a:spcBef>
+                <a:spcPts val="0"/>
+              </a:spcBef>
+              <a:spcAft>
                 <a:spcPts val="800"/>
               </a:spcAft>
             </a:pPr>
             <a:r>
-              <a:rPr sz="1600" b="0">
+              <a:rPr sz="1500" b="0">
                 <a:solidFill>
                   <a:srgbClr val="1A1A1A"/>
                 </a:solidFill>
                 <a:latin typeface="Golos Text"/>
                 <a:rFonts ascii="Golos Text" hAnsi="Golos Text" cs="Golos Text" eastAsia="Golos Text"/>
               </a:rPr>
-              <a:t>ДНК + StoryBrand + DoD</a:t>
+              <a:t>Обещание и границы линейки</a:t>
+            </a:r>
+          </a:p>
+          <a:p>
+            <a:pPr algn="l">
+              <a:lnSpc>
+                <a:spcPct val="118000"/>
+              </a:lnSpc>
+              <a:spcBef>
+                <a:spcPts val="0"/>
+              </a:spcBef>
+              <a:spcAft>
+                <a:spcPts val="200"/>
+              </a:spcAft>
+            </a:pPr>
+            <a:r>
+              <a:rPr sz="1500" b="1">
+                <a:solidFill>
+                  <a:srgbClr val="1A1A1A"/>
+                </a:solidFill>
+                <a:latin typeface="Manrope"/>
+                <a:rFonts ascii="Manrope" hAnsi="Manrope" cs="Manrope" eastAsia="Manrope"/>
+              </a:rPr>
+              <a:t>StoryBrand</a:t>
             </a:r>
           </a:p>
           <a:p>
@@ -5688,60 +6125,129 @@
               </a:spcAft>
             </a:pPr>
             <a:r>
-              <a:rPr sz="1600" b="0">
+              <a:rPr sz="1500" b="0">
                 <a:solidFill>
                   <a:srgbClr val="1A1A1A"/>
                 </a:solidFill>
                 <a:latin typeface="Golos Text"/>
                 <a:rFonts ascii="Golos Text" hAnsi="Golos Text" cs="Golos Text" eastAsia="Golos Text"/>
               </a:rPr>
-              <a:t>Полевая защита</a:t>
-            </a:r>
-          </a:p>
-          <a:p>
-            <a:pPr algn="l">
-              <a:lnSpc>
-                <a:spcPct val="118000"/>
-              </a:lnSpc>
-              <a:spcBef>
-                <a:spcPts val="0"/>
-              </a:spcBef>
-              <a:spcAft>
-                <a:spcPts val="1400"/>
-              </a:spcAft>
-            </a:pPr>
-            <a:r>
-              <a:rPr sz="1600" b="0">
+              <a:t>Скрипт для продаж</a:t>
+            </a:r>
+          </a:p>
+          <a:p>
+            <a:pPr algn="l">
+              <a:lnSpc>
+                <a:spcPct val="118000"/>
+              </a:lnSpc>
+              <a:spcBef>
+                <a:spcPts val="0"/>
+              </a:spcBef>
+              <a:spcAft>
+                <a:spcPts val="200"/>
+              </a:spcAft>
+            </a:pPr>
+            <a:r>
+              <a:rPr sz="1500" b="1">
+                <a:solidFill>
+                  <a:srgbClr val="1A1A1A"/>
+                </a:solidFill>
+                <a:latin typeface="Manrope"/>
+                <a:rFonts ascii="Manrope" hAnsi="Manrope" cs="Manrope" eastAsia="Manrope"/>
+              </a:rPr>
+              <a:t>Чеклист</a:t>
+            </a:r>
+          </a:p>
+          <a:p>
+            <a:pPr algn="l">
+              <a:lnSpc>
+                <a:spcPct val="118000"/>
+              </a:lnSpc>
+              <a:spcBef>
+                <a:spcPts val="0"/>
+              </a:spcBef>
+              <a:spcAft>
+                <a:spcPts val="800"/>
+              </a:spcAft>
+            </a:pPr>
+            <a:r>
+              <a:rPr sz="1500" b="0">
                 <a:solidFill>
                   <a:srgbClr val="1A1A1A"/>
                 </a:solidFill>
                 <a:latin typeface="Golos Text"/>
                 <a:rFonts ascii="Golos Text" hAnsi="Golos Text" cs="Golos Text" eastAsia="Golos Text"/>
               </a:rPr>
-              <a:t>Чеклист поставок при Китае (раздел L)</a:t>
-            </a:r>
-          </a:p>
-          <a:p>
-            <a:pPr algn="l">
-              <a:lnSpc>
-                <a:spcPct val="118000"/>
-              </a:lnSpc>
-              <a:spcBef>
-                <a:spcPts val="0"/>
-              </a:spcBef>
-              <a:spcAft>
-                <a:spcPts val="600"/>
-              </a:spcAft>
-            </a:pPr>
-            <a:r>
-              <a:rPr sz="1400" b="0">
-                <a:solidFill>
-                  <a:srgbClr val="5C5C5C"/>
+              <a:t>Готовность продукта перед рынком</a:t>
+            </a:r>
+          </a:p>
+          <a:p>
+            <a:pPr algn="l">
+              <a:lnSpc>
+                <a:spcPct val="118000"/>
+              </a:lnSpc>
+              <a:spcBef>
+                <a:spcPts val="0"/>
+              </a:spcBef>
+              <a:spcAft>
+                <a:spcPts val="200"/>
+              </a:spcAft>
+            </a:pPr>
+            <a:r>
+              <a:rPr sz="1500" b="1">
+                <a:solidFill>
+                  <a:srgbClr val="1A1A1A"/>
+                </a:solidFill>
+                <a:latin typeface="Manrope"/>
+                <a:rFonts ascii="Manrope" hAnsi="Manrope" cs="Manrope" eastAsia="Manrope"/>
+              </a:rPr>
+              <a:t>Логистика</a:t>
+            </a:r>
+          </a:p>
+          <a:p>
+            <a:pPr algn="l">
+              <a:lnSpc>
+                <a:spcPct val="118000"/>
+              </a:lnSpc>
+              <a:spcBef>
+                <a:spcPts val="0"/>
+              </a:spcBef>
+              <a:spcAft>
+                <a:spcPts val="800"/>
+              </a:spcAft>
+            </a:pPr>
+            <a:r>
+              <a:rPr sz="1500" b="0">
+                <a:solidFill>
+                  <a:srgbClr val="1A1A1A"/>
                 </a:solidFill>
                 <a:latin typeface="Golos Text"/>
                 <a:rFonts ascii="Golos Text" hAnsi="Golos Text" cs="Golos Text" eastAsia="Golos Text"/>
               </a:rPr>
-              <a:t>Не прайс завода. Не КП.</a:t>
+              <a:t>Раздел L — путь при поставке из Китая</a:t>
+            </a:r>
+          </a:p>
+          <a:p>
+            <a:pPr algn="l">
+              <a:lnSpc>
+                <a:spcPct val="118000"/>
+              </a:lnSpc>
+              <a:spcBef>
+                <a:spcPts val="1800"/>
+              </a:spcBef>
+              <a:spcAft>
+                <a:spcPts val="0"/>
+              </a:spcAft>
+            </a:pPr>
+            <a:r>
+              <a:rPr sz="1200" b="0">
+                <a:solidFill>
+                  <a:srgbClr val="5C5C5C"/>
+                </a:solidFill>
+                <a:latin typeface="Golos Text"/>
+                <a:rFonts ascii="Golos Text" hAnsi="Golos Text" cs="Golos Text" eastAsia="Golos Text"/>
+              </a:rPr>
+              <a:t>Не прайс завода. Не коммерческое предложение.</a:t>
             </a:r>
           </a:p>
         </p:txBody>
@@ -5797,18 +6303,64 @@
                 <a:spcPts val="0"/>
               </a:spcBef>
               <a:spcAft>
+                <a:spcPts val="200"/>
+              </a:spcAft>
+            </a:pPr>
+            <a:r>
+              <a:rPr sz="1500" b="1">
+                <a:solidFill>
+                  <a:srgbClr val="1A1A1A"/>
+                </a:solidFill>
+                <a:latin typeface="Manrope"/>
+                <a:rFonts ascii="Manrope" hAnsi="Manrope" cs="Manrope" eastAsia="Manrope"/>
+              </a:rPr>
+              <a:t>Блокеры</a:t>
+            </a:r>
+          </a:p>
+          <a:p>
+            <a:pPr algn="l">
+              <a:lnSpc>
+                <a:spcPct val="118000"/>
+              </a:lnSpc>
+              <a:spcBef>
+                <a:spcPts val="0"/>
+              </a:spcBef>
+              <a:spcAft>
                 <a:spcPts val="800"/>
               </a:spcAft>
             </a:pPr>
             <a:r>
-              <a:rPr sz="1600" b="0">
+              <a:rPr sz="1500" b="0">
                 <a:solidFill>
                   <a:srgbClr val="1A1A1A"/>
                 </a:solidFill>
                 <a:latin typeface="Golos Text"/>
                 <a:rFonts ascii="Golos Text" hAnsi="Golos Text" cs="Golos Text" eastAsia="Golos Text"/>
               </a:rPr>
-              <a:t>1) Приоритет блокеров этапа 2 с технологом</a:t>
+              <a:t>Приоритет этапа 2 с технологом</a:t>
+            </a:r>
+          </a:p>
+          <a:p>
+            <a:pPr algn="l">
+              <a:lnSpc>
+                <a:spcPct val="118000"/>
+              </a:lnSpc>
+              <a:spcBef>
+                <a:spcPts val="0"/>
+              </a:spcBef>
+              <a:spcAft>
+                <a:spcPts val="200"/>
+              </a:spcAft>
+            </a:pPr>
+            <a:r>
+              <a:rPr sz="1500" b="1">
+                <a:solidFill>
+                  <a:srgbClr val="1A1A1A"/>
+                </a:solidFill>
+                <a:latin typeface="Manrope"/>
+                <a:rFonts ascii="Manrope" hAnsi="Manrope" cs="Manrope" eastAsia="Manrope"/>
+              </a:rPr>
+              <a:t>Сегмент</a:t>
             </a:r>
           </a:p>
           <a:p>
@@ -5824,60 +6376,106 @@
               </a:spcAft>
             </a:pPr>
             <a:r>
-              <a:rPr sz="1600" b="0">
+              <a:rPr sz="1500" b="0">
                 <a:solidFill>
                   <a:srgbClr val="1A1A1A"/>
                 </a:solidFill>
                 <a:latin typeface="Golos Text"/>
                 <a:rFonts ascii="Golos Text" hAnsi="Golos Text" cs="Golos Text" eastAsia="Golos Text"/>
               </a:rPr>
-              <a:t>2) Пилотный сегмент eco / wellness</a:t>
-            </a:r>
-          </a:p>
-          <a:p>
-            <a:pPr algn="l">
-              <a:lnSpc>
-                <a:spcPct val="118000"/>
-              </a:lnSpc>
-              <a:spcBef>
-                <a:spcPts val="0"/>
-              </a:spcBef>
-              <a:spcAft>
-                <a:spcPts val="1400"/>
-              </a:spcAft>
-            </a:pPr>
-            <a:r>
-              <a:rPr sz="1600" b="0">
+              <a:t>Пилот eco / wellness</a:t>
+            </a:r>
+          </a:p>
+          <a:p>
+            <a:pPr algn="l">
+              <a:lnSpc>
+                <a:spcPct val="118000"/>
+              </a:lnSpc>
+              <a:spcBef>
+                <a:spcPts val="0"/>
+              </a:spcBef>
+              <a:spcAft>
+                <a:spcPts val="200"/>
+              </a:spcAft>
+            </a:pPr>
+            <a:r>
+              <a:rPr sz="1500" b="1">
+                <a:solidFill>
+                  <a:srgbClr val="1A1A1A"/>
+                </a:solidFill>
+                <a:latin typeface="Manrope"/>
+                <a:rFonts ascii="Manrope" hAnsi="Manrope" cs="Manrope" eastAsia="Manrope"/>
+              </a:rPr>
+              <a:t>Продажи</a:t>
+            </a:r>
+          </a:p>
+          <a:p>
+            <a:pPr algn="l">
+              <a:lnSpc>
+                <a:spcPct val="118000"/>
+              </a:lnSpc>
+              <a:spcBef>
+                <a:spcPts val="0"/>
+              </a:spcBef>
+              <a:spcAft>
+                <a:spcPts val="800"/>
+              </a:spcAft>
+            </a:pPr>
+            <a:r>
+              <a:rPr sz="1500" b="0">
                 <a:solidFill>
                   <a:srgbClr val="1A1A1A"/>
                 </a:solidFill>
                 <a:latin typeface="Golos Text"/>
                 <a:rFonts ascii="Golos Text" hAnsi="Golos Text" cs="Golos Text" eastAsia="Golos Text"/>
               </a:rPr>
-              <a:t>3) Как вести продажи, чтобы Natural не ушёл в эконом Hotel Line</a:t>
-            </a:r>
-          </a:p>
-          <a:p>
-            <a:pPr algn="l">
-              <a:lnSpc>
-                <a:spcPct val="118000"/>
-              </a:lnSpc>
-              <a:spcBef>
-                <a:spcPts val="0"/>
-              </a:spcBef>
-              <a:spcAft>
-                <a:spcPts val="800"/>
-              </a:spcAft>
-            </a:pPr>
-            <a:r>
-              <a:rPr sz="1600" b="1">
+              <a:t>Как не увести Natural в эконом Hotel Line</a:t>
+            </a:r>
+          </a:p>
+          <a:p>
+            <a:pPr algn="l">
+              <a:lnSpc>
+                <a:spcPct val="118000"/>
+              </a:lnSpc>
+              <a:spcBef>
+                <a:spcPts val="0"/>
+              </a:spcBef>
+              <a:spcAft>
+                <a:spcPts val="200"/>
+              </a:spcAft>
+            </a:pPr>
+            <a:r>
+              <a:rPr sz="1500" b="1">
                 <a:solidFill>
                   <a:srgbClr val="1A1A1A"/>
                 </a:solidFill>
                 <a:latin typeface="Manrope"/>
                 <a:rFonts ascii="Manrope" hAnsi="Manrope" cs="Manrope" eastAsia="Manrope"/>
               </a:rPr>
-              <a:t>Спасибо. Вопросы.</a:t>
+              <a:t>Вопросы</a:t>
+            </a:r>
+          </a:p>
+          <a:p>
+            <a:pPr algn="l">
+              <a:lnSpc>
+                <a:spcPct val="118000"/>
+              </a:lnSpc>
+              <a:spcBef>
+                <a:spcPts val="0"/>
+              </a:spcBef>
+              <a:spcAft>
+                <a:spcPts val="0"/>
+              </a:spcAft>
+            </a:pPr>
+            <a:r>
+              <a:rPr sz="1500" b="0">
+                <a:solidFill>
+                  <a:srgbClr val="1A1A1A"/>
+                </a:solidFill>
+                <a:latin typeface="Golos Text"/>
+                <a:rFonts ascii="Golos Text" hAnsi="Golos Text" cs="Golos Text" eastAsia="Golos Text"/>
+              </a:rPr>
+              <a:t>Спасибо</a:t>
             </a:r>
           </a:p>
         </p:txBody>
@@ -10937,7 +11535,7 @@
         <p:spPr>
           <a:xfrm>
             <a:off x="804672" y="1426464"/>
-            <a:ext cx="10582351" cy="3602736"/>
+            <a:ext cx="10582351" cy="3163824"/>
           </a:xfrm>
           <a:prstGeom prst="rect">
             <a:avLst/>
@@ -10956,18 +11554,18 @@
                 <a:spcPts val="0"/>
               </a:spcBef>
               <a:spcAft>
-                <a:spcPts val="400"/>
-              </a:spcAft>
-            </a:pPr>
-            <a:r>
-              <a:rPr sz="1600" b="1">
+                <a:spcPts val="200"/>
+              </a:spcAft>
+            </a:pPr>
+            <a:r>
+              <a:rPr sz="1500" b="1">
                 <a:solidFill>
                   <a:srgbClr val="1A1A1A"/>
                 </a:solidFill>
                 <a:latin typeface="Manrope"/>
                 <a:rFonts ascii="Manrope" hAnsi="Manrope" cs="Manrope" eastAsia="Manrope"/>
               </a:rPr>
-              <a:t>Задача закупщика</a:t>
+              <a:t>Задача</a:t>
             </a:r>
           </a:p>
           <a:p>
@@ -10990,42 +11588,42 @@
                 <a:latin typeface="Golos Text"/>
                 <a:rFonts ascii="Golos Text" hAnsi="Golos Text" cs="Golos Text" eastAsia="Golos Text"/>
               </a:rPr>
-              <a:t>Отель хочет выглядеть экологичнее — без риска для гостя и без пробелов в документах при проверке.</a:t>
-            </a:r>
-          </a:p>
-          <a:p>
-            <a:pPr algn="l">
-              <a:lnSpc>
-                <a:spcPct val="118000"/>
-              </a:lnSpc>
-              <a:spcBef>
-                <a:spcPts val="0"/>
-              </a:spcBef>
-              <a:spcAft>
-                <a:spcPts val="400"/>
-              </a:spcAft>
-            </a:pPr>
-            <a:r>
-              <a:rPr sz="1600" b="1">
+              <a:t>Отель хочет выглядеть экологичнее — без риска для гостя и без пробелов в документах</a:t>
+            </a:r>
+          </a:p>
+          <a:p>
+            <a:pPr algn="l">
+              <a:lnSpc>
+                <a:spcPct val="118000"/>
+              </a:lnSpc>
+              <a:spcBef>
+                <a:spcPts val="0"/>
+              </a:spcBef>
+              <a:spcAft>
+                <a:spcPts val="200"/>
+              </a:spcAft>
+            </a:pPr>
+            <a:r>
+              <a:rPr sz="1500" b="1">
                 <a:solidFill>
                   <a:srgbClr val="1A1A1A"/>
                 </a:solidFill>
                 <a:latin typeface="Manrope"/>
                 <a:rFonts ascii="Manrope" hAnsi="Manrope" cs="Manrope" eastAsia="Manrope"/>
               </a:rPr>
-              <a:t>Что предлагаем</a:t>
-            </a:r>
-          </a:p>
-          <a:p>
-            <a:pPr algn="l">
-              <a:lnSpc>
-                <a:spcPct val="118000"/>
-              </a:lnSpc>
-              <a:spcBef>
-                <a:spcPts val="0"/>
-              </a:spcBef>
-              <a:spcAft>
-                <a:spcPts val="600"/>
+              <a:t>Предложение</a:t>
+            </a:r>
+          </a:p>
+          <a:p>
+            <a:pPr algn="l">
+              <a:lnSpc>
+                <a:spcPct val="118000"/>
+              </a:lnSpc>
+              <a:spcBef>
+                <a:spcPts val="0"/>
+              </a:spcBef>
+              <a:spcAft>
+                <a:spcPts val="1000"/>
               </a:spcAft>
             </a:pPr>
             <a:r>
@@ -11036,19 +11634,42 @@
                 <a:latin typeface="Golos Text"/>
                 <a:rFonts ascii="Golos Text" hAnsi="Golos Text" cs="Golos Text" eastAsia="Golos Text"/>
               </a:rPr>
-              <a:t>Travel+ Natural — пакет документов как у Hotel Line и Fleur:</a:t>
-            </a:r>
-          </a:p>
-          <a:p>
-            <a:pPr algn="l">
-              <a:lnSpc>
-                <a:spcPct val="118000"/>
-              </a:lnSpc>
-              <a:spcBef>
-                <a:spcPts val="0"/>
-              </a:spcBef>
-              <a:spcAft>
-                <a:spcPts val="600"/>
+              <a:t>Travel+ Natural: пакет как у Hotel Line и Fleur (декларация, INCI, протоколы по запросу)</a:t>
+            </a:r>
+          </a:p>
+          <a:p>
+            <a:pPr algn="l">
+              <a:lnSpc>
+                <a:spcPct val="118000"/>
+              </a:lnSpc>
+              <a:spcBef>
+                <a:spcPts val="0"/>
+              </a:spcBef>
+              <a:spcAft>
+                <a:spcPts val="200"/>
+              </a:spcAft>
+            </a:pPr>
+            <a:r>
+              <a:rPr sz="1500" b="1">
+                <a:solidFill>
+                  <a:srgbClr val="1A1A1A"/>
+                </a:solidFill>
+                <a:latin typeface="Manrope"/>
+                <a:rFonts ascii="Manrope" hAnsi="Manrope" cs="Manrope" eastAsia="Manrope"/>
+              </a:rPr>
+              <a:t>На номер</a:t>
+            </a:r>
+          </a:p>
+          <a:p>
+            <a:pPr algn="l">
+              <a:lnSpc>
+                <a:spcPct val="118000"/>
+              </a:lnSpc>
+              <a:spcBef>
+                <a:spcPts val="0"/>
+              </a:spcBef>
+              <a:spcAft>
+                <a:spcPts val="800"/>
               </a:spcAft>
             </a:pPr>
             <a:r>
@@ -11059,19 +11680,42 @@
                 <a:latin typeface="Golos Text"/>
                 <a:rFonts ascii="Golos Text" hAnsi="Golos Text" cs="Golos Text" eastAsia="Golos Text"/>
               </a:rPr>
-              <a:t>декларация или СГР, INCI, протоколы по запросу.</a:t>
-            </a:r>
-          </a:p>
-          <a:p>
-            <a:pPr algn="l">
-              <a:lnSpc>
-                <a:spcPct val="118000"/>
-              </a:lnSpc>
-              <a:spcBef>
-                <a:spcPts val="0"/>
-              </a:spcBef>
-              <a:spcAft>
-                <a:spcPts val="1000"/>
+              <a:t>Состав с блоком «простыми словами», один договор на весь номер</a:t>
+            </a:r>
+          </a:p>
+          <a:p>
+            <a:pPr algn="l">
+              <a:lnSpc>
+                <a:spcPct val="118000"/>
+              </a:lnSpc>
+              <a:spcBef>
+                <a:spcPts val="0"/>
+              </a:spcBef>
+              <a:spcAft>
+                <a:spcPts val="200"/>
+              </a:spcAft>
+            </a:pPr>
+            <a:r>
+              <a:rPr sz="1500" b="1">
+                <a:solidFill>
+                  <a:srgbClr val="1A1A1A"/>
+                </a:solidFill>
+                <a:latin typeface="Manrope"/>
+                <a:rFonts ascii="Manrope" hAnsi="Manrope" cs="Manrope" eastAsia="Manrope"/>
+              </a:rPr>
+              <a:t>Шаг 1</a:t>
+            </a:r>
+          </a:p>
+          <a:p>
+            <a:pPr algn="l">
+              <a:lnSpc>
+                <a:spcPct val="118000"/>
+              </a:lnSpc>
+              <a:spcBef>
+                <a:spcPts val="0"/>
+              </a:spcBef>
+              <a:spcAft>
+                <a:spcPts val="800"/>
               </a:spcAft>
             </a:pPr>
             <a:r>
@@ -11082,42 +11726,42 @@
                 <a:latin typeface="Golos Text"/>
                 <a:rFonts ascii="Golos Text" hAnsi="Golos Text" cs="Golos Text" eastAsia="Golos Text"/>
               </a:rPr>
-              <a:t>Состав с блоком «простыми словами». Один договор на весь номер.</a:t>
-            </a:r>
-          </a:p>
-          <a:p>
-            <a:pPr algn="l">
-              <a:lnSpc>
-                <a:spcPct val="118000"/>
-              </a:lnSpc>
-              <a:spcBef>
-                <a:spcPts val="0"/>
-              </a:spcBef>
-              <a:spcAft>
-                <a:spcPts val="400"/>
-              </a:spcAft>
-            </a:pPr>
-            <a:r>
-              <a:rPr sz="1600" b="1">
+              <a:t>Сегмент eco / wellness и объект</a:t>
+            </a:r>
+          </a:p>
+          <a:p>
+            <a:pPr algn="l">
+              <a:lnSpc>
+                <a:spcPct val="118000"/>
+              </a:lnSpc>
+              <a:spcBef>
+                <a:spcPts val="0"/>
+              </a:spcBef>
+              <a:spcAft>
+                <a:spcPts val="200"/>
+              </a:spcAft>
+            </a:pPr>
+            <a:r>
+              <a:rPr sz="1500" b="1">
                 <a:solidFill>
                   <a:srgbClr val="1A1A1A"/>
                 </a:solidFill>
                 <a:latin typeface="Manrope"/>
                 <a:rFonts ascii="Manrope" hAnsi="Manrope" cs="Manrope" eastAsia="Manrope"/>
               </a:rPr>
-              <a:t>Три шага</a:t>
-            </a:r>
-          </a:p>
-          <a:p>
-            <a:pPr algn="l">
-              <a:lnSpc>
-                <a:spcPct val="118000"/>
-              </a:lnSpc>
-              <a:spcBef>
-                <a:spcPts val="0"/>
-              </a:spcBef>
-              <a:spcAft>
-                <a:spcPts val="600"/>
+              <a:t>Шаг 2</a:t>
+            </a:r>
+          </a:p>
+          <a:p>
+            <a:pPr algn="l">
+              <a:lnSpc>
+                <a:spcPct val="118000"/>
+              </a:lnSpc>
+              <a:spcBef>
+                <a:spcPts val="0"/>
+              </a:spcBef>
+              <a:spcAft>
+                <a:spcPts val="800"/>
               </a:spcAft>
             </a:pPr>
             <a:r>
@@ -11128,19 +11772,42 @@
                 <a:latin typeface="Golos Text"/>
                 <a:rFonts ascii="Golos Text" hAnsi="Golos Text" cs="Golos Text" eastAsia="Golos Text"/>
               </a:rPr>
-              <a:t>1. Сегмент eco / wellness и объект</a:t>
-            </a:r>
-          </a:p>
-          <a:p>
-            <a:pPr algn="l">
-              <a:lnSpc>
-                <a:spcPct val="118000"/>
-              </a:lnSpc>
-              <a:spcBef>
-                <a:spcPts val="0"/>
-              </a:spcBef>
-              <a:spcAft>
-                <a:spcPts val="600"/>
+              <a:t>Образец с этикеткой и документами</a:t>
+            </a:r>
+          </a:p>
+          <a:p>
+            <a:pPr algn="l">
+              <a:lnSpc>
+                <a:spcPct val="118000"/>
+              </a:lnSpc>
+              <a:spcBef>
+                <a:spcPts val="0"/>
+              </a:spcBef>
+              <a:spcAft>
+                <a:spcPts val="200"/>
+              </a:spcAft>
+            </a:pPr>
+            <a:r>
+              <a:rPr sz="1500" b="1">
+                <a:solidFill>
+                  <a:srgbClr val="1A1A1A"/>
+                </a:solidFill>
+                <a:latin typeface="Manrope"/>
+                <a:rFonts ascii="Manrope" hAnsi="Manrope" cs="Manrope" eastAsia="Manrope"/>
+              </a:rPr>
+              <a:t>Шаг 3</a:t>
+            </a:r>
+          </a:p>
+          <a:p>
+            <a:pPr algn="l">
+              <a:lnSpc>
+                <a:spcPct val="118000"/>
+              </a:lnSpc>
+              <a:spcBef>
+                <a:spcPts val="0"/>
+              </a:spcBef>
+              <a:spcAft>
+                <a:spcPts val="0"/>
               </a:spcAft>
             </a:pPr>
             <a:r>
@@ -11151,30 +11818,7 @@
                 <a:latin typeface="Golos Text"/>
                 <a:rFonts ascii="Golos Text" hAnsi="Golos Text" cs="Golos Text" eastAsia="Golos Text"/>
               </a:rPr>
-              <a:t>2. Образец с этикеткой и документами</a:t>
-            </a:r>
-          </a:p>
-          <a:p>
-            <a:pPr algn="l">
-              <a:lnSpc>
-                <a:spcPct val="118000"/>
-              </a:lnSpc>
-              <a:spcBef>
-                <a:spcPts val="0"/>
-              </a:spcBef>
-              <a:spcAft>
-                <a:spcPts val="600"/>
-              </a:spcAft>
-            </a:pPr>
-            <a:r>
-              <a:rPr sz="1500" b="0">
-                <a:solidFill>
-                  <a:srgbClr val="1A1A1A"/>
-                </a:solidFill>
-                <a:latin typeface="Golos Text"/>
-                <a:rFonts ascii="Golos Text" hAnsi="Golos Text" cs="Golos Text" eastAsia="Golos Text"/>
-              </a:rPr>
-              <a:t>3. Пилот на этаже или в корпусе</a:t>
+              <a:t>Пилот на этаже или в корпусе</a:t>
             </a:r>
           </a:p>
         </p:txBody>
@@ -11187,8 +11831,8 @@
         </p:nvSpPr>
         <p:spPr>
           <a:xfrm>
-            <a:off x="804672" y="5468112"/>
-            <a:ext cx="10582351" cy="502920"/>
+            <a:off x="804672" y="4590288"/>
+            <a:ext cx="10582351" cy="438912"/>
           </a:xfrm>
           <a:prstGeom prst="rect">
             <a:avLst/>
@@ -11211,7 +11855,7 @@
               </a:spcAft>
             </a:pPr>
             <a:r>
-              <a:rPr sz="1400" b="0">
+              <a:rPr sz="1200" b="0">
                 <a:solidFill>
                   <a:srgbClr val="5C5C5C"/>
                 </a:solidFill>
@@ -11773,7 +12417,7 @@
                 <a:spcPts val="0"/>
               </a:spcBef>
               <a:spcAft>
-                <a:spcPts val="1000"/>
+                <a:spcPts val="800"/>
               </a:spcAft>
             </a:pPr>
             <a:r>
@@ -11784,7 +12428,7 @@
                 <a:latin typeface="Golos Text"/>
                 <a:rFonts ascii="Golos Text" hAnsi="Golos Text" cs="Golos Text" eastAsia="Golos Text"/>
               </a:rPr>
-              <a:t>Знака нет — Natural в это коммерческое предложение не ставим. Предлагаем Hotel Line или отказ.</a:t>
+              <a:t>Знака нет — Natural в КП не ставим. Hotel Line или отказ.</a:t>
             </a:r>
           </a:p>
           <a:p>
@@ -11819,7 +12463,7 @@
                 <a:spcPts val="0"/>
               </a:spcBef>
               <a:spcAft>
-                <a:spcPts val="1000"/>
+                <a:spcPts val="800"/>
               </a:spcAft>
             </a:pPr>
             <a:r>
@@ -11830,7 +12474,7 @@
                 <a:latin typeface="Golos Text"/>
                 <a:rFonts ascii="Golos Text" hAnsi="Golos Text" cs="Golos Text" eastAsia="Golos Text"/>
               </a:rPr>
-              <a:t>Нет. Другая себестоимость и другая позиция на полке.</a:t>
+              <a:t>Нет. Другая себестоимость и позиция на полке.</a:t>
             </a:r>
           </a:p>
           <a:p>
@@ -11911,7 +12555,7 @@
                 <a:spcPts val="0"/>
               </a:spcBef>
               <a:spcAft>
-                <a:spcPts val="600"/>
+                <a:spcPts val="0"/>
               </a:spcAft>
             </a:pPr>
             <a:r>
@@ -11922,7 +12566,7 @@
                 <a:latin typeface="Golos Text"/>
                 <a:rFonts ascii="Golos Text" hAnsi="Golos Text" cs="Golos Text" eastAsia="Golos Text"/>
               </a:rPr>
-              <a:t>Только зафиксированное происхождение. Без догадок и «скорее всего».</a:t>
+              <a:t>Только зафиксированное происхождение. Без догадок.</a:t>
             </a:r>
           </a:p>
         </p:txBody>
@@ -11978,7 +12622,30 @@
                 <a:spcPts val="0"/>
               </a:spcBef>
               <a:spcAft>
-                <a:spcPts val="600"/>
+                <a:spcPts val="200"/>
+              </a:spcAft>
+            </a:pPr>
+            <a:r>
+              <a:rPr sz="1500" b="1">
+                <a:solidFill>
+                  <a:srgbClr val="1A1A1A"/>
+                </a:solidFill>
+                <a:latin typeface="Manrope"/>
+                <a:rFonts ascii="Manrope" hAnsi="Manrope" cs="Manrope" eastAsia="Manrope"/>
+              </a:rPr>
+              <a:t>Реестр рисков</a:t>
+            </a:r>
+          </a:p>
+          <a:p>
+            <a:pPr algn="l">
+              <a:lnSpc>
+                <a:spcPct val="118000"/>
+              </a:lnSpc>
+              <a:spcBef>
+                <a:spcPts val="0"/>
+              </a:spcBef>
+              <a:spcAft>
+                <a:spcPts val="1000"/>
               </a:spcAft>
             </a:pPr>
             <a:r>
@@ -11989,7 +12656,30 @@
                 <a:latin typeface="Golos Text"/>
                 <a:rFonts ascii="Golos Text" hAnsi="Golos Text" cs="Golos Text" eastAsia="Golos Text"/>
               </a:rPr>
-              <a:t>Реестр рисков — один лист в пульте (14 пунктов).</a:t>
+              <a:t>Один лист в пульте — 14 пунктов</a:t>
+            </a:r>
+          </a:p>
+          <a:p>
+            <a:pPr algn="l">
+              <a:lnSpc>
+                <a:spcPct val="118000"/>
+              </a:lnSpc>
+              <a:spcBef>
+                <a:spcPts val="0"/>
+              </a:spcBef>
+              <a:spcAft>
+                <a:spcPts val="200"/>
+              </a:spcAft>
+            </a:pPr>
+            <a:r>
+              <a:rPr sz="1500" b="1">
+                <a:solidFill>
+                  <a:srgbClr val="1A1A1A"/>
+                </a:solidFill>
+                <a:latin typeface="Manrope"/>
+                <a:rFonts ascii="Manrope" hAnsi="Manrope" cs="Manrope" eastAsia="Manrope"/>
+              </a:rPr>
+              <a:t>Сегмент</a:t>
             </a:r>
           </a:p>
           <a:p>
@@ -12012,19 +12702,19 @@
                 <a:latin typeface="Golos Text"/>
                 <a:rFonts ascii="Golos Text" hAnsi="Golos Text" cs="Golos Text" eastAsia="Golos Text"/>
               </a:rPr>
-              <a:t>Сегмент не размываем: Natural не уходит в эконом-запрос.</a:t>
-            </a:r>
-          </a:p>
-          <a:p>
-            <a:pPr algn="l">
-              <a:lnSpc>
-                <a:spcPct val="118000"/>
-              </a:lnSpc>
-              <a:spcBef>
-                <a:spcPts val="0"/>
-              </a:spcBef>
-              <a:spcAft>
-                <a:spcPts val="800"/>
+              <a:t>Не размываем: Natural не уходит в эконом-запрос</a:t>
+            </a:r>
+          </a:p>
+          <a:p>
+            <a:pPr algn="l">
+              <a:lnSpc>
+                <a:spcPct val="118000"/>
+              </a:lnSpc>
+              <a:spcBef>
+                <a:spcPts val="0"/>
+              </a:spcBef>
+              <a:spcAft>
+                <a:spcPts val="200"/>
               </a:spcAft>
             </a:pPr>
             <a:r>
@@ -12035,30 +12725,30 @@
                 <a:latin typeface="Manrope"/>
                 <a:rFonts ascii="Manrope" hAnsi="Manrope" cs="Manrope" eastAsia="Manrope"/>
               </a:rPr>
-              <a:t>Не продаём Natural вместо Hotel Line по цене базовой линейки.</a:t>
-            </a:r>
-          </a:p>
-          <a:p>
-            <a:pPr algn="l">
-              <a:lnSpc>
-                <a:spcPct val="118000"/>
-              </a:lnSpc>
-              <a:spcBef>
-                <a:spcPts val="1800"/>
-              </a:spcBef>
-              <a:spcAft>
-                <a:spcPts val="0"/>
-              </a:spcAft>
-            </a:pPr>
-            <a:r>
-              <a:rPr sz="1200" b="0">
-                <a:solidFill>
-                  <a:srgbClr val="5C5C5C"/>
+              <a:t>Цена</a:t>
+            </a:r>
+          </a:p>
+          <a:p>
+            <a:pPr algn="l">
+              <a:lnSpc>
+                <a:spcPct val="118000"/>
+              </a:lnSpc>
+              <a:spcBef>
+                <a:spcPts val="0"/>
+              </a:spcBef>
+              <a:spcAft>
+                <a:spcPts val="0"/>
+              </a:spcAft>
+            </a:pPr>
+            <a:r>
+              <a:rPr sz="1500" b="0">
+                <a:solidFill>
+                  <a:srgbClr val="1A1A1A"/>
                 </a:solidFill>
                 <a:latin typeface="Golos Text"/>
                 <a:rFonts ascii="Golos Text" hAnsi="Golos Text" cs="Golos Text" eastAsia="Golos Text"/>
               </a:rPr>
-              <a:t>Цифры сценария — учебный пример, не отчёт завода.</a:t>
+              <a:t>Не продаём Natural вместо Hotel Line по цене базовой линейки</a:t>
             </a:r>
           </a:p>
         </p:txBody>
@@ -12578,19 +13268,42 @@
                 <a:latin typeface="Manrope"/>
                 <a:rFonts ascii="Manrope" hAnsi="Manrope" cs="Manrope" eastAsia="Manrope"/>
               </a:rPr>
-              <a:t>Успех (учебный порог)</a:t>
-            </a:r>
-          </a:p>
-          <a:p>
-            <a:pPr algn="l">
-              <a:lnSpc>
-                <a:spcPct val="118000"/>
-              </a:lnSpc>
-              <a:spcBef>
-                <a:spcPts val="0"/>
-              </a:spcBef>
-              <a:spcAft>
-                <a:spcPts val="600"/>
+              <a:t>Успех</a:t>
+            </a:r>
+          </a:p>
+          <a:p>
+            <a:pPr algn="l">
+              <a:lnSpc>
+                <a:spcPct val="118000"/>
+              </a:lnSpc>
+              <a:spcBef>
+                <a:spcPts val="0"/>
+              </a:spcBef>
+              <a:spcAft>
+                <a:spcPts val="200"/>
+              </a:spcAft>
+            </a:pPr>
+            <a:r>
+              <a:rPr sz="1500" b="1">
+                <a:solidFill>
+                  <a:srgbClr val="1A1A1A"/>
+                </a:solidFill>
+                <a:latin typeface="Manrope"/>
+                <a:rFonts ascii="Manrope" hAnsi="Manrope" cs="Manrope" eastAsia="Manrope"/>
+              </a:rPr>
+              <a:t>Клиенты</a:t>
+            </a:r>
+          </a:p>
+          <a:p>
+            <a:pPr algn="l">
+              <a:lnSpc>
+                <a:spcPct val="118000"/>
+              </a:lnSpc>
+              <a:spcBef>
+                <a:spcPts val="0"/>
+              </a:spcBef>
+              <a:spcAft>
+                <a:spcPts val="800"/>
               </a:spcAft>
             </a:pPr>
             <a:r>
@@ -12601,19 +13314,42 @@
                 <a:latin typeface="Golos Text"/>
                 <a:rFonts ascii="Golos Text" hAnsi="Golos Text" cs="Golos Text" eastAsia="Golos Text"/>
               </a:rPr>
-              <a:t>• Три пилотных клиента</a:t>
-            </a:r>
-          </a:p>
-          <a:p>
-            <a:pPr algn="l">
-              <a:lnSpc>
-                <a:spcPct val="118000"/>
-              </a:lnSpc>
-              <a:spcBef>
-                <a:spcPts val="0"/>
-              </a:spcBef>
-              <a:spcAft>
-                <a:spcPts val="600"/>
+              <a:t>Три пилотных объекта</a:t>
+            </a:r>
+          </a:p>
+          <a:p>
+            <a:pPr algn="l">
+              <a:lnSpc>
+                <a:spcPct val="118000"/>
+              </a:lnSpc>
+              <a:spcBef>
+                <a:spcPts val="0"/>
+              </a:spcBef>
+              <a:spcAft>
+                <a:spcPts val="200"/>
+              </a:spcAft>
+            </a:pPr>
+            <a:r>
+              <a:rPr sz="1500" b="1">
+                <a:solidFill>
+                  <a:srgbClr val="1A1A1A"/>
+                </a:solidFill>
+                <a:latin typeface="Manrope"/>
+                <a:rFonts ascii="Manrope" hAnsi="Manrope" cs="Manrope" eastAsia="Manrope"/>
+              </a:rPr>
+              <a:t>Повтор</a:t>
+            </a:r>
+          </a:p>
+          <a:p>
+            <a:pPr algn="l">
+              <a:lnSpc>
+                <a:spcPct val="118000"/>
+              </a:lnSpc>
+              <a:spcBef>
+                <a:spcPts val="0"/>
+              </a:spcBef>
+              <a:spcAft>
+                <a:spcPts val="800"/>
               </a:spcAft>
             </a:pPr>
             <a:r>
@@ -12624,19 +13360,42 @@
                 <a:latin typeface="Golos Text"/>
                 <a:rFonts ascii="Golos Text" hAnsi="Golos Text" cs="Golos Text" eastAsia="Golos Text"/>
               </a:rPr>
-              <a:t>• Повторный заказ минимум у двух из трёх</a:t>
-            </a:r>
-          </a:p>
-          <a:p>
-            <a:pPr algn="l">
-              <a:lnSpc>
-                <a:spcPct val="118000"/>
-              </a:lnSpc>
-              <a:spcBef>
-                <a:spcPts val="0"/>
-              </a:spcBef>
-              <a:spcAft>
-                <a:spcPts val="600"/>
+              <a:t>Заказ повторяют минимум два из трёх</a:t>
+            </a:r>
+          </a:p>
+          <a:p>
+            <a:pPr algn="l">
+              <a:lnSpc>
+                <a:spcPct val="118000"/>
+              </a:lnSpc>
+              <a:spcBef>
+                <a:spcPts val="0"/>
+              </a:spcBef>
+              <a:spcAft>
+                <a:spcPts val="200"/>
+              </a:spcAft>
+            </a:pPr>
+            <a:r>
+              <a:rPr sz="1500" b="1">
+                <a:solidFill>
+                  <a:srgbClr val="1A1A1A"/>
+                </a:solidFill>
+                <a:latin typeface="Manrope"/>
+                <a:rFonts ascii="Manrope" hAnsi="Manrope" cs="Manrope" eastAsia="Manrope"/>
+              </a:rPr>
+              <a:t>Опрос</a:t>
+            </a:r>
+          </a:p>
+          <a:p>
+            <a:pPr algn="l">
+              <a:lnSpc>
+                <a:spcPct val="118000"/>
+              </a:lnSpc>
+              <a:spcBef>
+                <a:spcPts val="0"/>
+              </a:spcBef>
+              <a:spcAft>
+                <a:spcPts val="800"/>
               </a:spcAft>
             </a:pPr>
             <a:r>
@@ -12647,19 +13406,19 @@
                 <a:latin typeface="Golos Text"/>
                 <a:rFonts ascii="Golos Text" hAnsi="Golos Text" cs="Golos Text" eastAsia="Golos Text"/>
               </a:rPr>
-              <a:t>• Мягкость и ощущение натуральности — не ниже 70% в опросе</a:t>
-            </a:r>
-          </a:p>
-          <a:p>
-            <a:pPr algn="l">
-              <a:lnSpc>
-                <a:spcPct val="118000"/>
-              </a:lnSpc>
-              <a:spcBef>
-                <a:spcPts val="0"/>
-              </a:spcBef>
-              <a:spcAft>
-                <a:spcPts val="800"/>
+              <a:t>Мягкость и ощущение натуральности — не ниже 70%</a:t>
+            </a:r>
+          </a:p>
+          <a:p>
+            <a:pPr algn="l">
+              <a:lnSpc>
+                <a:spcPct val="118000"/>
+              </a:lnSpc>
+              <a:spcBef>
+                <a:spcPts val="0"/>
+              </a:spcBef>
+              <a:spcAft>
+                <a:spcPts val="200"/>
               </a:spcAft>
             </a:pPr>
             <a:r>
@@ -12670,29 +13429,52 @@
                 <a:latin typeface="Manrope"/>
                 <a:rFonts ascii="Manrope" hAnsi="Manrope" cs="Manrope" eastAsia="Manrope"/>
               </a:rPr>
-              <a:t>• Natural не ушёл в эконом Hotel Line</a:t>
-            </a:r>
-          </a:p>
-          <a:p>
-            <a:pPr algn="l">
-              <a:lnSpc>
-                <a:spcPct val="118000"/>
-              </a:lnSpc>
-              <a:spcBef>
-                <a:spcPts val="1800"/>
-              </a:spcBef>
-              <a:spcAft>
-                <a:spcPts val="0"/>
-              </a:spcAft>
-            </a:pPr>
-            <a:r>
-              <a:rPr sz="1200" b="0">
-                <a:solidFill>
-                  <a:srgbClr val="5C5C5C"/>
+              <a:t>Цена</a:t>
+            </a:r>
+          </a:p>
+          <a:p>
+            <a:pPr algn="l">
+              <a:lnSpc>
+                <a:spcPct val="118000"/>
+              </a:lnSpc>
+              <a:spcBef>
+                <a:spcPts val="0"/>
+              </a:spcBef>
+              <a:spcAft>
+                <a:spcPts val="800"/>
+              </a:spcAft>
+            </a:pPr>
+            <a:r>
+              <a:rPr sz="1500" b="0">
+                <a:solidFill>
+                  <a:srgbClr val="1A1A1A"/>
                 </a:solidFill>
                 <a:latin typeface="Golos Text"/>
                 <a:rFonts ascii="Golos Text" hAnsi="Golos Text" cs="Golos Text" eastAsia="Golos Text"/>
               </a:rPr>
+              <a:t>Natural не ушёл в эконом Hotel Line</a:t>
+            </a:r>
+          </a:p>
+          <a:p>
+            <a:pPr algn="l">
+              <a:lnSpc>
+                <a:spcPct val="118000"/>
+              </a:lnSpc>
+              <a:spcBef>
+                <a:spcPts val="1800"/>
+              </a:spcBef>
+              <a:spcAft>
+                <a:spcPts val="0"/>
+              </a:spcAft>
+            </a:pPr>
+            <a:r>
+              <a:rPr sz="1200" b="0">
+                <a:solidFill>
+                  <a:srgbClr val="5C5C5C"/>
+                </a:solidFill>
+                <a:latin typeface="Golos Text"/>
+                <a:rFonts ascii="Golos Text" hAnsi="Golos Text" cs="Golos Text" eastAsia="Golos Text"/>
+              </a:rPr>
               <a:t>Цифры сценария — учебный пример, не отчёт завода.</a:t>
             </a:r>
           </a:p>
@@ -12749,7 +13531,30 @@
                 <a:spcPts val="0"/>
               </a:spcBef>
               <a:spcAft>
-                <a:spcPts val="600"/>
+                <a:spcPts val="200"/>
+              </a:spcAft>
+            </a:pPr>
+            <a:r>
+              <a:rPr sz="1500" b="1">
+                <a:solidFill>
+                  <a:srgbClr val="1A1A1A"/>
+                </a:solidFill>
+                <a:latin typeface="Manrope"/>
+                <a:rFonts ascii="Manrope" hAnsi="Manrope" cs="Manrope" eastAsia="Manrope"/>
+              </a:rPr>
+              <a:t>Провал</a:t>
+            </a:r>
+          </a:p>
+          <a:p>
+            <a:pPr algn="l">
+              <a:lnSpc>
+                <a:spcPct val="118000"/>
+              </a:lnSpc>
+              <a:spcBef>
+                <a:spcPts val="0"/>
+              </a:spcBef>
+              <a:spcAft>
+                <a:spcPts val="800"/>
               </a:spcAft>
             </a:pPr>
             <a:r>
@@ -12760,19 +13565,19 @@
                 <a:latin typeface="Golos Text"/>
                 <a:rFonts ascii="Golos Text" hAnsi="Golos Text" cs="Golos Text" eastAsia="Golos Text"/>
               </a:rPr>
-              <a:t>Повторный заказ меньше чем у двух из трёх — или метрики ниже 60%.</a:t>
-            </a:r>
-          </a:p>
-          <a:p>
-            <a:pPr algn="l">
-              <a:lnSpc>
-                <a:spcPct val="118000"/>
-              </a:lnSpc>
-              <a:spcBef>
-                <a:spcPts val="0"/>
-              </a:spcBef>
-              <a:spcAft>
-                <a:spcPts val="800"/>
+              <a:t>Повтор у меньше двух из трёх — или метрики ниже 60%</a:t>
+            </a:r>
+          </a:p>
+          <a:p>
+            <a:pPr algn="l">
+              <a:lnSpc>
+                <a:spcPct val="118000"/>
+              </a:lnSpc>
+              <a:spcBef>
+                <a:spcPts val="0"/>
+              </a:spcBef>
+              <a:spcAft>
+                <a:spcPts val="200"/>
               </a:spcAft>
             </a:pPr>
             <a:r>
@@ -12783,19 +13588,19 @@
                 <a:latin typeface="Manrope"/>
                 <a:rFonts ascii="Manrope" hAnsi="Manrope" cs="Manrope" eastAsia="Manrope"/>
               </a:rPr>
-              <a:t>→ Останавливаем масштабирование</a:t>
-            </a:r>
-          </a:p>
-          <a:p>
-            <a:pPr algn="l">
-              <a:lnSpc>
-                <a:spcPct val="118000"/>
-              </a:lnSpc>
-              <a:spcBef>
-                <a:spcPts val="0"/>
-              </a:spcBef>
-              <a:spcAft>
-                <a:spcPts val="600"/>
+              <a:t>Действие</a:t>
+            </a:r>
+          </a:p>
+          <a:p>
+            <a:pPr algn="l">
+              <a:lnSpc>
+                <a:spcPct val="118000"/>
+              </a:lnSpc>
+              <a:spcBef>
+                <a:spcPts val="0"/>
+              </a:spcBef>
+              <a:spcAft>
+                <a:spcPts val="800"/>
               </a:spcAft>
             </a:pPr>
             <a:r>
@@ -12806,19 +13611,42 @@
                 <a:latin typeface="Golos Text"/>
                 <a:rFonts ascii="Golos Text" hAnsi="Golos Text" cs="Golos Text" eastAsia="Golos Text"/>
               </a:rPr>
-              <a:t>Диагноз бренд-менеджера — в течение двух недель.</a:t>
-            </a:r>
-          </a:p>
-          <a:p>
-            <a:pPr algn="l">
-              <a:lnSpc>
-                <a:spcPct val="118000"/>
-              </a:lnSpc>
-              <a:spcBef>
-                <a:spcPts val="0"/>
-              </a:spcBef>
-              <a:spcAft>
-                <a:spcPts val="600"/>
+              <a:t>Останавливаем масштабирование</a:t>
+            </a:r>
+          </a:p>
+          <a:p>
+            <a:pPr algn="l">
+              <a:lnSpc>
+                <a:spcPct val="118000"/>
+              </a:lnSpc>
+              <a:spcBef>
+                <a:spcPts val="0"/>
+              </a:spcBef>
+              <a:spcAft>
+                <a:spcPts val="200"/>
+              </a:spcAft>
+            </a:pPr>
+            <a:r>
+              <a:rPr sz="1500" b="1">
+                <a:solidFill>
+                  <a:srgbClr val="1A1A1A"/>
+                </a:solidFill>
+                <a:latin typeface="Manrope"/>
+                <a:rFonts ascii="Manrope" hAnsi="Manrope" cs="Manrope" eastAsia="Manrope"/>
+              </a:rPr>
+              <a:t>Диагноз</a:t>
+            </a:r>
+          </a:p>
+          <a:p>
+            <a:pPr algn="l">
+              <a:lnSpc>
+                <a:spcPct val="118000"/>
+              </a:lnSpc>
+              <a:spcBef>
+                <a:spcPts val="0"/>
+              </a:spcBef>
+              <a:spcAft>
+                <a:spcPts val="800"/>
               </a:spcAft>
             </a:pPr>
             <a:r>
@@ -12829,19 +13657,19 @@
                 <a:latin typeface="Golos Text"/>
                 <a:rFonts ascii="Golos Text" hAnsi="Golos Text" cs="Golos Text" eastAsia="Golos Text"/>
               </a:rPr>
-              <a:t>Второй пилотный круг снова провален.</a:t>
-            </a:r>
-          </a:p>
-          <a:p>
-            <a:pPr algn="l">
-              <a:lnSpc>
-                <a:spcPct val="118000"/>
-              </a:lnSpc>
-              <a:spcBef>
-                <a:spcPts val="0"/>
-              </a:spcBef>
-              <a:spcAft>
-                <a:spcPts val="800"/>
+              <a:t>Бренд-менеджер — в течение двух недель</a:t>
+            </a:r>
+          </a:p>
+          <a:p>
+            <a:pPr algn="l">
+              <a:lnSpc>
+                <a:spcPct val="118000"/>
+              </a:lnSpc>
+              <a:spcBef>
+                <a:spcPts val="0"/>
+              </a:spcBef>
+              <a:spcAft>
+                <a:spcPts val="200"/>
               </a:spcAft>
             </a:pPr>
             <a:r>
@@ -12852,7 +13680,30 @@
                 <a:latin typeface="Manrope"/>
                 <a:rFonts ascii="Manrope" hAnsi="Manrope" cs="Manrope" eastAsia="Manrope"/>
               </a:rPr>
-              <a:t>→ Закрываем линейку</a:t>
+              <a:t>Второй круг</a:t>
+            </a:r>
+          </a:p>
+          <a:p>
+            <a:pPr algn="l">
+              <a:lnSpc>
+                <a:spcPct val="118000"/>
+              </a:lnSpc>
+              <a:spcBef>
+                <a:spcPts val="0"/>
+              </a:spcBef>
+              <a:spcAft>
+                <a:spcPts val="800"/>
+              </a:spcAft>
+            </a:pPr>
+            <a:r>
+              <a:rPr sz="1500" b="0">
+                <a:solidFill>
+                  <a:srgbClr val="1A1A1A"/>
+                </a:solidFill>
+                <a:latin typeface="Golos Text"/>
+                <a:rFonts ascii="Golos Text" hAnsi="Golos Text" cs="Golos Text" eastAsia="Golos Text"/>
+              </a:rPr>
+              <a:t>Снова провал → закрываем линейку</a:t>
             </a:r>
           </a:p>
           <a:p>

</xml_diff>

<commit_message>
content(presentation): slide 11 plain copy with teaching example
Co-authored-by: pagasbot-coder <pagasbot-coder@users.noreply.github.com>
</commit_message>
<xml_diff>
--- a/knowledge-base/presentation-travelplus-interview.pptx
+++ b/knowledge-base/presentation-travelplus-interview.pptx
@@ -4658,7 +4658,7 @@
                 <a:latin typeface="Manrope"/>
                 <a:rFonts ascii="Manrope" hAnsi="Manrope" cs="Manrope" eastAsia="Manrope"/>
               </a:rPr>
-              <a:t>Что уже есть в пульте</a:t>
+              <a:t>Себестоимость: как считаю</a:t>
             </a:r>
           </a:p>
         </p:txBody>
@@ -5039,7 +5039,7 @@
                 <a:latin typeface="Manrope"/>
                 <a:rFonts ascii="Manrope" hAnsi="Manrope" cs="Manrope" eastAsia="Manrope"/>
               </a:rPr>
-              <a:t>Содержание v1.14</a:t>
+              <a:t>Цена на складе</a:t>
             </a:r>
           </a:p>
           <a:p>
@@ -5062,7 +5062,7 @@
                 <a:latin typeface="Manrope"/>
                 <a:rFonts ascii="Manrope" hAnsi="Manrope" cs="Manrope" eastAsia="Manrope"/>
               </a:rPr>
-              <a:t>Этапы 0–2</a:t>
+              <a:t>FOB</a:t>
             </a:r>
           </a:p>
           <a:p>
@@ -5085,7 +5085,7 @@
                 <a:latin typeface="Golos Text"/>
                 <a:rFonts ascii="Golos Text" hAnsi="Golos Text" cs="Golos Text" eastAsia="Golos Text"/>
               </a:rPr>
-              <a:t>Разведка, правила, границы продукта</a:t>
+              <a:t>База сравнения заводов — отдельно от логистики</a:t>
             </a:r>
           </a:p>
           <a:p>
@@ -5108,7 +5108,7 @@
                 <a:latin typeface="Manrope"/>
                 <a:rFonts ascii="Manrope" hAnsi="Manrope" cs="Manrope" eastAsia="Manrope"/>
               </a:rPr>
-              <a:t>Этапы 3–6</a:t>
+              <a:t>Доставка</a:t>
             </a:r>
           </a:p>
           <a:p>
@@ -5131,7 +5131,7 @@
                 <a:latin typeface="Golos Text"/>
                 <a:rFonts ascii="Golos Text" hAnsi="Golos Text" cs="Golos Text" eastAsia="Golos Text"/>
               </a:rPr>
-              <a:t>Сценарий «как вести дело»</a:t>
+              <a:t>Фрахт, экспедитор, довоз до Кириши</a:t>
             </a:r>
           </a:p>
           <a:p>
@@ -5154,7 +5154,7 @@
                 <a:latin typeface="Manrope"/>
                 <a:rFonts ascii="Manrope" hAnsi="Manrope" cs="Manrope" eastAsia="Manrope"/>
               </a:rPr>
-              <a:t>Инструменты</a:t>
+              <a:t>Таможня</a:t>
             </a:r>
           </a:p>
           <a:p>
@@ -5177,7 +5177,7 @@
                 <a:latin typeface="Golos Text"/>
                 <a:rFonts ascii="Golos Text" hAnsi="Golos Text" cs="Golos Text" eastAsia="Golos Text"/>
               </a:rPr>
-              <a:t>StoryBrand, чеклист, реестр рисков, пилот</a:t>
+              <a:t>Пошлина, НДС, брокер</a:t>
             </a:r>
           </a:p>
           <a:p>
@@ -5200,7 +5200,7 @@
                 <a:latin typeface="Manrope"/>
                 <a:rFonts ascii="Manrope" hAnsi="Manrope" cs="Manrope" eastAsia="Manrope"/>
               </a:rPr>
-              <a:t>Портфель</a:t>
+              <a:t>Запас</a:t>
             </a:r>
           </a:p>
           <a:p>
@@ -5223,30 +5223,76 @@
                 <a:latin typeface="Golos Text"/>
                 <a:rFonts ascii="Golos Text" hAnsi="Golos Text" cs="Golos Text" eastAsia="Golos Text"/>
               </a:rPr>
-              <a:t>Мостик Travel+: Hotel Line, Fleur, Natural, СТМ</a:t>
-            </a:r>
-          </a:p>
-          <a:p>
-            <a:pPr algn="l">
-              <a:lnSpc>
-                <a:spcPct val="118000"/>
-              </a:lnSpc>
-              <a:spcBef>
-                <a:spcPts val="1800"/>
-              </a:spcBef>
-              <a:spcAft>
-                <a:spcPts val="0"/>
-              </a:spcAft>
-            </a:pPr>
-            <a:r>
-              <a:rPr sz="1200" b="0">
-                <a:solidFill>
-                  <a:srgbClr val="5C5C5C"/>
+              <a:t>Брак, пересорт, курс</a:t>
+            </a:r>
+          </a:p>
+          <a:p>
+            <a:pPr algn="l">
+              <a:lnSpc>
+                <a:spcPct val="118000"/>
+              </a:lnSpc>
+              <a:spcBef>
+                <a:spcPts val="0"/>
+              </a:spcBef>
+              <a:spcAft>
+                <a:spcPts val="200"/>
+              </a:spcAft>
+            </a:pPr>
+            <a:r>
+              <a:rPr sz="1500" b="1">
+                <a:solidFill>
+                  <a:srgbClr val="1A1A1A"/>
+                </a:solidFill>
+                <a:latin typeface="Manrope"/>
+                <a:rFonts ascii="Manrope" hAnsi="Manrope" cs="Manrope" eastAsia="Manrope"/>
+              </a:rPr>
+              <a:t>Итог</a:t>
+            </a:r>
+          </a:p>
+          <a:p>
+            <a:pPr algn="l">
+              <a:lnSpc>
+                <a:spcPct val="118000"/>
+              </a:lnSpc>
+              <a:spcBef>
+                <a:spcPts val="0"/>
+              </a:spcBef>
+              <a:spcAft>
+                <a:spcPts val="800"/>
+              </a:spcAft>
+            </a:pPr>
+            <a:r>
+              <a:rPr sz="1500" b="0">
+                <a:solidFill>
+                  <a:srgbClr val="1A1A1A"/>
                 </a:solidFill>
                 <a:latin typeface="Golos Text"/>
                 <a:rFonts ascii="Golos Text" hAnsi="Golos Text" cs="Golos Text" eastAsia="Golos Text"/>
               </a:rPr>
-              <a:t>Образец для поля и собеседования. Не коммерческое предложение.</a:t>
+              <a:t>Сумма строк = цена на складе → из неё прайс и маржа</a:t>
+            </a:r>
+          </a:p>
+          <a:p>
+            <a:pPr algn="l">
+              <a:lnSpc>
+                <a:spcPct val="118000"/>
+              </a:lnSpc>
+              <a:spcBef>
+                <a:spcPts val="1800"/>
+              </a:spcBef>
+              <a:spcAft>
+                <a:spcPts val="0"/>
+              </a:spcAft>
+            </a:pPr>
+            <a:r>
+              <a:rPr sz="1200" b="0">
+                <a:solidFill>
+                  <a:srgbClr val="5C5C5C"/>
+                </a:solidFill>
+                <a:latin typeface="Golos Text"/>
+                <a:rFonts ascii="Golos Text" hAnsi="Golos Text" cs="Golos Text" eastAsia="Golos Text"/>
+              </a:rPr>
+              <a:t>Без этой таблицы прайс Natural не утверждаю.</a:t>
             </a:r>
           </a:p>
         </p:txBody>
@@ -5290,7 +5336,7 @@
                 <a:latin typeface="Manrope"/>
                 <a:rFonts ascii="Manrope" hAnsi="Manrope" cs="Manrope" eastAsia="Manrope"/>
               </a:rPr>
-              <a:t>Справочники</a:t>
+              <a:t>Правила расчёта</a:t>
             </a:r>
           </a:p>
           <a:p>
@@ -5313,7 +5359,7 @@
                 <a:latin typeface="Manrope"/>
                 <a:rFonts ascii="Manrope" hAnsi="Manrope" cs="Manrope" eastAsia="Manrope"/>
               </a:rPr>
-              <a:t>Глоссарии</a:t>
+              <a:t>Заводы</a:t>
             </a:r>
           </a:p>
           <a:p>
@@ -5336,7 +5382,7 @@
                 <a:latin typeface="Golos Text"/>
                 <a:rFonts ascii="Golos Text" hAnsi="Golos Text" cs="Golos Text" eastAsia="Golos Text"/>
               </a:rPr>
-              <a:t>Бренд и ВЭД</a:t>
+              <a:t>Минимум два FOB в сравнении до контракта</a:t>
             </a:r>
           </a:p>
           <a:p>
@@ -5359,7 +5405,7 @@
                 <a:latin typeface="Manrope"/>
                 <a:rFonts ascii="Manrope" hAnsi="Manrope" cs="Manrope" eastAsia="Manrope"/>
               </a:rPr>
-              <a:t>Раздел L</a:t>
+              <a:t>Прайс</a:t>
             </a:r>
           </a:p>
           <a:p>
@@ -5382,7 +5428,7 @@
                 <a:latin typeface="Golos Text"/>
                 <a:rFonts ascii="Golos Text" hAnsi="Golos Text" cs="Golos Text" eastAsia="Golos Text"/>
               </a:rPr>
-              <a:t>Путь товара, Incoterms, RFQ, приёмка</a:t>
+              <a:t>Только после landed cost, не «с потолка»</a:t>
             </a:r>
           </a:p>
           <a:p>
@@ -5405,7 +5451,7 @@
                 <a:latin typeface="Manrope"/>
                 <a:rFonts ascii="Manrope" hAnsi="Manrope" cs="Manrope" eastAsia="Manrope"/>
               </a:rPr>
-              <a:t>Волна A</a:t>
+              <a:t>Маржа</a:t>
             </a:r>
           </a:p>
           <a:p>
@@ -5428,7 +5474,7 @@
                 <a:latin typeface="Golos Text"/>
                 <a:rFonts ascii="Golos Text" hAnsi="Golos Text" cs="Golos Text" eastAsia="Golos Text"/>
               </a:rPr>
-              <a:t>Markdown-реестры в папке brand-pult/</a:t>
+              <a:t>Natural и Hotel Line — разная экономика</a:t>
             </a:r>
           </a:p>
           <a:p>
@@ -5451,7 +5497,7 @@
                 <a:latin typeface="Manrope"/>
                 <a:rFonts ascii="Manrope" hAnsi="Manrope" cs="Manrope" eastAsia="Manrope"/>
               </a:rPr>
-              <a:t>Синхрон</a:t>
+              <a:t>Срок в КП</a:t>
             </a:r>
           </a:p>
           <a:p>
@@ -5474,7 +5520,7 @@
                 <a:latin typeface="Golos Text"/>
                 <a:rFonts ascii="Golos Text" hAnsi="Golos Text" cs="Golos Text" eastAsia="Golos Text"/>
               </a:rPr>
-              <a:t>Презентация и скрипт с пультом</a:t>
+              <a:t>Дата «на складе», не «завод отгрузил»</a:t>
             </a:r>
           </a:p>
           <a:p>
@@ -5497,7 +5543,7 @@
                 <a:latin typeface="Manrope"/>
                 <a:rFonts ascii="Manrope" hAnsi="Manrope" cs="Manrope" eastAsia="Manrope"/>
               </a:rPr>
-              <a:t>Версия 2.0</a:t>
+              <a:t>Коридор</a:t>
             </a:r>
           </a:p>
           <a:p>
@@ -5520,7 +5566,7 @@
                 <a:latin typeface="Golos Text"/>
                 <a:rFonts ascii="Golos Text" hAnsi="Golos Text" cs="Golos Text" eastAsia="Golos Text"/>
               </a:rPr>
-              <a:t>Когда технолог закроет цифры завода</a:t>
+              <a:t>Выше Hotel Line, рядом с ЕТС, ниже Natura Siberica</a:t>
             </a:r>
           </a:p>
         </p:txBody>
@@ -5659,7 +5705,7 @@
                 <a:latin typeface="Manrope"/>
                 <a:rFonts ascii="Manrope" hAnsi="Manrope" cs="Manrope" eastAsia="Manrope"/>
               </a:rPr>
-              <a:t>Итог и следующий шаг</a:t>
+              <a:t>Итог</a:t>
             </a:r>
           </a:p>
         </p:txBody>
@@ -6040,7 +6086,7 @@
                 <a:latin typeface="Manrope"/>
                 <a:rFonts ascii="Manrope" hAnsi="Manrope" cs="Manrope" eastAsia="Manrope"/>
               </a:rPr>
-              <a:t>Собрал</a:t>
+              <a:t>Почему Travel+</a:t>
             </a:r>
           </a:p>
           <a:p>
@@ -6063,7 +6109,7 @@
                 <a:latin typeface="Manrope"/>
                 <a:rFonts ascii="Manrope" hAnsi="Manrope" cs="Manrope" eastAsia="Manrope"/>
               </a:rPr>
-              <a:t>ДНК</a:t>
+              <a:t>Задача</a:t>
             </a:r>
           </a:p>
           <a:p>
@@ -6086,7 +6132,7 @@
                 <a:latin typeface="Golos Text"/>
                 <a:rFonts ascii="Golos Text" hAnsi="Golos Text" cs="Golos Text" eastAsia="Golos Text"/>
               </a:rPr>
-              <a:t>Обещание и границы линейки</a:t>
+              <a:t>Физический товар: своё производство, Китай, дыра Natural на полке</a:t>
             </a:r>
           </a:p>
           <a:p>
@@ -6109,7 +6155,7 @@
                 <a:latin typeface="Manrope"/>
                 <a:rFonts ascii="Manrope" hAnsi="Manrope" cs="Manrope" eastAsia="Manrope"/>
               </a:rPr>
-              <a:t>StoryBrand</a:t>
+              <a:t>Роль</a:t>
             </a:r>
           </a:p>
           <a:p>
@@ -6132,7 +6178,7 @@
                 <a:latin typeface="Golos Text"/>
                 <a:rFonts ascii="Golos Text" hAnsi="Golos Text" cs="Golos Text" eastAsia="Golos Text"/>
               </a:rPr>
-              <a:t>Скрипт для продаж</a:t>
+              <a:t>От рамки линейки до пилота — продукт, цена, документы, поставка</a:t>
             </a:r>
           </a:p>
           <a:p>
@@ -6155,19 +6201,19 @@
                 <a:latin typeface="Manrope"/>
                 <a:rFonts ascii="Manrope" hAnsi="Manrope" cs="Manrope" eastAsia="Manrope"/>
               </a:rPr>
-              <a:t>Чеклист</a:t>
-            </a:r>
-          </a:p>
-          <a:p>
-            <a:pPr algn="l">
-              <a:lnSpc>
-                <a:spcPct val="118000"/>
-              </a:lnSpc>
-              <a:spcBef>
-                <a:spcPts val="0"/>
-              </a:spcBef>
-              <a:spcAft>
-                <a:spcPts val="800"/>
+              <a:t>Старт</a:t>
+            </a:r>
+          </a:p>
+          <a:p>
+            <a:pPr algn="l">
+              <a:lnSpc>
+                <a:spcPct val="118000"/>
+              </a:lnSpc>
+              <a:spcBef>
+                <a:spcPts val="0"/>
+              </a:spcBef>
+              <a:spcAft>
+                <a:spcPts val="0"/>
               </a:spcAft>
             </a:pPr>
             <a:r>
@@ -6178,30 +6224,74 @@
                 <a:latin typeface="Golos Text"/>
                 <a:rFonts ascii="Golos Text" hAnsi="Golos Text" cs="Golos Text" eastAsia="Golos Text"/>
               </a:rPr>
-              <a:t>Готовность продукта перед рынком</a:t>
-            </a:r>
-          </a:p>
-          <a:p>
-            <a:pPr algn="l">
-              <a:lnSpc>
-                <a:spcPct val="118000"/>
-              </a:lnSpc>
-              <a:spcBef>
-                <a:spcPts val="0"/>
-              </a:spcBef>
-              <a:spcAft>
-                <a:spcPts val="200"/>
+              <a:t>Блокеры этапа 2 с технологом и пилотный сегмент eco / wellness</a:t>
+            </a:r>
+          </a:p>
+        </p:txBody>
+      </p:sp>
+      <p:sp>
+        <p:nvSpPr>
+          <p:cNvPr id="14" name="TextBox 13"/>
+          <p:cNvSpPr txBox="1"/>
+          <p:nvPr/>
+        </p:nvSpPr>
+        <p:spPr>
+          <a:xfrm>
+            <a:off x="6571335" y="1426464"/>
+            <a:ext cx="4815687" cy="4334256"/>
+          </a:xfrm>
+          <a:prstGeom prst="rect">
+            <a:avLst/>
+          </a:prstGeom>
+          <a:noFill/>
+        </p:spPr>
+        <p:txBody>
+          <a:bodyPr wrap="square" anchor="t" lIns="50800" rIns="50800" tIns="25400" bIns="25400"/>
+          <a:lstStyle/>
+          <a:p>
+            <a:pPr algn="l">
+              <a:lnSpc>
+                <a:spcPct val="118000"/>
+              </a:lnSpc>
+              <a:spcBef>
+                <a:spcPts val="0"/>
+              </a:spcBef>
+              <a:spcAft>
+                <a:spcPts val="1200"/>
               </a:spcAft>
             </a:pPr>
             <a:r>
               <a:rPr sz="1500" b="1">
                 <a:solidFill>
-                  <a:srgbClr val="1A1A1A"/>
+                  <a:srgbClr val="2A554A"/>
                 </a:solidFill>
                 <a:latin typeface="Manrope"/>
                 <a:rFonts ascii="Manrope" hAnsi="Manrope" cs="Manrope" eastAsia="Manrope"/>
               </a:rPr>
-              <a:t>Логистика</a:t>
+              <a:t>Готов присоединиться</a:t>
+            </a:r>
+          </a:p>
+          <a:p>
+            <a:pPr algn="l">
+              <a:lnSpc>
+                <a:spcPct val="118000"/>
+              </a:lnSpc>
+              <a:spcBef>
+                <a:spcPts val="0"/>
+              </a:spcBef>
+              <a:spcAft>
+                <a:spcPts val="200"/>
+              </a:spcAft>
+            </a:pPr>
+            <a:r>
+              <a:rPr sz="1500" b="1">
+                <a:solidFill>
+                  <a:srgbClr val="1A1A1A"/>
+                </a:solidFill>
+                <a:latin typeface="Manrope"/>
+                <a:rFonts ascii="Manrope" hAnsi="Manrope" cs="Manrope" eastAsia="Manrope"/>
+              </a:rPr>
+              <a:t>Направление</a:t>
             </a:r>
           </a:p>
           <a:p>
@@ -6224,109 +6314,88 @@
                 <a:latin typeface="Golos Text"/>
                 <a:rFonts ascii="Golos Text" hAnsi="Golos Text" cs="Golos Text" eastAsia="Golos Text"/>
               </a:rPr>
-              <a:t>Раздел L — путь при поставке из Китая</a:t>
-            </a:r>
-          </a:p>
-          <a:p>
-            <a:pPr algn="l">
-              <a:lnSpc>
-                <a:spcPct val="118000"/>
-              </a:lnSpc>
-              <a:spcBef>
-                <a:spcPts val="1800"/>
-              </a:spcBef>
-              <a:spcAft>
-                <a:spcPts val="0"/>
-              </a:spcAft>
-            </a:pPr>
-            <a:r>
-              <a:rPr sz="1200" b="0">
-                <a:solidFill>
-                  <a:srgbClr val="5C5C5C"/>
+              <a:t>Вести Natural и работать с линейкой в этом контуре</a:t>
+            </a:r>
+          </a:p>
+          <a:p>
+            <a:pPr algn="l">
+              <a:lnSpc>
+                <a:spcPct val="118000"/>
+              </a:lnSpc>
+              <a:spcBef>
+                <a:spcPts val="0"/>
+              </a:spcBef>
+              <a:spcAft>
+                <a:spcPts val="200"/>
+              </a:spcAft>
+            </a:pPr>
+            <a:r>
+              <a:rPr sz="1500" b="1">
+                <a:solidFill>
+                  <a:srgbClr val="1A1A1A"/>
+                </a:solidFill>
+                <a:latin typeface="Manrope"/>
+                <a:rFonts ascii="Manrope" hAnsi="Manrope" cs="Manrope" eastAsia="Manrope"/>
+              </a:rPr>
+              <a:t>Подход</a:t>
+            </a:r>
+          </a:p>
+          <a:p>
+            <a:pPr algn="l">
+              <a:lnSpc>
+                <a:spcPct val="118000"/>
+              </a:lnSpc>
+              <a:spcBef>
+                <a:spcPts val="0"/>
+              </a:spcBef>
+              <a:spcAft>
+                <a:spcPts val="800"/>
+              </a:spcAft>
+            </a:pPr>
+            <a:r>
+              <a:rPr sz="1500" b="0">
+                <a:solidFill>
+                  <a:srgbClr val="1A1A1A"/>
                 </a:solidFill>
                 <a:latin typeface="Golos Text"/>
                 <a:rFonts ascii="Golos Text" hAnsi="Golos Text" cs="Golos Text" eastAsia="Golos Text"/>
               </a:rPr>
-              <a:t>Не прайс завода. Не коммерческое предложение.</a:t>
-            </a:r>
-          </a:p>
-        </p:txBody>
-      </p:sp>
-      <p:sp>
-        <p:nvSpPr>
-          <p:cNvPr id="14" name="TextBox 13"/>
-          <p:cNvSpPr txBox="1"/>
-          <p:nvPr/>
-        </p:nvSpPr>
-        <p:spPr>
-          <a:xfrm>
-            <a:off x="6571335" y="1426464"/>
-            <a:ext cx="4815687" cy="4334256"/>
-          </a:xfrm>
-          <a:prstGeom prst="rect">
-            <a:avLst/>
-          </a:prstGeom>
-          <a:noFill/>
-        </p:spPr>
-        <p:txBody>
-          <a:bodyPr wrap="square" anchor="t" lIns="50800" rIns="50800" tIns="25400" bIns="25400"/>
-          <a:lstStyle/>
-          <a:p>
-            <a:pPr algn="l">
-              <a:lnSpc>
-                <a:spcPct val="118000"/>
-              </a:lnSpc>
-              <a:spcBef>
-                <a:spcPts val="0"/>
-              </a:spcBef>
-              <a:spcAft>
-                <a:spcPts val="1200"/>
+              <a:t>Цифры и рамка в руках у продаж и завода — не презентация ради слайдов</a:t>
+            </a:r>
+          </a:p>
+          <a:p>
+            <a:pPr algn="l">
+              <a:lnSpc>
+                <a:spcPct val="118000"/>
+              </a:lnSpc>
+              <a:spcBef>
+                <a:spcPts val="0"/>
+              </a:spcBef>
+              <a:spcAft>
+                <a:spcPts val="200"/>
               </a:spcAft>
             </a:pPr>
             <a:r>
               <a:rPr sz="1500" b="1">
                 <a:solidFill>
-                  <a:srgbClr val="2A554A"/>
+                  <a:srgbClr val="1A1A1A"/>
                 </a:solidFill>
                 <a:latin typeface="Manrope"/>
                 <a:rFonts ascii="Manrope" hAnsi="Manrope" cs="Manrope" eastAsia="Manrope"/>
               </a:rPr>
-              <a:t>Готов обсудить</a:t>
-            </a:r>
-          </a:p>
-          <a:p>
-            <a:pPr algn="l">
-              <a:lnSpc>
-                <a:spcPct val="118000"/>
-              </a:lnSpc>
-              <a:spcBef>
-                <a:spcPts val="0"/>
-              </a:spcBef>
-              <a:spcAft>
-                <a:spcPts val="200"/>
-              </a:spcAft>
-            </a:pPr>
-            <a:r>
-              <a:rPr sz="1500" b="1">
-                <a:solidFill>
-                  <a:srgbClr val="1A1A1A"/>
-                </a:solidFill>
-                <a:latin typeface="Manrope"/>
-                <a:rFonts ascii="Manrope" hAnsi="Manrope" cs="Manrope" eastAsia="Manrope"/>
-              </a:rPr>
-              <a:t>Блокеры</a:t>
-            </a:r>
-          </a:p>
-          <a:p>
-            <a:pPr algn="l">
-              <a:lnSpc>
-                <a:spcPct val="118000"/>
-              </a:lnSpc>
-              <a:spcBef>
-                <a:spcPts val="0"/>
-              </a:spcBef>
-              <a:spcAft>
-                <a:spcPts val="800"/>
+              <a:t>Финал</a:t>
+            </a:r>
+          </a:p>
+          <a:p>
+            <a:pPr algn="l">
+              <a:lnSpc>
+                <a:spcPct val="118000"/>
+              </a:lnSpc>
+              <a:spcBef>
+                <a:spcPts val="0"/>
+              </a:spcBef>
+              <a:spcAft>
+                <a:spcPts val="0"/>
               </a:spcAft>
             </a:pPr>
             <a:r>
@@ -6337,145 +6406,7 @@
                 <a:latin typeface="Golos Text"/>
                 <a:rFonts ascii="Golos Text" hAnsi="Golos Text" cs="Golos Text" eastAsia="Golos Text"/>
               </a:rPr>
-              <a:t>Приоритет этапа 2 с технологом</a:t>
-            </a:r>
-          </a:p>
-          <a:p>
-            <a:pPr algn="l">
-              <a:lnSpc>
-                <a:spcPct val="118000"/>
-              </a:lnSpc>
-              <a:spcBef>
-                <a:spcPts val="0"/>
-              </a:spcBef>
-              <a:spcAft>
-                <a:spcPts val="200"/>
-              </a:spcAft>
-            </a:pPr>
-            <a:r>
-              <a:rPr sz="1500" b="1">
-                <a:solidFill>
-                  <a:srgbClr val="1A1A1A"/>
-                </a:solidFill>
-                <a:latin typeface="Manrope"/>
-                <a:rFonts ascii="Manrope" hAnsi="Manrope" cs="Manrope" eastAsia="Manrope"/>
-              </a:rPr>
-              <a:t>Сегмент</a:t>
-            </a:r>
-          </a:p>
-          <a:p>
-            <a:pPr algn="l">
-              <a:lnSpc>
-                <a:spcPct val="118000"/>
-              </a:lnSpc>
-              <a:spcBef>
-                <a:spcPts val="0"/>
-              </a:spcBef>
-              <a:spcAft>
-                <a:spcPts val="800"/>
-              </a:spcAft>
-            </a:pPr>
-            <a:r>
-              <a:rPr sz="1500" b="0">
-                <a:solidFill>
-                  <a:srgbClr val="1A1A1A"/>
-                </a:solidFill>
-                <a:latin typeface="Golos Text"/>
-                <a:rFonts ascii="Golos Text" hAnsi="Golos Text" cs="Golos Text" eastAsia="Golos Text"/>
-              </a:rPr>
-              <a:t>Пилот eco / wellness</a:t>
-            </a:r>
-          </a:p>
-          <a:p>
-            <a:pPr algn="l">
-              <a:lnSpc>
-                <a:spcPct val="118000"/>
-              </a:lnSpc>
-              <a:spcBef>
-                <a:spcPts val="0"/>
-              </a:spcBef>
-              <a:spcAft>
-                <a:spcPts val="200"/>
-              </a:spcAft>
-            </a:pPr>
-            <a:r>
-              <a:rPr sz="1500" b="1">
-                <a:solidFill>
-                  <a:srgbClr val="1A1A1A"/>
-                </a:solidFill>
-                <a:latin typeface="Manrope"/>
-                <a:rFonts ascii="Manrope" hAnsi="Manrope" cs="Manrope" eastAsia="Manrope"/>
-              </a:rPr>
-              <a:t>Продажи</a:t>
-            </a:r>
-          </a:p>
-          <a:p>
-            <a:pPr algn="l">
-              <a:lnSpc>
-                <a:spcPct val="118000"/>
-              </a:lnSpc>
-              <a:spcBef>
-                <a:spcPts val="0"/>
-              </a:spcBef>
-              <a:spcAft>
-                <a:spcPts val="800"/>
-              </a:spcAft>
-            </a:pPr>
-            <a:r>
-              <a:rPr sz="1500" b="0">
-                <a:solidFill>
-                  <a:srgbClr val="1A1A1A"/>
-                </a:solidFill>
-                <a:latin typeface="Golos Text"/>
-                <a:rFonts ascii="Golos Text" hAnsi="Golos Text" cs="Golos Text" eastAsia="Golos Text"/>
-              </a:rPr>
-              <a:t>Как не увести Natural в эконом Hotel Line</a:t>
-            </a:r>
-          </a:p>
-          <a:p>
-            <a:pPr algn="l">
-              <a:lnSpc>
-                <a:spcPct val="118000"/>
-              </a:lnSpc>
-              <a:spcBef>
-                <a:spcPts val="0"/>
-              </a:spcBef>
-              <a:spcAft>
-                <a:spcPts val="200"/>
-              </a:spcAft>
-            </a:pPr>
-            <a:r>
-              <a:rPr sz="1500" b="1">
-                <a:solidFill>
-                  <a:srgbClr val="1A1A1A"/>
-                </a:solidFill>
-                <a:latin typeface="Manrope"/>
-                <a:rFonts ascii="Manrope" hAnsi="Manrope" cs="Manrope" eastAsia="Manrope"/>
-              </a:rPr>
-              <a:t>Вопросы</a:t>
-            </a:r>
-          </a:p>
-          <a:p>
-            <a:pPr algn="l">
-              <a:lnSpc>
-                <a:spcPct val="118000"/>
-              </a:lnSpc>
-              <a:spcBef>
-                <a:spcPts val="0"/>
-              </a:spcBef>
-              <a:spcAft>
-                <a:spcPts val="0"/>
-              </a:spcAft>
-            </a:pPr>
-            <a:r>
-              <a:rPr sz="1500" b="0">
-                <a:solidFill>
-                  <a:srgbClr val="1A1A1A"/>
-                </a:solidFill>
-                <a:latin typeface="Golos Text"/>
-                <a:rFonts ascii="Golos Text" hAnsi="Golos Text" cs="Golos Text" eastAsia="Golos Text"/>
-              </a:rPr>
-              <a:t>Спасибо</a:t>
+              <a:t>Буду рад присоединиться к команде. Спасибо. Вопросы?</a:t>
             </a:r>
           </a:p>
         </p:txBody>

</xml_diff>

<commit_message>
content(presentation): slide 11 запас clarified, markup to buyer price
Co-authored-by: pagasbot-coder <pagasbot-coder@users.noreply.github.com>
</commit_message>
<xml_diff>
--- a/knowledge-base/presentation-travelplus-interview.pptx
+++ b/knowledge-base/presentation-travelplus-interview.pptx
@@ -4658,7 +4658,7 @@
                 <a:latin typeface="Manrope"/>
                 <a:rFonts ascii="Manrope" hAnsi="Manrope" cs="Manrope" eastAsia="Manrope"/>
               </a:rPr>
-              <a:t>Себестоимость: как считаю</a:t>
+              <a:t>Себестоимость: простыми словами</a:t>
             </a:r>
           </a:p>
         </p:txBody>
@@ -5039,7 +5039,7 @@
                 <a:latin typeface="Manrope"/>
                 <a:rFonts ascii="Manrope" hAnsi="Manrope" cs="Manrope" eastAsia="Manrope"/>
               </a:rPr>
-              <a:t>Цена на складе</a:t>
+              <a:t>До склада</a:t>
             </a:r>
           </a:p>
           <a:p>
@@ -5062,7 +5062,7 @@
                 <a:latin typeface="Manrope"/>
                 <a:rFonts ascii="Manrope" hAnsi="Manrope" cs="Manrope" eastAsia="Manrope"/>
               </a:rPr>
-              <a:t>FOB</a:t>
+              <a:t>Цена завода</a:t>
             </a:r>
           </a:p>
           <a:p>
@@ -5085,7 +5085,7 @@
                 <a:latin typeface="Golos Text"/>
                 <a:rFonts ascii="Golos Text" hAnsi="Golos Text" cs="Golos Text" eastAsia="Golos Text"/>
               </a:rPr>
-              <a:t>База сравнения заводов — отдельно от логистики</a:t>
+              <a:t>Сколько стоит товар у производителя до отправки</a:t>
             </a:r>
           </a:p>
           <a:p>
@@ -5131,7 +5131,7 @@
                 <a:latin typeface="Golos Text"/>
                 <a:rFonts ascii="Golos Text" hAnsi="Golos Text" cs="Golos Text" eastAsia="Golos Text"/>
               </a:rPr>
-              <a:t>Фрахт, экспедитор, довоз до Кириши</a:t>
+              <a:t>Море или самолёт, экспедитор, довоз до Кириши</a:t>
             </a:r>
           </a:p>
           <a:p>
@@ -5177,7 +5177,7 @@
                 <a:latin typeface="Golos Text"/>
                 <a:rFonts ascii="Golos Text" hAnsi="Golos Text" cs="Golos Text" eastAsia="Golos Text"/>
               </a:rPr>
-              <a:t>Пошлина, НДС, брокер</a:t>
+              <a:t>Пошлина, налог, услуги брокера</a:t>
             </a:r>
           </a:p>
           <a:p>
@@ -5223,7 +5223,7 @@
                 <a:latin typeface="Golos Text"/>
                 <a:rFonts ascii="Golos Text" hAnsi="Golos Text" cs="Golos Text" eastAsia="Golos Text"/>
               </a:rPr>
-              <a:t>Брак, пересорт, курс</a:t>
+              <a:t>Резерв на брак, пересорт и скачок курса — не прибыль</a:t>
             </a:r>
           </a:p>
           <a:p>
@@ -5246,7 +5246,7 @@
                 <a:latin typeface="Manrope"/>
                 <a:rFonts ascii="Manrope" hAnsi="Manrope" cs="Manrope" eastAsia="Manrope"/>
               </a:rPr>
-              <a:t>Итог</a:t>
+              <a:t>На складе</a:t>
             </a:r>
           </a:p>
           <a:p>
@@ -5269,7 +5269,7 @@
                 <a:latin typeface="Golos Text"/>
                 <a:rFonts ascii="Golos Text" hAnsi="Golos Text" cs="Golos Text" eastAsia="Golos Text"/>
               </a:rPr>
-              <a:t>Сумма строк = цена на складе → из неё прайс и маржа</a:t>
+              <a:t>Сложили строки = себестоимость единицы</a:t>
             </a:r>
           </a:p>
           <a:p>
@@ -5292,7 +5292,7 @@
                 <a:latin typeface="Golos Text"/>
                 <a:rFonts ascii="Golos Text" hAnsi="Golos Text" cs="Golos Text" eastAsia="Golos Text"/>
               </a:rPr>
-              <a:t>Без этой таблицы прайс Natural не утверждаю.</a:t>
+              <a:t>Прайс для отеля считаю только от этой цифры.</a:t>
             </a:r>
           </a:p>
         </p:txBody>
@@ -5336,7 +5336,7 @@
                 <a:latin typeface="Manrope"/>
                 <a:rFonts ascii="Manrope" hAnsi="Manrope" cs="Manrope" eastAsia="Manrope"/>
               </a:rPr>
-              <a:t>Правила расчёта</a:t>
+              <a:t>До цены закупщику (ориентировочно)</a:t>
             </a:r>
           </a:p>
           <a:p>
@@ -5359,7 +5359,7 @@
                 <a:latin typeface="Manrope"/>
                 <a:rFonts ascii="Manrope" hAnsi="Manrope" cs="Manrope" eastAsia="Manrope"/>
               </a:rPr>
-              <a:t>Заводы</a:t>
+              <a:t>На складе</a:t>
             </a:r>
           </a:p>
           <a:p>
@@ -5382,7 +5382,7 @@
                 <a:latin typeface="Golos Text"/>
                 <a:rFonts ascii="Golos Text" hAnsi="Golos Text" cs="Golos Text" eastAsia="Golos Text"/>
               </a:rPr>
-              <a:t>Минимум два FOB в сравнении до контракта</a:t>
+              <a:t>14 ₽ за флакон</a:t>
             </a:r>
           </a:p>
           <a:p>
@@ -5405,7 +5405,7 @@
                 <a:latin typeface="Manrope"/>
                 <a:rFonts ascii="Manrope" hAnsi="Manrope" cs="Manrope" eastAsia="Manrope"/>
               </a:rPr>
-              <a:t>Прайс</a:t>
+              <a:t>Рынок</a:t>
             </a:r>
           </a:p>
           <a:p>
@@ -5428,7 +5428,7 @@
                 <a:latin typeface="Golos Text"/>
                 <a:rFonts ascii="Golos Text" hAnsi="Golos Text" cs="Golos Text" eastAsia="Golos Text"/>
               </a:rPr>
-              <a:t>Только после landed cost, не «с потолка»</a:t>
+              <a:t>Hotel Line 12–15 ₽ · ЕТС ~18 ₽ · Natura Siberica 30–40 ₽</a:t>
             </a:r>
           </a:p>
           <a:p>
@@ -5451,7 +5451,7 @@
                 <a:latin typeface="Manrope"/>
                 <a:rFonts ascii="Manrope" hAnsi="Manrope" cs="Manrope" eastAsia="Manrope"/>
               </a:rPr>
-              <a:t>Маржа</a:t>
+              <a:t>Наценка</a:t>
             </a:r>
           </a:p>
           <a:p>
@@ -5474,7 +5474,7 @@
                 <a:latin typeface="Golos Text"/>
                 <a:rFonts ascii="Golos Text" hAnsi="Golos Text" cs="Golos Text" eastAsia="Golos Text"/>
               </a:rPr>
-              <a:t>Natural и Hotel Line — разная экономика</a:t>
+              <a:t>Смотрю маржу Travel+ и коридор «между Hotel Line и Natura Siberica»</a:t>
             </a:r>
           </a:p>
           <a:p>
@@ -5497,7 +5497,7 @@
                 <a:latin typeface="Manrope"/>
                 <a:rFonts ascii="Manrope" hAnsi="Manrope" cs="Manrope" eastAsia="Manrope"/>
               </a:rPr>
-              <a:t>Срок в КП</a:t>
+              <a:t>Цена закупщику</a:t>
             </a:r>
           </a:p>
           <a:p>
@@ -5520,7 +5520,7 @@
                 <a:latin typeface="Golos Text"/>
                 <a:rFonts ascii="Golos Text" hAnsi="Golos Text" cs="Golos Text" eastAsia="Golos Text"/>
               </a:rPr>
-              <a:t>Дата «на складе», не «завод отгрузил»</a:t>
+              <a:t>Ориентир ~22–26 ₽ — выше Hotel Line, рядом с ЕТС, ниже Natura Siberica</a:t>
             </a:r>
           </a:p>
           <a:p>
@@ -5543,7 +5543,7 @@
                 <a:latin typeface="Manrope"/>
                 <a:rFonts ascii="Manrope" hAnsi="Manrope" cs="Manrope" eastAsia="Manrope"/>
               </a:rPr>
-              <a:t>Коридор</a:t>
+              <a:t>Проверка</a:t>
             </a:r>
           </a:p>
           <a:p>
@@ -5566,7 +5566,7 @@
                 <a:latin typeface="Golos Text"/>
                 <a:rFonts ascii="Golos Text" hAnsi="Golos Text" cs="Golos Text" eastAsia="Golos Text"/>
               </a:rPr>
-              <a:t>Выше Hotel Line, рядом с ЕТС, ниже Natura Siberica</a:t>
+              <a:t>Если наценка не держится — меняю завод или не выхожу в прайс</a:t>
             </a:r>
           </a:p>
         </p:txBody>

</xml_diff>

<commit_message>
content(presentation): slide 11 stages + markup % + buyer price
Co-authored-by: pagasbot-coder <pagasbot-coder@users.noreply.github.com>
</commit_message>
<xml_diff>
--- a/knowledge-base/presentation-travelplus-interview.pptx
+++ b/knowledge-base/presentation-travelplus-interview.pptx
@@ -5039,7 +5039,7 @@
                 <a:latin typeface="Manrope"/>
                 <a:rFonts ascii="Manrope" hAnsi="Manrope" cs="Manrope" eastAsia="Manrope"/>
               </a:rPr>
-              <a:t>До склада</a:t>
+              <a:t>До склада (ориентировочно)</a:t>
             </a:r>
           </a:p>
           <a:p>
@@ -5085,7 +5085,7 @@
                 <a:latin typeface="Golos Text"/>
                 <a:rFonts ascii="Golos Text" hAnsi="Golos Text" cs="Golos Text" eastAsia="Golos Text"/>
               </a:rPr>
-              <a:t>Сколько стоит товар у производителя до отправки</a:t>
+              <a:t>8 ₽ — у производителя до отправки</a:t>
             </a:r>
           </a:p>
           <a:p>
@@ -5131,7 +5131,7 @@
                 <a:latin typeface="Golos Text"/>
                 <a:rFonts ascii="Golos Text" hAnsi="Golos Text" cs="Golos Text" eastAsia="Golos Text"/>
               </a:rPr>
-              <a:t>Море или самолёт, экспедитор, довоз до Кириши</a:t>
+              <a:t>3 ₽ — море / самолёт, экспедитор, довоз</a:t>
             </a:r>
           </a:p>
           <a:p>
@@ -5177,7 +5177,7 @@
                 <a:latin typeface="Golos Text"/>
                 <a:rFonts ascii="Golos Text" hAnsi="Golos Text" cs="Golos Text" eastAsia="Golos Text"/>
               </a:rPr>
-              <a:t>Пошлина, налог, услуги брокера</a:t>
+              <a:t>2 ₽ — пошлина, налог, брокер</a:t>
             </a:r>
           </a:p>
           <a:p>
@@ -5223,7 +5223,7 @@
                 <a:latin typeface="Golos Text"/>
                 <a:rFonts ascii="Golos Text" hAnsi="Golos Text" cs="Golos Text" eastAsia="Golos Text"/>
               </a:rPr>
-              <a:t>Резерв на брак, пересорт и скачок курса — не прибыль</a:t>
+              <a:t>1 ₽ — резерв на брак, пересорт и курс; это не прибыль</a:t>
             </a:r>
           </a:p>
           <a:p>
@@ -5269,7 +5269,7 @@
                 <a:latin typeface="Golos Text"/>
                 <a:rFonts ascii="Golos Text" hAnsi="Golos Text" cs="Golos Text" eastAsia="Golos Text"/>
               </a:rPr>
-              <a:t>Сложили строки = себестоимость единицы</a:t>
+              <a:t>14 ₽ — себестоимость единицы в Киришах</a:t>
             </a:r>
           </a:p>
           <a:p>

</xml_diff>

<commit_message>
content(presentation): slide 11 add FOB supplier compare rule
Co-authored-by: pagasbot-coder <pagasbot-coder@users.noreply.github.com>
</commit_message>
<xml_diff>
--- a/knowledge-base/presentation-travelplus-interview.pptx
+++ b/knowledge-base/presentation-travelplus-interview.pptx
@@ -5062,7 +5062,7 @@
                 <a:latin typeface="Manrope"/>
                 <a:rFonts ascii="Manrope" hAnsi="Manrope" cs="Manrope" eastAsia="Manrope"/>
               </a:rPr>
-              <a:t>Цена завода</a:t>
+              <a:t>1. Цена завода</a:t>
             </a:r>
           </a:p>
           <a:p>
@@ -5108,7 +5108,7 @@
                 <a:latin typeface="Manrope"/>
                 <a:rFonts ascii="Manrope" hAnsi="Manrope" cs="Manrope" eastAsia="Manrope"/>
               </a:rPr>
-              <a:t>Доставка</a:t>
+              <a:t>2. Доставка</a:t>
             </a:r>
           </a:p>
           <a:p>
@@ -5154,7 +5154,7 @@
                 <a:latin typeface="Manrope"/>
                 <a:rFonts ascii="Manrope" hAnsi="Manrope" cs="Manrope" eastAsia="Manrope"/>
               </a:rPr>
-              <a:t>Таможня</a:t>
+              <a:t>3. Таможня</a:t>
             </a:r>
           </a:p>
           <a:p>
@@ -5200,7 +5200,7 @@
                 <a:latin typeface="Manrope"/>
                 <a:rFonts ascii="Manrope" hAnsi="Manrope" cs="Manrope" eastAsia="Manrope"/>
               </a:rPr>
-              <a:t>Запас</a:t>
+              <a:t>4. Запас</a:t>
             </a:r>
           </a:p>
           <a:p>
@@ -5223,7 +5223,7 @@
                 <a:latin typeface="Golos Text"/>
                 <a:rFonts ascii="Golos Text" hAnsi="Golos Text" cs="Golos Text" eastAsia="Golos Text"/>
               </a:rPr>
-              <a:t>1 ₽ — резерв на брак, пересорт и курс; это не прибыль</a:t>
+              <a:t>1 ₽ — резерв на брак, пересорт и курс; не прибыль</a:t>
             </a:r>
           </a:p>
           <a:p>
@@ -5246,19 +5246,19 @@
                 <a:latin typeface="Manrope"/>
                 <a:rFonts ascii="Manrope" hAnsi="Manrope" cs="Manrope" eastAsia="Manrope"/>
               </a:rPr>
-              <a:t>На складе</a:t>
-            </a:r>
-          </a:p>
-          <a:p>
-            <a:pPr algn="l">
-              <a:lnSpc>
-                <a:spcPct val="118000"/>
-              </a:lnSpc>
-              <a:spcBef>
-                <a:spcPts val="0"/>
-              </a:spcBef>
-              <a:spcAft>
-                <a:spcPts val="800"/>
+              <a:t>5. На складе</a:t>
+            </a:r>
+          </a:p>
+          <a:p>
+            <a:pPr algn="l">
+              <a:lnSpc>
+                <a:spcPct val="118000"/>
+              </a:lnSpc>
+              <a:spcBef>
+                <a:spcPts val="0"/>
+              </a:spcBef>
+              <a:spcAft>
+                <a:spcPts val="0"/>
               </a:spcAft>
             </a:pPr>
             <a:r>
@@ -5269,74 +5269,143 @@
                 <a:latin typeface="Golos Text"/>
                 <a:rFonts ascii="Golos Text" hAnsi="Golos Text" cs="Golos Text" eastAsia="Golos Text"/>
               </a:rPr>
-              <a:t>14 ₽ — себестоимость единицы в Киришах</a:t>
-            </a:r>
-          </a:p>
-          <a:p>
-            <a:pPr algn="l">
-              <a:lnSpc>
-                <a:spcPct val="118000"/>
-              </a:lnSpc>
-              <a:spcBef>
-                <a:spcPts val="1800"/>
-              </a:spcBef>
-              <a:spcAft>
-                <a:spcPts val="0"/>
-              </a:spcAft>
-            </a:pPr>
-            <a:r>
-              <a:rPr sz="1200" b="0">
-                <a:solidFill>
-                  <a:srgbClr val="5C5C5C"/>
+              <a:t>8 + 3 + 2 + 1 = 14 ₽ за флакон</a:t>
+            </a:r>
+          </a:p>
+        </p:txBody>
+      </p:sp>
+      <p:sp>
+        <p:nvSpPr>
+          <p:cNvPr id="14" name="TextBox 13"/>
+          <p:cNvSpPr txBox="1"/>
+          <p:nvPr/>
+        </p:nvSpPr>
+        <p:spPr>
+          <a:xfrm>
+            <a:off x="6571335" y="1426464"/>
+            <a:ext cx="4815687" cy="4334256"/>
+          </a:xfrm>
+          <a:prstGeom prst="rect">
+            <a:avLst/>
+          </a:prstGeom>
+          <a:noFill/>
+        </p:spPr>
+        <p:txBody>
+          <a:bodyPr wrap="square" anchor="t" lIns="50800" rIns="50800" tIns="25400" bIns="25400"/>
+          <a:lstStyle/>
+          <a:p>
+            <a:pPr algn="l">
+              <a:lnSpc>
+                <a:spcPct val="118000"/>
+              </a:lnSpc>
+              <a:spcBef>
+                <a:spcPts val="0"/>
+              </a:spcBef>
+              <a:spcAft>
+                <a:spcPts val="1200"/>
+              </a:spcAft>
+            </a:pPr>
+            <a:r>
+              <a:rPr sz="1500" b="1">
+                <a:solidFill>
+                  <a:srgbClr val="2A554A"/>
+                </a:solidFill>
+                <a:latin typeface="Manrope"/>
+                <a:rFonts ascii="Manrope" hAnsi="Manrope" cs="Manrope" eastAsia="Manrope"/>
+              </a:rPr>
+              <a:t>До закупщика (ориентировочно)</a:t>
+            </a:r>
+          </a:p>
+          <a:p>
+            <a:pPr algn="l">
+              <a:lnSpc>
+                <a:spcPct val="118000"/>
+              </a:lnSpc>
+              <a:spcBef>
+                <a:spcPts val="0"/>
+              </a:spcBef>
+              <a:spcAft>
+                <a:spcPts val="200"/>
+              </a:spcAft>
+            </a:pPr>
+            <a:r>
+              <a:rPr sz="1500" b="1">
+                <a:solidFill>
+                  <a:srgbClr val="1A1A1A"/>
+                </a:solidFill>
+                <a:latin typeface="Manrope"/>
+                <a:rFonts ascii="Manrope" hAnsi="Manrope" cs="Manrope" eastAsia="Manrope"/>
+              </a:rPr>
+              <a:t>Себестоимость</a:t>
+            </a:r>
+          </a:p>
+          <a:p>
+            <a:pPr algn="l">
+              <a:lnSpc>
+                <a:spcPct val="118000"/>
+              </a:lnSpc>
+              <a:spcBef>
+                <a:spcPts val="0"/>
+              </a:spcBef>
+              <a:spcAft>
+                <a:spcPts val="800"/>
+              </a:spcAft>
+            </a:pPr>
+            <a:r>
+              <a:rPr sz="1500" b="0">
+                <a:solidFill>
+                  <a:srgbClr val="1A1A1A"/>
                 </a:solidFill>
                 <a:latin typeface="Golos Text"/>
                 <a:rFonts ascii="Golos Text" hAnsi="Golos Text" cs="Golos Text" eastAsia="Golos Text"/>
               </a:rPr>
-              <a:t>Прайс для отеля считаю только от этой цифры.</a:t>
-            </a:r>
-          </a:p>
-        </p:txBody>
-      </p:sp>
-      <p:sp>
-        <p:nvSpPr>
-          <p:cNvPr id="14" name="TextBox 13"/>
-          <p:cNvSpPr txBox="1"/>
-          <p:nvPr/>
-        </p:nvSpPr>
-        <p:spPr>
-          <a:xfrm>
-            <a:off x="6571335" y="1426464"/>
-            <a:ext cx="4815687" cy="4334256"/>
-          </a:xfrm>
-          <a:prstGeom prst="rect">
-            <a:avLst/>
-          </a:prstGeom>
-          <a:noFill/>
-        </p:spPr>
-        <p:txBody>
-          <a:bodyPr wrap="square" anchor="t" lIns="50800" rIns="50800" tIns="25400" bIns="25400"/>
-          <a:lstStyle/>
-          <a:p>
-            <a:pPr algn="l">
-              <a:lnSpc>
-                <a:spcPct val="118000"/>
-              </a:lnSpc>
-              <a:spcBef>
-                <a:spcPts val="0"/>
-              </a:spcBef>
-              <a:spcAft>
-                <a:spcPts val="1200"/>
+              <a:t>14 ₽ на складе в Киришах</a:t>
+            </a:r>
+          </a:p>
+          <a:p>
+            <a:pPr algn="l">
+              <a:lnSpc>
+                <a:spcPct val="118000"/>
+              </a:lnSpc>
+              <a:spcBef>
+                <a:spcPts val="0"/>
+              </a:spcBef>
+              <a:spcAft>
+                <a:spcPts val="200"/>
               </a:spcAft>
             </a:pPr>
             <a:r>
               <a:rPr sz="1500" b="1">
                 <a:solidFill>
-                  <a:srgbClr val="2A554A"/>
+                  <a:srgbClr val="1A1A1A"/>
                 </a:solidFill>
                 <a:latin typeface="Manrope"/>
                 <a:rFonts ascii="Manrope" hAnsi="Manrope" cs="Manrope" eastAsia="Manrope"/>
               </a:rPr>
-              <a:t>До цены закупщику (ориентировочно)</a:t>
+              <a:t>Рынок</a:t>
+            </a:r>
+          </a:p>
+          <a:p>
+            <a:pPr algn="l">
+              <a:lnSpc>
+                <a:spcPct val="118000"/>
+              </a:lnSpc>
+              <a:spcBef>
+                <a:spcPts val="0"/>
+              </a:spcBef>
+              <a:spcAft>
+                <a:spcPts val="800"/>
+              </a:spcAft>
+            </a:pPr>
+            <a:r>
+              <a:rPr sz="1500" b="0">
+                <a:solidFill>
+                  <a:srgbClr val="1A1A1A"/>
+                </a:solidFill>
+                <a:latin typeface="Golos Text"/>
+                <a:rFonts ascii="Golos Text" hAnsi="Golos Text" cs="Golos Text" eastAsia="Golos Text"/>
+              </a:rPr>
+              <a:t>Hotel Line 12–15 ₽ · ЕТС ~18 ₽ · Natura Siberica 30–40 ₽</a:t>
             </a:r>
           </a:p>
           <a:p>
@@ -5359,7 +5428,7 @@
                 <a:latin typeface="Manrope"/>
                 <a:rFonts ascii="Manrope" hAnsi="Manrope" cs="Manrope" eastAsia="Manrope"/>
               </a:rPr>
-              <a:t>На складе</a:t>
+              <a:t>Наценка</a:t>
             </a:r>
           </a:p>
           <a:p>
@@ -5382,7 +5451,7 @@
                 <a:latin typeface="Golos Text"/>
                 <a:rFonts ascii="Golos Text" hAnsi="Golos Text" cs="Golos Text" eastAsia="Golos Text"/>
               </a:rPr>
-              <a:t>14 ₽ за флакон</a:t>
+              <a:t>~70% к себестоимости — маржа Travel+ в коридоре рынка</a:t>
             </a:r>
           </a:p>
           <a:p>
@@ -5405,7 +5474,7 @@
                 <a:latin typeface="Manrope"/>
                 <a:rFonts ascii="Manrope" hAnsi="Manrope" cs="Manrope" eastAsia="Manrope"/>
               </a:rPr>
-              <a:t>Рынок</a:t>
+              <a:t>Цена закупщику</a:t>
             </a:r>
           </a:p>
           <a:p>
@@ -5428,7 +5497,7 @@
                 <a:latin typeface="Golos Text"/>
                 <a:rFonts ascii="Golos Text" hAnsi="Golos Text" cs="Golos Text" eastAsia="Golos Text"/>
               </a:rPr>
-              <a:t>Hotel Line 12–15 ₽ · ЕТС ~18 ₽ · Natura Siberica 30–40 ₽</a:t>
+              <a:t>14 ₽ × 1,7 ≈ 24 ₽ — выше Hotel Line, рядом с ЕТС, ниже Natura Siberica</a:t>
             </a:r>
           </a:p>
           <a:p>
@@ -5451,19 +5520,19 @@
                 <a:latin typeface="Manrope"/>
                 <a:rFonts ascii="Manrope" hAnsi="Manrope" cs="Manrope" eastAsia="Manrope"/>
               </a:rPr>
-              <a:t>Наценка</a:t>
-            </a:r>
-          </a:p>
-          <a:p>
-            <a:pPr algn="l">
-              <a:lnSpc>
-                <a:spcPct val="118000"/>
-              </a:lnSpc>
-              <a:spcBef>
-                <a:spcPts val="0"/>
-              </a:spcBef>
-              <a:spcAft>
-                <a:spcPts val="800"/>
+              <a:t>Проверка</a:t>
+            </a:r>
+          </a:p>
+          <a:p>
+            <a:pPr algn="l">
+              <a:lnSpc>
+                <a:spcPct val="118000"/>
+              </a:lnSpc>
+              <a:spcBef>
+                <a:spcPts val="0"/>
+              </a:spcBef>
+              <a:spcAft>
+                <a:spcPts val="0"/>
               </a:spcAft>
             </a:pPr>
             <a:r>
@@ -5474,99 +5543,7 @@
                 <a:latin typeface="Golos Text"/>
                 <a:rFonts ascii="Golos Text" hAnsi="Golos Text" cs="Golos Text" eastAsia="Golos Text"/>
               </a:rPr>
-              <a:t>Смотрю маржу Travel+ и коридор «между Hotel Line и Natura Siberica»</a:t>
-            </a:r>
-          </a:p>
-          <a:p>
-            <a:pPr algn="l">
-              <a:lnSpc>
-                <a:spcPct val="118000"/>
-              </a:lnSpc>
-              <a:spcBef>
-                <a:spcPts val="0"/>
-              </a:spcBef>
-              <a:spcAft>
-                <a:spcPts val="200"/>
-              </a:spcAft>
-            </a:pPr>
-            <a:r>
-              <a:rPr sz="1500" b="1">
-                <a:solidFill>
-                  <a:srgbClr val="1A1A1A"/>
-                </a:solidFill>
-                <a:latin typeface="Manrope"/>
-                <a:rFonts ascii="Manrope" hAnsi="Manrope" cs="Manrope" eastAsia="Manrope"/>
-              </a:rPr>
-              <a:t>Цена закупщику</a:t>
-            </a:r>
-          </a:p>
-          <a:p>
-            <a:pPr algn="l">
-              <a:lnSpc>
-                <a:spcPct val="118000"/>
-              </a:lnSpc>
-              <a:spcBef>
-                <a:spcPts val="0"/>
-              </a:spcBef>
-              <a:spcAft>
-                <a:spcPts val="800"/>
-              </a:spcAft>
-            </a:pPr>
-            <a:r>
-              <a:rPr sz="1500" b="0">
-                <a:solidFill>
-                  <a:srgbClr val="1A1A1A"/>
-                </a:solidFill>
-                <a:latin typeface="Golos Text"/>
-                <a:rFonts ascii="Golos Text" hAnsi="Golos Text" cs="Golos Text" eastAsia="Golos Text"/>
-              </a:rPr>
-              <a:t>Ориентир ~22–26 ₽ — выше Hotel Line, рядом с ЕТС, ниже Natura Siberica</a:t>
-            </a:r>
-          </a:p>
-          <a:p>
-            <a:pPr algn="l">
-              <a:lnSpc>
-                <a:spcPct val="118000"/>
-              </a:lnSpc>
-              <a:spcBef>
-                <a:spcPts val="0"/>
-              </a:spcBef>
-              <a:spcAft>
-                <a:spcPts val="200"/>
-              </a:spcAft>
-            </a:pPr>
-            <a:r>
-              <a:rPr sz="1500" b="1">
-                <a:solidFill>
-                  <a:srgbClr val="1A1A1A"/>
-                </a:solidFill>
-                <a:latin typeface="Manrope"/>
-                <a:rFonts ascii="Manrope" hAnsi="Manrope" cs="Manrope" eastAsia="Manrope"/>
-              </a:rPr>
-              <a:t>Проверка</a:t>
-            </a:r>
-          </a:p>
-          <a:p>
-            <a:pPr algn="l">
-              <a:lnSpc>
-                <a:spcPct val="118000"/>
-              </a:lnSpc>
-              <a:spcBef>
-                <a:spcPts val="0"/>
-              </a:spcBef>
-              <a:spcAft>
-                <a:spcPts val="0"/>
-              </a:spcAft>
-            </a:pPr>
-            <a:r>
-              <a:rPr sz="1500" b="0">
-                <a:solidFill>
-                  <a:srgbClr val="1A1A1A"/>
-                </a:solidFill>
-                <a:latin typeface="Golos Text"/>
-                <a:rFonts ascii="Golos Text" hAnsi="Golos Text" cs="Golos Text" eastAsia="Golos Text"/>
-              </a:rPr>
-              <a:t>Если наценка не держится — меняю завод или не выхожу в прайс</a:t>
+              <a:t>Наценка не держится — меняю завод или не выхожу в прайс</a:t>
             </a:r>
           </a:p>
         </p:txBody>

</xml_diff>

<commit_message>
build(presentation): rebuild pptx with slide 11 FOB
Co-authored-by: pagasbot-coder <pagasbot-coder@users.noreply.github.com>
</commit_message>
<xml_diff>
--- a/knowledge-base/presentation-travelplus-interview.pptx
+++ b/knowledge-base/presentation-travelplus-interview.pptx
@@ -5085,7 +5085,7 @@
                 <a:latin typeface="Golos Text"/>
                 <a:rFonts ascii="Golos Text" hAnsi="Golos Text" cs="Golos Text" eastAsia="Golos Text"/>
               </a:rPr>
-              <a:t>8 ₽ — у производителя до отправки</a:t>
+              <a:t>8 ₽ — у производителя до отправки (FOB)</a:t>
             </a:r>
           </a:p>
           <a:p>
@@ -5258,7 +5258,7 @@
                 <a:spcPts val="0"/>
               </a:spcBef>
               <a:spcAft>
-                <a:spcPts val="0"/>
+                <a:spcPts val="800"/>
               </a:spcAft>
             </a:pPr>
             <a:r>
@@ -5270,6 +5270,52 @@
                 <a:rFonts ascii="Golos Text" hAnsi="Golos Text" cs="Golos Text" eastAsia="Golos Text"/>
               </a:rPr>
               <a:t>8 + 3 + 2 + 1 = 14 ₽ за флакон</a:t>
+            </a:r>
+          </a:p>
+          <a:p>
+            <a:pPr algn="l">
+              <a:lnSpc>
+                <a:spcPct val="118000"/>
+              </a:lnSpc>
+              <a:spcBef>
+                <a:spcPts val="0"/>
+              </a:spcBef>
+              <a:spcAft>
+                <a:spcPts val="200"/>
+              </a:spcAft>
+            </a:pPr>
+            <a:r>
+              <a:rPr sz="1500" b="1">
+                <a:solidFill>
+                  <a:srgbClr val="1A1A1A"/>
+                </a:solidFill>
+                <a:latin typeface="Manrope"/>
+                <a:rFonts ascii="Manrope" hAnsi="Manrope" cs="Manrope" eastAsia="Manrope"/>
+              </a:rPr>
+              <a:t>FOB</a:t>
+            </a:r>
+          </a:p>
+          <a:p>
+            <a:pPr algn="l">
+              <a:lnSpc>
+                <a:spcPct val="118000"/>
+              </a:lnSpc>
+              <a:spcBef>
+                <a:spcPts val="0"/>
+              </a:spcBef>
+              <a:spcAft>
+                <a:spcPts val="0"/>
+              </a:spcAft>
+            </a:pPr>
+            <a:r>
+              <a:rPr sz="1500" b="0">
+                <a:solidFill>
+                  <a:srgbClr val="1A1A1A"/>
+                </a:solidFill>
+                <a:latin typeface="Golos Text"/>
+                <a:rFonts ascii="Golos Text" hAnsi="Golos Text" cs="Golos Text" eastAsia="Golos Text"/>
+              </a:rPr>
+              <a:t>Поставщиков сравниваю по цене FOB — одинаковая база, без доставки</a:t>
             </a:r>
           </a:p>
         </p:txBody>

</xml_diff>